<commit_message>
Add scenario 3 to master scenario deck
</commit_message>
<xml_diff>
--- a/presentation/harness_aware_scenario_results_master.pptx
+++ b/presentation/harness_aware_scenario_results_master.pptx
@@ -2,14 +2,15 @@
 <file path=ppt/presentation.xml><?xml version="1.0" encoding="utf-8"?>
 <p:presentation xmlns:p="http://schemas.openxmlformats.org/presentationml/2006/main">
   <p:sldMasterIdLst>
-    <p:sldMasterId xmlns:r="http://schemas.openxmlformats.org/officeDocument/2006/relationships" id="2147483648" r:id="Ra0fed94b7c3845e3"/>
+    <p:sldMasterId xmlns:r="http://schemas.openxmlformats.org/officeDocument/2006/relationships" id="2147483648" r:id="R701362693c7740fb"/>
   </p:sldMasterIdLst>
   <p:notesMasterIdLst>
-    <p:notesMasterId xmlns:r="http://schemas.openxmlformats.org/officeDocument/2006/relationships" r:id="R4d2f2e499f674d7e"/>
+    <p:notesMasterId xmlns:r="http://schemas.openxmlformats.org/officeDocument/2006/relationships" r:id="Rcbcce05344d14244"/>
   </p:notesMasterIdLst>
   <p:sldIdLst>
-    <p:sldId xmlns:r="http://schemas.openxmlformats.org/officeDocument/2006/relationships" id="256" r:id="R2d4314964f544156"/>
-    <p:sldId xmlns:r="http://schemas.openxmlformats.org/officeDocument/2006/relationships" id="257" r:id="R38bc182368054a2d"/>
+    <p:sldId xmlns:r="http://schemas.openxmlformats.org/officeDocument/2006/relationships" id="256" r:id="Raa6b3ca4e4ba4d59"/>
+    <p:sldId xmlns:r="http://schemas.openxmlformats.org/officeDocument/2006/relationships" id="257" r:id="R7e1c56995e034d3f"/>
+    <p:sldId xmlns:r="http://schemas.openxmlformats.org/officeDocument/2006/relationships" id="258" r:id="R0cf8101012a24711"/>
   </p:sldIdLst>
   <p:sldSz cx="12192000" cy="6858000"/>
   <p:notesSz cx="6858000" cy="9144000"/>
@@ -653,6 +654,141 @@
 </p:notes>
 </file>
 
+<file path=ppt/notesSlides/notesSlide3.xml><?xml version="1.0" encoding="utf-8"?>
+<p:notes xmlns:p="http://schemas.openxmlformats.org/presentationml/2006/main">
+  <p:cSld>
+    <p:spTree>
+      <p:nvGrpSpPr>
+        <p:cNvPr id="1" name=""/>
+        <p:cNvGrpSpPr/>
+        <p:nvPr/>
+      </p:nvGrpSpPr>
+      <p:grpSpPr>
+        <a:xfrm xmlns:a="http://schemas.openxmlformats.org/drawingml/2006/main"/>
+      </p:grpSpPr>
+      <p:sp>
+        <p:nvSpPr>
+          <p:cNvPr id="2" name="Slide Image Placeholder 1"/>
+          <p:cNvSpPr>
+            <a:spLocks xmlns:a="http://schemas.openxmlformats.org/drawingml/2006/main" noGrp="1"/>
+          </p:cNvSpPr>
+          <p:nvPr>
+            <p:ph type="sldImg" idx="0"/>
+          </p:nvPr>
+        </p:nvSpPr>
+        <p:spPr/>
+      </p:sp>
+      <p:sp>
+        <p:nvSpPr>
+          <p:cNvPr id="3" name="Notes Placeholder 2"/>
+          <p:cNvSpPr>
+            <a:spLocks xmlns:a="http://schemas.openxmlformats.org/drawingml/2006/main" noGrp="1"/>
+          </p:cNvSpPr>
+          <p:nvPr>
+            <p:ph type="body" idx="1"/>
+          </p:nvPr>
+        </p:nvSpPr>
+        <p:spPr/>
+        <p:txBody>
+          <a:bodyPr xmlns:a="http://schemas.openxmlformats.org/drawingml/2006/main"/>
+          <a:lstStyle xmlns:a="http://schemas.openxmlformats.org/drawingml/2006/main"/>
+          <a:p xmlns:a="http://schemas.openxmlformats.org/drawingml/2006/main">
+            <a:r>
+              <a:t>Scenario 3 source: harness_aware_scenario_tracker.html.</a:t>
+            </a:r>
+          </a:p>
+          <a:p xmlns:a="http://schemas.openxmlformats.org/drawingml/2006/main">
+            <a:r>
+              <a:t/>
+            </a:r>
+          </a:p>
+          <a:p xmlns:a="http://schemas.openxmlformats.org/drawingml/2006/main">
+            <a:r>
+              <a:t>Setup: same 32 replay requests in both modes using the same generated timeline. The load generator creates enough concurrent long-context sessions to force KV eviction decisions. Baseline mode runs without value-aware eviction signals. Controller mode scores every replay-capable prefix as high, normal, or low value from harness signals, and SGLang's native priority radix eviction path performs the real eviction.</a:t>
+            </a:r>
+          </a:p>
+          <a:p xmlns:a="http://schemas.openxmlformats.org/drawingml/2006/main">
+            <a:r>
+              <a:t/>
+            </a:r>
+          </a:p>
+          <a:p xmlns:a="http://schemas.openxmlformats.org/drawingml/2006/main">
+            <a:r>
+              <a:t>Run: value_aware_eviction_all_requests_fixed_20260917_163518 compared no_prefetch against controller_value_aware_eviction.</a:t>
+            </a:r>
+          </a:p>
+          <a:p xmlns:a="http://schemas.openxmlformats.org/drawingml/2006/main">
+            <a:r>
+              <a:t/>
+            </a:r>
+          </a:p>
+          <a:p xmlns:a="http://schemas.openxmlformats.org/drawingml/2006/main">
+            <a:r>
+              <a:t>Results: Total TTFT improved from 482.3 s to 233.5 s, or 51.6%. Average replay TTFT improved from 15.1 s to 7.3 s. Total lateness improved from 1014.0 s to 659.9 s, or 34.9%. Average replay lateness improved from 31.7 s to 20.6 s. The trade-off is that the overall workload window increased from 205.6 s to 268.8 s, or 63.1 s longer.</a:t>
+            </a:r>
+          </a:p>
+          <a:p xmlns:a="http://schemas.openxmlformats.org/drawingml/2006/main">
+            <a:r>
+              <a:t/>
+            </a:r>
+          </a:p>
+          <a:p xmlns:a="http://schemas.openxmlformats.org/drawingml/2006/main">
+            <a:r>
+              <a:t>Mechanism evidence: value classes reached SGLang as 23 high, 16 normal, and 9 low values with zero mismatches. SGLang ran with radix priority eviction. Native SGLang and HiCache eviction events were observed: 324 device eviction events and 77 host eviction events.</a:t>
+            </a:r>
+          </a:p>
+          <a:p xmlns:a="http://schemas.openxmlformats.org/drawingml/2006/main">
+            <a:r>
+              <a:t/>
+            </a:r>
+          </a:p>
+          <a:p xmlns:a="http://schemas.openxmlformats.org/drawingml/2006/main">
+            <a:r>
+              <a:t>Important caveat: this produced a strong replay responsiveness win, but not a no-cost system win. The next tuning question is how to keep the TTFT and lateness benefit while reducing the workload-window cost.</a:t>
+            </a:r>
+          </a:p>
+          <a:p xmlns:a="http://schemas.openxmlformats.org/drawingml/2006/main">
+            <a:r>
+              <a:t/>
+            </a:r>
+          </a:p>
+          <a:p xmlns:a="http://schemas.openxmlformats.org/drawingml/2006/main">
+            <a:r>
+              <a:t>[Sources]</a:t>
+            </a:r>
+          </a:p>
+          <a:p xmlns:a="http://schemas.openxmlformats.org/drawingml/2006/main">
+            <a:r>
+              <a:t>Local file: /Users/oluwolejaiyeoba/Documents/GitHub/agentic_hardware/harness_aware_scenario_tracker.html</a:t>
+            </a:r>
+          </a:p>
+        </p:txBody>
+      </p:sp>
+      <p:sp>
+        <p:nvSpPr>
+          <p:cNvPr id="4" name="Slide Number Placeholder 3"/>
+          <p:cNvSpPr>
+            <a:spLocks xmlns:a="http://schemas.openxmlformats.org/drawingml/2006/main" noGrp="1"/>
+          </p:cNvSpPr>
+          <p:nvPr>
+            <p:ph type="sldNum" idx="5"/>
+          </p:nvPr>
+        </p:nvSpPr>
+        <p:spPr/>
+        <p:txBody>
+          <a:bodyPr xmlns:a="http://schemas.openxmlformats.org/drawingml/2006/main"/>
+          <a:lstStyle xmlns:a="http://schemas.openxmlformats.org/drawingml/2006/main"/>
+          <a:p xmlns:a="http://schemas.openxmlformats.org/drawingml/2006/main"/>
+        </p:txBody>
+      </p:sp>
+    </p:spTree>
+  </p:cSld>
+  <p:clrMapOvr>
+    <a:masterClrMapping xmlns:a="http://schemas.openxmlformats.org/drawingml/2006/main"/>
+  </p:clrMapOvr>
+</p:notes>
+</file>
+
 <file path=ppt/slideLayouts/slideLayout1.xml><?xml version="1.0" encoding="utf-8"?>
 <p:sldLayout xmlns:p="http://schemas.openxmlformats.org/presentationml/2006/main" type="title">
   <p:cSld name="Title Slide">
@@ -691,7 +827,7 @@
   </p:cSld>
   <p:clrMap bg1="lt1" tx1="dk1" bg2="lt2" tx2="dk2" accent1="accent1" accent2="accent2" accent3="accent3" accent4="accent4" accent5="accent5" accent6="accent6" hlink="hlink" folHlink="folHlink"/>
   <p:sldLayoutIdLst>
-    <p:sldLayoutId xmlns:r="http://schemas.openxmlformats.org/officeDocument/2006/relationships" id="2147483649" r:id="R0aae46e9e0994acb"/>
+    <p:sldLayoutId xmlns:r="http://schemas.openxmlformats.org/officeDocument/2006/relationships" id="2147483649" r:id="R8a016a2352d34d5b"/>
   </p:sldLayoutIdLst>
   <p:txStyles>
     <p:titleStyle>
@@ -1242,7 +1378,7 @@
           <p:cNvPr id="43" name="">
             <a:extLst xmlns:a="http://schemas.openxmlformats.org/drawingml/2006/main">
               <a:ext uri="{FF2B5EF4-FFF2-40B4-BE49-F238E27FC236}">
-                <a16:creationId xmlns:a16="http://schemas.microsoft.com/office/drawing/2014/main" id="{3E5BFDDC-854F-479C-B789-042F920DCBA6}"/>
+                <a16:creationId xmlns:a16="http://schemas.microsoft.com/office/drawing/2014/main" id="{501EFE3A-5D53-49A2-816A-B90BF906D85B}"/>
               </a:ext>
             </a:extLst>
           </p:cNvPr>
@@ -1300,7 +1436,7 @@
           <p:cNvPr id="2" name="">
             <a:extLst xmlns:a="http://schemas.openxmlformats.org/drawingml/2006/main">
               <a:ext uri="{FF2B5EF4-FFF2-40B4-BE49-F238E27FC236}">
-                <a16:creationId xmlns:a16="http://schemas.microsoft.com/office/drawing/2014/main" id="{8189BD98-975B-4937-A23D-E2B72247091C}"/>
+                <a16:creationId xmlns:a16="http://schemas.microsoft.com/office/drawing/2014/main" id="{04479EE1-9A1F-43CE-914D-DBFC9B6D6DA8}"/>
               </a:ext>
             </a:extLst>
           </p:cNvPr>
@@ -1358,7 +1494,7 @@
           <p:cNvPr id="3" name="">
             <a:extLst xmlns:a="http://schemas.openxmlformats.org/drawingml/2006/main">
               <a:ext uri="{FF2B5EF4-FFF2-40B4-BE49-F238E27FC236}">
-                <a16:creationId xmlns:a16="http://schemas.microsoft.com/office/drawing/2014/main" id="{BA4D5F7E-CCA2-4A24-8C4C-D263ED5FBF5A}"/>
+                <a16:creationId xmlns:a16="http://schemas.microsoft.com/office/drawing/2014/main" id="{B1E08D2C-CAB4-4E15-9DCB-9F12F15DA6BD}"/>
               </a:ext>
             </a:extLst>
           </p:cNvPr>
@@ -1416,7 +1552,7 @@
           <p:cNvPr id="4" name="">
             <a:extLst xmlns:a="http://schemas.openxmlformats.org/drawingml/2006/main">
               <a:ext uri="{FF2B5EF4-FFF2-40B4-BE49-F238E27FC236}">
-                <a16:creationId xmlns:a16="http://schemas.microsoft.com/office/drawing/2014/main" id="{A3DD0273-813C-4EDE-9303-AA0F76003D8D}"/>
+                <a16:creationId xmlns:a16="http://schemas.microsoft.com/office/drawing/2014/main" id="{0BC65DE1-9BA0-45F9-90E0-77277C659F3E}"/>
               </a:ext>
             </a:extLst>
           </p:cNvPr>
@@ -1447,7 +1583,7 @@
           <p:cNvPr id="5" name="">
             <a:extLst xmlns:a="http://schemas.openxmlformats.org/drawingml/2006/main">
               <a:ext uri="{FF2B5EF4-FFF2-40B4-BE49-F238E27FC236}">
-                <a16:creationId xmlns:a16="http://schemas.microsoft.com/office/drawing/2014/main" id="{8129A2CC-1CD8-48F0-9244-0DA34D7D30AB}"/>
+                <a16:creationId xmlns:a16="http://schemas.microsoft.com/office/drawing/2014/main" id="{AE85E1AE-D214-46A8-ADAE-465E6EC06442}"/>
               </a:ext>
             </a:extLst>
           </p:cNvPr>
@@ -1505,7 +1641,7 @@
           <p:cNvPr id="6" name="">
             <a:extLst xmlns:a="http://schemas.openxmlformats.org/drawingml/2006/main">
               <a:ext uri="{FF2B5EF4-FFF2-40B4-BE49-F238E27FC236}">
-                <a16:creationId xmlns:a16="http://schemas.microsoft.com/office/drawing/2014/main" id="{ACC5762C-C863-4AC6-B61E-073F8F0C1380}"/>
+                <a16:creationId xmlns:a16="http://schemas.microsoft.com/office/drawing/2014/main" id="{6CB4C420-622C-4B0D-9998-5254C12E0E8C}"/>
               </a:ext>
             </a:extLst>
           </p:cNvPr>
@@ -1538,7 +1674,7 @@
           <p:cNvPr id="7" name="">
             <a:extLst xmlns:a="http://schemas.openxmlformats.org/drawingml/2006/main">
               <a:ext uri="{FF2B5EF4-FFF2-40B4-BE49-F238E27FC236}">
-                <a16:creationId xmlns:a16="http://schemas.microsoft.com/office/drawing/2014/main" id="{3E225746-A7EC-409C-9C8E-F4FE7C3126AB}"/>
+                <a16:creationId xmlns:a16="http://schemas.microsoft.com/office/drawing/2014/main" id="{5E61760F-E135-48E1-97ED-78B18C4D9CE4}"/>
               </a:ext>
             </a:extLst>
           </p:cNvPr>
@@ -1596,7 +1732,7 @@
           <p:cNvPr id="8" name="">
             <a:extLst xmlns:a="http://schemas.openxmlformats.org/drawingml/2006/main">
               <a:ext uri="{FF2B5EF4-FFF2-40B4-BE49-F238E27FC236}">
-                <a16:creationId xmlns:a16="http://schemas.microsoft.com/office/drawing/2014/main" id="{1EDA2550-D0CC-4525-B195-83C66712C35D}"/>
+                <a16:creationId xmlns:a16="http://schemas.microsoft.com/office/drawing/2014/main" id="{526CE2D4-8997-42B0-A19F-7D75F35A3785}"/>
               </a:ext>
             </a:extLst>
           </p:cNvPr>
@@ -1629,7 +1765,7 @@
           <p:cNvPr id="9" name="">
             <a:extLst xmlns:a="http://schemas.openxmlformats.org/drawingml/2006/main">
               <a:ext uri="{FF2B5EF4-FFF2-40B4-BE49-F238E27FC236}">
-                <a16:creationId xmlns:a16="http://schemas.microsoft.com/office/drawing/2014/main" id="{556C66F0-91CB-4BAD-B784-1EB68FA1105E}"/>
+                <a16:creationId xmlns:a16="http://schemas.microsoft.com/office/drawing/2014/main" id="{2C56B02E-AA47-4436-AC78-DC9D07728B7E}"/>
               </a:ext>
             </a:extLst>
           </p:cNvPr>
@@ -1687,7 +1823,7 @@
           <p:cNvPr id="10" name="">
             <a:extLst xmlns:a="http://schemas.openxmlformats.org/drawingml/2006/main">
               <a:ext uri="{FF2B5EF4-FFF2-40B4-BE49-F238E27FC236}">
-                <a16:creationId xmlns:a16="http://schemas.microsoft.com/office/drawing/2014/main" id="{434C604C-1649-4DA2-8274-13BA2A27DBCA}"/>
+                <a16:creationId xmlns:a16="http://schemas.microsoft.com/office/drawing/2014/main" id="{23378B31-01F3-4382-A123-93DD8D38A816}"/>
               </a:ext>
             </a:extLst>
           </p:cNvPr>
@@ -1720,7 +1856,7 @@
           <p:cNvPr id="11" name="">
             <a:extLst xmlns:a="http://schemas.openxmlformats.org/drawingml/2006/main">
               <a:ext uri="{FF2B5EF4-FFF2-40B4-BE49-F238E27FC236}">
-                <a16:creationId xmlns:a16="http://schemas.microsoft.com/office/drawing/2014/main" id="{E113FB35-58D6-459F-8D14-8EC973A2D22D}"/>
+                <a16:creationId xmlns:a16="http://schemas.microsoft.com/office/drawing/2014/main" id="{26C7D899-243B-4F91-AEC8-83E27F58B088}"/>
               </a:ext>
             </a:extLst>
           </p:cNvPr>
@@ -1778,7 +1914,7 @@
           <p:cNvPr id="12" name="">
             <a:extLst xmlns:a="http://schemas.openxmlformats.org/drawingml/2006/main">
               <a:ext uri="{FF2B5EF4-FFF2-40B4-BE49-F238E27FC236}">
-                <a16:creationId xmlns:a16="http://schemas.microsoft.com/office/drawing/2014/main" id="{3F7F4F3D-774E-4716-A7EB-7701DF4C77E8}"/>
+                <a16:creationId xmlns:a16="http://schemas.microsoft.com/office/drawing/2014/main" id="{169B31E3-F654-4125-8B7A-5001C5A51C9F}"/>
               </a:ext>
             </a:extLst>
           </p:cNvPr>
@@ -1811,7 +1947,7 @@
           <p:cNvPr id="13" name="">
             <a:extLst xmlns:a="http://schemas.openxmlformats.org/drawingml/2006/main">
               <a:ext uri="{FF2B5EF4-FFF2-40B4-BE49-F238E27FC236}">
-                <a16:creationId xmlns:a16="http://schemas.microsoft.com/office/drawing/2014/main" id="{870A4143-CF12-4C22-B597-9504D72CD4AE}"/>
+                <a16:creationId xmlns:a16="http://schemas.microsoft.com/office/drawing/2014/main" id="{3A7C0F1F-D7C2-40A2-A2C2-303798302BE0}"/>
               </a:ext>
             </a:extLst>
           </p:cNvPr>
@@ -1869,7 +2005,7 @@
           <p:cNvPr id="14" name="">
             <a:extLst xmlns:a="http://schemas.openxmlformats.org/drawingml/2006/main">
               <a:ext uri="{FF2B5EF4-FFF2-40B4-BE49-F238E27FC236}">
-                <a16:creationId xmlns:a16="http://schemas.microsoft.com/office/drawing/2014/main" id="{D4432DF4-5FE2-4583-9600-7ABEE7813D69}"/>
+                <a16:creationId xmlns:a16="http://schemas.microsoft.com/office/drawing/2014/main" id="{8F4517CD-017F-49E1-85D6-A17911D81258}"/>
               </a:ext>
             </a:extLst>
           </p:cNvPr>
@@ -1902,7 +2038,7 @@
           <p:cNvPr id="15" name="">
             <a:extLst xmlns:a="http://schemas.openxmlformats.org/drawingml/2006/main">
               <a:ext uri="{FF2B5EF4-FFF2-40B4-BE49-F238E27FC236}">
-                <a16:creationId xmlns:a16="http://schemas.microsoft.com/office/drawing/2014/main" id="{87D4B017-FAFC-4FD2-A70C-CAC7438D3273}"/>
+                <a16:creationId xmlns:a16="http://schemas.microsoft.com/office/drawing/2014/main" id="{B35FBC2F-8D30-464B-8D0D-C0307803441A}"/>
               </a:ext>
             </a:extLst>
           </p:cNvPr>
@@ -1960,7 +2096,7 @@
           <p:cNvPr id="16" name="">
             <a:extLst xmlns:a="http://schemas.openxmlformats.org/drawingml/2006/main">
               <a:ext uri="{FF2B5EF4-FFF2-40B4-BE49-F238E27FC236}">
-                <a16:creationId xmlns:a16="http://schemas.microsoft.com/office/drawing/2014/main" id="{8122D032-8E83-4EB2-9AEB-3A4077A10A13}"/>
+                <a16:creationId xmlns:a16="http://schemas.microsoft.com/office/drawing/2014/main" id="{E5A9D8C3-8292-4E67-A035-E1E52604F76A}"/>
               </a:ext>
             </a:extLst>
           </p:cNvPr>
@@ -2018,7 +2154,7 @@
           <p:cNvPr id="17" name="">
             <a:extLst xmlns:a="http://schemas.openxmlformats.org/drawingml/2006/main">
               <a:ext uri="{FF2B5EF4-FFF2-40B4-BE49-F238E27FC236}">
-                <a16:creationId xmlns:a16="http://schemas.microsoft.com/office/drawing/2014/main" id="{C6DD190F-8D1A-4E45-ABAA-608DAC8E5174}"/>
+                <a16:creationId xmlns:a16="http://schemas.microsoft.com/office/drawing/2014/main" id="{3250CB48-971A-404B-BB86-21FE5C624AE3}"/>
               </a:ext>
             </a:extLst>
           </p:cNvPr>
@@ -2076,7 +2212,7 @@
           <p:cNvPr id="18" name="">
             <a:extLst xmlns:a="http://schemas.openxmlformats.org/drawingml/2006/main">
               <a:ext uri="{FF2B5EF4-FFF2-40B4-BE49-F238E27FC236}">
-                <a16:creationId xmlns:a16="http://schemas.microsoft.com/office/drawing/2014/main" id="{8B6C80D8-7043-40FD-9EB2-E099DA23A4C5}"/>
+                <a16:creationId xmlns:a16="http://schemas.microsoft.com/office/drawing/2014/main" id="{59A3EDC5-2A41-46B5-A020-523924930411}"/>
               </a:ext>
             </a:extLst>
           </p:cNvPr>
@@ -2134,7 +2270,7 @@
           <p:cNvPr id="19" name="">
             <a:extLst xmlns:a="http://schemas.openxmlformats.org/drawingml/2006/main">
               <a:ext uri="{FF2B5EF4-FFF2-40B4-BE49-F238E27FC236}">
-                <a16:creationId xmlns:a16="http://schemas.microsoft.com/office/drawing/2014/main" id="{21E7228A-1E43-4ADD-941E-661A2864D01E}"/>
+                <a16:creationId xmlns:a16="http://schemas.microsoft.com/office/drawing/2014/main" id="{EEBFA014-DF7A-484D-B374-5857A4C5F055}"/>
               </a:ext>
             </a:extLst>
           </p:cNvPr>
@@ -2167,7 +2303,7 @@
           <p:cNvPr id="20" name="">
             <a:extLst xmlns:a="http://schemas.openxmlformats.org/drawingml/2006/main">
               <a:ext uri="{FF2B5EF4-FFF2-40B4-BE49-F238E27FC236}">
-                <a16:creationId xmlns:a16="http://schemas.microsoft.com/office/drawing/2014/main" id="{8AB8A31E-AEEA-4911-860D-A409E041F74F}"/>
+                <a16:creationId xmlns:a16="http://schemas.microsoft.com/office/drawing/2014/main" id="{3776D0A7-5090-476F-B01D-EDEC51A945EE}"/>
               </a:ext>
             </a:extLst>
           </p:cNvPr>
@@ -2225,7 +2361,7 @@
           <p:cNvPr id="21" name="">
             <a:extLst xmlns:a="http://schemas.openxmlformats.org/drawingml/2006/main">
               <a:ext uri="{FF2B5EF4-FFF2-40B4-BE49-F238E27FC236}">
-                <a16:creationId xmlns:a16="http://schemas.microsoft.com/office/drawing/2014/main" id="{BE29960D-00DD-4148-B2B1-C10CB4902F3F}"/>
+                <a16:creationId xmlns:a16="http://schemas.microsoft.com/office/drawing/2014/main" id="{FBDCD185-D268-4D40-B9B5-6A8DCBE67EAF}"/>
               </a:ext>
             </a:extLst>
           </p:cNvPr>
@@ -2283,7 +2419,7 @@
           <p:cNvPr id="22" name="">
             <a:extLst xmlns:a="http://schemas.openxmlformats.org/drawingml/2006/main">
               <a:ext uri="{FF2B5EF4-FFF2-40B4-BE49-F238E27FC236}">
-                <a16:creationId xmlns:a16="http://schemas.microsoft.com/office/drawing/2014/main" id="{47975472-5360-47FA-8C16-225E444D84FB}"/>
+                <a16:creationId xmlns:a16="http://schemas.microsoft.com/office/drawing/2014/main" id="{53CB441C-0545-42B0-900B-BE61A86C6607}"/>
               </a:ext>
             </a:extLst>
           </p:cNvPr>
@@ -2341,7 +2477,7 @@
           <p:cNvPr id="23" name="">
             <a:extLst xmlns:a="http://schemas.openxmlformats.org/drawingml/2006/main">
               <a:ext uri="{FF2B5EF4-FFF2-40B4-BE49-F238E27FC236}">
-                <a16:creationId xmlns:a16="http://schemas.microsoft.com/office/drawing/2014/main" id="{04F39A30-A954-4F80-B53A-EF2F6C7C204B}"/>
+                <a16:creationId xmlns:a16="http://schemas.microsoft.com/office/drawing/2014/main" id="{9765193B-260C-4FAE-A962-2D48239E6863}"/>
               </a:ext>
             </a:extLst>
           </p:cNvPr>
@@ -2374,7 +2510,7 @@
           <p:cNvPr id="24" name="">
             <a:extLst xmlns:a="http://schemas.openxmlformats.org/drawingml/2006/main">
               <a:ext uri="{FF2B5EF4-FFF2-40B4-BE49-F238E27FC236}">
-                <a16:creationId xmlns:a16="http://schemas.microsoft.com/office/drawing/2014/main" id="{1B716832-050D-4B16-ABD0-C394F86B41F2}"/>
+                <a16:creationId xmlns:a16="http://schemas.microsoft.com/office/drawing/2014/main" id="{57649084-AD29-43C6-A954-0D3CA31BD79B}"/>
               </a:ext>
             </a:extLst>
           </p:cNvPr>
@@ -2432,7 +2568,7 @@
           <p:cNvPr id="25" name="">
             <a:extLst xmlns:a="http://schemas.openxmlformats.org/drawingml/2006/main">
               <a:ext uri="{FF2B5EF4-FFF2-40B4-BE49-F238E27FC236}">
-                <a16:creationId xmlns:a16="http://schemas.microsoft.com/office/drawing/2014/main" id="{1626C3FF-5ECF-4043-B228-E171C085FC45}"/>
+                <a16:creationId xmlns:a16="http://schemas.microsoft.com/office/drawing/2014/main" id="{F26F7CA0-C106-4ABF-A41E-4FA06F101686}"/>
               </a:ext>
             </a:extLst>
           </p:cNvPr>
@@ -2490,7 +2626,7 @@
           <p:cNvPr id="26" name="">
             <a:extLst xmlns:a="http://schemas.openxmlformats.org/drawingml/2006/main">
               <a:ext uri="{FF2B5EF4-FFF2-40B4-BE49-F238E27FC236}">
-                <a16:creationId xmlns:a16="http://schemas.microsoft.com/office/drawing/2014/main" id="{354BD9FA-91F9-45F6-85F7-A06AF8489FFC}"/>
+                <a16:creationId xmlns:a16="http://schemas.microsoft.com/office/drawing/2014/main" id="{D467DF82-1AD7-4288-A8D0-ACA75B34389F}"/>
               </a:ext>
             </a:extLst>
           </p:cNvPr>
@@ -2548,7 +2684,7 @@
           <p:cNvPr id="27" name="">
             <a:extLst xmlns:a="http://schemas.openxmlformats.org/drawingml/2006/main">
               <a:ext uri="{FF2B5EF4-FFF2-40B4-BE49-F238E27FC236}">
-                <a16:creationId xmlns:a16="http://schemas.microsoft.com/office/drawing/2014/main" id="{AF727695-547F-44B0-9FD9-3081249536EA}"/>
+                <a16:creationId xmlns:a16="http://schemas.microsoft.com/office/drawing/2014/main" id="{9C2A938E-8F42-4ECB-87BB-B55E1708B235}"/>
               </a:ext>
             </a:extLst>
           </p:cNvPr>
@@ -2581,7 +2717,7 @@
           <p:cNvPr id="28" name="">
             <a:extLst xmlns:a="http://schemas.openxmlformats.org/drawingml/2006/main">
               <a:ext uri="{FF2B5EF4-FFF2-40B4-BE49-F238E27FC236}">
-                <a16:creationId xmlns:a16="http://schemas.microsoft.com/office/drawing/2014/main" id="{6A7F1523-D99D-48A8-BA2B-279610E435BA}"/>
+                <a16:creationId xmlns:a16="http://schemas.microsoft.com/office/drawing/2014/main" id="{CECADDB1-2AFB-4FD1-A7CD-907FBDE78105}"/>
               </a:ext>
             </a:extLst>
           </p:cNvPr>
@@ -2639,7 +2775,7 @@
           <p:cNvPr id="29" name="">
             <a:extLst xmlns:a="http://schemas.openxmlformats.org/drawingml/2006/main">
               <a:ext uri="{FF2B5EF4-FFF2-40B4-BE49-F238E27FC236}">
-                <a16:creationId xmlns:a16="http://schemas.microsoft.com/office/drawing/2014/main" id="{5FE09E21-210A-4422-A7DE-26A81289AB28}"/>
+                <a16:creationId xmlns:a16="http://schemas.microsoft.com/office/drawing/2014/main" id="{4D8320EC-2EB6-44C0-8BC2-40FECCC21DF3}"/>
               </a:ext>
             </a:extLst>
           </p:cNvPr>
@@ -2697,7 +2833,7 @@
           <p:cNvPr id="30" name="">
             <a:extLst xmlns:a="http://schemas.openxmlformats.org/drawingml/2006/main">
               <a:ext uri="{FF2B5EF4-FFF2-40B4-BE49-F238E27FC236}">
-                <a16:creationId xmlns:a16="http://schemas.microsoft.com/office/drawing/2014/main" id="{B5CCD1DB-302D-4DAE-AB7A-FA1565FB9317}"/>
+                <a16:creationId xmlns:a16="http://schemas.microsoft.com/office/drawing/2014/main" id="{0EBF8321-D64D-44E1-A1C1-9EB6BB0F6466}"/>
               </a:ext>
             </a:extLst>
           </p:cNvPr>
@@ -2755,7 +2891,7 @@
           <p:cNvPr id="31" name="">
             <a:extLst xmlns:a="http://schemas.openxmlformats.org/drawingml/2006/main">
               <a:ext uri="{FF2B5EF4-FFF2-40B4-BE49-F238E27FC236}">
-                <a16:creationId xmlns:a16="http://schemas.microsoft.com/office/drawing/2014/main" id="{9EF70F5A-FF7B-47A6-81E0-B256151E6988}"/>
+                <a16:creationId xmlns:a16="http://schemas.microsoft.com/office/drawing/2014/main" id="{CEC83AF0-6B53-4E3C-915E-024BB7A8AEED}"/>
               </a:ext>
             </a:extLst>
           </p:cNvPr>
@@ -2788,7 +2924,7 @@
           <p:cNvPr id="32" name="">
             <a:extLst xmlns:a="http://schemas.openxmlformats.org/drawingml/2006/main">
               <a:ext uri="{FF2B5EF4-FFF2-40B4-BE49-F238E27FC236}">
-                <a16:creationId xmlns:a16="http://schemas.microsoft.com/office/drawing/2014/main" id="{AE3048C4-6F38-4B94-A925-4CB63433B401}"/>
+                <a16:creationId xmlns:a16="http://schemas.microsoft.com/office/drawing/2014/main" id="{761673CD-3B24-413A-87ED-024E3A045041}"/>
               </a:ext>
             </a:extLst>
           </p:cNvPr>
@@ -2846,7 +2982,7 @@
           <p:cNvPr id="33" name="">
             <a:extLst xmlns:a="http://schemas.openxmlformats.org/drawingml/2006/main">
               <a:ext uri="{FF2B5EF4-FFF2-40B4-BE49-F238E27FC236}">
-                <a16:creationId xmlns:a16="http://schemas.microsoft.com/office/drawing/2014/main" id="{582DE729-174F-4F82-9255-00541BF6574A}"/>
+                <a16:creationId xmlns:a16="http://schemas.microsoft.com/office/drawing/2014/main" id="{C83F8DE5-CEBE-46FD-ABC1-4D6B9D843D5B}"/>
               </a:ext>
             </a:extLst>
           </p:cNvPr>
@@ -2904,7 +3040,7 @@
           <p:cNvPr id="34" name="">
             <a:extLst xmlns:a="http://schemas.openxmlformats.org/drawingml/2006/main">
               <a:ext uri="{FF2B5EF4-FFF2-40B4-BE49-F238E27FC236}">
-                <a16:creationId xmlns:a16="http://schemas.microsoft.com/office/drawing/2014/main" id="{F55CAB25-B66D-4C17-9938-559B1FFAAFA5}"/>
+                <a16:creationId xmlns:a16="http://schemas.microsoft.com/office/drawing/2014/main" id="{B80EDE76-F5C0-443C-9470-7FED337646B9}"/>
               </a:ext>
             </a:extLst>
           </p:cNvPr>
@@ -2962,7 +3098,7 @@
           <p:cNvPr id="35" name="">
             <a:extLst xmlns:a="http://schemas.openxmlformats.org/drawingml/2006/main">
               <a:ext uri="{FF2B5EF4-FFF2-40B4-BE49-F238E27FC236}">
-                <a16:creationId xmlns:a16="http://schemas.microsoft.com/office/drawing/2014/main" id="{5AD15735-BE81-42C7-B4B3-B84A08890BF2}"/>
+                <a16:creationId xmlns:a16="http://schemas.microsoft.com/office/drawing/2014/main" id="{912FED48-FD68-4DF1-BD57-67CD233509FE}"/>
               </a:ext>
             </a:extLst>
           </p:cNvPr>
@@ -2995,7 +3131,7 @@
           <p:cNvPr id="36" name="">
             <a:extLst xmlns:a="http://schemas.openxmlformats.org/drawingml/2006/main">
               <a:ext uri="{FF2B5EF4-FFF2-40B4-BE49-F238E27FC236}">
-                <a16:creationId xmlns:a16="http://schemas.microsoft.com/office/drawing/2014/main" id="{D248C5B8-43A8-4B17-94F9-B20AB394260A}"/>
+                <a16:creationId xmlns:a16="http://schemas.microsoft.com/office/drawing/2014/main" id="{FCE79FED-98D5-40FD-BA8F-28310D4A1230}"/>
               </a:ext>
             </a:extLst>
           </p:cNvPr>
@@ -3053,7 +3189,7 @@
           <p:cNvPr id="37" name="">
             <a:extLst xmlns:a="http://schemas.openxmlformats.org/drawingml/2006/main">
               <a:ext uri="{FF2B5EF4-FFF2-40B4-BE49-F238E27FC236}">
-                <a16:creationId xmlns:a16="http://schemas.microsoft.com/office/drawing/2014/main" id="{B9930680-BF8A-4148-AB26-C5E40965885F}"/>
+                <a16:creationId xmlns:a16="http://schemas.microsoft.com/office/drawing/2014/main" id="{09DBB3E3-CD62-44B3-9A13-6E027CB58E30}"/>
               </a:ext>
             </a:extLst>
           </p:cNvPr>
@@ -3111,7 +3247,7 @@
           <p:cNvPr id="38" name="">
             <a:extLst xmlns:a="http://schemas.openxmlformats.org/drawingml/2006/main">
               <a:ext uri="{FF2B5EF4-FFF2-40B4-BE49-F238E27FC236}">
-                <a16:creationId xmlns:a16="http://schemas.microsoft.com/office/drawing/2014/main" id="{EE4625A7-5DDB-4B92-8C7A-2801F45E2AD9}"/>
+                <a16:creationId xmlns:a16="http://schemas.microsoft.com/office/drawing/2014/main" id="{4B8A5FBA-756A-4BBA-B2C4-96092C6839D3}"/>
               </a:ext>
             </a:extLst>
           </p:cNvPr>
@@ -3169,7 +3305,7 @@
           <p:cNvPr id="39" name="">
             <a:extLst xmlns:a="http://schemas.openxmlformats.org/drawingml/2006/main">
               <a:ext uri="{FF2B5EF4-FFF2-40B4-BE49-F238E27FC236}">
-                <a16:creationId xmlns:a16="http://schemas.microsoft.com/office/drawing/2014/main" id="{AEB7E764-CEE2-4FEA-B785-ED2DDAE2AACA}"/>
+                <a16:creationId xmlns:a16="http://schemas.microsoft.com/office/drawing/2014/main" id="{FDEF2E8B-3ECA-4758-AF8B-ABB588CB2210}"/>
               </a:ext>
             </a:extLst>
           </p:cNvPr>
@@ -3200,7 +3336,7 @@
           <p:cNvPr id="40" name="">
             <a:extLst xmlns:a="http://schemas.openxmlformats.org/drawingml/2006/main">
               <a:ext uri="{FF2B5EF4-FFF2-40B4-BE49-F238E27FC236}">
-                <a16:creationId xmlns:a16="http://schemas.microsoft.com/office/drawing/2014/main" id="{92EAD9D7-B58A-4FBA-BD39-963C10414D88}"/>
+                <a16:creationId xmlns:a16="http://schemas.microsoft.com/office/drawing/2014/main" id="{10413AE6-8D9C-44DF-A249-49C9BF511BFC}"/>
               </a:ext>
             </a:extLst>
           </p:cNvPr>
@@ -3258,7 +3394,7 @@
           <p:cNvPr id="41" name="">
             <a:extLst xmlns:a="http://schemas.openxmlformats.org/drawingml/2006/main">
               <a:ext uri="{FF2B5EF4-FFF2-40B4-BE49-F238E27FC236}">
-                <a16:creationId xmlns:a16="http://schemas.microsoft.com/office/drawing/2014/main" id="{42DA4C41-3BDE-418E-8E69-143EBBC3D873}"/>
+                <a16:creationId xmlns:a16="http://schemas.microsoft.com/office/drawing/2014/main" id="{68A49374-474D-445C-B46A-E00964FABC07}"/>
               </a:ext>
             </a:extLst>
           </p:cNvPr>
@@ -3316,7 +3452,7 @@
           <p:cNvPr id="42" name="">
             <a:extLst xmlns:a="http://schemas.openxmlformats.org/drawingml/2006/main">
               <a:ext uri="{FF2B5EF4-FFF2-40B4-BE49-F238E27FC236}">
-                <a16:creationId xmlns:a16="http://schemas.microsoft.com/office/drawing/2014/main" id="{8DFCDEC8-93A3-4BC8-A75E-4BA33FFCD1A2}"/>
+                <a16:creationId xmlns:a16="http://schemas.microsoft.com/office/drawing/2014/main" id="{E685D8DF-0652-4918-A945-4466A34694F9}"/>
               </a:ext>
             </a:extLst>
           </p:cNvPr>
@@ -3372,7 +3508,7 @@
     </p:spTree>
     <p:extLst>
       <p:ext uri="{BB962C8B-B14F-4D97-AF65-F5344CB8AC3E}">
-        <p14:creationId xmlns:p14="http://schemas.microsoft.com/office/powerpoint/2010/main" val="1969905567"/>
+        <p14:creationId xmlns:p14="http://schemas.microsoft.com/office/powerpoint/2010/main" val="31888467"/>
       </p:ext>
     </p:extLst>
   </p:cSld>
@@ -3403,7 +3539,7 @@
           <p:cNvPr id="47" name="">
             <a:extLst xmlns:a="http://schemas.openxmlformats.org/drawingml/2006/main">
               <a:ext uri="{FF2B5EF4-FFF2-40B4-BE49-F238E27FC236}">
-                <a16:creationId xmlns:a16="http://schemas.microsoft.com/office/drawing/2014/main" id="{78B81638-D806-44CD-A3B3-966931196A27}"/>
+                <a16:creationId xmlns:a16="http://schemas.microsoft.com/office/drawing/2014/main" id="{E0B451F9-1290-4384-8359-C1FD85E33F64}"/>
               </a:ext>
             </a:extLst>
           </p:cNvPr>
@@ -3461,7 +3597,7 @@
           <p:cNvPr id="2" name="">
             <a:extLst xmlns:a="http://schemas.openxmlformats.org/drawingml/2006/main">
               <a:ext uri="{FF2B5EF4-FFF2-40B4-BE49-F238E27FC236}">
-                <a16:creationId xmlns:a16="http://schemas.microsoft.com/office/drawing/2014/main" id="{7D173C4D-D683-42CC-BA80-CFE2636A18A4}"/>
+                <a16:creationId xmlns:a16="http://schemas.microsoft.com/office/drawing/2014/main" id="{564617A7-6086-4EA1-8B9F-A554D076269B}"/>
               </a:ext>
             </a:extLst>
           </p:cNvPr>
@@ -3519,7 +3655,7 @@
           <p:cNvPr id="3" name="">
             <a:extLst xmlns:a="http://schemas.openxmlformats.org/drawingml/2006/main">
               <a:ext uri="{FF2B5EF4-FFF2-40B4-BE49-F238E27FC236}">
-                <a16:creationId xmlns:a16="http://schemas.microsoft.com/office/drawing/2014/main" id="{F1EFEA39-C1F4-436E-BDE5-9795D497CAE4}"/>
+                <a16:creationId xmlns:a16="http://schemas.microsoft.com/office/drawing/2014/main" id="{D6D3DC21-989E-4397-8157-2EC78F5F4394}"/>
               </a:ext>
             </a:extLst>
           </p:cNvPr>
@@ -3577,7 +3713,7 @@
           <p:cNvPr id="4" name="">
             <a:extLst xmlns:a="http://schemas.openxmlformats.org/drawingml/2006/main">
               <a:ext uri="{FF2B5EF4-FFF2-40B4-BE49-F238E27FC236}">
-                <a16:creationId xmlns:a16="http://schemas.microsoft.com/office/drawing/2014/main" id="{A66E4D4A-C04E-4609-8386-266BE5D135C0}"/>
+                <a16:creationId xmlns:a16="http://schemas.microsoft.com/office/drawing/2014/main" id="{2560B120-1A3E-4142-A536-8D658E27DF94}"/>
               </a:ext>
             </a:extLst>
           </p:cNvPr>
@@ -3608,7 +3744,7 @@
           <p:cNvPr id="5" name="">
             <a:extLst xmlns:a="http://schemas.openxmlformats.org/drawingml/2006/main">
               <a:ext uri="{FF2B5EF4-FFF2-40B4-BE49-F238E27FC236}">
-                <a16:creationId xmlns:a16="http://schemas.microsoft.com/office/drawing/2014/main" id="{56450237-F0E3-487E-A67F-30D23EA35102}"/>
+                <a16:creationId xmlns:a16="http://schemas.microsoft.com/office/drawing/2014/main" id="{5A4E957A-7F5B-4038-8B8D-1782AC1B93CE}"/>
               </a:ext>
             </a:extLst>
           </p:cNvPr>
@@ -3666,7 +3802,7 @@
           <p:cNvPr id="6" name="">
             <a:extLst xmlns:a="http://schemas.openxmlformats.org/drawingml/2006/main">
               <a:ext uri="{FF2B5EF4-FFF2-40B4-BE49-F238E27FC236}">
-                <a16:creationId xmlns:a16="http://schemas.microsoft.com/office/drawing/2014/main" id="{CA5448EB-88A9-46A4-9CAE-89D079D3C5D4}"/>
+                <a16:creationId xmlns:a16="http://schemas.microsoft.com/office/drawing/2014/main" id="{5B516D41-B236-436E-A5BD-EEFDBFBC6337}"/>
               </a:ext>
             </a:extLst>
           </p:cNvPr>
@@ -3699,7 +3835,7 @@
           <p:cNvPr id="7" name="">
             <a:extLst xmlns:a="http://schemas.openxmlformats.org/drawingml/2006/main">
               <a:ext uri="{FF2B5EF4-FFF2-40B4-BE49-F238E27FC236}">
-                <a16:creationId xmlns:a16="http://schemas.microsoft.com/office/drawing/2014/main" id="{AC98C01F-52E2-4D40-816A-4B9DE6BB4AB6}"/>
+                <a16:creationId xmlns:a16="http://schemas.microsoft.com/office/drawing/2014/main" id="{103FFF5D-09AF-419B-BEA6-07A9D6362215}"/>
               </a:ext>
             </a:extLst>
           </p:cNvPr>
@@ -3757,7 +3893,7 @@
           <p:cNvPr id="8" name="">
             <a:extLst xmlns:a="http://schemas.openxmlformats.org/drawingml/2006/main">
               <a:ext uri="{FF2B5EF4-FFF2-40B4-BE49-F238E27FC236}">
-                <a16:creationId xmlns:a16="http://schemas.microsoft.com/office/drawing/2014/main" id="{FEC72C88-0DD2-4F7D-B254-06BD851A300B}"/>
+                <a16:creationId xmlns:a16="http://schemas.microsoft.com/office/drawing/2014/main" id="{9B369722-A7BB-4C89-BADD-2241D022A2F1}"/>
               </a:ext>
             </a:extLst>
           </p:cNvPr>
@@ -3790,7 +3926,7 @@
           <p:cNvPr id="9" name="">
             <a:extLst xmlns:a="http://schemas.openxmlformats.org/drawingml/2006/main">
               <a:ext uri="{FF2B5EF4-FFF2-40B4-BE49-F238E27FC236}">
-                <a16:creationId xmlns:a16="http://schemas.microsoft.com/office/drawing/2014/main" id="{CB168FE3-C093-4CB8-85E1-A20E5D099233}"/>
+                <a16:creationId xmlns:a16="http://schemas.microsoft.com/office/drawing/2014/main" id="{45F4C7CA-D71D-45F3-9297-32A825AAE948}"/>
               </a:ext>
             </a:extLst>
           </p:cNvPr>
@@ -3848,7 +3984,7 @@
           <p:cNvPr id="10" name="">
             <a:extLst xmlns:a="http://schemas.openxmlformats.org/drawingml/2006/main">
               <a:ext uri="{FF2B5EF4-FFF2-40B4-BE49-F238E27FC236}">
-                <a16:creationId xmlns:a16="http://schemas.microsoft.com/office/drawing/2014/main" id="{62B33604-BD31-45B2-9B1C-434018DCE2F0}"/>
+                <a16:creationId xmlns:a16="http://schemas.microsoft.com/office/drawing/2014/main" id="{D2AB9321-9699-4A03-A00D-5F99D3CA4848}"/>
               </a:ext>
             </a:extLst>
           </p:cNvPr>
@@ -3881,7 +4017,7 @@
           <p:cNvPr id="11" name="">
             <a:extLst xmlns:a="http://schemas.openxmlformats.org/drawingml/2006/main">
               <a:ext uri="{FF2B5EF4-FFF2-40B4-BE49-F238E27FC236}">
-                <a16:creationId xmlns:a16="http://schemas.microsoft.com/office/drawing/2014/main" id="{BE598E45-29F2-4A71-AFE8-C41FA5AD4D3A}"/>
+                <a16:creationId xmlns:a16="http://schemas.microsoft.com/office/drawing/2014/main" id="{6A7F2BD3-E0CD-4ED0-B76E-D0DE12A6EC81}"/>
               </a:ext>
             </a:extLst>
           </p:cNvPr>
@@ -3939,7 +4075,7 @@
           <p:cNvPr id="12" name="">
             <a:extLst xmlns:a="http://schemas.openxmlformats.org/drawingml/2006/main">
               <a:ext uri="{FF2B5EF4-FFF2-40B4-BE49-F238E27FC236}">
-                <a16:creationId xmlns:a16="http://schemas.microsoft.com/office/drawing/2014/main" id="{F870B90B-305D-4F78-B04A-AE87E8B2CFB5}"/>
+                <a16:creationId xmlns:a16="http://schemas.microsoft.com/office/drawing/2014/main" id="{324A716E-535E-4904-8148-B3F258E4DBA1}"/>
               </a:ext>
             </a:extLst>
           </p:cNvPr>
@@ -3972,7 +4108,7 @@
           <p:cNvPr id="13" name="">
             <a:extLst xmlns:a="http://schemas.openxmlformats.org/drawingml/2006/main">
               <a:ext uri="{FF2B5EF4-FFF2-40B4-BE49-F238E27FC236}">
-                <a16:creationId xmlns:a16="http://schemas.microsoft.com/office/drawing/2014/main" id="{906A963D-F67F-44A8-9BEF-7E10CEC2C94B}"/>
+                <a16:creationId xmlns:a16="http://schemas.microsoft.com/office/drawing/2014/main" id="{04413196-4E0A-4E84-9D81-92612852B58A}"/>
               </a:ext>
             </a:extLst>
           </p:cNvPr>
@@ -4030,7 +4166,7 @@
           <p:cNvPr id="14" name="">
             <a:extLst xmlns:a="http://schemas.openxmlformats.org/drawingml/2006/main">
               <a:ext uri="{FF2B5EF4-FFF2-40B4-BE49-F238E27FC236}">
-                <a16:creationId xmlns:a16="http://schemas.microsoft.com/office/drawing/2014/main" id="{323F4619-4DB1-4D00-A526-5052F6B54177}"/>
+                <a16:creationId xmlns:a16="http://schemas.microsoft.com/office/drawing/2014/main" id="{EDDF3B48-80AC-4450-BAA3-645C3EEA521D}"/>
               </a:ext>
             </a:extLst>
           </p:cNvPr>
@@ -4063,7 +4199,7 @@
           <p:cNvPr id="15" name="">
             <a:extLst xmlns:a="http://schemas.openxmlformats.org/drawingml/2006/main">
               <a:ext uri="{FF2B5EF4-FFF2-40B4-BE49-F238E27FC236}">
-                <a16:creationId xmlns:a16="http://schemas.microsoft.com/office/drawing/2014/main" id="{2602F6A4-F9A8-4FC9-A700-6B7183BC23FC}"/>
+                <a16:creationId xmlns:a16="http://schemas.microsoft.com/office/drawing/2014/main" id="{ED2B3D40-69FE-412E-853B-D0B3E0AA606A}"/>
               </a:ext>
             </a:extLst>
           </p:cNvPr>
@@ -4121,7 +4257,7 @@
           <p:cNvPr id="16" name="">
             <a:extLst xmlns:a="http://schemas.openxmlformats.org/drawingml/2006/main">
               <a:ext uri="{FF2B5EF4-FFF2-40B4-BE49-F238E27FC236}">
-                <a16:creationId xmlns:a16="http://schemas.microsoft.com/office/drawing/2014/main" id="{C94C98C8-1E53-471D-BF89-7484F009B143}"/>
+                <a16:creationId xmlns:a16="http://schemas.microsoft.com/office/drawing/2014/main" id="{6E09F8E4-6B56-4B58-B1B2-296E11B6D2DE}"/>
               </a:ext>
             </a:extLst>
           </p:cNvPr>
@@ -4179,7 +4315,7 @@
           <p:cNvPr id="17" name="">
             <a:extLst xmlns:a="http://schemas.openxmlformats.org/drawingml/2006/main">
               <a:ext uri="{FF2B5EF4-FFF2-40B4-BE49-F238E27FC236}">
-                <a16:creationId xmlns:a16="http://schemas.microsoft.com/office/drawing/2014/main" id="{9E60300E-CB90-4282-B753-FEAA01E8FCBA}"/>
+                <a16:creationId xmlns:a16="http://schemas.microsoft.com/office/drawing/2014/main" id="{92DACE5B-869D-4AA7-84FA-75AF887FAEEC}"/>
               </a:ext>
             </a:extLst>
           </p:cNvPr>
@@ -4237,7 +4373,7 @@
           <p:cNvPr id="18" name="">
             <a:extLst xmlns:a="http://schemas.openxmlformats.org/drawingml/2006/main">
               <a:ext uri="{FF2B5EF4-FFF2-40B4-BE49-F238E27FC236}">
-                <a16:creationId xmlns:a16="http://schemas.microsoft.com/office/drawing/2014/main" id="{2A54ECC1-85A2-448D-8EFF-5957B6217CC9}"/>
+                <a16:creationId xmlns:a16="http://schemas.microsoft.com/office/drawing/2014/main" id="{EB740B7C-0BA2-459A-B14C-53240872D4B5}"/>
               </a:ext>
             </a:extLst>
           </p:cNvPr>
@@ -4295,7 +4431,7 @@
           <p:cNvPr id="19" name="">
             <a:extLst xmlns:a="http://schemas.openxmlformats.org/drawingml/2006/main">
               <a:ext uri="{FF2B5EF4-FFF2-40B4-BE49-F238E27FC236}">
-                <a16:creationId xmlns:a16="http://schemas.microsoft.com/office/drawing/2014/main" id="{E519A8E2-CF00-4003-822B-021BA6A7CB08}"/>
+                <a16:creationId xmlns:a16="http://schemas.microsoft.com/office/drawing/2014/main" id="{40EBBC34-D936-4D4B-B559-23EB3B1BD715}"/>
               </a:ext>
             </a:extLst>
           </p:cNvPr>
@@ -4328,7 +4464,7 @@
           <p:cNvPr id="20" name="">
             <a:extLst xmlns:a="http://schemas.openxmlformats.org/drawingml/2006/main">
               <a:ext uri="{FF2B5EF4-FFF2-40B4-BE49-F238E27FC236}">
-                <a16:creationId xmlns:a16="http://schemas.microsoft.com/office/drawing/2014/main" id="{0FEED8B8-7ED0-4CE5-A16A-034A6CE088A0}"/>
+                <a16:creationId xmlns:a16="http://schemas.microsoft.com/office/drawing/2014/main" id="{D3937D20-4AA0-46A8-85B8-50EF1FAAADB7}"/>
               </a:ext>
             </a:extLst>
           </p:cNvPr>
@@ -4386,7 +4522,7 @@
           <p:cNvPr id="21" name="">
             <a:extLst xmlns:a="http://schemas.openxmlformats.org/drawingml/2006/main">
               <a:ext uri="{FF2B5EF4-FFF2-40B4-BE49-F238E27FC236}">
-                <a16:creationId xmlns:a16="http://schemas.microsoft.com/office/drawing/2014/main" id="{33A4285E-1BFB-4DE2-BC47-17B96182FDBF}"/>
+                <a16:creationId xmlns:a16="http://schemas.microsoft.com/office/drawing/2014/main" id="{728CAA82-F920-4F10-B943-43043EB375F1}"/>
               </a:ext>
             </a:extLst>
           </p:cNvPr>
@@ -4444,7 +4580,7 @@
           <p:cNvPr id="22" name="">
             <a:extLst xmlns:a="http://schemas.openxmlformats.org/drawingml/2006/main">
               <a:ext uri="{FF2B5EF4-FFF2-40B4-BE49-F238E27FC236}">
-                <a16:creationId xmlns:a16="http://schemas.microsoft.com/office/drawing/2014/main" id="{83D71F3A-3C37-420F-A811-BB21E52F1ED0}"/>
+                <a16:creationId xmlns:a16="http://schemas.microsoft.com/office/drawing/2014/main" id="{E267F1D1-7DE0-4999-88D8-CBD9A207E8C1}"/>
               </a:ext>
             </a:extLst>
           </p:cNvPr>
@@ -4502,7 +4638,7 @@
           <p:cNvPr id="23" name="">
             <a:extLst xmlns:a="http://schemas.openxmlformats.org/drawingml/2006/main">
               <a:ext uri="{FF2B5EF4-FFF2-40B4-BE49-F238E27FC236}">
-                <a16:creationId xmlns:a16="http://schemas.microsoft.com/office/drawing/2014/main" id="{1FF72A9D-602E-4865-A450-E584A37CC806}"/>
+                <a16:creationId xmlns:a16="http://schemas.microsoft.com/office/drawing/2014/main" id="{7282BC09-25BC-4D63-86D7-5FA3DCE44071}"/>
               </a:ext>
             </a:extLst>
           </p:cNvPr>
@@ -4535,7 +4671,7 @@
           <p:cNvPr id="24" name="">
             <a:extLst xmlns:a="http://schemas.openxmlformats.org/drawingml/2006/main">
               <a:ext uri="{FF2B5EF4-FFF2-40B4-BE49-F238E27FC236}">
-                <a16:creationId xmlns:a16="http://schemas.microsoft.com/office/drawing/2014/main" id="{60DCB0AD-33BD-4932-B885-AFA9F8C59D77}"/>
+                <a16:creationId xmlns:a16="http://schemas.microsoft.com/office/drawing/2014/main" id="{350A6106-4EF1-482D-83AC-9F5DD95EFD97}"/>
               </a:ext>
             </a:extLst>
           </p:cNvPr>
@@ -4593,7 +4729,7 @@
           <p:cNvPr id="25" name="">
             <a:extLst xmlns:a="http://schemas.openxmlformats.org/drawingml/2006/main">
               <a:ext uri="{FF2B5EF4-FFF2-40B4-BE49-F238E27FC236}">
-                <a16:creationId xmlns:a16="http://schemas.microsoft.com/office/drawing/2014/main" id="{7E32C5C1-1AA0-4C6C-90FB-E413C7320950}"/>
+                <a16:creationId xmlns:a16="http://schemas.microsoft.com/office/drawing/2014/main" id="{AC127AF4-6B01-4930-B082-6EC492B6517A}"/>
               </a:ext>
             </a:extLst>
           </p:cNvPr>
@@ -4651,7 +4787,7 @@
           <p:cNvPr id="26" name="">
             <a:extLst xmlns:a="http://schemas.openxmlformats.org/drawingml/2006/main">
               <a:ext uri="{FF2B5EF4-FFF2-40B4-BE49-F238E27FC236}">
-                <a16:creationId xmlns:a16="http://schemas.microsoft.com/office/drawing/2014/main" id="{69396F87-F29A-456B-B7E1-C8DF00B73EDC}"/>
+                <a16:creationId xmlns:a16="http://schemas.microsoft.com/office/drawing/2014/main" id="{D95CBF56-036F-4239-AFB2-FF844ACB4CEB}"/>
               </a:ext>
             </a:extLst>
           </p:cNvPr>
@@ -4709,7 +4845,7 @@
           <p:cNvPr id="27" name="">
             <a:extLst xmlns:a="http://schemas.openxmlformats.org/drawingml/2006/main">
               <a:ext uri="{FF2B5EF4-FFF2-40B4-BE49-F238E27FC236}">
-                <a16:creationId xmlns:a16="http://schemas.microsoft.com/office/drawing/2014/main" id="{58736666-FF2F-4523-8360-F9D95B388DC2}"/>
+                <a16:creationId xmlns:a16="http://schemas.microsoft.com/office/drawing/2014/main" id="{BAFE27E6-BBD4-4EFF-9E2F-6EF386382358}"/>
               </a:ext>
             </a:extLst>
           </p:cNvPr>
@@ -4742,7 +4878,7 @@
           <p:cNvPr id="28" name="">
             <a:extLst xmlns:a="http://schemas.openxmlformats.org/drawingml/2006/main">
               <a:ext uri="{FF2B5EF4-FFF2-40B4-BE49-F238E27FC236}">
-                <a16:creationId xmlns:a16="http://schemas.microsoft.com/office/drawing/2014/main" id="{C99B9C0B-D4BE-448E-A4F8-CA56B2EFE28E}"/>
+                <a16:creationId xmlns:a16="http://schemas.microsoft.com/office/drawing/2014/main" id="{E23D125D-BC87-46F5-A124-2633E763D703}"/>
               </a:ext>
             </a:extLst>
           </p:cNvPr>
@@ -4800,7 +4936,7 @@
           <p:cNvPr id="29" name="">
             <a:extLst xmlns:a="http://schemas.openxmlformats.org/drawingml/2006/main">
               <a:ext uri="{FF2B5EF4-FFF2-40B4-BE49-F238E27FC236}">
-                <a16:creationId xmlns:a16="http://schemas.microsoft.com/office/drawing/2014/main" id="{4E7146F3-AA0A-4494-8B64-B0B49BFD7084}"/>
+                <a16:creationId xmlns:a16="http://schemas.microsoft.com/office/drawing/2014/main" id="{2DF0493C-A7BB-4EF4-82C2-3A91339A9B4D}"/>
               </a:ext>
             </a:extLst>
           </p:cNvPr>
@@ -4858,7 +4994,7 @@
           <p:cNvPr id="30" name="">
             <a:extLst xmlns:a="http://schemas.openxmlformats.org/drawingml/2006/main">
               <a:ext uri="{FF2B5EF4-FFF2-40B4-BE49-F238E27FC236}">
-                <a16:creationId xmlns:a16="http://schemas.microsoft.com/office/drawing/2014/main" id="{9440EFB7-6D25-4201-BE7D-F9EF8A2CC1DF}"/>
+                <a16:creationId xmlns:a16="http://schemas.microsoft.com/office/drawing/2014/main" id="{C9999C55-A50E-4A8F-916E-4072ED2916AE}"/>
               </a:ext>
             </a:extLst>
           </p:cNvPr>
@@ -4916,7 +5052,7 @@
           <p:cNvPr id="31" name="">
             <a:extLst xmlns:a="http://schemas.openxmlformats.org/drawingml/2006/main">
               <a:ext uri="{FF2B5EF4-FFF2-40B4-BE49-F238E27FC236}">
-                <a16:creationId xmlns:a16="http://schemas.microsoft.com/office/drawing/2014/main" id="{50CDC1B0-ECA3-4503-9AA3-DDEE390C428B}"/>
+                <a16:creationId xmlns:a16="http://schemas.microsoft.com/office/drawing/2014/main" id="{251B1B4E-1263-40E0-A03E-BA9024293965}"/>
               </a:ext>
             </a:extLst>
           </p:cNvPr>
@@ -4949,7 +5085,7 @@
           <p:cNvPr id="32" name="">
             <a:extLst xmlns:a="http://schemas.openxmlformats.org/drawingml/2006/main">
               <a:ext uri="{FF2B5EF4-FFF2-40B4-BE49-F238E27FC236}">
-                <a16:creationId xmlns:a16="http://schemas.microsoft.com/office/drawing/2014/main" id="{FFDE175A-D923-420A-8DB0-BD4D5C90C160}"/>
+                <a16:creationId xmlns:a16="http://schemas.microsoft.com/office/drawing/2014/main" id="{7B7BAB0E-77D1-438F-9D20-28DF78EF5937}"/>
               </a:ext>
             </a:extLst>
           </p:cNvPr>
@@ -5007,7 +5143,7 @@
           <p:cNvPr id="33" name="">
             <a:extLst xmlns:a="http://schemas.openxmlformats.org/drawingml/2006/main">
               <a:ext uri="{FF2B5EF4-FFF2-40B4-BE49-F238E27FC236}">
-                <a16:creationId xmlns:a16="http://schemas.microsoft.com/office/drawing/2014/main" id="{6D2702E8-599B-4646-9D46-73F5F1C33647}"/>
+                <a16:creationId xmlns:a16="http://schemas.microsoft.com/office/drawing/2014/main" id="{DA6D3C8D-51F2-45CA-B7A1-BC91E40B30A4}"/>
               </a:ext>
             </a:extLst>
           </p:cNvPr>
@@ -5065,7 +5201,7 @@
           <p:cNvPr id="34" name="">
             <a:extLst xmlns:a="http://schemas.openxmlformats.org/drawingml/2006/main">
               <a:ext uri="{FF2B5EF4-FFF2-40B4-BE49-F238E27FC236}">
-                <a16:creationId xmlns:a16="http://schemas.microsoft.com/office/drawing/2014/main" id="{25E1FB1B-F241-40D6-8964-6D5068622586}"/>
+                <a16:creationId xmlns:a16="http://schemas.microsoft.com/office/drawing/2014/main" id="{E1A13371-9FC4-46FF-A136-685B7134FEDB}"/>
               </a:ext>
             </a:extLst>
           </p:cNvPr>
@@ -5123,7 +5259,7 @@
           <p:cNvPr id="35" name="">
             <a:extLst xmlns:a="http://schemas.openxmlformats.org/drawingml/2006/main">
               <a:ext uri="{FF2B5EF4-FFF2-40B4-BE49-F238E27FC236}">
-                <a16:creationId xmlns:a16="http://schemas.microsoft.com/office/drawing/2014/main" id="{11A0E98B-DFDB-4F8F-AEC4-FD941A2304E0}"/>
+                <a16:creationId xmlns:a16="http://schemas.microsoft.com/office/drawing/2014/main" id="{16F8354C-9401-4233-AC5B-ACCF27992E69}"/>
               </a:ext>
             </a:extLst>
           </p:cNvPr>
@@ -5156,7 +5292,7 @@
           <p:cNvPr id="36" name="">
             <a:extLst xmlns:a="http://schemas.openxmlformats.org/drawingml/2006/main">
               <a:ext uri="{FF2B5EF4-FFF2-40B4-BE49-F238E27FC236}">
-                <a16:creationId xmlns:a16="http://schemas.microsoft.com/office/drawing/2014/main" id="{A09CAAB1-2C3C-41B1-8651-E68AC65597C7}"/>
+                <a16:creationId xmlns:a16="http://schemas.microsoft.com/office/drawing/2014/main" id="{51B35289-4817-48D0-B5C0-64E4ED12EA74}"/>
               </a:ext>
             </a:extLst>
           </p:cNvPr>
@@ -5214,7 +5350,7 @@
           <p:cNvPr id="37" name="">
             <a:extLst xmlns:a="http://schemas.openxmlformats.org/drawingml/2006/main">
               <a:ext uri="{FF2B5EF4-FFF2-40B4-BE49-F238E27FC236}">
-                <a16:creationId xmlns:a16="http://schemas.microsoft.com/office/drawing/2014/main" id="{02546F4A-E12E-4706-8694-099CA1BEE1BF}"/>
+                <a16:creationId xmlns:a16="http://schemas.microsoft.com/office/drawing/2014/main" id="{9601D6C2-08B6-4664-8837-326C94A96627}"/>
               </a:ext>
             </a:extLst>
           </p:cNvPr>
@@ -5272,7 +5408,7 @@
           <p:cNvPr id="38" name="">
             <a:extLst xmlns:a="http://schemas.openxmlformats.org/drawingml/2006/main">
               <a:ext uri="{FF2B5EF4-FFF2-40B4-BE49-F238E27FC236}">
-                <a16:creationId xmlns:a16="http://schemas.microsoft.com/office/drawing/2014/main" id="{01FEAB91-1751-44A7-A4C6-9E46F52547BE}"/>
+                <a16:creationId xmlns:a16="http://schemas.microsoft.com/office/drawing/2014/main" id="{5C5EFAAE-CBA4-4C28-8A57-3B664817D913}"/>
               </a:ext>
             </a:extLst>
           </p:cNvPr>
@@ -5330,7 +5466,7 @@
           <p:cNvPr id="39" name="">
             <a:extLst xmlns:a="http://schemas.openxmlformats.org/drawingml/2006/main">
               <a:ext uri="{FF2B5EF4-FFF2-40B4-BE49-F238E27FC236}">
-                <a16:creationId xmlns:a16="http://schemas.microsoft.com/office/drawing/2014/main" id="{802565B7-9E3F-4C7E-993F-45BA2C8E836A}"/>
+                <a16:creationId xmlns:a16="http://schemas.microsoft.com/office/drawing/2014/main" id="{C66ACD67-F634-49B0-8D7C-AFAC27C33633}"/>
               </a:ext>
             </a:extLst>
           </p:cNvPr>
@@ -5363,7 +5499,7 @@
           <p:cNvPr id="40" name="">
             <a:extLst xmlns:a="http://schemas.openxmlformats.org/drawingml/2006/main">
               <a:ext uri="{FF2B5EF4-FFF2-40B4-BE49-F238E27FC236}">
-                <a16:creationId xmlns:a16="http://schemas.microsoft.com/office/drawing/2014/main" id="{9D749E07-2D25-4E21-9B5F-1A20A696FDC3}"/>
+                <a16:creationId xmlns:a16="http://schemas.microsoft.com/office/drawing/2014/main" id="{92EAAD83-2336-4D62-8F5A-ADE2D74C7E7A}"/>
               </a:ext>
             </a:extLst>
           </p:cNvPr>
@@ -5421,7 +5557,7 @@
           <p:cNvPr id="41" name="">
             <a:extLst xmlns:a="http://schemas.openxmlformats.org/drawingml/2006/main">
               <a:ext uri="{FF2B5EF4-FFF2-40B4-BE49-F238E27FC236}">
-                <a16:creationId xmlns:a16="http://schemas.microsoft.com/office/drawing/2014/main" id="{5E230C8C-6498-4DB8-BC3A-1A7578E41FC4}"/>
+                <a16:creationId xmlns:a16="http://schemas.microsoft.com/office/drawing/2014/main" id="{9015CA9E-1843-42B8-84F6-4D1773BAE562}"/>
               </a:ext>
             </a:extLst>
           </p:cNvPr>
@@ -5479,7 +5615,7 @@
           <p:cNvPr id="42" name="">
             <a:extLst xmlns:a="http://schemas.openxmlformats.org/drawingml/2006/main">
               <a:ext uri="{FF2B5EF4-FFF2-40B4-BE49-F238E27FC236}">
-                <a16:creationId xmlns:a16="http://schemas.microsoft.com/office/drawing/2014/main" id="{F644D1AC-05D1-43F5-8083-E8AE5E4EF094}"/>
+                <a16:creationId xmlns:a16="http://schemas.microsoft.com/office/drawing/2014/main" id="{150714F6-0EE1-44F5-9CA7-1A3C42FF20E4}"/>
               </a:ext>
             </a:extLst>
           </p:cNvPr>
@@ -5537,7 +5673,7 @@
           <p:cNvPr id="43" name="">
             <a:extLst xmlns:a="http://schemas.openxmlformats.org/drawingml/2006/main">
               <a:ext uri="{FF2B5EF4-FFF2-40B4-BE49-F238E27FC236}">
-                <a16:creationId xmlns:a16="http://schemas.microsoft.com/office/drawing/2014/main" id="{26C656FB-1D5E-4EC9-89A4-0681AA36E6FA}"/>
+                <a16:creationId xmlns:a16="http://schemas.microsoft.com/office/drawing/2014/main" id="{F62F65FB-97BA-4903-B79C-4F77468A6171}"/>
               </a:ext>
             </a:extLst>
           </p:cNvPr>
@@ -5568,7 +5704,7 @@
           <p:cNvPr id="44" name="">
             <a:extLst xmlns:a="http://schemas.openxmlformats.org/drawingml/2006/main">
               <a:ext uri="{FF2B5EF4-FFF2-40B4-BE49-F238E27FC236}">
-                <a16:creationId xmlns:a16="http://schemas.microsoft.com/office/drawing/2014/main" id="{B93CCE23-37CE-422F-8054-0DB095803764}"/>
+                <a16:creationId xmlns:a16="http://schemas.microsoft.com/office/drawing/2014/main" id="{CFE18C21-9738-4909-A88B-8148C8EC970F}"/>
               </a:ext>
             </a:extLst>
           </p:cNvPr>
@@ -5626,7 +5762,7 @@
           <p:cNvPr id="45" name="">
             <a:extLst xmlns:a="http://schemas.openxmlformats.org/drawingml/2006/main">
               <a:ext uri="{FF2B5EF4-FFF2-40B4-BE49-F238E27FC236}">
-                <a16:creationId xmlns:a16="http://schemas.microsoft.com/office/drawing/2014/main" id="{1D4EE6E8-5D3C-41C2-A485-DC542E596B19}"/>
+                <a16:creationId xmlns:a16="http://schemas.microsoft.com/office/drawing/2014/main" id="{44BC5EF3-39D8-465A-A2D3-ED7416D1B648}"/>
               </a:ext>
             </a:extLst>
           </p:cNvPr>
@@ -5684,7 +5820,7 @@
           <p:cNvPr id="46" name="">
             <a:extLst xmlns:a="http://schemas.openxmlformats.org/drawingml/2006/main">
               <a:ext uri="{FF2B5EF4-FFF2-40B4-BE49-F238E27FC236}">
-                <a16:creationId xmlns:a16="http://schemas.microsoft.com/office/drawing/2014/main" id="{57D6A5D3-0FB1-4D38-B0FF-F200404727E5}"/>
+                <a16:creationId xmlns:a16="http://schemas.microsoft.com/office/drawing/2014/main" id="{03FA132B-002D-46D9-B237-C4F32387EFB2}"/>
               </a:ext>
             </a:extLst>
           </p:cNvPr>
@@ -5740,7 +5876,2375 @@
     </p:spTree>
     <p:extLst>
       <p:ext uri="{BB962C8B-B14F-4D97-AF65-F5344CB8AC3E}">
-        <p14:creationId xmlns:p14="http://schemas.microsoft.com/office/powerpoint/2010/main" val="583637870"/>
+        <p14:creationId xmlns:p14="http://schemas.microsoft.com/office/powerpoint/2010/main" val="798250258"/>
+      </p:ext>
+    </p:extLst>
+  </p:cSld>
+</p:sld>
+</file>
+
+<file path=ppt/slides/slide3.xml><?xml version="1.0" encoding="utf-8"?>
+<p:sld xmlns:p="http://schemas.openxmlformats.org/presentationml/2006/main">
+  <p:cSld>
+    <p:bg>
+      <p:bgPr>
+        <a:solidFill xmlns:a="http://schemas.openxmlformats.org/drawingml/2006/main">
+          <a:srgbClr val="FFFFFF"/>
+        </a:solidFill>
+      </p:bgPr>
+    </p:bg>
+    <p:spTree>
+      <p:nvGrpSpPr>
+        <p:cNvPr id="1" name=""/>
+        <p:cNvGrpSpPr/>
+        <p:nvPr/>
+      </p:nvGrpSpPr>
+      <p:grpSpPr>
+        <a:xfrm xmlns:a="http://schemas.openxmlformats.org/drawingml/2006/main"/>
+      </p:grpSpPr>
+      <p:sp>
+        <p:nvSpPr>
+          <p:cNvPr id="47" name="">
+            <a:extLst xmlns:a="http://schemas.openxmlformats.org/drawingml/2006/main">
+              <a:ext uri="{FF2B5EF4-FFF2-40B4-BE49-F238E27FC236}">
+                <a16:creationId xmlns:a16="http://schemas.microsoft.com/office/drawing/2014/main" id="{157EFF41-C480-426F-94FB-CEA1E2ACEFB2}"/>
+              </a:ext>
+            </a:extLst>
+          </p:cNvPr>
+          <p:cNvSpPr>
+            <a:spLocks xmlns:a="http://schemas.openxmlformats.org/drawingml/2006/main" noGrp="1"/>
+          </p:cNvSpPr>
+          <p:nvPr/>
+        </p:nvSpPr>
+        <p:spPr>
+          <a:xfrm xmlns:a="http://schemas.openxmlformats.org/drawingml/2006/main">
+            <a:off x="533400" y="342900"/>
+            <a:ext cx="7810500" cy="457200"/>
+          </a:xfrm>
+          <a:prstGeom xmlns:a="http://schemas.openxmlformats.org/drawingml/2006/main" prst="rect">
+            <a:avLst/>
+          </a:prstGeom>
+          <a:noFill xmlns:a="http://schemas.openxmlformats.org/drawingml/2006/main"/>
+          <a:ln xmlns:a="http://schemas.openxmlformats.org/drawingml/2006/main" w="0">
+            <a:noFill/>
+            <a:prstDash val="solid"/>
+          </a:ln>
+        </p:spPr>
+        <p:txBody>
+          <a:bodyPr xmlns:a="http://schemas.openxmlformats.org/drawingml/2006/main" anchor="t">
+            <a:noAutofit/>
+          </a:bodyPr>
+          <a:lstStyle xmlns:a="http://schemas.openxmlformats.org/drawingml/2006/main"/>
+          <a:p xmlns:a="http://schemas.openxmlformats.org/drawingml/2006/main">
+            <a:pPr algn="l">
+              <a:defRPr sz="2850" b="1">
+                <a:solidFill>
+                  <a:srgbClr val="111827"/>
+                </a:solidFill>
+                <a:latin typeface="Helvetica Neue"/>
+                <a:ea typeface="Helvetica Neue"/>
+                <a:cs typeface="Helvetica Neue"/>
+              </a:defRPr>
+            </a:pPr>
+            <a:r>
+              <a:rPr sz="2850" b="1">
+                <a:solidFill>
+                  <a:srgbClr val="111827"/>
+                </a:solidFill>
+                <a:latin typeface="Helvetica Neue"/>
+                <a:ea typeface="Helvetica Neue"/>
+                <a:cs typeface="Helvetica Neue"/>
+              </a:rPr>
+              <a:t>Scenario 3: Value-Aware KV Eviction</a:t>
+            </a:r>
+          </a:p>
+        </p:txBody>
+      </p:sp>
+      <p:sp>
+        <p:nvSpPr>
+          <p:cNvPr id="2" name="">
+            <a:extLst xmlns:a="http://schemas.openxmlformats.org/drawingml/2006/main">
+              <a:ext uri="{FF2B5EF4-FFF2-40B4-BE49-F238E27FC236}">
+                <a16:creationId xmlns:a16="http://schemas.microsoft.com/office/drawing/2014/main" id="{A4C919E6-E349-43BF-8259-CE8456A8C737}"/>
+              </a:ext>
+            </a:extLst>
+          </p:cNvPr>
+          <p:cNvSpPr>
+            <a:spLocks xmlns:a="http://schemas.openxmlformats.org/drawingml/2006/main" noGrp="1"/>
+          </p:cNvSpPr>
+          <p:nvPr/>
+        </p:nvSpPr>
+        <p:spPr>
+          <a:xfrm xmlns:a="http://schemas.openxmlformats.org/drawingml/2006/main">
+            <a:off x="552450" y="838200"/>
+            <a:ext cx="8953500" cy="266700"/>
+          </a:xfrm>
+          <a:prstGeom xmlns:a="http://schemas.openxmlformats.org/drawingml/2006/main" prst="rect">
+            <a:avLst/>
+          </a:prstGeom>
+          <a:noFill xmlns:a="http://schemas.openxmlformats.org/drawingml/2006/main"/>
+          <a:ln xmlns:a="http://schemas.openxmlformats.org/drawingml/2006/main" w="0">
+            <a:noFill/>
+            <a:prstDash val="solid"/>
+          </a:ln>
+        </p:spPr>
+        <p:txBody>
+          <a:bodyPr xmlns:a="http://schemas.openxmlformats.org/drawingml/2006/main" anchor="t">
+            <a:noAutofit/>
+          </a:bodyPr>
+          <a:lstStyle xmlns:a="http://schemas.openxmlformats.org/drawingml/2006/main"/>
+          <a:p xmlns:a="http://schemas.openxmlformats.org/drawingml/2006/main">
+            <a:pPr algn="l">
+              <a:defRPr sz="1425" b="0">
+                <a:solidFill>
+                  <a:srgbClr val="64748B"/>
+                </a:solidFill>
+                <a:latin typeface="Helvetica Neue"/>
+                <a:ea typeface="Helvetica Neue"/>
+                <a:cs typeface="Helvetica Neue"/>
+              </a:defRPr>
+            </a:pPr>
+            <a:r>
+              <a:rPr sz="1425" b="0">
+                <a:solidFill>
+                  <a:srgbClr val="64748B"/>
+                </a:solidFill>
+                <a:latin typeface="Helvetica Neue"/>
+                <a:ea typeface="Helvetica Neue"/>
+                <a:cs typeface="Helvetica Neue"/>
+              </a:rPr>
+              <a:t>When memory pressure forces evictions, SGLang keeps KV that is more likely to matter soon.</a:t>
+            </a:r>
+          </a:p>
+        </p:txBody>
+      </p:sp>
+      <p:sp>
+        <p:nvSpPr>
+          <p:cNvPr id="3" name="">
+            <a:extLst xmlns:a="http://schemas.openxmlformats.org/drawingml/2006/main">
+              <a:ext uri="{FF2B5EF4-FFF2-40B4-BE49-F238E27FC236}">
+                <a16:creationId xmlns:a16="http://schemas.microsoft.com/office/drawing/2014/main" id="{1A758981-2021-46E9-9A89-D7949DC12A82}"/>
+              </a:ext>
+            </a:extLst>
+          </p:cNvPr>
+          <p:cNvSpPr>
+            <a:spLocks xmlns:a="http://schemas.openxmlformats.org/drawingml/2006/main" noGrp="1"/>
+          </p:cNvSpPr>
+          <p:nvPr/>
+        </p:nvSpPr>
+        <p:spPr>
+          <a:xfrm xmlns:a="http://schemas.openxmlformats.org/drawingml/2006/main">
+            <a:off x="9429750" y="476250"/>
+            <a:ext cx="2000250" cy="247650"/>
+          </a:xfrm>
+          <a:prstGeom xmlns:a="http://schemas.openxmlformats.org/drawingml/2006/main" prst="rect">
+            <a:avLst/>
+          </a:prstGeom>
+          <a:noFill xmlns:a="http://schemas.openxmlformats.org/drawingml/2006/main"/>
+          <a:ln xmlns:a="http://schemas.openxmlformats.org/drawingml/2006/main" w="0">
+            <a:noFill/>
+            <a:prstDash val="solid"/>
+          </a:ln>
+        </p:spPr>
+        <p:txBody>
+          <a:bodyPr xmlns:a="http://schemas.openxmlformats.org/drawingml/2006/main" anchor="t">
+            <a:noAutofit/>
+          </a:bodyPr>
+          <a:lstStyle xmlns:a="http://schemas.openxmlformats.org/drawingml/2006/main"/>
+          <a:p xmlns:a="http://schemas.openxmlformats.org/drawingml/2006/main">
+            <a:pPr algn="r">
+              <a:defRPr sz="1350" b="1">
+                <a:solidFill>
+                  <a:srgbClr val="2F6F56"/>
+                </a:solidFill>
+                <a:latin typeface="Helvetica Neue"/>
+                <a:ea typeface="Helvetica Neue"/>
+                <a:cs typeface="Helvetica Neue"/>
+              </a:defRPr>
+            </a:pPr>
+            <a:r>
+              <a:rPr sz="1350" b="1">
+                <a:solidFill>
+                  <a:srgbClr val="2F6F56"/>
+                </a:solidFill>
+                <a:latin typeface="Helvetica Neue"/>
+                <a:ea typeface="Helvetica Neue"/>
+                <a:cs typeface="Helvetica Neue"/>
+              </a:rPr>
+              <a:t>Request win + trade-off</a:t>
+            </a:r>
+          </a:p>
+        </p:txBody>
+      </p:sp>
+      <p:sp>
+        <p:nvSpPr>
+          <p:cNvPr id="4" name="">
+            <a:extLst xmlns:a="http://schemas.openxmlformats.org/drawingml/2006/main">
+              <a:ext uri="{FF2B5EF4-FFF2-40B4-BE49-F238E27FC236}">
+                <a16:creationId xmlns:a16="http://schemas.microsoft.com/office/drawing/2014/main" id="{87922529-8659-48B1-8657-AFED10BEDCF7}"/>
+              </a:ext>
+            </a:extLst>
+          </p:cNvPr>
+          <p:cNvSpPr>
+            <a:spLocks xmlns:a="http://schemas.openxmlformats.org/drawingml/2006/main" noGrp="1"/>
+          </p:cNvSpPr>
+          <p:nvPr/>
+        </p:nvSpPr>
+        <p:spPr>
+          <a:xfrm xmlns:a="http://schemas.openxmlformats.org/drawingml/2006/main">
+            <a:off x="533400" y="1200150"/>
+            <a:ext cx="11125200" cy="13335"/>
+          </a:xfrm>
+          <a:prstGeom xmlns:a="http://schemas.openxmlformats.org/drawingml/2006/main" prst="rect">
+            <a:avLst/>
+          </a:prstGeom>
+          <a:solidFill xmlns:a="http://schemas.openxmlformats.org/drawingml/2006/main">
+            <a:srgbClr val="D7DEE8"/>
+          </a:solidFill>
+          <a:ln xmlns:a="http://schemas.openxmlformats.org/drawingml/2006/main" w="0">
+            <a:noFill/>
+            <a:prstDash val="solid"/>
+          </a:ln>
+        </p:spPr>
+      </p:sp>
+      <p:sp>
+        <p:nvSpPr>
+          <p:cNvPr id="5" name="">
+            <a:extLst xmlns:a="http://schemas.openxmlformats.org/drawingml/2006/main">
+              <a:ext uri="{FF2B5EF4-FFF2-40B4-BE49-F238E27FC236}">
+                <a16:creationId xmlns:a16="http://schemas.microsoft.com/office/drawing/2014/main" id="{B6B6110B-3B5C-4863-9425-77A97525E9B0}"/>
+              </a:ext>
+            </a:extLst>
+          </p:cNvPr>
+          <p:cNvSpPr>
+            <a:spLocks xmlns:a="http://schemas.openxmlformats.org/drawingml/2006/main" noGrp="1"/>
+          </p:cNvSpPr>
+          <p:nvPr/>
+        </p:nvSpPr>
+        <p:spPr>
+          <a:xfrm xmlns:a="http://schemas.openxmlformats.org/drawingml/2006/main">
+            <a:off x="628650" y="1524000"/>
+            <a:ext cx="4333875" cy="266700"/>
+          </a:xfrm>
+          <a:prstGeom xmlns:a="http://schemas.openxmlformats.org/drawingml/2006/main" prst="rect">
+            <a:avLst/>
+          </a:prstGeom>
+          <a:noFill xmlns:a="http://schemas.openxmlformats.org/drawingml/2006/main"/>
+          <a:ln xmlns:a="http://schemas.openxmlformats.org/drawingml/2006/main" w="0">
+            <a:noFill/>
+            <a:prstDash val="solid"/>
+          </a:ln>
+        </p:spPr>
+        <p:txBody>
+          <a:bodyPr xmlns:a="http://schemas.openxmlformats.org/drawingml/2006/main" anchor="t">
+            <a:noAutofit/>
+          </a:bodyPr>
+          <a:lstStyle xmlns:a="http://schemas.openxmlformats.org/drawingml/2006/main"/>
+          <a:p xmlns:a="http://schemas.openxmlformats.org/drawingml/2006/main">
+            <a:pPr algn="l">
+              <a:defRPr sz="1425" b="1">
+                <a:solidFill>
+                  <a:srgbClr val="111827"/>
+                </a:solidFill>
+                <a:latin typeface="Helvetica Neue"/>
+                <a:ea typeface="Helvetica Neue"/>
+                <a:cs typeface="Helvetica Neue"/>
+              </a:defRPr>
+            </a:pPr>
+            <a:r>
+              <a:rPr sz="1425" b="1">
+                <a:solidFill>
+                  <a:srgbClr val="111827"/>
+                </a:solidFill>
+                <a:latin typeface="Helvetica Neue"/>
+                <a:ea typeface="Helvetica Neue"/>
+                <a:cs typeface="Helvetica Neue"/>
+              </a:rPr>
+              <a:t>What the setup tests</a:t>
+            </a:r>
+          </a:p>
+        </p:txBody>
+      </p:sp>
+      <p:sp>
+        <p:nvSpPr>
+          <p:cNvPr id="6" name="">
+            <a:extLst xmlns:a="http://schemas.openxmlformats.org/drawingml/2006/main">
+              <a:ext uri="{FF2B5EF4-FFF2-40B4-BE49-F238E27FC236}">
+                <a16:creationId xmlns:a16="http://schemas.microsoft.com/office/drawing/2014/main" id="{84335AB3-5DFB-4083-A97B-4350173768F4}"/>
+              </a:ext>
+            </a:extLst>
+          </p:cNvPr>
+          <p:cNvSpPr>
+            <a:spLocks xmlns:a="http://schemas.openxmlformats.org/drawingml/2006/main" noGrp="1"/>
+          </p:cNvSpPr>
+          <p:nvPr/>
+        </p:nvSpPr>
+        <p:spPr>
+          <a:xfrm xmlns:a="http://schemas.openxmlformats.org/drawingml/2006/main">
+            <a:off x="628650" y="1990725"/>
+            <a:ext cx="76200" cy="76200"/>
+          </a:xfrm>
+          <a:prstGeom xmlns:a="http://schemas.openxmlformats.org/drawingml/2006/main" prst="rect">
+            <a:avLst/>
+          </a:prstGeom>
+          <a:solidFill xmlns:a="http://schemas.openxmlformats.org/drawingml/2006/main">
+            <a:srgbClr val="1F4E79"/>
+          </a:solidFill>
+          <a:ln xmlns:a="http://schemas.openxmlformats.org/drawingml/2006/main" w="0">
+            <a:solidFill>
+              <a:srgbClr val="1F4E79"/>
+            </a:solidFill>
+            <a:prstDash val="solid"/>
+          </a:ln>
+        </p:spPr>
+      </p:sp>
+      <p:sp>
+        <p:nvSpPr>
+          <p:cNvPr id="7" name="">
+            <a:extLst xmlns:a="http://schemas.openxmlformats.org/drawingml/2006/main">
+              <a:ext uri="{FF2B5EF4-FFF2-40B4-BE49-F238E27FC236}">
+                <a16:creationId xmlns:a16="http://schemas.microsoft.com/office/drawing/2014/main" id="{85AD5607-C693-4118-951C-31EB552128E1}"/>
+              </a:ext>
+            </a:extLst>
+          </p:cNvPr>
+          <p:cNvSpPr>
+            <a:spLocks xmlns:a="http://schemas.openxmlformats.org/drawingml/2006/main" noGrp="1"/>
+          </p:cNvSpPr>
+          <p:nvPr/>
+        </p:nvSpPr>
+        <p:spPr>
+          <a:xfrm xmlns:a="http://schemas.openxmlformats.org/drawingml/2006/main">
+            <a:off x="819150" y="1905000"/>
+            <a:ext cx="4143375" cy="323850"/>
+          </a:xfrm>
+          <a:prstGeom xmlns:a="http://schemas.openxmlformats.org/drawingml/2006/main" prst="rect">
+            <a:avLst/>
+          </a:prstGeom>
+          <a:noFill xmlns:a="http://schemas.openxmlformats.org/drawingml/2006/main"/>
+          <a:ln xmlns:a="http://schemas.openxmlformats.org/drawingml/2006/main" w="0">
+            <a:noFill/>
+            <a:prstDash val="solid"/>
+          </a:ln>
+        </p:spPr>
+        <p:txBody>
+          <a:bodyPr xmlns:a="http://schemas.openxmlformats.org/drawingml/2006/main" anchor="t">
+            <a:noAutofit/>
+          </a:bodyPr>
+          <a:lstStyle xmlns:a="http://schemas.openxmlformats.org/drawingml/2006/main"/>
+          <a:p xmlns:a="http://schemas.openxmlformats.org/drawingml/2006/main">
+            <a:pPr algn="l">
+              <a:defRPr sz="1275" b="0">
+                <a:solidFill>
+                  <a:srgbClr val="334155"/>
+                </a:solidFill>
+                <a:latin typeface="Helvetica Neue"/>
+                <a:ea typeface="Helvetica Neue"/>
+                <a:cs typeface="Helvetica Neue"/>
+              </a:defRPr>
+            </a:pPr>
+            <a:r>
+              <a:rPr sz="1275" b="0">
+                <a:solidFill>
+                  <a:srgbClr val="334155"/>
+                </a:solidFill>
+                <a:latin typeface="Helvetica Neue"/>
+                <a:ea typeface="Helvetica Neue"/>
+                <a:cs typeface="Helvetica Neue"/>
+              </a:rPr>
+              <a:t>32 replay requests run in both modes.</a:t>
+            </a:r>
+          </a:p>
+        </p:txBody>
+      </p:sp>
+      <p:sp>
+        <p:nvSpPr>
+          <p:cNvPr id="8" name="">
+            <a:extLst xmlns:a="http://schemas.openxmlformats.org/drawingml/2006/main">
+              <a:ext uri="{FF2B5EF4-FFF2-40B4-BE49-F238E27FC236}">
+                <a16:creationId xmlns:a16="http://schemas.microsoft.com/office/drawing/2014/main" id="{EC562871-667D-4772-9F45-3EAE37FE5BD7}"/>
+              </a:ext>
+            </a:extLst>
+          </p:cNvPr>
+          <p:cNvSpPr>
+            <a:spLocks xmlns:a="http://schemas.openxmlformats.org/drawingml/2006/main" noGrp="1"/>
+          </p:cNvSpPr>
+          <p:nvPr/>
+        </p:nvSpPr>
+        <p:spPr>
+          <a:xfrm xmlns:a="http://schemas.openxmlformats.org/drawingml/2006/main">
+            <a:off x="628650" y="2352675"/>
+            <a:ext cx="76200" cy="76200"/>
+          </a:xfrm>
+          <a:prstGeom xmlns:a="http://schemas.openxmlformats.org/drawingml/2006/main" prst="rect">
+            <a:avLst/>
+          </a:prstGeom>
+          <a:solidFill xmlns:a="http://schemas.openxmlformats.org/drawingml/2006/main">
+            <a:srgbClr val="1F4E79"/>
+          </a:solidFill>
+          <a:ln xmlns:a="http://schemas.openxmlformats.org/drawingml/2006/main" w="0">
+            <a:solidFill>
+              <a:srgbClr val="1F4E79"/>
+            </a:solidFill>
+            <a:prstDash val="solid"/>
+          </a:ln>
+        </p:spPr>
+      </p:sp>
+      <p:sp>
+        <p:nvSpPr>
+          <p:cNvPr id="9" name="">
+            <a:extLst xmlns:a="http://schemas.openxmlformats.org/drawingml/2006/main">
+              <a:ext uri="{FF2B5EF4-FFF2-40B4-BE49-F238E27FC236}">
+                <a16:creationId xmlns:a16="http://schemas.microsoft.com/office/drawing/2014/main" id="{6C1E400C-3F53-4462-9525-D15D5D9A808C}"/>
+              </a:ext>
+            </a:extLst>
+          </p:cNvPr>
+          <p:cNvSpPr>
+            <a:spLocks xmlns:a="http://schemas.openxmlformats.org/drawingml/2006/main" noGrp="1"/>
+          </p:cNvSpPr>
+          <p:nvPr/>
+        </p:nvSpPr>
+        <p:spPr>
+          <a:xfrm xmlns:a="http://schemas.openxmlformats.org/drawingml/2006/main">
+            <a:off x="819150" y="2266950"/>
+            <a:ext cx="4143375" cy="323850"/>
+          </a:xfrm>
+          <a:prstGeom xmlns:a="http://schemas.openxmlformats.org/drawingml/2006/main" prst="rect">
+            <a:avLst/>
+          </a:prstGeom>
+          <a:noFill xmlns:a="http://schemas.openxmlformats.org/drawingml/2006/main"/>
+          <a:ln xmlns:a="http://schemas.openxmlformats.org/drawingml/2006/main" w="0">
+            <a:noFill/>
+            <a:prstDash val="solid"/>
+          </a:ln>
+        </p:spPr>
+        <p:txBody>
+          <a:bodyPr xmlns:a="http://schemas.openxmlformats.org/drawingml/2006/main" anchor="t">
+            <a:noAutofit/>
+          </a:bodyPr>
+          <a:lstStyle xmlns:a="http://schemas.openxmlformats.org/drawingml/2006/main"/>
+          <a:p xmlns:a="http://schemas.openxmlformats.org/drawingml/2006/main">
+            <a:pPr algn="l">
+              <a:defRPr sz="1275" b="0">
+                <a:solidFill>
+                  <a:srgbClr val="334155"/>
+                </a:solidFill>
+                <a:latin typeface="Helvetica Neue"/>
+                <a:ea typeface="Helvetica Neue"/>
+                <a:cs typeface="Helvetica Neue"/>
+              </a:defRPr>
+            </a:pPr>
+            <a:r>
+              <a:rPr sz="1275" b="0">
+                <a:solidFill>
+                  <a:srgbClr val="334155"/>
+                </a:solidFill>
+                <a:latin typeface="Helvetica Neue"/>
+                <a:ea typeface="Helvetica Neue"/>
+                <a:cs typeface="Helvetica Neue"/>
+              </a:rPr>
+              <a:t>Concurrent long-context sessions force KV eviction.</a:t>
+            </a:r>
+          </a:p>
+        </p:txBody>
+      </p:sp>
+      <p:sp>
+        <p:nvSpPr>
+          <p:cNvPr id="10" name="">
+            <a:extLst xmlns:a="http://schemas.openxmlformats.org/drawingml/2006/main">
+              <a:ext uri="{FF2B5EF4-FFF2-40B4-BE49-F238E27FC236}">
+                <a16:creationId xmlns:a16="http://schemas.microsoft.com/office/drawing/2014/main" id="{E19125B7-D6D7-42C1-BD84-784FAB1B687D}"/>
+              </a:ext>
+            </a:extLst>
+          </p:cNvPr>
+          <p:cNvSpPr>
+            <a:spLocks xmlns:a="http://schemas.openxmlformats.org/drawingml/2006/main" noGrp="1"/>
+          </p:cNvSpPr>
+          <p:nvPr/>
+        </p:nvSpPr>
+        <p:spPr>
+          <a:xfrm xmlns:a="http://schemas.openxmlformats.org/drawingml/2006/main">
+            <a:off x="628650" y="2714625"/>
+            <a:ext cx="76200" cy="76200"/>
+          </a:xfrm>
+          <a:prstGeom xmlns:a="http://schemas.openxmlformats.org/drawingml/2006/main" prst="rect">
+            <a:avLst/>
+          </a:prstGeom>
+          <a:solidFill xmlns:a="http://schemas.openxmlformats.org/drawingml/2006/main">
+            <a:srgbClr val="1F4E79"/>
+          </a:solidFill>
+          <a:ln xmlns:a="http://schemas.openxmlformats.org/drawingml/2006/main" w="0">
+            <a:solidFill>
+              <a:srgbClr val="1F4E79"/>
+            </a:solidFill>
+            <a:prstDash val="solid"/>
+          </a:ln>
+        </p:spPr>
+      </p:sp>
+      <p:sp>
+        <p:nvSpPr>
+          <p:cNvPr id="11" name="">
+            <a:extLst xmlns:a="http://schemas.openxmlformats.org/drawingml/2006/main">
+              <a:ext uri="{FF2B5EF4-FFF2-40B4-BE49-F238E27FC236}">
+                <a16:creationId xmlns:a16="http://schemas.microsoft.com/office/drawing/2014/main" id="{D8EB7E6B-1E1D-44A3-A5DB-568FE7DC6E53}"/>
+              </a:ext>
+            </a:extLst>
+          </p:cNvPr>
+          <p:cNvSpPr>
+            <a:spLocks xmlns:a="http://schemas.openxmlformats.org/drawingml/2006/main" noGrp="1"/>
+          </p:cNvSpPr>
+          <p:nvPr/>
+        </p:nvSpPr>
+        <p:spPr>
+          <a:xfrm xmlns:a="http://schemas.openxmlformats.org/drawingml/2006/main">
+            <a:off x="819150" y="2628900"/>
+            <a:ext cx="4143375" cy="323850"/>
+          </a:xfrm>
+          <a:prstGeom xmlns:a="http://schemas.openxmlformats.org/drawingml/2006/main" prst="rect">
+            <a:avLst/>
+          </a:prstGeom>
+          <a:noFill xmlns:a="http://schemas.openxmlformats.org/drawingml/2006/main"/>
+          <a:ln xmlns:a="http://schemas.openxmlformats.org/drawingml/2006/main" w="0">
+            <a:noFill/>
+            <a:prstDash val="solid"/>
+          </a:ln>
+        </p:spPr>
+        <p:txBody>
+          <a:bodyPr xmlns:a="http://schemas.openxmlformats.org/drawingml/2006/main" anchor="t">
+            <a:noAutofit/>
+          </a:bodyPr>
+          <a:lstStyle xmlns:a="http://schemas.openxmlformats.org/drawingml/2006/main"/>
+          <a:p xmlns:a="http://schemas.openxmlformats.org/drawingml/2006/main">
+            <a:pPr algn="l">
+              <a:defRPr sz="1275" b="0">
+                <a:solidFill>
+                  <a:srgbClr val="334155"/>
+                </a:solidFill>
+                <a:latin typeface="Helvetica Neue"/>
+                <a:ea typeface="Helvetica Neue"/>
+                <a:cs typeface="Helvetica Neue"/>
+              </a:defRPr>
+            </a:pPr>
+            <a:r>
+              <a:rPr sz="1275" b="0">
+                <a:solidFill>
+                  <a:srgbClr val="334155"/>
+                </a:solidFill>
+                <a:latin typeface="Helvetica Neue"/>
+                <a:ea typeface="Helvetica Neue"/>
+                <a:cs typeface="Helvetica Neue"/>
+              </a:rPr>
+              <a:t>Baseline uses ordinary eviction behavior.</a:t>
+            </a:r>
+          </a:p>
+        </p:txBody>
+      </p:sp>
+      <p:sp>
+        <p:nvSpPr>
+          <p:cNvPr id="12" name="">
+            <a:extLst xmlns:a="http://schemas.openxmlformats.org/drawingml/2006/main">
+              <a:ext uri="{FF2B5EF4-FFF2-40B4-BE49-F238E27FC236}">
+                <a16:creationId xmlns:a16="http://schemas.microsoft.com/office/drawing/2014/main" id="{6E86DF83-A7D4-4B4F-AEF3-346AF071D143}"/>
+              </a:ext>
+            </a:extLst>
+          </p:cNvPr>
+          <p:cNvSpPr>
+            <a:spLocks xmlns:a="http://schemas.openxmlformats.org/drawingml/2006/main" noGrp="1"/>
+          </p:cNvSpPr>
+          <p:nvPr/>
+        </p:nvSpPr>
+        <p:spPr>
+          <a:xfrm xmlns:a="http://schemas.openxmlformats.org/drawingml/2006/main">
+            <a:off x="628650" y="3076575"/>
+            <a:ext cx="76200" cy="76200"/>
+          </a:xfrm>
+          <a:prstGeom xmlns:a="http://schemas.openxmlformats.org/drawingml/2006/main" prst="rect">
+            <a:avLst/>
+          </a:prstGeom>
+          <a:solidFill xmlns:a="http://schemas.openxmlformats.org/drawingml/2006/main">
+            <a:srgbClr val="1F4E79"/>
+          </a:solidFill>
+          <a:ln xmlns:a="http://schemas.openxmlformats.org/drawingml/2006/main" w="0">
+            <a:solidFill>
+              <a:srgbClr val="1F4E79"/>
+            </a:solidFill>
+            <a:prstDash val="solid"/>
+          </a:ln>
+        </p:spPr>
+      </p:sp>
+      <p:sp>
+        <p:nvSpPr>
+          <p:cNvPr id="13" name="">
+            <a:extLst xmlns:a="http://schemas.openxmlformats.org/drawingml/2006/main">
+              <a:ext uri="{FF2B5EF4-FFF2-40B4-BE49-F238E27FC236}">
+                <a16:creationId xmlns:a16="http://schemas.microsoft.com/office/drawing/2014/main" id="{157F42BD-60F6-4361-ABB4-0808BC272650}"/>
+              </a:ext>
+            </a:extLst>
+          </p:cNvPr>
+          <p:cNvSpPr>
+            <a:spLocks xmlns:a="http://schemas.openxmlformats.org/drawingml/2006/main" noGrp="1"/>
+          </p:cNvSpPr>
+          <p:nvPr/>
+        </p:nvSpPr>
+        <p:spPr>
+          <a:xfrm xmlns:a="http://schemas.openxmlformats.org/drawingml/2006/main">
+            <a:off x="819150" y="2990850"/>
+            <a:ext cx="4143375" cy="323850"/>
+          </a:xfrm>
+          <a:prstGeom xmlns:a="http://schemas.openxmlformats.org/drawingml/2006/main" prst="rect">
+            <a:avLst/>
+          </a:prstGeom>
+          <a:noFill xmlns:a="http://schemas.openxmlformats.org/drawingml/2006/main"/>
+          <a:ln xmlns:a="http://schemas.openxmlformats.org/drawingml/2006/main" w="0">
+            <a:noFill/>
+            <a:prstDash val="solid"/>
+          </a:ln>
+        </p:spPr>
+        <p:txBody>
+          <a:bodyPr xmlns:a="http://schemas.openxmlformats.org/drawingml/2006/main" anchor="t">
+            <a:noAutofit/>
+          </a:bodyPr>
+          <a:lstStyle xmlns:a="http://schemas.openxmlformats.org/drawingml/2006/main"/>
+          <a:p xmlns:a="http://schemas.openxmlformats.org/drawingml/2006/main">
+            <a:pPr algn="l">
+              <a:defRPr sz="1275" b="0">
+                <a:solidFill>
+                  <a:srgbClr val="334155"/>
+                </a:solidFill>
+                <a:latin typeface="Helvetica Neue"/>
+                <a:ea typeface="Helvetica Neue"/>
+                <a:cs typeface="Helvetica Neue"/>
+              </a:defRPr>
+            </a:pPr>
+            <a:r>
+              <a:rPr sz="1275" b="0">
+                <a:solidFill>
+                  <a:srgbClr val="334155"/>
+                </a:solidFill>
+                <a:latin typeface="Helvetica Neue"/>
+                <a:ea typeface="Helvetica Neue"/>
+                <a:cs typeface="Helvetica Neue"/>
+              </a:rPr>
+              <a:t>Controller mode marks cached prefixes by value.</a:t>
+            </a:r>
+          </a:p>
+        </p:txBody>
+      </p:sp>
+      <p:sp>
+        <p:nvSpPr>
+          <p:cNvPr id="14" name="">
+            <a:extLst xmlns:a="http://schemas.openxmlformats.org/drawingml/2006/main">
+              <a:ext uri="{FF2B5EF4-FFF2-40B4-BE49-F238E27FC236}">
+                <a16:creationId xmlns:a16="http://schemas.microsoft.com/office/drawing/2014/main" id="{5C137647-0680-40B0-A9C2-2FBA1277778A}"/>
+              </a:ext>
+            </a:extLst>
+          </p:cNvPr>
+          <p:cNvSpPr>
+            <a:spLocks xmlns:a="http://schemas.openxmlformats.org/drawingml/2006/main" noGrp="1"/>
+          </p:cNvSpPr>
+          <p:nvPr/>
+        </p:nvSpPr>
+        <p:spPr>
+          <a:xfrm xmlns:a="http://schemas.openxmlformats.org/drawingml/2006/main">
+            <a:off x="628650" y="3562350"/>
+            <a:ext cx="4333875" cy="1466850"/>
+          </a:xfrm>
+          <a:prstGeom xmlns:a="http://schemas.openxmlformats.org/drawingml/2006/main" prst="rect">
+            <a:avLst/>
+          </a:prstGeom>
+          <a:solidFill xmlns:a="http://schemas.openxmlformats.org/drawingml/2006/main">
+            <a:srgbClr val="F8FAFC"/>
+          </a:solidFill>
+          <a:ln xmlns:a="http://schemas.openxmlformats.org/drawingml/2006/main" w="9525">
+            <a:solidFill>
+              <a:srgbClr val="DBE4EF"/>
+            </a:solidFill>
+            <a:prstDash val="solid"/>
+          </a:ln>
+        </p:spPr>
+      </p:sp>
+      <p:sp>
+        <p:nvSpPr>
+          <p:cNvPr id="15" name="">
+            <a:extLst xmlns:a="http://schemas.openxmlformats.org/drawingml/2006/main">
+              <a:ext uri="{FF2B5EF4-FFF2-40B4-BE49-F238E27FC236}">
+                <a16:creationId xmlns:a16="http://schemas.microsoft.com/office/drawing/2014/main" id="{72798870-6222-426B-9098-927B309A597E}"/>
+              </a:ext>
+            </a:extLst>
+          </p:cNvPr>
+          <p:cNvSpPr>
+            <a:spLocks xmlns:a="http://schemas.openxmlformats.org/drawingml/2006/main" noGrp="1"/>
+          </p:cNvSpPr>
+          <p:nvPr/>
+        </p:nvSpPr>
+        <p:spPr>
+          <a:xfrm xmlns:a="http://schemas.openxmlformats.org/drawingml/2006/main">
+            <a:off x="838200" y="3752850"/>
+            <a:ext cx="3714750" cy="247650"/>
+          </a:xfrm>
+          <a:prstGeom xmlns:a="http://schemas.openxmlformats.org/drawingml/2006/main" prst="rect">
+            <a:avLst/>
+          </a:prstGeom>
+          <a:noFill xmlns:a="http://schemas.openxmlformats.org/drawingml/2006/main"/>
+          <a:ln xmlns:a="http://schemas.openxmlformats.org/drawingml/2006/main" w="0">
+            <a:noFill/>
+            <a:prstDash val="solid"/>
+          </a:ln>
+        </p:spPr>
+        <p:txBody>
+          <a:bodyPr xmlns:a="http://schemas.openxmlformats.org/drawingml/2006/main" anchor="t">
+            <a:noAutofit/>
+          </a:bodyPr>
+          <a:lstStyle xmlns:a="http://schemas.openxmlformats.org/drawingml/2006/main"/>
+          <a:p xmlns:a="http://schemas.openxmlformats.org/drawingml/2006/main">
+            <a:pPr algn="l">
+              <a:defRPr sz="1425" b="1">
+                <a:solidFill>
+                  <a:srgbClr val="111827"/>
+                </a:solidFill>
+                <a:latin typeface="Helvetica Neue"/>
+                <a:ea typeface="Helvetica Neue"/>
+                <a:cs typeface="Helvetica Neue"/>
+              </a:defRPr>
+            </a:pPr>
+            <a:r>
+              <a:rPr sz="1425" b="1">
+                <a:solidFill>
+                  <a:srgbClr val="111827"/>
+                </a:solidFill>
+                <a:latin typeface="Helvetica Neue"/>
+                <a:ea typeface="Helvetica Neue"/>
+                <a:cs typeface="Helvetica Neue"/>
+              </a:rPr>
+              <a:t>What the controller does</a:t>
+            </a:r>
+          </a:p>
+        </p:txBody>
+      </p:sp>
+      <p:sp>
+        <p:nvSpPr>
+          <p:cNvPr id="16" name="">
+            <a:extLst xmlns:a="http://schemas.openxmlformats.org/drawingml/2006/main">
+              <a:ext uri="{FF2B5EF4-FFF2-40B4-BE49-F238E27FC236}">
+                <a16:creationId xmlns:a16="http://schemas.microsoft.com/office/drawing/2014/main" id="{93947A90-3215-418F-8941-B0C540C08F82}"/>
+              </a:ext>
+            </a:extLst>
+          </p:cNvPr>
+          <p:cNvSpPr>
+            <a:spLocks xmlns:a="http://schemas.openxmlformats.org/drawingml/2006/main" noGrp="1"/>
+          </p:cNvSpPr>
+          <p:nvPr/>
+        </p:nvSpPr>
+        <p:spPr>
+          <a:xfrm xmlns:a="http://schemas.openxmlformats.org/drawingml/2006/main">
+            <a:off x="838200" y="4076700"/>
+            <a:ext cx="3714750" cy="723900"/>
+          </a:xfrm>
+          <a:prstGeom xmlns:a="http://schemas.openxmlformats.org/drawingml/2006/main" prst="rect">
+            <a:avLst/>
+          </a:prstGeom>
+          <a:noFill xmlns:a="http://schemas.openxmlformats.org/drawingml/2006/main"/>
+          <a:ln xmlns:a="http://schemas.openxmlformats.org/drawingml/2006/main" w="0">
+            <a:noFill/>
+            <a:prstDash val="solid"/>
+          </a:ln>
+        </p:spPr>
+        <p:txBody>
+          <a:bodyPr xmlns:a="http://schemas.openxmlformats.org/drawingml/2006/main" anchor="t">
+            <a:noAutofit/>
+          </a:bodyPr>
+          <a:lstStyle xmlns:a="http://schemas.openxmlformats.org/drawingml/2006/main"/>
+          <a:p xmlns:a="http://schemas.openxmlformats.org/drawingml/2006/main">
+            <a:pPr algn="l">
+              <a:defRPr sz="1275" b="0">
+                <a:solidFill>
+                  <a:srgbClr val="334155"/>
+                </a:solidFill>
+                <a:latin typeface="Helvetica Neue"/>
+                <a:ea typeface="Helvetica Neue"/>
+                <a:cs typeface="Helvetica Neue"/>
+              </a:defRPr>
+            </a:pPr>
+            <a:r>
+              <a:rPr sz="1275" b="0">
+                <a:solidFill>
+                  <a:srgbClr val="334155"/>
+                </a:solidFill>
+                <a:latin typeface="Helvetica Neue"/>
+                <a:ea typeface="Helvetica Neue"/>
+                <a:cs typeface="Helvetica Neue"/>
+              </a:rPr>
+              <a:t>It scores cached prefixes using reuse likelihood, rebuild cost, and expected replay timing. SGLang's native radix eviction path then chooses what to evict.</a:t>
+            </a:r>
+          </a:p>
+        </p:txBody>
+      </p:sp>
+      <p:sp>
+        <p:nvSpPr>
+          <p:cNvPr id="17" name="">
+            <a:extLst xmlns:a="http://schemas.openxmlformats.org/drawingml/2006/main">
+              <a:ext uri="{FF2B5EF4-FFF2-40B4-BE49-F238E27FC236}">
+                <a16:creationId xmlns:a16="http://schemas.microsoft.com/office/drawing/2014/main" id="{7697BA95-4842-449B-9880-5ABC358A879E}"/>
+              </a:ext>
+            </a:extLst>
+          </p:cNvPr>
+          <p:cNvSpPr>
+            <a:spLocks xmlns:a="http://schemas.openxmlformats.org/drawingml/2006/main" noGrp="1"/>
+          </p:cNvSpPr>
+          <p:nvPr/>
+        </p:nvSpPr>
+        <p:spPr>
+          <a:xfrm xmlns:a="http://schemas.openxmlformats.org/drawingml/2006/main">
+            <a:off x="5619750" y="1524000"/>
+            <a:ext cx="5334000" cy="266700"/>
+          </a:xfrm>
+          <a:prstGeom xmlns:a="http://schemas.openxmlformats.org/drawingml/2006/main" prst="rect">
+            <a:avLst/>
+          </a:prstGeom>
+          <a:noFill xmlns:a="http://schemas.openxmlformats.org/drawingml/2006/main"/>
+          <a:ln xmlns:a="http://schemas.openxmlformats.org/drawingml/2006/main" w="0">
+            <a:noFill/>
+            <a:prstDash val="solid"/>
+          </a:ln>
+        </p:spPr>
+        <p:txBody>
+          <a:bodyPr xmlns:a="http://schemas.openxmlformats.org/drawingml/2006/main" anchor="t">
+            <a:noAutofit/>
+          </a:bodyPr>
+          <a:lstStyle xmlns:a="http://schemas.openxmlformats.org/drawingml/2006/main"/>
+          <a:p xmlns:a="http://schemas.openxmlformats.org/drawingml/2006/main">
+            <a:pPr algn="l">
+              <a:defRPr sz="1575" b="1">
+                <a:solidFill>
+                  <a:srgbClr val="111827"/>
+                </a:solidFill>
+                <a:latin typeface="Helvetica Neue"/>
+                <a:ea typeface="Helvetica Neue"/>
+                <a:cs typeface="Helvetica Neue"/>
+              </a:defRPr>
+            </a:pPr>
+            <a:r>
+              <a:rPr sz="1575" b="1">
+                <a:solidFill>
+                  <a:srgbClr val="111827"/>
+                </a:solidFill>
+                <a:latin typeface="Helvetica Neue"/>
+                <a:ea typeface="Helvetica Neue"/>
+                <a:cs typeface="Helvetica Neue"/>
+              </a:rPr>
+              <a:t>Results across all replay requests</a:t>
+            </a:r>
+          </a:p>
+        </p:txBody>
+      </p:sp>
+      <p:sp>
+        <p:nvSpPr>
+          <p:cNvPr id="18" name="">
+            <a:extLst xmlns:a="http://schemas.openxmlformats.org/drawingml/2006/main">
+              <a:ext uri="{FF2B5EF4-FFF2-40B4-BE49-F238E27FC236}">
+                <a16:creationId xmlns:a16="http://schemas.microsoft.com/office/drawing/2014/main" id="{A8DDD8C4-6A97-4297-A1CA-B4F90612DD14}"/>
+              </a:ext>
+            </a:extLst>
+          </p:cNvPr>
+          <p:cNvSpPr>
+            <a:spLocks xmlns:a="http://schemas.openxmlformats.org/drawingml/2006/main" noGrp="1"/>
+          </p:cNvSpPr>
+          <p:nvPr/>
+        </p:nvSpPr>
+        <p:spPr>
+          <a:xfrm xmlns:a="http://schemas.openxmlformats.org/drawingml/2006/main">
+            <a:off x="5619750" y="1828800"/>
+            <a:ext cx="5715000" cy="228600"/>
+          </a:xfrm>
+          <a:prstGeom xmlns:a="http://schemas.openxmlformats.org/drawingml/2006/main" prst="rect">
+            <a:avLst/>
+          </a:prstGeom>
+          <a:noFill xmlns:a="http://schemas.openxmlformats.org/drawingml/2006/main"/>
+          <a:ln xmlns:a="http://schemas.openxmlformats.org/drawingml/2006/main" w="0">
+            <a:noFill/>
+            <a:prstDash val="solid"/>
+          </a:ln>
+        </p:spPr>
+        <p:txBody>
+          <a:bodyPr xmlns:a="http://schemas.openxmlformats.org/drawingml/2006/main" anchor="t">
+            <a:noAutofit/>
+          </a:bodyPr>
+          <a:lstStyle xmlns:a="http://schemas.openxmlformats.org/drawingml/2006/main"/>
+          <a:p xmlns:a="http://schemas.openxmlformats.org/drawingml/2006/main">
+            <a:pPr algn="l">
+              <a:defRPr sz="975" b="0">
+                <a:solidFill>
+                  <a:srgbClr val="64748B"/>
+                </a:solidFill>
+                <a:latin typeface="Helvetica Neue"/>
+                <a:ea typeface="Helvetica Neue"/>
+                <a:cs typeface="Helvetica Neue"/>
+              </a:defRPr>
+            </a:pPr>
+            <a:r>
+              <a:rPr sz="975" b="0">
+                <a:solidFill>
+                  <a:srgbClr val="64748B"/>
+                </a:solidFill>
+                <a:latin typeface="Helvetica Neue"/>
+                <a:ea typeface="Helvetica Neue"/>
+                <a:cs typeface="Helvetica Neue"/>
+              </a:rPr>
+              <a:t>Latest all-request run: value_aware_eviction_all_requests_fixed_20260917_163518</a:t>
+            </a:r>
+          </a:p>
+        </p:txBody>
+      </p:sp>
+      <p:sp>
+        <p:nvSpPr>
+          <p:cNvPr id="19" name="">
+            <a:extLst xmlns:a="http://schemas.openxmlformats.org/drawingml/2006/main">
+              <a:ext uri="{FF2B5EF4-FFF2-40B4-BE49-F238E27FC236}">
+                <a16:creationId xmlns:a16="http://schemas.microsoft.com/office/drawing/2014/main" id="{DE8B9931-788F-425D-8D4B-83B5BC2167DA}"/>
+              </a:ext>
+            </a:extLst>
+          </p:cNvPr>
+          <p:cNvSpPr>
+            <a:spLocks xmlns:a="http://schemas.openxmlformats.org/drawingml/2006/main" noGrp="1"/>
+          </p:cNvSpPr>
+          <p:nvPr/>
+        </p:nvSpPr>
+        <p:spPr>
+          <a:xfrm xmlns:a="http://schemas.openxmlformats.org/drawingml/2006/main">
+            <a:off x="5619750" y="2171700"/>
+            <a:ext cx="2571750" cy="838200"/>
+          </a:xfrm>
+          <a:prstGeom xmlns:a="http://schemas.openxmlformats.org/drawingml/2006/main" prst="rect">
+            <a:avLst/>
+          </a:prstGeom>
+          <a:solidFill xmlns:a="http://schemas.openxmlformats.org/drawingml/2006/main">
+            <a:srgbClr val="F8FAFC"/>
+          </a:solidFill>
+          <a:ln xmlns:a="http://schemas.openxmlformats.org/drawingml/2006/main" w="9525">
+            <a:solidFill>
+              <a:srgbClr val="DBE4EF"/>
+            </a:solidFill>
+            <a:prstDash val="solid"/>
+          </a:ln>
+        </p:spPr>
+      </p:sp>
+      <p:sp>
+        <p:nvSpPr>
+          <p:cNvPr id="20" name="">
+            <a:extLst xmlns:a="http://schemas.openxmlformats.org/drawingml/2006/main">
+              <a:ext uri="{FF2B5EF4-FFF2-40B4-BE49-F238E27FC236}">
+                <a16:creationId xmlns:a16="http://schemas.microsoft.com/office/drawing/2014/main" id="{CAD07384-0548-489F-8F03-1808A75A0882}"/>
+              </a:ext>
+            </a:extLst>
+          </p:cNvPr>
+          <p:cNvSpPr>
+            <a:spLocks xmlns:a="http://schemas.openxmlformats.org/drawingml/2006/main" noGrp="1"/>
+          </p:cNvSpPr>
+          <p:nvPr/>
+        </p:nvSpPr>
+        <p:spPr>
+          <a:xfrm xmlns:a="http://schemas.openxmlformats.org/drawingml/2006/main">
+            <a:off x="5772150" y="2286000"/>
+            <a:ext cx="2266950" cy="209550"/>
+          </a:xfrm>
+          <a:prstGeom xmlns:a="http://schemas.openxmlformats.org/drawingml/2006/main" prst="rect">
+            <a:avLst/>
+          </a:prstGeom>
+          <a:noFill xmlns:a="http://schemas.openxmlformats.org/drawingml/2006/main"/>
+          <a:ln xmlns:a="http://schemas.openxmlformats.org/drawingml/2006/main" w="0">
+            <a:noFill/>
+            <a:prstDash val="solid"/>
+          </a:ln>
+        </p:spPr>
+        <p:txBody>
+          <a:bodyPr xmlns:a="http://schemas.openxmlformats.org/drawingml/2006/main" anchor="t">
+            <a:noAutofit/>
+          </a:bodyPr>
+          <a:lstStyle xmlns:a="http://schemas.openxmlformats.org/drawingml/2006/main"/>
+          <a:p xmlns:a="http://schemas.openxmlformats.org/drawingml/2006/main">
+            <a:pPr algn="l">
+              <a:defRPr sz="1050" b="1">
+                <a:solidFill>
+                  <a:srgbClr val="64748B"/>
+                </a:solidFill>
+                <a:latin typeface="Helvetica Neue"/>
+                <a:ea typeface="Helvetica Neue"/>
+                <a:cs typeface="Helvetica Neue"/>
+              </a:defRPr>
+            </a:pPr>
+            <a:r>
+              <a:rPr sz="1050" b="1">
+                <a:solidFill>
+                  <a:srgbClr val="64748B"/>
+                </a:solidFill>
+                <a:latin typeface="Helvetica Neue"/>
+                <a:ea typeface="Helvetica Neue"/>
+                <a:cs typeface="Helvetica Neue"/>
+              </a:rPr>
+              <a:t>Total TTFT</a:t>
+            </a:r>
+          </a:p>
+        </p:txBody>
+      </p:sp>
+      <p:sp>
+        <p:nvSpPr>
+          <p:cNvPr id="21" name="">
+            <a:extLst xmlns:a="http://schemas.openxmlformats.org/drawingml/2006/main">
+              <a:ext uri="{FF2B5EF4-FFF2-40B4-BE49-F238E27FC236}">
+                <a16:creationId xmlns:a16="http://schemas.microsoft.com/office/drawing/2014/main" id="{B77DE799-1EF8-4ADA-9282-59528F257143}"/>
+              </a:ext>
+            </a:extLst>
+          </p:cNvPr>
+          <p:cNvSpPr>
+            <a:spLocks xmlns:a="http://schemas.openxmlformats.org/drawingml/2006/main" noGrp="1"/>
+          </p:cNvSpPr>
+          <p:nvPr/>
+        </p:nvSpPr>
+        <p:spPr>
+          <a:xfrm xmlns:a="http://schemas.openxmlformats.org/drawingml/2006/main">
+            <a:off x="5772150" y="2514600"/>
+            <a:ext cx="2266950" cy="266700"/>
+          </a:xfrm>
+          <a:prstGeom xmlns:a="http://schemas.openxmlformats.org/drawingml/2006/main" prst="rect">
+            <a:avLst/>
+          </a:prstGeom>
+          <a:noFill xmlns:a="http://schemas.openxmlformats.org/drawingml/2006/main"/>
+          <a:ln xmlns:a="http://schemas.openxmlformats.org/drawingml/2006/main" w="0">
+            <a:noFill/>
+            <a:prstDash val="solid"/>
+          </a:ln>
+        </p:spPr>
+        <p:txBody>
+          <a:bodyPr xmlns:a="http://schemas.openxmlformats.org/drawingml/2006/main" anchor="t">
+            <a:noAutofit/>
+          </a:bodyPr>
+          <a:lstStyle xmlns:a="http://schemas.openxmlformats.org/drawingml/2006/main"/>
+          <a:p xmlns:a="http://schemas.openxmlformats.org/drawingml/2006/main">
+            <a:pPr algn="l">
+              <a:defRPr sz="1725" b="1">
+                <a:solidFill>
+                  <a:srgbClr val="111827"/>
+                </a:solidFill>
+                <a:latin typeface="Helvetica Neue"/>
+                <a:ea typeface="Helvetica Neue"/>
+                <a:cs typeface="Helvetica Neue"/>
+              </a:defRPr>
+            </a:pPr>
+            <a:r>
+              <a:rPr sz="1725" b="1">
+                <a:solidFill>
+                  <a:srgbClr val="111827"/>
+                </a:solidFill>
+                <a:latin typeface="Helvetica Neue"/>
+                <a:ea typeface="Helvetica Neue"/>
+                <a:cs typeface="Helvetica Neue"/>
+              </a:rPr>
+              <a:t>51.6% better</a:t>
+            </a:r>
+          </a:p>
+        </p:txBody>
+      </p:sp>
+      <p:sp>
+        <p:nvSpPr>
+          <p:cNvPr id="22" name="">
+            <a:extLst xmlns:a="http://schemas.openxmlformats.org/drawingml/2006/main">
+              <a:ext uri="{FF2B5EF4-FFF2-40B4-BE49-F238E27FC236}">
+                <a16:creationId xmlns:a16="http://schemas.microsoft.com/office/drawing/2014/main" id="{DAA67374-DBEE-42E1-9608-881070C58FB7}"/>
+              </a:ext>
+            </a:extLst>
+          </p:cNvPr>
+          <p:cNvSpPr>
+            <a:spLocks xmlns:a="http://schemas.openxmlformats.org/drawingml/2006/main" noGrp="1"/>
+          </p:cNvSpPr>
+          <p:nvPr/>
+        </p:nvSpPr>
+        <p:spPr>
+          <a:xfrm xmlns:a="http://schemas.openxmlformats.org/drawingml/2006/main">
+            <a:off x="5772150" y="2800350"/>
+            <a:ext cx="2266950" cy="171450"/>
+          </a:xfrm>
+          <a:prstGeom xmlns:a="http://schemas.openxmlformats.org/drawingml/2006/main" prst="rect">
+            <a:avLst/>
+          </a:prstGeom>
+          <a:noFill xmlns:a="http://schemas.openxmlformats.org/drawingml/2006/main"/>
+          <a:ln xmlns:a="http://schemas.openxmlformats.org/drawingml/2006/main" w="0">
+            <a:noFill/>
+            <a:prstDash val="solid"/>
+          </a:ln>
+        </p:spPr>
+        <p:txBody>
+          <a:bodyPr xmlns:a="http://schemas.openxmlformats.org/drawingml/2006/main" anchor="t">
+            <a:noAutofit/>
+          </a:bodyPr>
+          <a:lstStyle xmlns:a="http://schemas.openxmlformats.org/drawingml/2006/main"/>
+          <a:p xmlns:a="http://schemas.openxmlformats.org/drawingml/2006/main">
+            <a:pPr algn="l">
+              <a:defRPr sz="938" b="0">
+                <a:solidFill>
+                  <a:srgbClr val="334155"/>
+                </a:solidFill>
+                <a:latin typeface="Helvetica Neue"/>
+                <a:ea typeface="Helvetica Neue"/>
+                <a:cs typeface="Helvetica Neue"/>
+              </a:defRPr>
+            </a:pPr>
+            <a:r>
+              <a:rPr sz="938" b="0">
+                <a:solidFill>
+                  <a:srgbClr val="334155"/>
+                </a:solidFill>
+                <a:latin typeface="Helvetica Neue"/>
+                <a:ea typeface="Helvetica Neue"/>
+                <a:cs typeface="Helvetica Neue"/>
+              </a:rPr>
+              <a:t>482.3 s to 233.5 s</a:t>
+            </a:r>
+          </a:p>
+        </p:txBody>
+      </p:sp>
+      <p:sp>
+        <p:nvSpPr>
+          <p:cNvPr id="23" name="">
+            <a:extLst xmlns:a="http://schemas.openxmlformats.org/drawingml/2006/main">
+              <a:ext uri="{FF2B5EF4-FFF2-40B4-BE49-F238E27FC236}">
+                <a16:creationId xmlns:a16="http://schemas.microsoft.com/office/drawing/2014/main" id="{0610C4E4-89E4-4D13-B108-5272E9E4E32E}"/>
+              </a:ext>
+            </a:extLst>
+          </p:cNvPr>
+          <p:cNvSpPr>
+            <a:spLocks xmlns:a="http://schemas.openxmlformats.org/drawingml/2006/main" noGrp="1"/>
+          </p:cNvSpPr>
+          <p:nvPr/>
+        </p:nvSpPr>
+        <p:spPr>
+          <a:xfrm xmlns:a="http://schemas.openxmlformats.org/drawingml/2006/main">
+            <a:off x="8401050" y="2171700"/>
+            <a:ext cx="2571750" cy="838200"/>
+          </a:xfrm>
+          <a:prstGeom xmlns:a="http://schemas.openxmlformats.org/drawingml/2006/main" prst="rect">
+            <a:avLst/>
+          </a:prstGeom>
+          <a:solidFill xmlns:a="http://schemas.openxmlformats.org/drawingml/2006/main">
+            <a:srgbClr val="F8FAFC"/>
+          </a:solidFill>
+          <a:ln xmlns:a="http://schemas.openxmlformats.org/drawingml/2006/main" w="9525">
+            <a:solidFill>
+              <a:srgbClr val="DBE4EF"/>
+            </a:solidFill>
+            <a:prstDash val="solid"/>
+          </a:ln>
+        </p:spPr>
+      </p:sp>
+      <p:sp>
+        <p:nvSpPr>
+          <p:cNvPr id="24" name="">
+            <a:extLst xmlns:a="http://schemas.openxmlformats.org/drawingml/2006/main">
+              <a:ext uri="{FF2B5EF4-FFF2-40B4-BE49-F238E27FC236}">
+                <a16:creationId xmlns:a16="http://schemas.microsoft.com/office/drawing/2014/main" id="{EB1557D0-9D75-440E-9F83-AF35BAD05D68}"/>
+              </a:ext>
+            </a:extLst>
+          </p:cNvPr>
+          <p:cNvSpPr>
+            <a:spLocks xmlns:a="http://schemas.openxmlformats.org/drawingml/2006/main" noGrp="1"/>
+          </p:cNvSpPr>
+          <p:nvPr/>
+        </p:nvSpPr>
+        <p:spPr>
+          <a:xfrm xmlns:a="http://schemas.openxmlformats.org/drawingml/2006/main">
+            <a:off x="8553450" y="2286000"/>
+            <a:ext cx="2266950" cy="209550"/>
+          </a:xfrm>
+          <a:prstGeom xmlns:a="http://schemas.openxmlformats.org/drawingml/2006/main" prst="rect">
+            <a:avLst/>
+          </a:prstGeom>
+          <a:noFill xmlns:a="http://schemas.openxmlformats.org/drawingml/2006/main"/>
+          <a:ln xmlns:a="http://schemas.openxmlformats.org/drawingml/2006/main" w="0">
+            <a:noFill/>
+            <a:prstDash val="solid"/>
+          </a:ln>
+        </p:spPr>
+        <p:txBody>
+          <a:bodyPr xmlns:a="http://schemas.openxmlformats.org/drawingml/2006/main" anchor="t">
+            <a:noAutofit/>
+          </a:bodyPr>
+          <a:lstStyle xmlns:a="http://schemas.openxmlformats.org/drawingml/2006/main"/>
+          <a:p xmlns:a="http://schemas.openxmlformats.org/drawingml/2006/main">
+            <a:pPr algn="l">
+              <a:defRPr sz="1050" b="1">
+                <a:solidFill>
+                  <a:srgbClr val="64748B"/>
+                </a:solidFill>
+                <a:latin typeface="Helvetica Neue"/>
+                <a:ea typeface="Helvetica Neue"/>
+                <a:cs typeface="Helvetica Neue"/>
+              </a:defRPr>
+            </a:pPr>
+            <a:r>
+              <a:rPr sz="1050" b="1">
+                <a:solidFill>
+                  <a:srgbClr val="64748B"/>
+                </a:solidFill>
+                <a:latin typeface="Helvetica Neue"/>
+                <a:ea typeface="Helvetica Neue"/>
+                <a:cs typeface="Helvetica Neue"/>
+              </a:rPr>
+              <a:t>Avg TTFT per request</a:t>
+            </a:r>
+          </a:p>
+        </p:txBody>
+      </p:sp>
+      <p:sp>
+        <p:nvSpPr>
+          <p:cNvPr id="25" name="">
+            <a:extLst xmlns:a="http://schemas.openxmlformats.org/drawingml/2006/main">
+              <a:ext uri="{FF2B5EF4-FFF2-40B4-BE49-F238E27FC236}">
+                <a16:creationId xmlns:a16="http://schemas.microsoft.com/office/drawing/2014/main" id="{FD76D413-3275-4DA3-A6C3-480CCCE2ED08}"/>
+              </a:ext>
+            </a:extLst>
+          </p:cNvPr>
+          <p:cNvSpPr>
+            <a:spLocks xmlns:a="http://schemas.openxmlformats.org/drawingml/2006/main" noGrp="1"/>
+          </p:cNvSpPr>
+          <p:nvPr/>
+        </p:nvSpPr>
+        <p:spPr>
+          <a:xfrm xmlns:a="http://schemas.openxmlformats.org/drawingml/2006/main">
+            <a:off x="8553450" y="2514600"/>
+            <a:ext cx="2266950" cy="266700"/>
+          </a:xfrm>
+          <a:prstGeom xmlns:a="http://schemas.openxmlformats.org/drawingml/2006/main" prst="rect">
+            <a:avLst/>
+          </a:prstGeom>
+          <a:noFill xmlns:a="http://schemas.openxmlformats.org/drawingml/2006/main"/>
+          <a:ln xmlns:a="http://schemas.openxmlformats.org/drawingml/2006/main" w="0">
+            <a:noFill/>
+            <a:prstDash val="solid"/>
+          </a:ln>
+        </p:spPr>
+        <p:txBody>
+          <a:bodyPr xmlns:a="http://schemas.openxmlformats.org/drawingml/2006/main" anchor="t">
+            <a:noAutofit/>
+          </a:bodyPr>
+          <a:lstStyle xmlns:a="http://schemas.openxmlformats.org/drawingml/2006/main"/>
+          <a:p xmlns:a="http://schemas.openxmlformats.org/drawingml/2006/main">
+            <a:pPr algn="l">
+              <a:defRPr sz="1725" b="1">
+                <a:solidFill>
+                  <a:srgbClr val="111827"/>
+                </a:solidFill>
+                <a:latin typeface="Helvetica Neue"/>
+                <a:ea typeface="Helvetica Neue"/>
+                <a:cs typeface="Helvetica Neue"/>
+              </a:defRPr>
+            </a:pPr>
+            <a:r>
+              <a:rPr sz="1725" b="1">
+                <a:solidFill>
+                  <a:srgbClr val="111827"/>
+                </a:solidFill>
+                <a:latin typeface="Helvetica Neue"/>
+                <a:ea typeface="Helvetica Neue"/>
+                <a:cs typeface="Helvetica Neue"/>
+              </a:rPr>
+              <a:t>7.8 s faster</a:t>
+            </a:r>
+          </a:p>
+        </p:txBody>
+      </p:sp>
+      <p:sp>
+        <p:nvSpPr>
+          <p:cNvPr id="26" name="">
+            <a:extLst xmlns:a="http://schemas.openxmlformats.org/drawingml/2006/main">
+              <a:ext uri="{FF2B5EF4-FFF2-40B4-BE49-F238E27FC236}">
+                <a16:creationId xmlns:a16="http://schemas.microsoft.com/office/drawing/2014/main" id="{1282039E-9247-42E1-8B7F-6C0E03DA2B11}"/>
+              </a:ext>
+            </a:extLst>
+          </p:cNvPr>
+          <p:cNvSpPr>
+            <a:spLocks xmlns:a="http://schemas.openxmlformats.org/drawingml/2006/main" noGrp="1"/>
+          </p:cNvSpPr>
+          <p:nvPr/>
+        </p:nvSpPr>
+        <p:spPr>
+          <a:xfrm xmlns:a="http://schemas.openxmlformats.org/drawingml/2006/main">
+            <a:off x="8553450" y="2800350"/>
+            <a:ext cx="2266950" cy="171450"/>
+          </a:xfrm>
+          <a:prstGeom xmlns:a="http://schemas.openxmlformats.org/drawingml/2006/main" prst="rect">
+            <a:avLst/>
+          </a:prstGeom>
+          <a:noFill xmlns:a="http://schemas.openxmlformats.org/drawingml/2006/main"/>
+          <a:ln xmlns:a="http://schemas.openxmlformats.org/drawingml/2006/main" w="0">
+            <a:noFill/>
+            <a:prstDash val="solid"/>
+          </a:ln>
+        </p:spPr>
+        <p:txBody>
+          <a:bodyPr xmlns:a="http://schemas.openxmlformats.org/drawingml/2006/main" anchor="t">
+            <a:noAutofit/>
+          </a:bodyPr>
+          <a:lstStyle xmlns:a="http://schemas.openxmlformats.org/drawingml/2006/main"/>
+          <a:p xmlns:a="http://schemas.openxmlformats.org/drawingml/2006/main">
+            <a:pPr algn="l">
+              <a:defRPr sz="938" b="0">
+                <a:solidFill>
+                  <a:srgbClr val="334155"/>
+                </a:solidFill>
+                <a:latin typeface="Helvetica Neue"/>
+                <a:ea typeface="Helvetica Neue"/>
+                <a:cs typeface="Helvetica Neue"/>
+              </a:defRPr>
+            </a:pPr>
+            <a:r>
+              <a:rPr sz="938" b="0">
+                <a:solidFill>
+                  <a:srgbClr val="334155"/>
+                </a:solidFill>
+                <a:latin typeface="Helvetica Neue"/>
+                <a:ea typeface="Helvetica Neue"/>
+                <a:cs typeface="Helvetica Neue"/>
+              </a:rPr>
+              <a:t>15.1 s to 7.3 s</a:t>
+            </a:r>
+          </a:p>
+        </p:txBody>
+      </p:sp>
+      <p:sp>
+        <p:nvSpPr>
+          <p:cNvPr id="27" name="">
+            <a:extLst xmlns:a="http://schemas.openxmlformats.org/drawingml/2006/main">
+              <a:ext uri="{FF2B5EF4-FFF2-40B4-BE49-F238E27FC236}">
+                <a16:creationId xmlns:a16="http://schemas.microsoft.com/office/drawing/2014/main" id="{AFAA961E-34FF-4851-A27D-39E29FBD8A9F}"/>
+              </a:ext>
+            </a:extLst>
+          </p:cNvPr>
+          <p:cNvSpPr>
+            <a:spLocks xmlns:a="http://schemas.openxmlformats.org/drawingml/2006/main" noGrp="1"/>
+          </p:cNvSpPr>
+          <p:nvPr/>
+        </p:nvSpPr>
+        <p:spPr>
+          <a:xfrm xmlns:a="http://schemas.openxmlformats.org/drawingml/2006/main">
+            <a:off x="5619750" y="3181350"/>
+            <a:ext cx="2571750" cy="838200"/>
+          </a:xfrm>
+          <a:prstGeom xmlns:a="http://schemas.openxmlformats.org/drawingml/2006/main" prst="rect">
+            <a:avLst/>
+          </a:prstGeom>
+          <a:solidFill xmlns:a="http://schemas.openxmlformats.org/drawingml/2006/main">
+            <a:srgbClr val="F8FAFC"/>
+          </a:solidFill>
+          <a:ln xmlns:a="http://schemas.openxmlformats.org/drawingml/2006/main" w="9525">
+            <a:solidFill>
+              <a:srgbClr val="DBE4EF"/>
+            </a:solidFill>
+            <a:prstDash val="solid"/>
+          </a:ln>
+        </p:spPr>
+      </p:sp>
+      <p:sp>
+        <p:nvSpPr>
+          <p:cNvPr id="28" name="">
+            <a:extLst xmlns:a="http://schemas.openxmlformats.org/drawingml/2006/main">
+              <a:ext uri="{FF2B5EF4-FFF2-40B4-BE49-F238E27FC236}">
+                <a16:creationId xmlns:a16="http://schemas.microsoft.com/office/drawing/2014/main" id="{6FD8BF38-AB7C-4F34-A188-4772585E61DF}"/>
+              </a:ext>
+            </a:extLst>
+          </p:cNvPr>
+          <p:cNvSpPr>
+            <a:spLocks xmlns:a="http://schemas.openxmlformats.org/drawingml/2006/main" noGrp="1"/>
+          </p:cNvSpPr>
+          <p:nvPr/>
+        </p:nvSpPr>
+        <p:spPr>
+          <a:xfrm xmlns:a="http://schemas.openxmlformats.org/drawingml/2006/main">
+            <a:off x="5772150" y="3295650"/>
+            <a:ext cx="2266950" cy="209550"/>
+          </a:xfrm>
+          <a:prstGeom xmlns:a="http://schemas.openxmlformats.org/drawingml/2006/main" prst="rect">
+            <a:avLst/>
+          </a:prstGeom>
+          <a:noFill xmlns:a="http://schemas.openxmlformats.org/drawingml/2006/main"/>
+          <a:ln xmlns:a="http://schemas.openxmlformats.org/drawingml/2006/main" w="0">
+            <a:noFill/>
+            <a:prstDash val="solid"/>
+          </a:ln>
+        </p:spPr>
+        <p:txBody>
+          <a:bodyPr xmlns:a="http://schemas.openxmlformats.org/drawingml/2006/main" anchor="t">
+            <a:noAutofit/>
+          </a:bodyPr>
+          <a:lstStyle xmlns:a="http://schemas.openxmlformats.org/drawingml/2006/main"/>
+          <a:p xmlns:a="http://schemas.openxmlformats.org/drawingml/2006/main">
+            <a:pPr algn="l">
+              <a:defRPr sz="1050" b="1">
+                <a:solidFill>
+                  <a:srgbClr val="64748B"/>
+                </a:solidFill>
+                <a:latin typeface="Helvetica Neue"/>
+                <a:ea typeface="Helvetica Neue"/>
+                <a:cs typeface="Helvetica Neue"/>
+              </a:defRPr>
+            </a:pPr>
+            <a:r>
+              <a:rPr sz="1050" b="1">
+                <a:solidFill>
+                  <a:srgbClr val="64748B"/>
+                </a:solidFill>
+                <a:latin typeface="Helvetica Neue"/>
+                <a:ea typeface="Helvetica Neue"/>
+                <a:cs typeface="Helvetica Neue"/>
+              </a:rPr>
+              <a:t>Total lateness</a:t>
+            </a:r>
+          </a:p>
+        </p:txBody>
+      </p:sp>
+      <p:sp>
+        <p:nvSpPr>
+          <p:cNvPr id="29" name="">
+            <a:extLst xmlns:a="http://schemas.openxmlformats.org/drawingml/2006/main">
+              <a:ext uri="{FF2B5EF4-FFF2-40B4-BE49-F238E27FC236}">
+                <a16:creationId xmlns:a16="http://schemas.microsoft.com/office/drawing/2014/main" id="{762B32F7-029C-47C4-9908-CDDB0BBDFF06}"/>
+              </a:ext>
+            </a:extLst>
+          </p:cNvPr>
+          <p:cNvSpPr>
+            <a:spLocks xmlns:a="http://schemas.openxmlformats.org/drawingml/2006/main" noGrp="1"/>
+          </p:cNvSpPr>
+          <p:nvPr/>
+        </p:nvSpPr>
+        <p:spPr>
+          <a:xfrm xmlns:a="http://schemas.openxmlformats.org/drawingml/2006/main">
+            <a:off x="5772150" y="3524250"/>
+            <a:ext cx="2266950" cy="266700"/>
+          </a:xfrm>
+          <a:prstGeom xmlns:a="http://schemas.openxmlformats.org/drawingml/2006/main" prst="rect">
+            <a:avLst/>
+          </a:prstGeom>
+          <a:noFill xmlns:a="http://schemas.openxmlformats.org/drawingml/2006/main"/>
+          <a:ln xmlns:a="http://schemas.openxmlformats.org/drawingml/2006/main" w="0">
+            <a:noFill/>
+            <a:prstDash val="solid"/>
+          </a:ln>
+        </p:spPr>
+        <p:txBody>
+          <a:bodyPr xmlns:a="http://schemas.openxmlformats.org/drawingml/2006/main" anchor="t">
+            <a:noAutofit/>
+          </a:bodyPr>
+          <a:lstStyle xmlns:a="http://schemas.openxmlformats.org/drawingml/2006/main"/>
+          <a:p xmlns:a="http://schemas.openxmlformats.org/drawingml/2006/main">
+            <a:pPr algn="l">
+              <a:defRPr sz="1725" b="1">
+                <a:solidFill>
+                  <a:srgbClr val="111827"/>
+                </a:solidFill>
+                <a:latin typeface="Helvetica Neue"/>
+                <a:ea typeface="Helvetica Neue"/>
+                <a:cs typeface="Helvetica Neue"/>
+              </a:defRPr>
+            </a:pPr>
+            <a:r>
+              <a:rPr sz="1725" b="1">
+                <a:solidFill>
+                  <a:srgbClr val="111827"/>
+                </a:solidFill>
+                <a:latin typeface="Helvetica Neue"/>
+                <a:ea typeface="Helvetica Neue"/>
+                <a:cs typeface="Helvetica Neue"/>
+              </a:rPr>
+              <a:t>34.9% better</a:t>
+            </a:r>
+          </a:p>
+        </p:txBody>
+      </p:sp>
+      <p:sp>
+        <p:nvSpPr>
+          <p:cNvPr id="30" name="">
+            <a:extLst xmlns:a="http://schemas.openxmlformats.org/drawingml/2006/main">
+              <a:ext uri="{FF2B5EF4-FFF2-40B4-BE49-F238E27FC236}">
+                <a16:creationId xmlns:a16="http://schemas.microsoft.com/office/drawing/2014/main" id="{CE742687-7808-4E35-ABE5-E298740861BD}"/>
+              </a:ext>
+            </a:extLst>
+          </p:cNvPr>
+          <p:cNvSpPr>
+            <a:spLocks xmlns:a="http://schemas.openxmlformats.org/drawingml/2006/main" noGrp="1"/>
+          </p:cNvSpPr>
+          <p:nvPr/>
+        </p:nvSpPr>
+        <p:spPr>
+          <a:xfrm xmlns:a="http://schemas.openxmlformats.org/drawingml/2006/main">
+            <a:off x="5772150" y="3810000"/>
+            <a:ext cx="2266950" cy="171450"/>
+          </a:xfrm>
+          <a:prstGeom xmlns:a="http://schemas.openxmlformats.org/drawingml/2006/main" prst="rect">
+            <a:avLst/>
+          </a:prstGeom>
+          <a:noFill xmlns:a="http://schemas.openxmlformats.org/drawingml/2006/main"/>
+          <a:ln xmlns:a="http://schemas.openxmlformats.org/drawingml/2006/main" w="0">
+            <a:noFill/>
+            <a:prstDash val="solid"/>
+          </a:ln>
+        </p:spPr>
+        <p:txBody>
+          <a:bodyPr xmlns:a="http://schemas.openxmlformats.org/drawingml/2006/main" anchor="t">
+            <a:noAutofit/>
+          </a:bodyPr>
+          <a:lstStyle xmlns:a="http://schemas.openxmlformats.org/drawingml/2006/main"/>
+          <a:p xmlns:a="http://schemas.openxmlformats.org/drawingml/2006/main">
+            <a:pPr algn="l">
+              <a:defRPr sz="938" b="0">
+                <a:solidFill>
+                  <a:srgbClr val="334155"/>
+                </a:solidFill>
+                <a:latin typeface="Helvetica Neue"/>
+                <a:ea typeface="Helvetica Neue"/>
+                <a:cs typeface="Helvetica Neue"/>
+              </a:defRPr>
+            </a:pPr>
+            <a:r>
+              <a:rPr sz="938" b="0">
+                <a:solidFill>
+                  <a:srgbClr val="334155"/>
+                </a:solidFill>
+                <a:latin typeface="Helvetica Neue"/>
+                <a:ea typeface="Helvetica Neue"/>
+                <a:cs typeface="Helvetica Neue"/>
+              </a:rPr>
+              <a:t>1014.0 s to 659.9 s</a:t>
+            </a:r>
+          </a:p>
+        </p:txBody>
+      </p:sp>
+      <p:sp>
+        <p:nvSpPr>
+          <p:cNvPr id="31" name="">
+            <a:extLst xmlns:a="http://schemas.openxmlformats.org/drawingml/2006/main">
+              <a:ext uri="{FF2B5EF4-FFF2-40B4-BE49-F238E27FC236}">
+                <a16:creationId xmlns:a16="http://schemas.microsoft.com/office/drawing/2014/main" id="{814EA06F-7EBE-4240-B7A5-0E403049D78B}"/>
+              </a:ext>
+            </a:extLst>
+          </p:cNvPr>
+          <p:cNvSpPr>
+            <a:spLocks xmlns:a="http://schemas.openxmlformats.org/drawingml/2006/main" noGrp="1"/>
+          </p:cNvSpPr>
+          <p:nvPr/>
+        </p:nvSpPr>
+        <p:spPr>
+          <a:xfrm xmlns:a="http://schemas.openxmlformats.org/drawingml/2006/main">
+            <a:off x="8401050" y="3181350"/>
+            <a:ext cx="2571750" cy="838200"/>
+          </a:xfrm>
+          <a:prstGeom xmlns:a="http://schemas.openxmlformats.org/drawingml/2006/main" prst="rect">
+            <a:avLst/>
+          </a:prstGeom>
+          <a:solidFill xmlns:a="http://schemas.openxmlformats.org/drawingml/2006/main">
+            <a:srgbClr val="F8FAFC"/>
+          </a:solidFill>
+          <a:ln xmlns:a="http://schemas.openxmlformats.org/drawingml/2006/main" w="9525">
+            <a:solidFill>
+              <a:srgbClr val="DBE4EF"/>
+            </a:solidFill>
+            <a:prstDash val="solid"/>
+          </a:ln>
+        </p:spPr>
+      </p:sp>
+      <p:sp>
+        <p:nvSpPr>
+          <p:cNvPr id="32" name="">
+            <a:extLst xmlns:a="http://schemas.openxmlformats.org/drawingml/2006/main">
+              <a:ext uri="{FF2B5EF4-FFF2-40B4-BE49-F238E27FC236}">
+                <a16:creationId xmlns:a16="http://schemas.microsoft.com/office/drawing/2014/main" id="{45AC1C30-A9D3-4BE5-B45B-A8778AAA151B}"/>
+              </a:ext>
+            </a:extLst>
+          </p:cNvPr>
+          <p:cNvSpPr>
+            <a:spLocks xmlns:a="http://schemas.openxmlformats.org/drawingml/2006/main" noGrp="1"/>
+          </p:cNvSpPr>
+          <p:nvPr/>
+        </p:nvSpPr>
+        <p:spPr>
+          <a:xfrm xmlns:a="http://schemas.openxmlformats.org/drawingml/2006/main">
+            <a:off x="8553450" y="3295650"/>
+            <a:ext cx="2266950" cy="209550"/>
+          </a:xfrm>
+          <a:prstGeom xmlns:a="http://schemas.openxmlformats.org/drawingml/2006/main" prst="rect">
+            <a:avLst/>
+          </a:prstGeom>
+          <a:noFill xmlns:a="http://schemas.openxmlformats.org/drawingml/2006/main"/>
+          <a:ln xmlns:a="http://schemas.openxmlformats.org/drawingml/2006/main" w="0">
+            <a:noFill/>
+            <a:prstDash val="solid"/>
+          </a:ln>
+        </p:spPr>
+        <p:txBody>
+          <a:bodyPr xmlns:a="http://schemas.openxmlformats.org/drawingml/2006/main" anchor="t">
+            <a:noAutofit/>
+          </a:bodyPr>
+          <a:lstStyle xmlns:a="http://schemas.openxmlformats.org/drawingml/2006/main"/>
+          <a:p xmlns:a="http://schemas.openxmlformats.org/drawingml/2006/main">
+            <a:pPr algn="l">
+              <a:defRPr sz="1050" b="1">
+                <a:solidFill>
+                  <a:srgbClr val="64748B"/>
+                </a:solidFill>
+                <a:latin typeface="Helvetica Neue"/>
+                <a:ea typeface="Helvetica Neue"/>
+                <a:cs typeface="Helvetica Neue"/>
+              </a:defRPr>
+            </a:pPr>
+            <a:r>
+              <a:rPr sz="1050" b="1">
+                <a:solidFill>
+                  <a:srgbClr val="64748B"/>
+                </a:solidFill>
+                <a:latin typeface="Helvetica Neue"/>
+                <a:ea typeface="Helvetica Neue"/>
+                <a:cs typeface="Helvetica Neue"/>
+              </a:rPr>
+              <a:t>Avg lateness</a:t>
+            </a:r>
+          </a:p>
+        </p:txBody>
+      </p:sp>
+      <p:sp>
+        <p:nvSpPr>
+          <p:cNvPr id="33" name="">
+            <a:extLst xmlns:a="http://schemas.openxmlformats.org/drawingml/2006/main">
+              <a:ext uri="{FF2B5EF4-FFF2-40B4-BE49-F238E27FC236}">
+                <a16:creationId xmlns:a16="http://schemas.microsoft.com/office/drawing/2014/main" id="{CB8D7A2A-840D-4DF3-B07F-50A85CD38D20}"/>
+              </a:ext>
+            </a:extLst>
+          </p:cNvPr>
+          <p:cNvSpPr>
+            <a:spLocks xmlns:a="http://schemas.openxmlformats.org/drawingml/2006/main" noGrp="1"/>
+          </p:cNvSpPr>
+          <p:nvPr/>
+        </p:nvSpPr>
+        <p:spPr>
+          <a:xfrm xmlns:a="http://schemas.openxmlformats.org/drawingml/2006/main">
+            <a:off x="8553450" y="3524250"/>
+            <a:ext cx="2266950" cy="266700"/>
+          </a:xfrm>
+          <a:prstGeom xmlns:a="http://schemas.openxmlformats.org/drawingml/2006/main" prst="rect">
+            <a:avLst/>
+          </a:prstGeom>
+          <a:noFill xmlns:a="http://schemas.openxmlformats.org/drawingml/2006/main"/>
+          <a:ln xmlns:a="http://schemas.openxmlformats.org/drawingml/2006/main" w="0">
+            <a:noFill/>
+            <a:prstDash val="solid"/>
+          </a:ln>
+        </p:spPr>
+        <p:txBody>
+          <a:bodyPr xmlns:a="http://schemas.openxmlformats.org/drawingml/2006/main" anchor="t">
+            <a:noAutofit/>
+          </a:bodyPr>
+          <a:lstStyle xmlns:a="http://schemas.openxmlformats.org/drawingml/2006/main"/>
+          <a:p xmlns:a="http://schemas.openxmlformats.org/drawingml/2006/main">
+            <a:pPr algn="l">
+              <a:defRPr sz="1725" b="1">
+                <a:solidFill>
+                  <a:srgbClr val="111827"/>
+                </a:solidFill>
+                <a:latin typeface="Helvetica Neue"/>
+                <a:ea typeface="Helvetica Neue"/>
+                <a:cs typeface="Helvetica Neue"/>
+              </a:defRPr>
+            </a:pPr>
+            <a:r>
+              <a:rPr sz="1725" b="1">
+                <a:solidFill>
+                  <a:srgbClr val="111827"/>
+                </a:solidFill>
+                <a:latin typeface="Helvetica Neue"/>
+                <a:ea typeface="Helvetica Neue"/>
+                <a:cs typeface="Helvetica Neue"/>
+              </a:rPr>
+              <a:t>11.1 s less late</a:t>
+            </a:r>
+          </a:p>
+        </p:txBody>
+      </p:sp>
+      <p:sp>
+        <p:nvSpPr>
+          <p:cNvPr id="34" name="">
+            <a:extLst xmlns:a="http://schemas.openxmlformats.org/drawingml/2006/main">
+              <a:ext uri="{FF2B5EF4-FFF2-40B4-BE49-F238E27FC236}">
+                <a16:creationId xmlns:a16="http://schemas.microsoft.com/office/drawing/2014/main" id="{EE8F60F8-8B90-4454-95A4-8205EE6BC092}"/>
+              </a:ext>
+            </a:extLst>
+          </p:cNvPr>
+          <p:cNvSpPr>
+            <a:spLocks xmlns:a="http://schemas.openxmlformats.org/drawingml/2006/main" noGrp="1"/>
+          </p:cNvSpPr>
+          <p:nvPr/>
+        </p:nvSpPr>
+        <p:spPr>
+          <a:xfrm xmlns:a="http://schemas.openxmlformats.org/drawingml/2006/main">
+            <a:off x="8553450" y="3810000"/>
+            <a:ext cx="2266950" cy="171450"/>
+          </a:xfrm>
+          <a:prstGeom xmlns:a="http://schemas.openxmlformats.org/drawingml/2006/main" prst="rect">
+            <a:avLst/>
+          </a:prstGeom>
+          <a:noFill xmlns:a="http://schemas.openxmlformats.org/drawingml/2006/main"/>
+          <a:ln xmlns:a="http://schemas.openxmlformats.org/drawingml/2006/main" w="0">
+            <a:noFill/>
+            <a:prstDash val="solid"/>
+          </a:ln>
+        </p:spPr>
+        <p:txBody>
+          <a:bodyPr xmlns:a="http://schemas.openxmlformats.org/drawingml/2006/main" anchor="t">
+            <a:noAutofit/>
+          </a:bodyPr>
+          <a:lstStyle xmlns:a="http://schemas.openxmlformats.org/drawingml/2006/main"/>
+          <a:p xmlns:a="http://schemas.openxmlformats.org/drawingml/2006/main">
+            <a:pPr algn="l">
+              <a:defRPr sz="938" b="0">
+                <a:solidFill>
+                  <a:srgbClr val="334155"/>
+                </a:solidFill>
+                <a:latin typeface="Helvetica Neue"/>
+                <a:ea typeface="Helvetica Neue"/>
+                <a:cs typeface="Helvetica Neue"/>
+              </a:defRPr>
+            </a:pPr>
+            <a:r>
+              <a:rPr sz="938" b="0">
+                <a:solidFill>
+                  <a:srgbClr val="334155"/>
+                </a:solidFill>
+                <a:latin typeface="Helvetica Neue"/>
+                <a:ea typeface="Helvetica Neue"/>
+                <a:cs typeface="Helvetica Neue"/>
+              </a:rPr>
+              <a:t>31.7 s to 20.6 s</a:t>
+            </a:r>
+          </a:p>
+        </p:txBody>
+      </p:sp>
+      <p:sp>
+        <p:nvSpPr>
+          <p:cNvPr id="35" name="">
+            <a:extLst xmlns:a="http://schemas.openxmlformats.org/drawingml/2006/main">
+              <a:ext uri="{FF2B5EF4-FFF2-40B4-BE49-F238E27FC236}">
+                <a16:creationId xmlns:a16="http://schemas.microsoft.com/office/drawing/2014/main" id="{7544E251-D6B3-43CD-A363-D3E6E4B7E06E}"/>
+              </a:ext>
+            </a:extLst>
+          </p:cNvPr>
+          <p:cNvSpPr>
+            <a:spLocks xmlns:a="http://schemas.openxmlformats.org/drawingml/2006/main" noGrp="1"/>
+          </p:cNvSpPr>
+          <p:nvPr/>
+        </p:nvSpPr>
+        <p:spPr>
+          <a:xfrm xmlns:a="http://schemas.openxmlformats.org/drawingml/2006/main">
+            <a:off x="5619750" y="4191000"/>
+            <a:ext cx="2571750" cy="838200"/>
+          </a:xfrm>
+          <a:prstGeom xmlns:a="http://schemas.openxmlformats.org/drawingml/2006/main" prst="rect">
+            <a:avLst/>
+          </a:prstGeom>
+          <a:solidFill xmlns:a="http://schemas.openxmlformats.org/drawingml/2006/main">
+            <a:srgbClr val="F8FAFC"/>
+          </a:solidFill>
+          <a:ln xmlns:a="http://schemas.openxmlformats.org/drawingml/2006/main" w="9525">
+            <a:solidFill>
+              <a:srgbClr val="DBE4EF"/>
+            </a:solidFill>
+            <a:prstDash val="solid"/>
+          </a:ln>
+        </p:spPr>
+      </p:sp>
+      <p:sp>
+        <p:nvSpPr>
+          <p:cNvPr id="36" name="">
+            <a:extLst xmlns:a="http://schemas.openxmlformats.org/drawingml/2006/main">
+              <a:ext uri="{FF2B5EF4-FFF2-40B4-BE49-F238E27FC236}">
+                <a16:creationId xmlns:a16="http://schemas.microsoft.com/office/drawing/2014/main" id="{886472C4-A6DB-4378-B67C-104B943900C0}"/>
+              </a:ext>
+            </a:extLst>
+          </p:cNvPr>
+          <p:cNvSpPr>
+            <a:spLocks xmlns:a="http://schemas.openxmlformats.org/drawingml/2006/main" noGrp="1"/>
+          </p:cNvSpPr>
+          <p:nvPr/>
+        </p:nvSpPr>
+        <p:spPr>
+          <a:xfrm xmlns:a="http://schemas.openxmlformats.org/drawingml/2006/main">
+            <a:off x="5772150" y="4305300"/>
+            <a:ext cx="2266950" cy="209550"/>
+          </a:xfrm>
+          <a:prstGeom xmlns:a="http://schemas.openxmlformats.org/drawingml/2006/main" prst="rect">
+            <a:avLst/>
+          </a:prstGeom>
+          <a:noFill xmlns:a="http://schemas.openxmlformats.org/drawingml/2006/main"/>
+          <a:ln xmlns:a="http://schemas.openxmlformats.org/drawingml/2006/main" w="0">
+            <a:noFill/>
+            <a:prstDash val="solid"/>
+          </a:ln>
+        </p:spPr>
+        <p:txBody>
+          <a:bodyPr xmlns:a="http://schemas.openxmlformats.org/drawingml/2006/main" anchor="t">
+            <a:noAutofit/>
+          </a:bodyPr>
+          <a:lstStyle xmlns:a="http://schemas.openxmlformats.org/drawingml/2006/main"/>
+          <a:p xmlns:a="http://schemas.openxmlformats.org/drawingml/2006/main">
+            <a:pPr algn="l">
+              <a:defRPr sz="1050" b="1">
+                <a:solidFill>
+                  <a:srgbClr val="64748B"/>
+                </a:solidFill>
+                <a:latin typeface="Helvetica Neue"/>
+                <a:ea typeface="Helvetica Neue"/>
+                <a:cs typeface="Helvetica Neue"/>
+              </a:defRPr>
+            </a:pPr>
+            <a:r>
+              <a:rPr sz="1050" b="1">
+                <a:solidFill>
+                  <a:srgbClr val="64748B"/>
+                </a:solidFill>
+                <a:latin typeface="Helvetica Neue"/>
+                <a:ea typeface="Helvetica Neue"/>
+                <a:cs typeface="Helvetica Neue"/>
+              </a:rPr>
+              <a:t>Value alignment</a:t>
+            </a:r>
+          </a:p>
+        </p:txBody>
+      </p:sp>
+      <p:sp>
+        <p:nvSpPr>
+          <p:cNvPr id="37" name="">
+            <a:extLst xmlns:a="http://schemas.openxmlformats.org/drawingml/2006/main">
+              <a:ext uri="{FF2B5EF4-FFF2-40B4-BE49-F238E27FC236}">
+                <a16:creationId xmlns:a16="http://schemas.microsoft.com/office/drawing/2014/main" id="{9FFA927D-9D01-4DBC-97FE-CB4A56222053}"/>
+              </a:ext>
+            </a:extLst>
+          </p:cNvPr>
+          <p:cNvSpPr>
+            <a:spLocks xmlns:a="http://schemas.openxmlformats.org/drawingml/2006/main" noGrp="1"/>
+          </p:cNvSpPr>
+          <p:nvPr/>
+        </p:nvSpPr>
+        <p:spPr>
+          <a:xfrm xmlns:a="http://schemas.openxmlformats.org/drawingml/2006/main">
+            <a:off x="5772150" y="4533900"/>
+            <a:ext cx="2266950" cy="266700"/>
+          </a:xfrm>
+          <a:prstGeom xmlns:a="http://schemas.openxmlformats.org/drawingml/2006/main" prst="rect">
+            <a:avLst/>
+          </a:prstGeom>
+          <a:noFill xmlns:a="http://schemas.openxmlformats.org/drawingml/2006/main"/>
+          <a:ln xmlns:a="http://schemas.openxmlformats.org/drawingml/2006/main" w="0">
+            <a:noFill/>
+            <a:prstDash val="solid"/>
+          </a:ln>
+        </p:spPr>
+        <p:txBody>
+          <a:bodyPr xmlns:a="http://schemas.openxmlformats.org/drawingml/2006/main" anchor="t">
+            <a:noAutofit/>
+          </a:bodyPr>
+          <a:lstStyle xmlns:a="http://schemas.openxmlformats.org/drawingml/2006/main"/>
+          <a:p xmlns:a="http://schemas.openxmlformats.org/drawingml/2006/main">
+            <a:pPr algn="l">
+              <a:defRPr sz="1725" b="1">
+                <a:solidFill>
+                  <a:srgbClr val="111827"/>
+                </a:solidFill>
+                <a:latin typeface="Helvetica Neue"/>
+                <a:ea typeface="Helvetica Neue"/>
+                <a:cs typeface="Helvetica Neue"/>
+              </a:defRPr>
+            </a:pPr>
+            <a:r>
+              <a:rPr sz="1725" b="1">
+                <a:solidFill>
+                  <a:srgbClr val="111827"/>
+                </a:solidFill>
+                <a:latin typeface="Helvetica Neue"/>
+                <a:ea typeface="Helvetica Neue"/>
+                <a:cs typeface="Helvetica Neue"/>
+              </a:rPr>
+              <a:t>0 mismatches</a:t>
+            </a:r>
+          </a:p>
+        </p:txBody>
+      </p:sp>
+      <p:sp>
+        <p:nvSpPr>
+          <p:cNvPr id="38" name="">
+            <a:extLst xmlns:a="http://schemas.openxmlformats.org/drawingml/2006/main">
+              <a:ext uri="{FF2B5EF4-FFF2-40B4-BE49-F238E27FC236}">
+                <a16:creationId xmlns:a16="http://schemas.microsoft.com/office/drawing/2014/main" id="{E8ECD6AD-DF55-4DB9-B7D3-2EDE05A1C62E}"/>
+              </a:ext>
+            </a:extLst>
+          </p:cNvPr>
+          <p:cNvSpPr>
+            <a:spLocks xmlns:a="http://schemas.openxmlformats.org/drawingml/2006/main" noGrp="1"/>
+          </p:cNvSpPr>
+          <p:nvPr/>
+        </p:nvSpPr>
+        <p:spPr>
+          <a:xfrm xmlns:a="http://schemas.openxmlformats.org/drawingml/2006/main">
+            <a:off x="5772150" y="4819650"/>
+            <a:ext cx="2266950" cy="171450"/>
+          </a:xfrm>
+          <a:prstGeom xmlns:a="http://schemas.openxmlformats.org/drawingml/2006/main" prst="rect">
+            <a:avLst/>
+          </a:prstGeom>
+          <a:noFill xmlns:a="http://schemas.openxmlformats.org/drawingml/2006/main"/>
+          <a:ln xmlns:a="http://schemas.openxmlformats.org/drawingml/2006/main" w="0">
+            <a:noFill/>
+            <a:prstDash val="solid"/>
+          </a:ln>
+        </p:spPr>
+        <p:txBody>
+          <a:bodyPr xmlns:a="http://schemas.openxmlformats.org/drawingml/2006/main" anchor="t">
+            <a:noAutofit/>
+          </a:bodyPr>
+          <a:lstStyle xmlns:a="http://schemas.openxmlformats.org/drawingml/2006/main"/>
+          <a:p xmlns:a="http://schemas.openxmlformats.org/drawingml/2006/main">
+            <a:pPr algn="l">
+              <a:defRPr sz="938" b="0">
+                <a:solidFill>
+                  <a:srgbClr val="334155"/>
+                </a:solidFill>
+                <a:latin typeface="Helvetica Neue"/>
+                <a:ea typeface="Helvetica Neue"/>
+                <a:cs typeface="Helvetica Neue"/>
+              </a:defRPr>
+            </a:pPr>
+            <a:r>
+              <a:rPr sz="938" b="0">
+                <a:solidFill>
+                  <a:srgbClr val="334155"/>
+                </a:solidFill>
+                <a:latin typeface="Helvetica Neue"/>
+                <a:ea typeface="Helvetica Neue"/>
+                <a:cs typeface="Helvetica Neue"/>
+              </a:rPr>
+              <a:t>23 high, 16 normal, 9 low</a:t>
+            </a:r>
+          </a:p>
+        </p:txBody>
+      </p:sp>
+      <p:sp>
+        <p:nvSpPr>
+          <p:cNvPr id="39" name="">
+            <a:extLst xmlns:a="http://schemas.openxmlformats.org/drawingml/2006/main">
+              <a:ext uri="{FF2B5EF4-FFF2-40B4-BE49-F238E27FC236}">
+                <a16:creationId xmlns:a16="http://schemas.microsoft.com/office/drawing/2014/main" id="{BB18FF7F-AA02-423C-A20B-1AA8F07C030B}"/>
+              </a:ext>
+            </a:extLst>
+          </p:cNvPr>
+          <p:cNvSpPr>
+            <a:spLocks xmlns:a="http://schemas.openxmlformats.org/drawingml/2006/main" noGrp="1"/>
+          </p:cNvSpPr>
+          <p:nvPr/>
+        </p:nvSpPr>
+        <p:spPr>
+          <a:xfrm xmlns:a="http://schemas.openxmlformats.org/drawingml/2006/main">
+            <a:off x="8401050" y="4191000"/>
+            <a:ext cx="2571750" cy="838200"/>
+          </a:xfrm>
+          <a:prstGeom xmlns:a="http://schemas.openxmlformats.org/drawingml/2006/main" prst="rect">
+            <a:avLst/>
+          </a:prstGeom>
+          <a:solidFill xmlns:a="http://schemas.openxmlformats.org/drawingml/2006/main">
+            <a:srgbClr val="F3F6FA"/>
+          </a:solidFill>
+          <a:ln xmlns:a="http://schemas.openxmlformats.org/drawingml/2006/main" w="9525">
+            <a:solidFill>
+              <a:srgbClr val="DBE4EF"/>
+            </a:solidFill>
+            <a:prstDash val="solid"/>
+          </a:ln>
+        </p:spPr>
+      </p:sp>
+      <p:sp>
+        <p:nvSpPr>
+          <p:cNvPr id="40" name="">
+            <a:extLst xmlns:a="http://schemas.openxmlformats.org/drawingml/2006/main">
+              <a:ext uri="{FF2B5EF4-FFF2-40B4-BE49-F238E27FC236}">
+                <a16:creationId xmlns:a16="http://schemas.microsoft.com/office/drawing/2014/main" id="{E2BABE59-ACD5-427A-9E70-9EE6CF96930C}"/>
+              </a:ext>
+            </a:extLst>
+          </p:cNvPr>
+          <p:cNvSpPr>
+            <a:spLocks xmlns:a="http://schemas.openxmlformats.org/drawingml/2006/main" noGrp="1"/>
+          </p:cNvSpPr>
+          <p:nvPr/>
+        </p:nvSpPr>
+        <p:spPr>
+          <a:xfrm xmlns:a="http://schemas.openxmlformats.org/drawingml/2006/main">
+            <a:off x="8553450" y="4305300"/>
+            <a:ext cx="2266950" cy="209550"/>
+          </a:xfrm>
+          <a:prstGeom xmlns:a="http://schemas.openxmlformats.org/drawingml/2006/main" prst="rect">
+            <a:avLst/>
+          </a:prstGeom>
+          <a:noFill xmlns:a="http://schemas.openxmlformats.org/drawingml/2006/main"/>
+          <a:ln xmlns:a="http://schemas.openxmlformats.org/drawingml/2006/main" w="0">
+            <a:noFill/>
+            <a:prstDash val="solid"/>
+          </a:ln>
+        </p:spPr>
+        <p:txBody>
+          <a:bodyPr xmlns:a="http://schemas.openxmlformats.org/drawingml/2006/main" anchor="t">
+            <a:noAutofit/>
+          </a:bodyPr>
+          <a:lstStyle xmlns:a="http://schemas.openxmlformats.org/drawingml/2006/main"/>
+          <a:p xmlns:a="http://schemas.openxmlformats.org/drawingml/2006/main">
+            <a:pPr algn="l">
+              <a:defRPr sz="1050" b="1">
+                <a:solidFill>
+                  <a:srgbClr val="64748B"/>
+                </a:solidFill>
+                <a:latin typeface="Helvetica Neue"/>
+                <a:ea typeface="Helvetica Neue"/>
+                <a:cs typeface="Helvetica Neue"/>
+              </a:defRPr>
+            </a:pPr>
+            <a:r>
+              <a:rPr sz="1050" b="1">
+                <a:solidFill>
+                  <a:srgbClr val="64748B"/>
+                </a:solidFill>
+                <a:latin typeface="Helvetica Neue"/>
+                <a:ea typeface="Helvetica Neue"/>
+                <a:cs typeface="Helvetica Neue"/>
+              </a:rPr>
+              <a:t>Workload window</a:t>
+            </a:r>
+          </a:p>
+        </p:txBody>
+      </p:sp>
+      <p:sp>
+        <p:nvSpPr>
+          <p:cNvPr id="41" name="">
+            <a:extLst xmlns:a="http://schemas.openxmlformats.org/drawingml/2006/main">
+              <a:ext uri="{FF2B5EF4-FFF2-40B4-BE49-F238E27FC236}">
+                <a16:creationId xmlns:a16="http://schemas.microsoft.com/office/drawing/2014/main" id="{5E8E2AC0-BED7-469F-AE13-CB4A8A59C9FB}"/>
+              </a:ext>
+            </a:extLst>
+          </p:cNvPr>
+          <p:cNvSpPr>
+            <a:spLocks xmlns:a="http://schemas.openxmlformats.org/drawingml/2006/main" noGrp="1"/>
+          </p:cNvSpPr>
+          <p:nvPr/>
+        </p:nvSpPr>
+        <p:spPr>
+          <a:xfrm xmlns:a="http://schemas.openxmlformats.org/drawingml/2006/main">
+            <a:off x="8553450" y="4533900"/>
+            <a:ext cx="2266950" cy="266700"/>
+          </a:xfrm>
+          <a:prstGeom xmlns:a="http://schemas.openxmlformats.org/drawingml/2006/main" prst="rect">
+            <a:avLst/>
+          </a:prstGeom>
+          <a:noFill xmlns:a="http://schemas.openxmlformats.org/drawingml/2006/main"/>
+          <a:ln xmlns:a="http://schemas.openxmlformats.org/drawingml/2006/main" w="0">
+            <a:noFill/>
+            <a:prstDash val="solid"/>
+          </a:ln>
+        </p:spPr>
+        <p:txBody>
+          <a:bodyPr xmlns:a="http://schemas.openxmlformats.org/drawingml/2006/main" anchor="t">
+            <a:noAutofit/>
+          </a:bodyPr>
+          <a:lstStyle xmlns:a="http://schemas.openxmlformats.org/drawingml/2006/main"/>
+          <a:p xmlns:a="http://schemas.openxmlformats.org/drawingml/2006/main">
+            <a:pPr algn="l">
+              <a:defRPr sz="1725" b="1">
+                <a:solidFill>
+                  <a:srgbClr val="334155"/>
+                </a:solidFill>
+                <a:latin typeface="Helvetica Neue"/>
+                <a:ea typeface="Helvetica Neue"/>
+                <a:cs typeface="Helvetica Neue"/>
+              </a:defRPr>
+            </a:pPr>
+            <a:r>
+              <a:rPr sz="1725" b="1">
+                <a:solidFill>
+                  <a:srgbClr val="334155"/>
+                </a:solidFill>
+                <a:latin typeface="Helvetica Neue"/>
+                <a:ea typeface="Helvetica Neue"/>
+                <a:cs typeface="Helvetica Neue"/>
+              </a:rPr>
+              <a:t>63.1 s longer</a:t>
+            </a:r>
+          </a:p>
+        </p:txBody>
+      </p:sp>
+      <p:sp>
+        <p:nvSpPr>
+          <p:cNvPr id="42" name="">
+            <a:extLst xmlns:a="http://schemas.openxmlformats.org/drawingml/2006/main">
+              <a:ext uri="{FF2B5EF4-FFF2-40B4-BE49-F238E27FC236}">
+                <a16:creationId xmlns:a16="http://schemas.microsoft.com/office/drawing/2014/main" id="{1BE9BD20-1615-42B2-8839-709F291438CA}"/>
+              </a:ext>
+            </a:extLst>
+          </p:cNvPr>
+          <p:cNvSpPr>
+            <a:spLocks xmlns:a="http://schemas.openxmlformats.org/drawingml/2006/main" noGrp="1"/>
+          </p:cNvSpPr>
+          <p:nvPr/>
+        </p:nvSpPr>
+        <p:spPr>
+          <a:xfrm xmlns:a="http://schemas.openxmlformats.org/drawingml/2006/main">
+            <a:off x="8553450" y="4819650"/>
+            <a:ext cx="2266950" cy="171450"/>
+          </a:xfrm>
+          <a:prstGeom xmlns:a="http://schemas.openxmlformats.org/drawingml/2006/main" prst="rect">
+            <a:avLst/>
+          </a:prstGeom>
+          <a:noFill xmlns:a="http://schemas.openxmlformats.org/drawingml/2006/main"/>
+          <a:ln xmlns:a="http://schemas.openxmlformats.org/drawingml/2006/main" w="0">
+            <a:noFill/>
+            <a:prstDash val="solid"/>
+          </a:ln>
+        </p:spPr>
+        <p:txBody>
+          <a:bodyPr xmlns:a="http://schemas.openxmlformats.org/drawingml/2006/main" anchor="t">
+            <a:noAutofit/>
+          </a:bodyPr>
+          <a:lstStyle xmlns:a="http://schemas.openxmlformats.org/drawingml/2006/main"/>
+          <a:p xmlns:a="http://schemas.openxmlformats.org/drawingml/2006/main">
+            <a:pPr algn="l">
+              <a:defRPr sz="938" b="0">
+                <a:solidFill>
+                  <a:srgbClr val="334155"/>
+                </a:solidFill>
+                <a:latin typeface="Helvetica Neue"/>
+                <a:ea typeface="Helvetica Neue"/>
+                <a:cs typeface="Helvetica Neue"/>
+              </a:defRPr>
+            </a:pPr>
+            <a:r>
+              <a:rPr sz="938" b="0">
+                <a:solidFill>
+                  <a:srgbClr val="334155"/>
+                </a:solidFill>
+                <a:latin typeface="Helvetica Neue"/>
+                <a:ea typeface="Helvetica Neue"/>
+                <a:cs typeface="Helvetica Neue"/>
+              </a:rPr>
+              <a:t>205.6 s to 268.8 s</a:t>
+            </a:r>
+          </a:p>
+        </p:txBody>
+      </p:sp>
+      <p:sp>
+        <p:nvSpPr>
+          <p:cNvPr id="43" name="">
+            <a:extLst xmlns:a="http://schemas.openxmlformats.org/drawingml/2006/main">
+              <a:ext uri="{FF2B5EF4-FFF2-40B4-BE49-F238E27FC236}">
+                <a16:creationId xmlns:a16="http://schemas.microsoft.com/office/drawing/2014/main" id="{77406B22-02D6-4E1A-83F6-5DE2CD9BCE71}"/>
+              </a:ext>
+            </a:extLst>
+          </p:cNvPr>
+          <p:cNvSpPr>
+            <a:spLocks xmlns:a="http://schemas.openxmlformats.org/drawingml/2006/main" noGrp="1"/>
+          </p:cNvSpPr>
+          <p:nvPr/>
+        </p:nvSpPr>
+        <p:spPr>
+          <a:xfrm xmlns:a="http://schemas.openxmlformats.org/drawingml/2006/main">
+            <a:off x="533400" y="5524500"/>
+            <a:ext cx="11125200" cy="13335"/>
+          </a:xfrm>
+          <a:prstGeom xmlns:a="http://schemas.openxmlformats.org/drawingml/2006/main" prst="rect">
+            <a:avLst/>
+          </a:prstGeom>
+          <a:solidFill xmlns:a="http://schemas.openxmlformats.org/drawingml/2006/main">
+            <a:srgbClr val="D7DEE8"/>
+          </a:solidFill>
+          <a:ln xmlns:a="http://schemas.openxmlformats.org/drawingml/2006/main" w="0">
+            <a:noFill/>
+            <a:prstDash val="solid"/>
+          </a:ln>
+        </p:spPr>
+      </p:sp>
+      <p:sp>
+        <p:nvSpPr>
+          <p:cNvPr id="44" name="">
+            <a:extLst xmlns:a="http://schemas.openxmlformats.org/drawingml/2006/main">
+              <a:ext uri="{FF2B5EF4-FFF2-40B4-BE49-F238E27FC236}">
+                <a16:creationId xmlns:a16="http://schemas.microsoft.com/office/drawing/2014/main" id="{2FCB5BCC-464C-4951-9873-C4C01EA46015}"/>
+              </a:ext>
+            </a:extLst>
+          </p:cNvPr>
+          <p:cNvSpPr>
+            <a:spLocks xmlns:a="http://schemas.openxmlformats.org/drawingml/2006/main" noGrp="1"/>
+          </p:cNvSpPr>
+          <p:nvPr/>
+        </p:nvSpPr>
+        <p:spPr>
+          <a:xfrm xmlns:a="http://schemas.openxmlformats.org/drawingml/2006/main">
+            <a:off x="628650" y="5753100"/>
+            <a:ext cx="1809750" cy="266700"/>
+          </a:xfrm>
+          <a:prstGeom xmlns:a="http://schemas.openxmlformats.org/drawingml/2006/main" prst="rect">
+            <a:avLst/>
+          </a:prstGeom>
+          <a:noFill xmlns:a="http://schemas.openxmlformats.org/drawingml/2006/main"/>
+          <a:ln xmlns:a="http://schemas.openxmlformats.org/drawingml/2006/main" w="0">
+            <a:noFill/>
+            <a:prstDash val="solid"/>
+          </a:ln>
+        </p:spPr>
+        <p:txBody>
+          <a:bodyPr xmlns:a="http://schemas.openxmlformats.org/drawingml/2006/main" anchor="t">
+            <a:noAutofit/>
+          </a:bodyPr>
+          <a:lstStyle xmlns:a="http://schemas.openxmlformats.org/drawingml/2006/main"/>
+          <a:p xmlns:a="http://schemas.openxmlformats.org/drawingml/2006/main">
+            <a:pPr algn="l">
+              <a:defRPr sz="1500" b="1">
+                <a:solidFill>
+                  <a:srgbClr val="111827"/>
+                </a:solidFill>
+                <a:latin typeface="Helvetica Neue"/>
+                <a:ea typeface="Helvetica Neue"/>
+                <a:cs typeface="Helvetica Neue"/>
+              </a:defRPr>
+            </a:pPr>
+            <a:r>
+              <a:rPr sz="1500" b="1">
+                <a:solidFill>
+                  <a:srgbClr val="111827"/>
+                </a:solidFill>
+                <a:latin typeface="Helvetica Neue"/>
+                <a:ea typeface="Helvetica Neue"/>
+                <a:cs typeface="Helvetica Neue"/>
+              </a:rPr>
+              <a:t>Mechanism proof</a:t>
+            </a:r>
+          </a:p>
+        </p:txBody>
+      </p:sp>
+      <p:sp>
+        <p:nvSpPr>
+          <p:cNvPr id="45" name="">
+            <a:extLst xmlns:a="http://schemas.openxmlformats.org/drawingml/2006/main">
+              <a:ext uri="{FF2B5EF4-FFF2-40B4-BE49-F238E27FC236}">
+                <a16:creationId xmlns:a16="http://schemas.microsoft.com/office/drawing/2014/main" id="{A693DF3D-3AAB-4A35-8991-185295377983}"/>
+              </a:ext>
+            </a:extLst>
+          </p:cNvPr>
+          <p:cNvSpPr>
+            <a:spLocks xmlns:a="http://schemas.openxmlformats.org/drawingml/2006/main" noGrp="1"/>
+          </p:cNvSpPr>
+          <p:nvPr/>
+        </p:nvSpPr>
+        <p:spPr>
+          <a:xfrm xmlns:a="http://schemas.openxmlformats.org/drawingml/2006/main">
+            <a:off x="2438400" y="5753100"/>
+            <a:ext cx="8191500" cy="400050"/>
+          </a:xfrm>
+          <a:prstGeom xmlns:a="http://schemas.openxmlformats.org/drawingml/2006/main" prst="rect">
+            <a:avLst/>
+          </a:prstGeom>
+          <a:noFill xmlns:a="http://schemas.openxmlformats.org/drawingml/2006/main"/>
+          <a:ln xmlns:a="http://schemas.openxmlformats.org/drawingml/2006/main" w="0">
+            <a:noFill/>
+            <a:prstDash val="solid"/>
+          </a:ln>
+        </p:spPr>
+        <p:txBody>
+          <a:bodyPr xmlns:a="http://schemas.openxmlformats.org/drawingml/2006/main" anchor="t">
+            <a:noAutofit/>
+          </a:bodyPr>
+          <a:lstStyle xmlns:a="http://schemas.openxmlformats.org/drawingml/2006/main"/>
+          <a:p xmlns:a="http://schemas.openxmlformats.org/drawingml/2006/main">
+            <a:pPr algn="l">
+              <a:defRPr sz="1500" b="1">
+                <a:solidFill>
+                  <a:srgbClr val="111827"/>
+                </a:solidFill>
+                <a:latin typeface="Helvetica Neue"/>
+                <a:ea typeface="Helvetica Neue"/>
+                <a:cs typeface="Helvetica Neue"/>
+              </a:defRPr>
+            </a:pPr>
+            <a:r>
+              <a:rPr sz="1500" b="1">
+                <a:solidFill>
+                  <a:srgbClr val="111827"/>
+                </a:solidFill>
+                <a:latin typeface="Helvetica Neue"/>
+                <a:ea typeface="Helvetica Neue"/>
+                <a:cs typeface="Helvetica Neue"/>
+              </a:rPr>
+              <a:t>Value classes reached SGLang with zero mismatches, and native HiCache eviction events were observed.</a:t>
+            </a:r>
+          </a:p>
+        </p:txBody>
+      </p:sp>
+      <p:sp>
+        <p:nvSpPr>
+          <p:cNvPr id="46" name="">
+            <a:extLst xmlns:a="http://schemas.openxmlformats.org/drawingml/2006/main">
+              <a:ext uri="{FF2B5EF4-FFF2-40B4-BE49-F238E27FC236}">
+                <a16:creationId xmlns:a16="http://schemas.microsoft.com/office/drawing/2014/main" id="{5E6F8568-07F9-4366-B2AC-3790A3BFF37D}"/>
+              </a:ext>
+            </a:extLst>
+          </p:cNvPr>
+          <p:cNvSpPr>
+            <a:spLocks xmlns:a="http://schemas.openxmlformats.org/drawingml/2006/main" noGrp="1"/>
+          </p:cNvSpPr>
+          <p:nvPr/>
+        </p:nvSpPr>
+        <p:spPr>
+          <a:xfrm xmlns:a="http://schemas.openxmlformats.org/drawingml/2006/main">
+            <a:off x="552450" y="6419850"/>
+            <a:ext cx="4191000" cy="190500"/>
+          </a:xfrm>
+          <a:prstGeom xmlns:a="http://schemas.openxmlformats.org/drawingml/2006/main" prst="rect">
+            <a:avLst/>
+          </a:prstGeom>
+          <a:noFill xmlns:a="http://schemas.openxmlformats.org/drawingml/2006/main"/>
+          <a:ln xmlns:a="http://schemas.openxmlformats.org/drawingml/2006/main" w="0">
+            <a:noFill/>
+            <a:prstDash val="solid"/>
+          </a:ln>
+        </p:spPr>
+        <p:txBody>
+          <a:bodyPr xmlns:a="http://schemas.openxmlformats.org/drawingml/2006/main" anchor="t">
+            <a:noAutofit/>
+          </a:bodyPr>
+          <a:lstStyle xmlns:a="http://schemas.openxmlformats.org/drawingml/2006/main"/>
+          <a:p xmlns:a="http://schemas.openxmlformats.org/drawingml/2006/main">
+            <a:pPr algn="l">
+              <a:defRPr sz="900" b="0">
+                <a:solidFill>
+                  <a:srgbClr val="64748B"/>
+                </a:solidFill>
+                <a:latin typeface="Helvetica Neue"/>
+                <a:ea typeface="Helvetica Neue"/>
+                <a:cs typeface="Helvetica Neue"/>
+              </a:defRPr>
+            </a:pPr>
+            <a:r>
+              <a:rPr sz="900" b="0">
+                <a:solidFill>
+                  <a:srgbClr val="64748B"/>
+                </a:solidFill>
+                <a:latin typeface="Helvetica Neue"/>
+                <a:ea typeface="Helvetica Neue"/>
+                <a:cs typeface="Helvetica Neue"/>
+              </a:rPr>
+              <a:t>Source: Harness-Aware Scenario Tracker</a:t>
+            </a:r>
+          </a:p>
+        </p:txBody>
+      </p:sp>
+    </p:spTree>
+    <p:extLst>
+      <p:ext uri="{BB962C8B-B14F-4D97-AF65-F5344CB8AC3E}">
+        <p14:creationId xmlns:p14="http://schemas.microsoft.com/office/powerpoint/2010/main" val="1227081678"/>
       </p:ext>
     </p:extLst>
   </p:cSld>

</xml_diff>

<commit_message>
Simplify controller wording in scenario deck
</commit_message>
<xml_diff>
--- a/presentation/harness_aware_scenario_results_master.pptx
+++ b/presentation/harness_aware_scenario_results_master.pptx
@@ -2,15 +2,15 @@
 <file path=ppt/presentation.xml><?xml version="1.0" encoding="utf-8"?>
 <p:presentation xmlns:p="http://schemas.openxmlformats.org/presentationml/2006/main">
   <p:sldMasterIdLst>
-    <p:sldMasterId xmlns:r="http://schemas.openxmlformats.org/officeDocument/2006/relationships" id="2147483648" r:id="R701362693c7740fb"/>
+    <p:sldMasterId xmlns:r="http://schemas.openxmlformats.org/officeDocument/2006/relationships" id="2147483648" r:id="Rd3430611585f41e0"/>
   </p:sldMasterIdLst>
   <p:notesMasterIdLst>
-    <p:notesMasterId xmlns:r="http://schemas.openxmlformats.org/officeDocument/2006/relationships" r:id="Rcbcce05344d14244"/>
+    <p:notesMasterId xmlns:r="http://schemas.openxmlformats.org/officeDocument/2006/relationships" r:id="Rfc158a5a535e4f49"/>
   </p:notesMasterIdLst>
   <p:sldIdLst>
-    <p:sldId xmlns:r="http://schemas.openxmlformats.org/officeDocument/2006/relationships" id="256" r:id="Raa6b3ca4e4ba4d59"/>
-    <p:sldId xmlns:r="http://schemas.openxmlformats.org/officeDocument/2006/relationships" id="257" r:id="R7e1c56995e034d3f"/>
-    <p:sldId xmlns:r="http://schemas.openxmlformats.org/officeDocument/2006/relationships" id="258" r:id="R0cf8101012a24711"/>
+    <p:sldId xmlns:r="http://schemas.openxmlformats.org/officeDocument/2006/relationships" id="256" r:id="R502070d3edc84f4c"/>
+    <p:sldId xmlns:r="http://schemas.openxmlformats.org/officeDocument/2006/relationships" id="257" r:id="R2dc0e0d833f84dd4"/>
+    <p:sldId xmlns:r="http://schemas.openxmlformats.org/officeDocument/2006/relationships" id="258" r:id="R90dd9ea0edc94f2f"/>
   </p:sldIdLst>
   <p:sldSz cx="12192000" cy="6858000"/>
   <p:notesSz cx="6858000" cy="9144000"/>
@@ -827,7 +827,7 @@
   </p:cSld>
   <p:clrMap bg1="lt1" tx1="dk1" bg2="lt2" tx2="dk2" accent1="accent1" accent2="accent2" accent3="accent3" accent4="accent4" accent5="accent5" accent6="accent6" hlink="hlink" folHlink="folHlink"/>
   <p:sldLayoutIdLst>
-    <p:sldLayoutId xmlns:r="http://schemas.openxmlformats.org/officeDocument/2006/relationships" id="2147483649" r:id="R8a016a2352d34d5b"/>
+    <p:sldLayoutId xmlns:r="http://schemas.openxmlformats.org/officeDocument/2006/relationships" id="2147483649" r:id="Rb7d4ae351270489b"/>
   </p:sldLayoutIdLst>
   <p:txStyles>
     <p:titleStyle>
@@ -1375,10 +1375,10 @@
       </p:grpSpPr>
       <p:sp>
         <p:nvSpPr>
-          <p:cNvPr id="43" name="">
-            <a:extLst xmlns:a="http://schemas.openxmlformats.org/drawingml/2006/main">
-              <a:ext uri="{FF2B5EF4-FFF2-40B4-BE49-F238E27FC236}">
-                <a16:creationId xmlns:a16="http://schemas.microsoft.com/office/drawing/2014/main" id="{501EFE3A-5D53-49A2-816A-B90BF906D85B}"/>
+          <p:cNvPr id="42" name="">
+            <a:extLst xmlns:a="http://schemas.openxmlformats.org/drawingml/2006/main">
+              <a:ext uri="{FF2B5EF4-FFF2-40B4-BE49-F238E27FC236}">
+                <a16:creationId xmlns:a16="http://schemas.microsoft.com/office/drawing/2014/main" id="{8F4B2ECE-115D-4993-A3C4-BA1DEE4D6C5C}"/>
               </a:ext>
             </a:extLst>
           </p:cNvPr>
@@ -1436,7 +1436,7 @@
           <p:cNvPr id="2" name="">
             <a:extLst xmlns:a="http://schemas.openxmlformats.org/drawingml/2006/main">
               <a:ext uri="{FF2B5EF4-FFF2-40B4-BE49-F238E27FC236}">
-                <a16:creationId xmlns:a16="http://schemas.microsoft.com/office/drawing/2014/main" id="{04479EE1-9A1F-43CE-914D-DBFC9B6D6DA8}"/>
+                <a16:creationId xmlns:a16="http://schemas.microsoft.com/office/drawing/2014/main" id="{1D6C82F7-484A-45ED-901F-586F444AB848}"/>
               </a:ext>
             </a:extLst>
           </p:cNvPr>
@@ -1494,7 +1494,7 @@
           <p:cNvPr id="3" name="">
             <a:extLst xmlns:a="http://schemas.openxmlformats.org/drawingml/2006/main">
               <a:ext uri="{FF2B5EF4-FFF2-40B4-BE49-F238E27FC236}">
-                <a16:creationId xmlns:a16="http://schemas.microsoft.com/office/drawing/2014/main" id="{B1E08D2C-CAB4-4E15-9DCB-9F12F15DA6BD}"/>
+                <a16:creationId xmlns:a16="http://schemas.microsoft.com/office/drawing/2014/main" id="{95459873-7E4C-4058-A1C6-1934B925FEAB}"/>
               </a:ext>
             </a:extLst>
           </p:cNvPr>
@@ -1552,7 +1552,7 @@
           <p:cNvPr id="4" name="">
             <a:extLst xmlns:a="http://schemas.openxmlformats.org/drawingml/2006/main">
               <a:ext uri="{FF2B5EF4-FFF2-40B4-BE49-F238E27FC236}">
-                <a16:creationId xmlns:a16="http://schemas.microsoft.com/office/drawing/2014/main" id="{0BC65DE1-9BA0-45F9-90E0-77277C659F3E}"/>
+                <a16:creationId xmlns:a16="http://schemas.microsoft.com/office/drawing/2014/main" id="{469EB804-552C-42A9-9BBE-140D9197B9EE}"/>
               </a:ext>
             </a:extLst>
           </p:cNvPr>
@@ -1583,7 +1583,7 @@
           <p:cNvPr id="5" name="">
             <a:extLst xmlns:a="http://schemas.openxmlformats.org/drawingml/2006/main">
               <a:ext uri="{FF2B5EF4-FFF2-40B4-BE49-F238E27FC236}">
-                <a16:creationId xmlns:a16="http://schemas.microsoft.com/office/drawing/2014/main" id="{AE85E1AE-D214-46A8-ADAE-465E6EC06442}"/>
+                <a16:creationId xmlns:a16="http://schemas.microsoft.com/office/drawing/2014/main" id="{0E9FB1D1-4F8E-45CA-95CF-5BF64B38BDDE}"/>
               </a:ext>
             </a:extLst>
           </p:cNvPr>
@@ -1641,7 +1641,7 @@
           <p:cNvPr id="6" name="">
             <a:extLst xmlns:a="http://schemas.openxmlformats.org/drawingml/2006/main">
               <a:ext uri="{FF2B5EF4-FFF2-40B4-BE49-F238E27FC236}">
-                <a16:creationId xmlns:a16="http://schemas.microsoft.com/office/drawing/2014/main" id="{6CB4C420-622C-4B0D-9998-5254C12E0E8C}"/>
+                <a16:creationId xmlns:a16="http://schemas.microsoft.com/office/drawing/2014/main" id="{84B7B279-32DD-475A-9DDD-7C9B57E89B02}"/>
               </a:ext>
             </a:extLst>
           </p:cNvPr>
@@ -1674,7 +1674,7 @@
           <p:cNvPr id="7" name="">
             <a:extLst xmlns:a="http://schemas.openxmlformats.org/drawingml/2006/main">
               <a:ext uri="{FF2B5EF4-FFF2-40B4-BE49-F238E27FC236}">
-                <a16:creationId xmlns:a16="http://schemas.microsoft.com/office/drawing/2014/main" id="{5E61760F-E135-48E1-97ED-78B18C4D9CE4}"/>
+                <a16:creationId xmlns:a16="http://schemas.microsoft.com/office/drawing/2014/main" id="{EEB52D7E-602F-4D94-A247-B1570BA1CB0E}"/>
               </a:ext>
             </a:extLst>
           </p:cNvPr>
@@ -1732,7 +1732,7 @@
           <p:cNvPr id="8" name="">
             <a:extLst xmlns:a="http://schemas.openxmlformats.org/drawingml/2006/main">
               <a:ext uri="{FF2B5EF4-FFF2-40B4-BE49-F238E27FC236}">
-                <a16:creationId xmlns:a16="http://schemas.microsoft.com/office/drawing/2014/main" id="{526CE2D4-8997-42B0-A19F-7D75F35A3785}"/>
+                <a16:creationId xmlns:a16="http://schemas.microsoft.com/office/drawing/2014/main" id="{BA253EBA-3329-40E6-9629-D4924F71288B}"/>
               </a:ext>
             </a:extLst>
           </p:cNvPr>
@@ -1765,7 +1765,7 @@
           <p:cNvPr id="9" name="">
             <a:extLst xmlns:a="http://schemas.openxmlformats.org/drawingml/2006/main">
               <a:ext uri="{FF2B5EF4-FFF2-40B4-BE49-F238E27FC236}">
-                <a16:creationId xmlns:a16="http://schemas.microsoft.com/office/drawing/2014/main" id="{2C56B02E-AA47-4436-AC78-DC9D07728B7E}"/>
+                <a16:creationId xmlns:a16="http://schemas.microsoft.com/office/drawing/2014/main" id="{54A7607E-E2A7-46B3-A252-5D40E8B7E0D8}"/>
               </a:ext>
             </a:extLst>
           </p:cNvPr>
@@ -1823,7 +1823,7 @@
           <p:cNvPr id="10" name="">
             <a:extLst xmlns:a="http://schemas.openxmlformats.org/drawingml/2006/main">
               <a:ext uri="{FF2B5EF4-FFF2-40B4-BE49-F238E27FC236}">
-                <a16:creationId xmlns:a16="http://schemas.microsoft.com/office/drawing/2014/main" id="{23378B31-01F3-4382-A123-93DD8D38A816}"/>
+                <a16:creationId xmlns:a16="http://schemas.microsoft.com/office/drawing/2014/main" id="{7DB83571-CD51-403C-87AA-E67756FB66D2}"/>
               </a:ext>
             </a:extLst>
           </p:cNvPr>
@@ -1856,7 +1856,7 @@
           <p:cNvPr id="11" name="">
             <a:extLst xmlns:a="http://schemas.openxmlformats.org/drawingml/2006/main">
               <a:ext uri="{FF2B5EF4-FFF2-40B4-BE49-F238E27FC236}">
-                <a16:creationId xmlns:a16="http://schemas.microsoft.com/office/drawing/2014/main" id="{26C7D899-243B-4F91-AEC8-83E27F58B088}"/>
+                <a16:creationId xmlns:a16="http://schemas.microsoft.com/office/drawing/2014/main" id="{61B2C6BE-FF5F-46D3-99B1-7879F29735A1}"/>
               </a:ext>
             </a:extLst>
           </p:cNvPr>
@@ -1914,7 +1914,7 @@
           <p:cNvPr id="12" name="">
             <a:extLst xmlns:a="http://schemas.openxmlformats.org/drawingml/2006/main">
               <a:ext uri="{FF2B5EF4-FFF2-40B4-BE49-F238E27FC236}">
-                <a16:creationId xmlns:a16="http://schemas.microsoft.com/office/drawing/2014/main" id="{169B31E3-F654-4125-8B7A-5001C5A51C9F}"/>
+                <a16:creationId xmlns:a16="http://schemas.microsoft.com/office/drawing/2014/main" id="{830230FF-999E-4312-9207-929B9AC776A6}"/>
               </a:ext>
             </a:extLst>
           </p:cNvPr>
@@ -1947,7 +1947,7 @@
           <p:cNvPr id="13" name="">
             <a:extLst xmlns:a="http://schemas.openxmlformats.org/drawingml/2006/main">
               <a:ext uri="{FF2B5EF4-FFF2-40B4-BE49-F238E27FC236}">
-                <a16:creationId xmlns:a16="http://schemas.microsoft.com/office/drawing/2014/main" id="{3A7C0F1F-D7C2-40A2-A2C2-303798302BE0}"/>
+                <a16:creationId xmlns:a16="http://schemas.microsoft.com/office/drawing/2014/main" id="{C9ACC71A-94FA-4870-9F17-2F7D4D49DDED}"/>
               </a:ext>
             </a:extLst>
           </p:cNvPr>
@@ -2005,7 +2005,7 @@
           <p:cNvPr id="14" name="">
             <a:extLst xmlns:a="http://schemas.openxmlformats.org/drawingml/2006/main">
               <a:ext uri="{FF2B5EF4-FFF2-40B4-BE49-F238E27FC236}">
-                <a16:creationId xmlns:a16="http://schemas.microsoft.com/office/drawing/2014/main" id="{8F4517CD-017F-49E1-85D6-A17911D81258}"/>
+                <a16:creationId xmlns:a16="http://schemas.microsoft.com/office/drawing/2014/main" id="{3C58996B-2D32-42E6-817E-27E64B22CD60}"/>
               </a:ext>
             </a:extLst>
           </p:cNvPr>
@@ -2038,7 +2038,7 @@
           <p:cNvPr id="15" name="">
             <a:extLst xmlns:a="http://schemas.openxmlformats.org/drawingml/2006/main">
               <a:ext uri="{FF2B5EF4-FFF2-40B4-BE49-F238E27FC236}">
-                <a16:creationId xmlns:a16="http://schemas.microsoft.com/office/drawing/2014/main" id="{B35FBC2F-8D30-464B-8D0D-C0307803441A}"/>
+                <a16:creationId xmlns:a16="http://schemas.microsoft.com/office/drawing/2014/main" id="{B0844033-B973-45FA-AB91-7862B83B5B5D}"/>
               </a:ext>
             </a:extLst>
           </p:cNvPr>
@@ -2096,7 +2096,7 @@
           <p:cNvPr id="16" name="">
             <a:extLst xmlns:a="http://schemas.openxmlformats.org/drawingml/2006/main">
               <a:ext uri="{FF2B5EF4-FFF2-40B4-BE49-F238E27FC236}">
-                <a16:creationId xmlns:a16="http://schemas.microsoft.com/office/drawing/2014/main" id="{E5A9D8C3-8292-4E67-A035-E1E52604F76A}"/>
+                <a16:creationId xmlns:a16="http://schemas.microsoft.com/office/drawing/2014/main" id="{B72EC854-09FA-4117-851D-F3D343AEEEDD}"/>
               </a:ext>
             </a:extLst>
           </p:cNvPr>
@@ -2144,7 +2144,7 @@
                 <a:ea typeface="Helvetica Neue"/>
                 <a:cs typeface="Helvetica Neue"/>
               </a:rPr>
-              <a:t>It estimates when each agent will resume, then releases ready replay requests in deadline order. The request payload stays the same; only the release sequence changes.</a:t>
+              <a:t>It uses expected tool-return times to decide which replay should enter next, so a soon-returning agent is not stuck behind later work.</a:t>
             </a:r>
           </a:p>
         </p:txBody>
@@ -2154,7 +2154,7 @@
           <p:cNvPr id="17" name="">
             <a:extLst xmlns:a="http://schemas.openxmlformats.org/drawingml/2006/main">
               <a:ext uri="{FF2B5EF4-FFF2-40B4-BE49-F238E27FC236}">
-                <a16:creationId xmlns:a16="http://schemas.microsoft.com/office/drawing/2014/main" id="{3250CB48-971A-404B-BB86-21FE5C624AE3}"/>
+                <a16:creationId xmlns:a16="http://schemas.microsoft.com/office/drawing/2014/main" id="{96D0166A-518C-4B27-8A3C-1D6D8095A634}"/>
               </a:ext>
             </a:extLst>
           </p:cNvPr>
@@ -2212,7 +2212,7 @@
           <p:cNvPr id="18" name="">
             <a:extLst xmlns:a="http://schemas.openxmlformats.org/drawingml/2006/main">
               <a:ext uri="{FF2B5EF4-FFF2-40B4-BE49-F238E27FC236}">
-                <a16:creationId xmlns:a16="http://schemas.microsoft.com/office/drawing/2014/main" id="{59A3EDC5-2A41-46B5-A020-523924930411}"/>
+                <a16:creationId xmlns:a16="http://schemas.microsoft.com/office/drawing/2014/main" id="{3ABB5872-AB11-4A52-BFE9-F9ADDF381D45}"/>
               </a:ext>
             </a:extLst>
           </p:cNvPr>
@@ -2270,7 +2270,7 @@
           <p:cNvPr id="19" name="">
             <a:extLst xmlns:a="http://schemas.openxmlformats.org/drawingml/2006/main">
               <a:ext uri="{FF2B5EF4-FFF2-40B4-BE49-F238E27FC236}">
-                <a16:creationId xmlns:a16="http://schemas.microsoft.com/office/drawing/2014/main" id="{EEBFA014-DF7A-484D-B374-5857A4C5F055}"/>
+                <a16:creationId xmlns:a16="http://schemas.microsoft.com/office/drawing/2014/main" id="{DBBCE9A5-8E66-406D-97B2-32C0CC6FEE48}"/>
               </a:ext>
             </a:extLst>
           </p:cNvPr>
@@ -2303,7 +2303,7 @@
           <p:cNvPr id="20" name="">
             <a:extLst xmlns:a="http://schemas.openxmlformats.org/drawingml/2006/main">
               <a:ext uri="{FF2B5EF4-FFF2-40B4-BE49-F238E27FC236}">
-                <a16:creationId xmlns:a16="http://schemas.microsoft.com/office/drawing/2014/main" id="{3776D0A7-5090-476F-B01D-EDEC51A945EE}"/>
+                <a16:creationId xmlns:a16="http://schemas.microsoft.com/office/drawing/2014/main" id="{438ECA5A-7A93-44C8-A21E-5A9C2F3A14AE}"/>
               </a:ext>
             </a:extLst>
           </p:cNvPr>
@@ -2361,7 +2361,7 @@
           <p:cNvPr id="21" name="">
             <a:extLst xmlns:a="http://schemas.openxmlformats.org/drawingml/2006/main">
               <a:ext uri="{FF2B5EF4-FFF2-40B4-BE49-F238E27FC236}">
-                <a16:creationId xmlns:a16="http://schemas.microsoft.com/office/drawing/2014/main" id="{FBDCD185-D268-4D40-B9B5-6A8DCBE67EAF}"/>
+                <a16:creationId xmlns:a16="http://schemas.microsoft.com/office/drawing/2014/main" id="{B0F06B2A-0FD9-4EA5-A80B-9CF9F41F0193}"/>
               </a:ext>
             </a:extLst>
           </p:cNvPr>
@@ -2419,7 +2419,7 @@
           <p:cNvPr id="22" name="">
             <a:extLst xmlns:a="http://schemas.openxmlformats.org/drawingml/2006/main">
               <a:ext uri="{FF2B5EF4-FFF2-40B4-BE49-F238E27FC236}">
-                <a16:creationId xmlns:a16="http://schemas.microsoft.com/office/drawing/2014/main" id="{53CB441C-0545-42B0-900B-BE61A86C6607}"/>
+                <a16:creationId xmlns:a16="http://schemas.microsoft.com/office/drawing/2014/main" id="{2A278566-BC36-4653-B331-6C1991A56ED1}"/>
               </a:ext>
             </a:extLst>
           </p:cNvPr>
@@ -2477,7 +2477,7 @@
           <p:cNvPr id="23" name="">
             <a:extLst xmlns:a="http://schemas.openxmlformats.org/drawingml/2006/main">
               <a:ext uri="{FF2B5EF4-FFF2-40B4-BE49-F238E27FC236}">
-                <a16:creationId xmlns:a16="http://schemas.microsoft.com/office/drawing/2014/main" id="{9765193B-260C-4FAE-A962-2D48239E6863}"/>
+                <a16:creationId xmlns:a16="http://schemas.microsoft.com/office/drawing/2014/main" id="{51E1225A-9BF1-45FC-BA84-A3194B3BCD10}"/>
               </a:ext>
             </a:extLst>
           </p:cNvPr>
@@ -2510,7 +2510,7 @@
           <p:cNvPr id="24" name="">
             <a:extLst xmlns:a="http://schemas.openxmlformats.org/drawingml/2006/main">
               <a:ext uri="{FF2B5EF4-FFF2-40B4-BE49-F238E27FC236}">
-                <a16:creationId xmlns:a16="http://schemas.microsoft.com/office/drawing/2014/main" id="{57649084-AD29-43C6-A954-0D3CA31BD79B}"/>
+                <a16:creationId xmlns:a16="http://schemas.microsoft.com/office/drawing/2014/main" id="{478478E7-C175-4E7F-ADD2-1F4DB7A2DCB8}"/>
               </a:ext>
             </a:extLst>
           </p:cNvPr>
@@ -2568,7 +2568,7 @@
           <p:cNvPr id="25" name="">
             <a:extLst xmlns:a="http://schemas.openxmlformats.org/drawingml/2006/main">
               <a:ext uri="{FF2B5EF4-FFF2-40B4-BE49-F238E27FC236}">
-                <a16:creationId xmlns:a16="http://schemas.microsoft.com/office/drawing/2014/main" id="{F26F7CA0-C106-4ABF-A41E-4FA06F101686}"/>
+                <a16:creationId xmlns:a16="http://schemas.microsoft.com/office/drawing/2014/main" id="{477F0875-C473-4A11-9FEE-ECC9405141E4}"/>
               </a:ext>
             </a:extLst>
           </p:cNvPr>
@@ -2626,7 +2626,7 @@
           <p:cNvPr id="26" name="">
             <a:extLst xmlns:a="http://schemas.openxmlformats.org/drawingml/2006/main">
               <a:ext uri="{FF2B5EF4-FFF2-40B4-BE49-F238E27FC236}">
-                <a16:creationId xmlns:a16="http://schemas.microsoft.com/office/drawing/2014/main" id="{D467DF82-1AD7-4288-A8D0-ACA75B34389F}"/>
+                <a16:creationId xmlns:a16="http://schemas.microsoft.com/office/drawing/2014/main" id="{3CE9ACA3-B7BB-4FF9-A191-F232037A14D3}"/>
               </a:ext>
             </a:extLst>
           </p:cNvPr>
@@ -2684,7 +2684,7 @@
           <p:cNvPr id="27" name="">
             <a:extLst xmlns:a="http://schemas.openxmlformats.org/drawingml/2006/main">
               <a:ext uri="{FF2B5EF4-FFF2-40B4-BE49-F238E27FC236}">
-                <a16:creationId xmlns:a16="http://schemas.microsoft.com/office/drawing/2014/main" id="{9C2A938E-8F42-4ECB-87BB-B55E1708B235}"/>
+                <a16:creationId xmlns:a16="http://schemas.microsoft.com/office/drawing/2014/main" id="{51E64235-4F3A-4A22-B1E1-9D7D86C5103D}"/>
               </a:ext>
             </a:extLst>
           </p:cNvPr>
@@ -2717,7 +2717,7 @@
           <p:cNvPr id="28" name="">
             <a:extLst xmlns:a="http://schemas.openxmlformats.org/drawingml/2006/main">
               <a:ext uri="{FF2B5EF4-FFF2-40B4-BE49-F238E27FC236}">
-                <a16:creationId xmlns:a16="http://schemas.microsoft.com/office/drawing/2014/main" id="{CECADDB1-2AFB-4FD1-A7CD-907FBDE78105}"/>
+                <a16:creationId xmlns:a16="http://schemas.microsoft.com/office/drawing/2014/main" id="{0CDB006B-C022-4B4C-86C3-F0F2430A761E}"/>
               </a:ext>
             </a:extLst>
           </p:cNvPr>
@@ -2775,7 +2775,7 @@
           <p:cNvPr id="29" name="">
             <a:extLst xmlns:a="http://schemas.openxmlformats.org/drawingml/2006/main">
               <a:ext uri="{FF2B5EF4-FFF2-40B4-BE49-F238E27FC236}">
-                <a16:creationId xmlns:a16="http://schemas.microsoft.com/office/drawing/2014/main" id="{4D8320EC-2EB6-44C0-8BC2-40FECCC21DF3}"/>
+                <a16:creationId xmlns:a16="http://schemas.microsoft.com/office/drawing/2014/main" id="{996AAD88-B06A-4EE3-8413-3749575E7472}"/>
               </a:ext>
             </a:extLst>
           </p:cNvPr>
@@ -2833,7 +2833,7 @@
           <p:cNvPr id="30" name="">
             <a:extLst xmlns:a="http://schemas.openxmlformats.org/drawingml/2006/main">
               <a:ext uri="{FF2B5EF4-FFF2-40B4-BE49-F238E27FC236}">
-                <a16:creationId xmlns:a16="http://schemas.microsoft.com/office/drawing/2014/main" id="{0EBF8321-D64D-44E1-A1C1-9EB6BB0F6466}"/>
+                <a16:creationId xmlns:a16="http://schemas.microsoft.com/office/drawing/2014/main" id="{CB706888-A01A-40F3-AFA5-4C7B240F2C00}"/>
               </a:ext>
             </a:extLst>
           </p:cNvPr>
@@ -2891,7 +2891,7 @@
           <p:cNvPr id="31" name="">
             <a:extLst xmlns:a="http://schemas.openxmlformats.org/drawingml/2006/main">
               <a:ext uri="{FF2B5EF4-FFF2-40B4-BE49-F238E27FC236}">
-                <a16:creationId xmlns:a16="http://schemas.microsoft.com/office/drawing/2014/main" id="{CEC83AF0-6B53-4E3C-915E-024BB7A8AEED}"/>
+                <a16:creationId xmlns:a16="http://schemas.microsoft.com/office/drawing/2014/main" id="{C3D4BE72-C7DC-437E-B09C-A98C919ED5D8}"/>
               </a:ext>
             </a:extLst>
           </p:cNvPr>
@@ -2924,7 +2924,7 @@
           <p:cNvPr id="32" name="">
             <a:extLst xmlns:a="http://schemas.openxmlformats.org/drawingml/2006/main">
               <a:ext uri="{FF2B5EF4-FFF2-40B4-BE49-F238E27FC236}">
-                <a16:creationId xmlns:a16="http://schemas.microsoft.com/office/drawing/2014/main" id="{761673CD-3B24-413A-87ED-024E3A045041}"/>
+                <a16:creationId xmlns:a16="http://schemas.microsoft.com/office/drawing/2014/main" id="{2A663CEC-FB15-4647-95E3-F0C997B4CD1D}"/>
               </a:ext>
             </a:extLst>
           </p:cNvPr>
@@ -2982,7 +2982,7 @@
           <p:cNvPr id="33" name="">
             <a:extLst xmlns:a="http://schemas.openxmlformats.org/drawingml/2006/main">
               <a:ext uri="{FF2B5EF4-FFF2-40B4-BE49-F238E27FC236}">
-                <a16:creationId xmlns:a16="http://schemas.microsoft.com/office/drawing/2014/main" id="{C83F8DE5-CEBE-46FD-ABC1-4D6B9D843D5B}"/>
+                <a16:creationId xmlns:a16="http://schemas.microsoft.com/office/drawing/2014/main" id="{86ED39A9-0574-4F21-979C-F6CB5DEE38BE}"/>
               </a:ext>
             </a:extLst>
           </p:cNvPr>
@@ -3040,7 +3040,7 @@
           <p:cNvPr id="34" name="">
             <a:extLst xmlns:a="http://schemas.openxmlformats.org/drawingml/2006/main">
               <a:ext uri="{FF2B5EF4-FFF2-40B4-BE49-F238E27FC236}">
-                <a16:creationId xmlns:a16="http://schemas.microsoft.com/office/drawing/2014/main" id="{B80EDE76-F5C0-443C-9470-7FED337646B9}"/>
+                <a16:creationId xmlns:a16="http://schemas.microsoft.com/office/drawing/2014/main" id="{7F43590F-0D16-4072-B5F9-A3798650783A}"/>
               </a:ext>
             </a:extLst>
           </p:cNvPr>
@@ -3098,7 +3098,7 @@
           <p:cNvPr id="35" name="">
             <a:extLst xmlns:a="http://schemas.openxmlformats.org/drawingml/2006/main">
               <a:ext uri="{FF2B5EF4-FFF2-40B4-BE49-F238E27FC236}">
-                <a16:creationId xmlns:a16="http://schemas.microsoft.com/office/drawing/2014/main" id="{912FED48-FD68-4DF1-BD57-67CD233509FE}"/>
+                <a16:creationId xmlns:a16="http://schemas.microsoft.com/office/drawing/2014/main" id="{FE2C81DD-F2F1-4740-AF1F-A3AD3C3F90AC}"/>
               </a:ext>
             </a:extLst>
           </p:cNvPr>
@@ -3131,7 +3131,7 @@
           <p:cNvPr id="36" name="">
             <a:extLst xmlns:a="http://schemas.openxmlformats.org/drawingml/2006/main">
               <a:ext uri="{FF2B5EF4-FFF2-40B4-BE49-F238E27FC236}">
-                <a16:creationId xmlns:a16="http://schemas.microsoft.com/office/drawing/2014/main" id="{FCE79FED-98D5-40FD-BA8F-28310D4A1230}"/>
+                <a16:creationId xmlns:a16="http://schemas.microsoft.com/office/drawing/2014/main" id="{63BD16C4-D808-4777-85ED-F87F24B4F6A5}"/>
               </a:ext>
             </a:extLst>
           </p:cNvPr>
@@ -3189,7 +3189,7 @@
           <p:cNvPr id="37" name="">
             <a:extLst xmlns:a="http://schemas.openxmlformats.org/drawingml/2006/main">
               <a:ext uri="{FF2B5EF4-FFF2-40B4-BE49-F238E27FC236}">
-                <a16:creationId xmlns:a16="http://schemas.microsoft.com/office/drawing/2014/main" id="{09DBB3E3-CD62-44B3-9A13-6E027CB58E30}"/>
+                <a16:creationId xmlns:a16="http://schemas.microsoft.com/office/drawing/2014/main" id="{62CEC689-E314-46AA-B20F-A66A10C4236C}"/>
               </a:ext>
             </a:extLst>
           </p:cNvPr>
@@ -3247,7 +3247,7 @@
           <p:cNvPr id="38" name="">
             <a:extLst xmlns:a="http://schemas.openxmlformats.org/drawingml/2006/main">
               <a:ext uri="{FF2B5EF4-FFF2-40B4-BE49-F238E27FC236}">
-                <a16:creationId xmlns:a16="http://schemas.microsoft.com/office/drawing/2014/main" id="{4B8A5FBA-756A-4BBA-B2C4-96092C6839D3}"/>
+                <a16:creationId xmlns:a16="http://schemas.microsoft.com/office/drawing/2014/main" id="{7CEBBADD-8404-4C1A-BE7E-A3F83CC6EB9A}"/>
               </a:ext>
             </a:extLst>
           </p:cNvPr>
@@ -3305,7 +3305,7 @@
           <p:cNvPr id="39" name="">
             <a:extLst xmlns:a="http://schemas.openxmlformats.org/drawingml/2006/main">
               <a:ext uri="{FF2B5EF4-FFF2-40B4-BE49-F238E27FC236}">
-                <a16:creationId xmlns:a16="http://schemas.microsoft.com/office/drawing/2014/main" id="{FDEF2E8B-3ECA-4758-AF8B-ABB588CB2210}"/>
+                <a16:creationId xmlns:a16="http://schemas.microsoft.com/office/drawing/2014/main" id="{E60DBC8F-A793-4641-9955-AFD627D7464F}"/>
               </a:ext>
             </a:extLst>
           </p:cNvPr>
@@ -3336,7 +3336,7 @@
           <p:cNvPr id="40" name="">
             <a:extLst xmlns:a="http://schemas.openxmlformats.org/drawingml/2006/main">
               <a:ext uri="{FF2B5EF4-FFF2-40B4-BE49-F238E27FC236}">
-                <a16:creationId xmlns:a16="http://schemas.microsoft.com/office/drawing/2014/main" id="{10413AE6-8D9C-44DF-A249-49C9BF511BFC}"/>
+                <a16:creationId xmlns:a16="http://schemas.microsoft.com/office/drawing/2014/main" id="{242389B1-3BEB-4656-9EE8-AC89BC49E3EB}"/>
               </a:ext>
             </a:extLst>
           </p:cNvPr>
@@ -3394,7 +3394,7 @@
           <p:cNvPr id="41" name="">
             <a:extLst xmlns:a="http://schemas.openxmlformats.org/drawingml/2006/main">
               <a:ext uri="{FF2B5EF4-FFF2-40B4-BE49-F238E27FC236}">
-                <a16:creationId xmlns:a16="http://schemas.microsoft.com/office/drawing/2014/main" id="{68A49374-474D-445C-B46A-E00964FABC07}"/>
+                <a16:creationId xmlns:a16="http://schemas.microsoft.com/office/drawing/2014/main" id="{00926EB6-E7E8-4154-83FC-50E0194B7BC5}"/>
               </a:ext>
             </a:extLst>
           </p:cNvPr>
@@ -3443,64 +3443,6 @@
                 <a:cs typeface="Helvetica Neue"/>
               </a:rPr>
               <a:t>Using harness timing to order replay work reduced replay delay across the full workload.</a:t>
-            </a:r>
-          </a:p>
-        </p:txBody>
-      </p:sp>
-      <p:sp>
-        <p:nvSpPr>
-          <p:cNvPr id="42" name="">
-            <a:extLst xmlns:a="http://schemas.openxmlformats.org/drawingml/2006/main">
-              <a:ext uri="{FF2B5EF4-FFF2-40B4-BE49-F238E27FC236}">
-                <a16:creationId xmlns:a16="http://schemas.microsoft.com/office/drawing/2014/main" id="{E685D8DF-0652-4918-A945-4466A34694F9}"/>
-              </a:ext>
-            </a:extLst>
-          </p:cNvPr>
-          <p:cNvSpPr>
-            <a:spLocks xmlns:a="http://schemas.openxmlformats.org/drawingml/2006/main" noGrp="1"/>
-          </p:cNvSpPr>
-          <p:nvPr/>
-        </p:nvSpPr>
-        <p:spPr>
-          <a:xfrm xmlns:a="http://schemas.openxmlformats.org/drawingml/2006/main">
-            <a:off x="552450" y="6419850"/>
-            <a:ext cx="4191000" cy="190500"/>
-          </a:xfrm>
-          <a:prstGeom xmlns:a="http://schemas.openxmlformats.org/drawingml/2006/main" prst="rect">
-            <a:avLst/>
-          </a:prstGeom>
-          <a:noFill xmlns:a="http://schemas.openxmlformats.org/drawingml/2006/main"/>
-          <a:ln xmlns:a="http://schemas.openxmlformats.org/drawingml/2006/main" w="0">
-            <a:noFill/>
-            <a:prstDash val="solid"/>
-          </a:ln>
-        </p:spPr>
-        <p:txBody>
-          <a:bodyPr xmlns:a="http://schemas.openxmlformats.org/drawingml/2006/main" anchor="t">
-            <a:noAutofit/>
-          </a:bodyPr>
-          <a:lstStyle xmlns:a="http://schemas.openxmlformats.org/drawingml/2006/main"/>
-          <a:p xmlns:a="http://schemas.openxmlformats.org/drawingml/2006/main">
-            <a:pPr algn="l">
-              <a:defRPr sz="900" b="0">
-                <a:solidFill>
-                  <a:srgbClr val="64748B"/>
-                </a:solidFill>
-                <a:latin typeface="Helvetica Neue"/>
-                <a:ea typeface="Helvetica Neue"/>
-                <a:cs typeface="Helvetica Neue"/>
-              </a:defRPr>
-            </a:pPr>
-            <a:r>
-              <a:rPr sz="900" b="0">
-                <a:solidFill>
-                  <a:srgbClr val="64748B"/>
-                </a:solidFill>
-                <a:latin typeface="Helvetica Neue"/>
-                <a:ea typeface="Helvetica Neue"/>
-                <a:cs typeface="Helvetica Neue"/>
-              </a:rPr>
-              <a:t>Source: Harness-Aware Scenario Tracker</a:t>
             </a:r>
           </a:p>
         </p:txBody>
@@ -3508,7 +3450,7 @@
     </p:spTree>
     <p:extLst>
       <p:ext uri="{BB962C8B-B14F-4D97-AF65-F5344CB8AC3E}">
-        <p14:creationId xmlns:p14="http://schemas.microsoft.com/office/powerpoint/2010/main" val="31888467"/>
+        <p14:creationId xmlns:p14="http://schemas.microsoft.com/office/powerpoint/2010/main" val="1030562307"/>
       </p:ext>
     </p:extLst>
   </p:cSld>
@@ -3536,10 +3478,10 @@
       </p:grpSpPr>
       <p:sp>
         <p:nvSpPr>
-          <p:cNvPr id="47" name="">
-            <a:extLst xmlns:a="http://schemas.openxmlformats.org/drawingml/2006/main">
-              <a:ext uri="{FF2B5EF4-FFF2-40B4-BE49-F238E27FC236}">
-                <a16:creationId xmlns:a16="http://schemas.microsoft.com/office/drawing/2014/main" id="{E0B451F9-1290-4384-8359-C1FD85E33F64}"/>
+          <p:cNvPr id="46" name="">
+            <a:extLst xmlns:a="http://schemas.openxmlformats.org/drawingml/2006/main">
+              <a:ext uri="{FF2B5EF4-FFF2-40B4-BE49-F238E27FC236}">
+                <a16:creationId xmlns:a16="http://schemas.microsoft.com/office/drawing/2014/main" id="{82E4480A-87B2-4E2F-8878-3A18A99A34BC}"/>
               </a:ext>
             </a:extLst>
           </p:cNvPr>
@@ -3597,7 +3539,7 @@
           <p:cNvPr id="2" name="">
             <a:extLst xmlns:a="http://schemas.openxmlformats.org/drawingml/2006/main">
               <a:ext uri="{FF2B5EF4-FFF2-40B4-BE49-F238E27FC236}">
-                <a16:creationId xmlns:a16="http://schemas.microsoft.com/office/drawing/2014/main" id="{564617A7-6086-4EA1-8B9F-A554D076269B}"/>
+                <a16:creationId xmlns:a16="http://schemas.microsoft.com/office/drawing/2014/main" id="{1C5AD24F-F87C-4735-A79F-C436BBF21D0D}"/>
               </a:ext>
             </a:extLst>
           </p:cNvPr>
@@ -3655,7 +3597,7 @@
           <p:cNvPr id="3" name="">
             <a:extLst xmlns:a="http://schemas.openxmlformats.org/drawingml/2006/main">
               <a:ext uri="{FF2B5EF4-FFF2-40B4-BE49-F238E27FC236}">
-                <a16:creationId xmlns:a16="http://schemas.microsoft.com/office/drawing/2014/main" id="{D6D3DC21-989E-4397-8157-2EC78F5F4394}"/>
+                <a16:creationId xmlns:a16="http://schemas.microsoft.com/office/drawing/2014/main" id="{920DF99C-2C7B-4D77-B5C2-145D80145535}"/>
               </a:ext>
             </a:extLst>
           </p:cNvPr>
@@ -3713,7 +3655,7 @@
           <p:cNvPr id="4" name="">
             <a:extLst xmlns:a="http://schemas.openxmlformats.org/drawingml/2006/main">
               <a:ext uri="{FF2B5EF4-FFF2-40B4-BE49-F238E27FC236}">
-                <a16:creationId xmlns:a16="http://schemas.microsoft.com/office/drawing/2014/main" id="{2560B120-1A3E-4142-A536-8D658E27DF94}"/>
+                <a16:creationId xmlns:a16="http://schemas.microsoft.com/office/drawing/2014/main" id="{85229626-C939-479B-92A5-D9D31E7D6303}"/>
               </a:ext>
             </a:extLst>
           </p:cNvPr>
@@ -3744,7 +3686,7 @@
           <p:cNvPr id="5" name="">
             <a:extLst xmlns:a="http://schemas.openxmlformats.org/drawingml/2006/main">
               <a:ext uri="{FF2B5EF4-FFF2-40B4-BE49-F238E27FC236}">
-                <a16:creationId xmlns:a16="http://schemas.microsoft.com/office/drawing/2014/main" id="{5A4E957A-7F5B-4038-8B8D-1782AC1B93CE}"/>
+                <a16:creationId xmlns:a16="http://schemas.microsoft.com/office/drawing/2014/main" id="{C3100907-53B3-4D6A-A458-B07DCD5F137C}"/>
               </a:ext>
             </a:extLst>
           </p:cNvPr>
@@ -3802,7 +3744,7 @@
           <p:cNvPr id="6" name="">
             <a:extLst xmlns:a="http://schemas.openxmlformats.org/drawingml/2006/main">
               <a:ext uri="{FF2B5EF4-FFF2-40B4-BE49-F238E27FC236}">
-                <a16:creationId xmlns:a16="http://schemas.microsoft.com/office/drawing/2014/main" id="{5B516D41-B236-436E-A5BD-EEFDBFBC6337}"/>
+                <a16:creationId xmlns:a16="http://schemas.microsoft.com/office/drawing/2014/main" id="{229E30BC-8828-4DE3-9298-7A1FD44D2F4A}"/>
               </a:ext>
             </a:extLst>
           </p:cNvPr>
@@ -3835,7 +3777,7 @@
           <p:cNvPr id="7" name="">
             <a:extLst xmlns:a="http://schemas.openxmlformats.org/drawingml/2006/main">
               <a:ext uri="{FF2B5EF4-FFF2-40B4-BE49-F238E27FC236}">
-                <a16:creationId xmlns:a16="http://schemas.microsoft.com/office/drawing/2014/main" id="{103FFF5D-09AF-419B-BEA6-07A9D6362215}"/>
+                <a16:creationId xmlns:a16="http://schemas.microsoft.com/office/drawing/2014/main" id="{F36455BC-4E64-4054-ABC9-B1E6C0A9634A}"/>
               </a:ext>
             </a:extLst>
           </p:cNvPr>
@@ -3893,7 +3835,7 @@
           <p:cNvPr id="8" name="">
             <a:extLst xmlns:a="http://schemas.openxmlformats.org/drawingml/2006/main">
               <a:ext uri="{FF2B5EF4-FFF2-40B4-BE49-F238E27FC236}">
-                <a16:creationId xmlns:a16="http://schemas.microsoft.com/office/drawing/2014/main" id="{9B369722-A7BB-4C89-BADD-2241D022A2F1}"/>
+                <a16:creationId xmlns:a16="http://schemas.microsoft.com/office/drawing/2014/main" id="{F9F50004-5024-40E6-92A1-1A7B2A5D4156}"/>
               </a:ext>
             </a:extLst>
           </p:cNvPr>
@@ -3926,7 +3868,7 @@
           <p:cNvPr id="9" name="">
             <a:extLst xmlns:a="http://schemas.openxmlformats.org/drawingml/2006/main">
               <a:ext uri="{FF2B5EF4-FFF2-40B4-BE49-F238E27FC236}">
-                <a16:creationId xmlns:a16="http://schemas.microsoft.com/office/drawing/2014/main" id="{45F4C7CA-D71D-45F3-9297-32A825AAE948}"/>
+                <a16:creationId xmlns:a16="http://schemas.microsoft.com/office/drawing/2014/main" id="{2E0DAE7C-2B48-4C10-909E-9B5C3E533CBE}"/>
               </a:ext>
             </a:extLst>
           </p:cNvPr>
@@ -3984,7 +3926,7 @@
           <p:cNvPr id="10" name="">
             <a:extLst xmlns:a="http://schemas.openxmlformats.org/drawingml/2006/main">
               <a:ext uri="{FF2B5EF4-FFF2-40B4-BE49-F238E27FC236}">
-                <a16:creationId xmlns:a16="http://schemas.microsoft.com/office/drawing/2014/main" id="{D2AB9321-9699-4A03-A00D-5F99D3CA4848}"/>
+                <a16:creationId xmlns:a16="http://schemas.microsoft.com/office/drawing/2014/main" id="{FA84A3D0-0E1C-4685-B427-616DC8C553AA}"/>
               </a:ext>
             </a:extLst>
           </p:cNvPr>
@@ -4017,7 +3959,7 @@
           <p:cNvPr id="11" name="">
             <a:extLst xmlns:a="http://schemas.openxmlformats.org/drawingml/2006/main">
               <a:ext uri="{FF2B5EF4-FFF2-40B4-BE49-F238E27FC236}">
-                <a16:creationId xmlns:a16="http://schemas.microsoft.com/office/drawing/2014/main" id="{6A7F2BD3-E0CD-4ED0-B76E-D0DE12A6EC81}"/>
+                <a16:creationId xmlns:a16="http://schemas.microsoft.com/office/drawing/2014/main" id="{1D7E6DAF-0080-4121-98D6-2C7E6C38054E}"/>
               </a:ext>
             </a:extLst>
           </p:cNvPr>
@@ -4075,7 +4017,7 @@
           <p:cNvPr id="12" name="">
             <a:extLst xmlns:a="http://schemas.openxmlformats.org/drawingml/2006/main">
               <a:ext uri="{FF2B5EF4-FFF2-40B4-BE49-F238E27FC236}">
-                <a16:creationId xmlns:a16="http://schemas.microsoft.com/office/drawing/2014/main" id="{324A716E-535E-4904-8148-B3F258E4DBA1}"/>
+                <a16:creationId xmlns:a16="http://schemas.microsoft.com/office/drawing/2014/main" id="{459A21C7-E6B9-4C18-A53A-E1B65B04BB8D}"/>
               </a:ext>
             </a:extLst>
           </p:cNvPr>
@@ -4108,7 +4050,7 @@
           <p:cNvPr id="13" name="">
             <a:extLst xmlns:a="http://schemas.openxmlformats.org/drawingml/2006/main">
               <a:ext uri="{FF2B5EF4-FFF2-40B4-BE49-F238E27FC236}">
-                <a16:creationId xmlns:a16="http://schemas.microsoft.com/office/drawing/2014/main" id="{04413196-4E0A-4E84-9D81-92612852B58A}"/>
+                <a16:creationId xmlns:a16="http://schemas.microsoft.com/office/drawing/2014/main" id="{932F6CB3-021B-4501-A172-28B0195BE06C}"/>
               </a:ext>
             </a:extLst>
           </p:cNvPr>
@@ -4166,7 +4108,7 @@
           <p:cNvPr id="14" name="">
             <a:extLst xmlns:a="http://schemas.openxmlformats.org/drawingml/2006/main">
               <a:ext uri="{FF2B5EF4-FFF2-40B4-BE49-F238E27FC236}">
-                <a16:creationId xmlns:a16="http://schemas.microsoft.com/office/drawing/2014/main" id="{EDDF3B48-80AC-4450-BAA3-645C3EEA521D}"/>
+                <a16:creationId xmlns:a16="http://schemas.microsoft.com/office/drawing/2014/main" id="{36FCE11F-16C5-4D49-A9A4-DA406387ABD7}"/>
               </a:ext>
             </a:extLst>
           </p:cNvPr>
@@ -4199,7 +4141,7 @@
           <p:cNvPr id="15" name="">
             <a:extLst xmlns:a="http://schemas.openxmlformats.org/drawingml/2006/main">
               <a:ext uri="{FF2B5EF4-FFF2-40B4-BE49-F238E27FC236}">
-                <a16:creationId xmlns:a16="http://schemas.microsoft.com/office/drawing/2014/main" id="{ED2B3D40-69FE-412E-853B-D0B3E0AA606A}"/>
+                <a16:creationId xmlns:a16="http://schemas.microsoft.com/office/drawing/2014/main" id="{3F7046EF-783F-404A-BF13-8E630D56E2E9}"/>
               </a:ext>
             </a:extLst>
           </p:cNvPr>
@@ -4257,7 +4199,7 @@
           <p:cNvPr id="16" name="">
             <a:extLst xmlns:a="http://schemas.openxmlformats.org/drawingml/2006/main">
               <a:ext uri="{FF2B5EF4-FFF2-40B4-BE49-F238E27FC236}">
-                <a16:creationId xmlns:a16="http://schemas.microsoft.com/office/drawing/2014/main" id="{6E09F8E4-6B56-4B58-B1B2-296E11B6D2DE}"/>
+                <a16:creationId xmlns:a16="http://schemas.microsoft.com/office/drawing/2014/main" id="{A910AD24-32DB-4AC0-A7C3-9F6F7D694FC6}"/>
               </a:ext>
             </a:extLst>
           </p:cNvPr>
@@ -4305,7 +4247,7 @@
                 <a:ea typeface="Helvetica Neue"/>
                 <a:cs typeface="Helvetica Neue"/>
               </a:rPr>
-              <a:t>It checks SGLang's live cache state before moving anything. Already-on-GPU prefixes are skipped. Small or unsafe loads are skipped. Useful host-backed KV is prepared through SGLang's own path.</a:t>
+              <a:t>It prepares likely-needed KV during the tool wait, but only when SGLang says the KV is worth loading.</a:t>
             </a:r>
           </a:p>
         </p:txBody>
@@ -4315,7 +4257,7 @@
           <p:cNvPr id="17" name="">
             <a:extLst xmlns:a="http://schemas.openxmlformats.org/drawingml/2006/main">
               <a:ext uri="{FF2B5EF4-FFF2-40B4-BE49-F238E27FC236}">
-                <a16:creationId xmlns:a16="http://schemas.microsoft.com/office/drawing/2014/main" id="{92DACE5B-869D-4AA7-84FA-75AF887FAEEC}"/>
+                <a16:creationId xmlns:a16="http://schemas.microsoft.com/office/drawing/2014/main" id="{FF4E7246-B99D-4165-B7A9-9E49BE00076B}"/>
               </a:ext>
             </a:extLst>
           </p:cNvPr>
@@ -4373,7 +4315,7 @@
           <p:cNvPr id="18" name="">
             <a:extLst xmlns:a="http://schemas.openxmlformats.org/drawingml/2006/main">
               <a:ext uri="{FF2B5EF4-FFF2-40B4-BE49-F238E27FC236}">
-                <a16:creationId xmlns:a16="http://schemas.microsoft.com/office/drawing/2014/main" id="{EB740B7C-0BA2-459A-B14C-53240872D4B5}"/>
+                <a16:creationId xmlns:a16="http://schemas.microsoft.com/office/drawing/2014/main" id="{D1A7667C-366F-40C5-9C60-13D5A3572D19}"/>
               </a:ext>
             </a:extLst>
           </p:cNvPr>
@@ -4431,7 +4373,7 @@
           <p:cNvPr id="19" name="">
             <a:extLst xmlns:a="http://schemas.openxmlformats.org/drawingml/2006/main">
               <a:ext uri="{FF2B5EF4-FFF2-40B4-BE49-F238E27FC236}">
-                <a16:creationId xmlns:a16="http://schemas.microsoft.com/office/drawing/2014/main" id="{40EBBC34-D936-4D4B-B559-23EB3B1BD715}"/>
+                <a16:creationId xmlns:a16="http://schemas.microsoft.com/office/drawing/2014/main" id="{E4606827-F561-4750-BBC8-9AC23A797603}"/>
               </a:ext>
             </a:extLst>
           </p:cNvPr>
@@ -4464,7 +4406,7 @@
           <p:cNvPr id="20" name="">
             <a:extLst xmlns:a="http://schemas.openxmlformats.org/drawingml/2006/main">
               <a:ext uri="{FF2B5EF4-FFF2-40B4-BE49-F238E27FC236}">
-                <a16:creationId xmlns:a16="http://schemas.microsoft.com/office/drawing/2014/main" id="{D3937D20-4AA0-46A8-85B8-50EF1FAAADB7}"/>
+                <a16:creationId xmlns:a16="http://schemas.microsoft.com/office/drawing/2014/main" id="{105C80CE-BA01-4C99-B1B9-C26D20099028}"/>
               </a:ext>
             </a:extLst>
           </p:cNvPr>
@@ -4522,7 +4464,7 @@
           <p:cNvPr id="21" name="">
             <a:extLst xmlns:a="http://schemas.openxmlformats.org/drawingml/2006/main">
               <a:ext uri="{FF2B5EF4-FFF2-40B4-BE49-F238E27FC236}">
-                <a16:creationId xmlns:a16="http://schemas.microsoft.com/office/drawing/2014/main" id="{728CAA82-F920-4F10-B943-43043EB375F1}"/>
+                <a16:creationId xmlns:a16="http://schemas.microsoft.com/office/drawing/2014/main" id="{C39A9229-AD60-492D-AE56-8CED28BD88D2}"/>
               </a:ext>
             </a:extLst>
           </p:cNvPr>
@@ -4580,7 +4522,7 @@
           <p:cNvPr id="22" name="">
             <a:extLst xmlns:a="http://schemas.openxmlformats.org/drawingml/2006/main">
               <a:ext uri="{FF2B5EF4-FFF2-40B4-BE49-F238E27FC236}">
-                <a16:creationId xmlns:a16="http://schemas.microsoft.com/office/drawing/2014/main" id="{E267F1D1-7DE0-4999-88D8-CBD9A207E8C1}"/>
+                <a16:creationId xmlns:a16="http://schemas.microsoft.com/office/drawing/2014/main" id="{B67F5F1F-E580-4473-968B-A890D6D82188}"/>
               </a:ext>
             </a:extLst>
           </p:cNvPr>
@@ -4638,7 +4580,7 @@
           <p:cNvPr id="23" name="">
             <a:extLst xmlns:a="http://schemas.openxmlformats.org/drawingml/2006/main">
               <a:ext uri="{FF2B5EF4-FFF2-40B4-BE49-F238E27FC236}">
-                <a16:creationId xmlns:a16="http://schemas.microsoft.com/office/drawing/2014/main" id="{7282BC09-25BC-4D63-86D7-5FA3DCE44071}"/>
+                <a16:creationId xmlns:a16="http://schemas.microsoft.com/office/drawing/2014/main" id="{8F56C1A4-FA38-4CFC-98B6-610F5D4E0FA4}"/>
               </a:ext>
             </a:extLst>
           </p:cNvPr>
@@ -4671,7 +4613,7 @@
           <p:cNvPr id="24" name="">
             <a:extLst xmlns:a="http://schemas.openxmlformats.org/drawingml/2006/main">
               <a:ext uri="{FF2B5EF4-FFF2-40B4-BE49-F238E27FC236}">
-                <a16:creationId xmlns:a16="http://schemas.microsoft.com/office/drawing/2014/main" id="{350A6106-4EF1-482D-83AC-9F5DD95EFD97}"/>
+                <a16:creationId xmlns:a16="http://schemas.microsoft.com/office/drawing/2014/main" id="{86F8D778-9B2D-457D-A5DA-6ACFEBF82820}"/>
               </a:ext>
             </a:extLst>
           </p:cNvPr>
@@ -4729,7 +4671,7 @@
           <p:cNvPr id="25" name="">
             <a:extLst xmlns:a="http://schemas.openxmlformats.org/drawingml/2006/main">
               <a:ext uri="{FF2B5EF4-FFF2-40B4-BE49-F238E27FC236}">
-                <a16:creationId xmlns:a16="http://schemas.microsoft.com/office/drawing/2014/main" id="{AC127AF4-6B01-4930-B082-6EC492B6517A}"/>
+                <a16:creationId xmlns:a16="http://schemas.microsoft.com/office/drawing/2014/main" id="{D17A01C4-B481-4139-B9C1-30109C6956AD}"/>
               </a:ext>
             </a:extLst>
           </p:cNvPr>
@@ -4787,7 +4729,7 @@
           <p:cNvPr id="26" name="">
             <a:extLst xmlns:a="http://schemas.openxmlformats.org/drawingml/2006/main">
               <a:ext uri="{FF2B5EF4-FFF2-40B4-BE49-F238E27FC236}">
-                <a16:creationId xmlns:a16="http://schemas.microsoft.com/office/drawing/2014/main" id="{D95CBF56-036F-4239-AFB2-FF844ACB4CEB}"/>
+                <a16:creationId xmlns:a16="http://schemas.microsoft.com/office/drawing/2014/main" id="{EAB603A9-C948-4D07-B5DE-9E07BD1C0C03}"/>
               </a:ext>
             </a:extLst>
           </p:cNvPr>
@@ -4845,7 +4787,7 @@
           <p:cNvPr id="27" name="">
             <a:extLst xmlns:a="http://schemas.openxmlformats.org/drawingml/2006/main">
               <a:ext uri="{FF2B5EF4-FFF2-40B4-BE49-F238E27FC236}">
-                <a16:creationId xmlns:a16="http://schemas.microsoft.com/office/drawing/2014/main" id="{BAFE27E6-BBD4-4EFF-9E2F-6EF386382358}"/>
+                <a16:creationId xmlns:a16="http://schemas.microsoft.com/office/drawing/2014/main" id="{3189E6F0-30CE-4F0C-9BF7-AD6738F77B52}"/>
               </a:ext>
             </a:extLst>
           </p:cNvPr>
@@ -4878,7 +4820,7 @@
           <p:cNvPr id="28" name="">
             <a:extLst xmlns:a="http://schemas.openxmlformats.org/drawingml/2006/main">
               <a:ext uri="{FF2B5EF4-FFF2-40B4-BE49-F238E27FC236}">
-                <a16:creationId xmlns:a16="http://schemas.microsoft.com/office/drawing/2014/main" id="{E23D125D-BC87-46F5-A124-2633E763D703}"/>
+                <a16:creationId xmlns:a16="http://schemas.microsoft.com/office/drawing/2014/main" id="{9A5A80E3-1C9A-4E24-ACD0-CCF29035C563}"/>
               </a:ext>
             </a:extLst>
           </p:cNvPr>
@@ -4936,7 +4878,7 @@
           <p:cNvPr id="29" name="">
             <a:extLst xmlns:a="http://schemas.openxmlformats.org/drawingml/2006/main">
               <a:ext uri="{FF2B5EF4-FFF2-40B4-BE49-F238E27FC236}">
-                <a16:creationId xmlns:a16="http://schemas.microsoft.com/office/drawing/2014/main" id="{2DF0493C-A7BB-4EF4-82C2-3A91339A9B4D}"/>
+                <a16:creationId xmlns:a16="http://schemas.microsoft.com/office/drawing/2014/main" id="{E888F9DE-A87A-46FF-BA2F-E96576C4CBF6}"/>
               </a:ext>
             </a:extLst>
           </p:cNvPr>
@@ -4994,7 +4936,7 @@
           <p:cNvPr id="30" name="">
             <a:extLst xmlns:a="http://schemas.openxmlformats.org/drawingml/2006/main">
               <a:ext uri="{FF2B5EF4-FFF2-40B4-BE49-F238E27FC236}">
-                <a16:creationId xmlns:a16="http://schemas.microsoft.com/office/drawing/2014/main" id="{C9999C55-A50E-4A8F-916E-4072ED2916AE}"/>
+                <a16:creationId xmlns:a16="http://schemas.microsoft.com/office/drawing/2014/main" id="{7EABB104-0C78-4F01-B972-C6650F7D57D7}"/>
               </a:ext>
             </a:extLst>
           </p:cNvPr>
@@ -5052,7 +4994,7 @@
           <p:cNvPr id="31" name="">
             <a:extLst xmlns:a="http://schemas.openxmlformats.org/drawingml/2006/main">
               <a:ext uri="{FF2B5EF4-FFF2-40B4-BE49-F238E27FC236}">
-                <a16:creationId xmlns:a16="http://schemas.microsoft.com/office/drawing/2014/main" id="{251B1B4E-1263-40E0-A03E-BA9024293965}"/>
+                <a16:creationId xmlns:a16="http://schemas.microsoft.com/office/drawing/2014/main" id="{447D4768-5EE4-4277-8659-0C1BA9196C7A}"/>
               </a:ext>
             </a:extLst>
           </p:cNvPr>
@@ -5085,7 +5027,7 @@
           <p:cNvPr id="32" name="">
             <a:extLst xmlns:a="http://schemas.openxmlformats.org/drawingml/2006/main">
               <a:ext uri="{FF2B5EF4-FFF2-40B4-BE49-F238E27FC236}">
-                <a16:creationId xmlns:a16="http://schemas.microsoft.com/office/drawing/2014/main" id="{7B7BAB0E-77D1-438F-9D20-28DF78EF5937}"/>
+                <a16:creationId xmlns:a16="http://schemas.microsoft.com/office/drawing/2014/main" id="{6B567F73-BE44-40B7-855A-94469D60698B}"/>
               </a:ext>
             </a:extLst>
           </p:cNvPr>
@@ -5143,7 +5085,7 @@
           <p:cNvPr id="33" name="">
             <a:extLst xmlns:a="http://schemas.openxmlformats.org/drawingml/2006/main">
               <a:ext uri="{FF2B5EF4-FFF2-40B4-BE49-F238E27FC236}">
-                <a16:creationId xmlns:a16="http://schemas.microsoft.com/office/drawing/2014/main" id="{DA6D3C8D-51F2-45CA-B7A1-BC91E40B30A4}"/>
+                <a16:creationId xmlns:a16="http://schemas.microsoft.com/office/drawing/2014/main" id="{7C216768-7EB0-4CFB-8C56-4B2D5AAA4F19}"/>
               </a:ext>
             </a:extLst>
           </p:cNvPr>
@@ -5201,7 +5143,7 @@
           <p:cNvPr id="34" name="">
             <a:extLst xmlns:a="http://schemas.openxmlformats.org/drawingml/2006/main">
               <a:ext uri="{FF2B5EF4-FFF2-40B4-BE49-F238E27FC236}">
-                <a16:creationId xmlns:a16="http://schemas.microsoft.com/office/drawing/2014/main" id="{E1A13371-9FC4-46FF-A136-685B7134FEDB}"/>
+                <a16:creationId xmlns:a16="http://schemas.microsoft.com/office/drawing/2014/main" id="{AF952594-74CA-4A86-990B-EE3A1AA51AC5}"/>
               </a:ext>
             </a:extLst>
           </p:cNvPr>
@@ -5259,7 +5201,7 @@
           <p:cNvPr id="35" name="">
             <a:extLst xmlns:a="http://schemas.openxmlformats.org/drawingml/2006/main">
               <a:ext uri="{FF2B5EF4-FFF2-40B4-BE49-F238E27FC236}">
-                <a16:creationId xmlns:a16="http://schemas.microsoft.com/office/drawing/2014/main" id="{16F8354C-9401-4233-AC5B-ACCF27992E69}"/>
+                <a16:creationId xmlns:a16="http://schemas.microsoft.com/office/drawing/2014/main" id="{A94AAAD5-EA54-4BFA-9DB4-8506BB455419}"/>
               </a:ext>
             </a:extLst>
           </p:cNvPr>
@@ -5292,7 +5234,7 @@
           <p:cNvPr id="36" name="">
             <a:extLst xmlns:a="http://schemas.openxmlformats.org/drawingml/2006/main">
               <a:ext uri="{FF2B5EF4-FFF2-40B4-BE49-F238E27FC236}">
-                <a16:creationId xmlns:a16="http://schemas.microsoft.com/office/drawing/2014/main" id="{51B35289-4817-48D0-B5C0-64E4ED12EA74}"/>
+                <a16:creationId xmlns:a16="http://schemas.microsoft.com/office/drawing/2014/main" id="{F7557246-4F5C-4AD7-BCC3-808BB19E11A7}"/>
               </a:ext>
             </a:extLst>
           </p:cNvPr>
@@ -5350,7 +5292,7 @@
           <p:cNvPr id="37" name="">
             <a:extLst xmlns:a="http://schemas.openxmlformats.org/drawingml/2006/main">
               <a:ext uri="{FF2B5EF4-FFF2-40B4-BE49-F238E27FC236}">
-                <a16:creationId xmlns:a16="http://schemas.microsoft.com/office/drawing/2014/main" id="{9601D6C2-08B6-4664-8837-326C94A96627}"/>
+                <a16:creationId xmlns:a16="http://schemas.microsoft.com/office/drawing/2014/main" id="{EAD4D930-038D-4C12-9B6F-B152B267A28F}"/>
               </a:ext>
             </a:extLst>
           </p:cNvPr>
@@ -5408,7 +5350,7 @@
           <p:cNvPr id="38" name="">
             <a:extLst xmlns:a="http://schemas.openxmlformats.org/drawingml/2006/main">
               <a:ext uri="{FF2B5EF4-FFF2-40B4-BE49-F238E27FC236}">
-                <a16:creationId xmlns:a16="http://schemas.microsoft.com/office/drawing/2014/main" id="{5C5EFAAE-CBA4-4C28-8A57-3B664817D913}"/>
+                <a16:creationId xmlns:a16="http://schemas.microsoft.com/office/drawing/2014/main" id="{58520918-860B-4246-86CF-AE2D6DD9B718}"/>
               </a:ext>
             </a:extLst>
           </p:cNvPr>
@@ -5466,7 +5408,7 @@
           <p:cNvPr id="39" name="">
             <a:extLst xmlns:a="http://schemas.openxmlformats.org/drawingml/2006/main">
               <a:ext uri="{FF2B5EF4-FFF2-40B4-BE49-F238E27FC236}">
-                <a16:creationId xmlns:a16="http://schemas.microsoft.com/office/drawing/2014/main" id="{C66ACD67-F634-49B0-8D7C-AFAC27C33633}"/>
+                <a16:creationId xmlns:a16="http://schemas.microsoft.com/office/drawing/2014/main" id="{5C4B5848-4531-4B5A-92A9-B1B2A398A870}"/>
               </a:ext>
             </a:extLst>
           </p:cNvPr>
@@ -5499,7 +5441,7 @@
           <p:cNvPr id="40" name="">
             <a:extLst xmlns:a="http://schemas.openxmlformats.org/drawingml/2006/main">
               <a:ext uri="{FF2B5EF4-FFF2-40B4-BE49-F238E27FC236}">
-                <a16:creationId xmlns:a16="http://schemas.microsoft.com/office/drawing/2014/main" id="{92EAAD83-2336-4D62-8F5A-ADE2D74C7E7A}"/>
+                <a16:creationId xmlns:a16="http://schemas.microsoft.com/office/drawing/2014/main" id="{CCC259D8-247A-4D45-9B4A-7AF1D6E06F25}"/>
               </a:ext>
             </a:extLst>
           </p:cNvPr>
@@ -5557,7 +5499,7 @@
           <p:cNvPr id="41" name="">
             <a:extLst xmlns:a="http://schemas.openxmlformats.org/drawingml/2006/main">
               <a:ext uri="{FF2B5EF4-FFF2-40B4-BE49-F238E27FC236}">
-                <a16:creationId xmlns:a16="http://schemas.microsoft.com/office/drawing/2014/main" id="{9015CA9E-1843-42B8-84F6-4D1773BAE562}"/>
+                <a16:creationId xmlns:a16="http://schemas.microsoft.com/office/drawing/2014/main" id="{0FB13AFF-DFF7-450E-9874-A8F385226659}"/>
               </a:ext>
             </a:extLst>
           </p:cNvPr>
@@ -5615,7 +5557,7 @@
           <p:cNvPr id="42" name="">
             <a:extLst xmlns:a="http://schemas.openxmlformats.org/drawingml/2006/main">
               <a:ext uri="{FF2B5EF4-FFF2-40B4-BE49-F238E27FC236}">
-                <a16:creationId xmlns:a16="http://schemas.microsoft.com/office/drawing/2014/main" id="{150714F6-0EE1-44F5-9CA7-1A3C42FF20E4}"/>
+                <a16:creationId xmlns:a16="http://schemas.microsoft.com/office/drawing/2014/main" id="{8342A5A5-2222-411D-98F4-872830772D71}"/>
               </a:ext>
             </a:extLst>
           </p:cNvPr>
@@ -5673,7 +5615,7 @@
           <p:cNvPr id="43" name="">
             <a:extLst xmlns:a="http://schemas.openxmlformats.org/drawingml/2006/main">
               <a:ext uri="{FF2B5EF4-FFF2-40B4-BE49-F238E27FC236}">
-                <a16:creationId xmlns:a16="http://schemas.microsoft.com/office/drawing/2014/main" id="{F62F65FB-97BA-4903-B79C-4F77468A6171}"/>
+                <a16:creationId xmlns:a16="http://schemas.microsoft.com/office/drawing/2014/main" id="{900D5DB9-0CC3-4BFA-B648-0BDA26DE8679}"/>
               </a:ext>
             </a:extLst>
           </p:cNvPr>
@@ -5704,7 +5646,7 @@
           <p:cNvPr id="44" name="">
             <a:extLst xmlns:a="http://schemas.openxmlformats.org/drawingml/2006/main">
               <a:ext uri="{FF2B5EF4-FFF2-40B4-BE49-F238E27FC236}">
-                <a16:creationId xmlns:a16="http://schemas.microsoft.com/office/drawing/2014/main" id="{CFE18C21-9738-4909-A88B-8148C8EC970F}"/>
+                <a16:creationId xmlns:a16="http://schemas.microsoft.com/office/drawing/2014/main" id="{9161CF86-BF21-49AD-A056-8752A4E1EEEB}"/>
               </a:ext>
             </a:extLst>
           </p:cNvPr>
@@ -5762,7 +5704,7 @@
           <p:cNvPr id="45" name="">
             <a:extLst xmlns:a="http://schemas.openxmlformats.org/drawingml/2006/main">
               <a:ext uri="{FF2B5EF4-FFF2-40B4-BE49-F238E27FC236}">
-                <a16:creationId xmlns:a16="http://schemas.microsoft.com/office/drawing/2014/main" id="{44BC5EF3-39D8-465A-A2D3-ED7416D1B648}"/>
+                <a16:creationId xmlns:a16="http://schemas.microsoft.com/office/drawing/2014/main" id="{7355603A-55F7-4998-AC98-9EC82B451062}"/>
               </a:ext>
             </a:extLst>
           </p:cNvPr>
@@ -5811,64 +5753,6 @@
                 <a:cs typeface="Helvetica Neue"/>
               </a:rPr>
               <a:t>21 cache checks, 6 admitted direct loads, 48,889 prepared tokens, and 560 H2D copy events before replay compute.</a:t>
-            </a:r>
-          </a:p>
-        </p:txBody>
-      </p:sp>
-      <p:sp>
-        <p:nvSpPr>
-          <p:cNvPr id="46" name="">
-            <a:extLst xmlns:a="http://schemas.openxmlformats.org/drawingml/2006/main">
-              <a:ext uri="{FF2B5EF4-FFF2-40B4-BE49-F238E27FC236}">
-                <a16:creationId xmlns:a16="http://schemas.microsoft.com/office/drawing/2014/main" id="{03FA132B-002D-46D9-B237-C4F32387EFB2}"/>
-              </a:ext>
-            </a:extLst>
-          </p:cNvPr>
-          <p:cNvSpPr>
-            <a:spLocks xmlns:a="http://schemas.openxmlformats.org/drawingml/2006/main" noGrp="1"/>
-          </p:cNvSpPr>
-          <p:nvPr/>
-        </p:nvSpPr>
-        <p:spPr>
-          <a:xfrm xmlns:a="http://schemas.openxmlformats.org/drawingml/2006/main">
-            <a:off x="552450" y="6419850"/>
-            <a:ext cx="4191000" cy="190500"/>
-          </a:xfrm>
-          <a:prstGeom xmlns:a="http://schemas.openxmlformats.org/drawingml/2006/main" prst="rect">
-            <a:avLst/>
-          </a:prstGeom>
-          <a:noFill xmlns:a="http://schemas.openxmlformats.org/drawingml/2006/main"/>
-          <a:ln xmlns:a="http://schemas.openxmlformats.org/drawingml/2006/main" w="0">
-            <a:noFill/>
-            <a:prstDash val="solid"/>
-          </a:ln>
-        </p:spPr>
-        <p:txBody>
-          <a:bodyPr xmlns:a="http://schemas.openxmlformats.org/drawingml/2006/main" anchor="t">
-            <a:noAutofit/>
-          </a:bodyPr>
-          <a:lstStyle xmlns:a="http://schemas.openxmlformats.org/drawingml/2006/main"/>
-          <a:p xmlns:a="http://schemas.openxmlformats.org/drawingml/2006/main">
-            <a:pPr algn="l">
-              <a:defRPr sz="900" b="0">
-                <a:solidFill>
-                  <a:srgbClr val="64748B"/>
-                </a:solidFill>
-                <a:latin typeface="Helvetica Neue"/>
-                <a:ea typeface="Helvetica Neue"/>
-                <a:cs typeface="Helvetica Neue"/>
-              </a:defRPr>
-            </a:pPr>
-            <a:r>
-              <a:rPr sz="900" b="0">
-                <a:solidFill>
-                  <a:srgbClr val="64748B"/>
-                </a:solidFill>
-                <a:latin typeface="Helvetica Neue"/>
-                <a:ea typeface="Helvetica Neue"/>
-                <a:cs typeface="Helvetica Neue"/>
-              </a:rPr>
-              <a:t>Source: Harness-Aware Scenario Tracker</a:t>
             </a:r>
           </a:p>
         </p:txBody>
@@ -5876,7 +5760,7 @@
     </p:spTree>
     <p:extLst>
       <p:ext uri="{BB962C8B-B14F-4D97-AF65-F5344CB8AC3E}">
-        <p14:creationId xmlns:p14="http://schemas.microsoft.com/office/powerpoint/2010/main" val="798250258"/>
+        <p14:creationId xmlns:p14="http://schemas.microsoft.com/office/powerpoint/2010/main" val="791965220"/>
       </p:ext>
     </p:extLst>
   </p:cSld>
@@ -5904,10 +5788,10 @@
       </p:grpSpPr>
       <p:sp>
         <p:nvSpPr>
-          <p:cNvPr id="47" name="">
-            <a:extLst xmlns:a="http://schemas.openxmlformats.org/drawingml/2006/main">
-              <a:ext uri="{FF2B5EF4-FFF2-40B4-BE49-F238E27FC236}">
-                <a16:creationId xmlns:a16="http://schemas.microsoft.com/office/drawing/2014/main" id="{157EFF41-C480-426F-94FB-CEA1E2ACEFB2}"/>
+          <p:cNvPr id="46" name="">
+            <a:extLst xmlns:a="http://schemas.openxmlformats.org/drawingml/2006/main">
+              <a:ext uri="{FF2B5EF4-FFF2-40B4-BE49-F238E27FC236}">
+                <a16:creationId xmlns:a16="http://schemas.microsoft.com/office/drawing/2014/main" id="{D00922CC-CE90-4843-95C4-841E50AEE8EA}"/>
               </a:ext>
             </a:extLst>
           </p:cNvPr>
@@ -5965,7 +5849,7 @@
           <p:cNvPr id="2" name="">
             <a:extLst xmlns:a="http://schemas.openxmlformats.org/drawingml/2006/main">
               <a:ext uri="{FF2B5EF4-FFF2-40B4-BE49-F238E27FC236}">
-                <a16:creationId xmlns:a16="http://schemas.microsoft.com/office/drawing/2014/main" id="{A4C919E6-E349-43BF-8259-CE8456A8C737}"/>
+                <a16:creationId xmlns:a16="http://schemas.microsoft.com/office/drawing/2014/main" id="{20A46475-E478-468F-B55B-B06AC33E0122}"/>
               </a:ext>
             </a:extLst>
           </p:cNvPr>
@@ -6023,7 +5907,7 @@
           <p:cNvPr id="3" name="">
             <a:extLst xmlns:a="http://schemas.openxmlformats.org/drawingml/2006/main">
               <a:ext uri="{FF2B5EF4-FFF2-40B4-BE49-F238E27FC236}">
-                <a16:creationId xmlns:a16="http://schemas.microsoft.com/office/drawing/2014/main" id="{1A758981-2021-46E9-9A89-D7949DC12A82}"/>
+                <a16:creationId xmlns:a16="http://schemas.microsoft.com/office/drawing/2014/main" id="{C9B7B45B-3084-4E88-B488-97B4D32AC120}"/>
               </a:ext>
             </a:extLst>
           </p:cNvPr>
@@ -6081,7 +5965,7 @@
           <p:cNvPr id="4" name="">
             <a:extLst xmlns:a="http://schemas.openxmlformats.org/drawingml/2006/main">
               <a:ext uri="{FF2B5EF4-FFF2-40B4-BE49-F238E27FC236}">
-                <a16:creationId xmlns:a16="http://schemas.microsoft.com/office/drawing/2014/main" id="{87922529-8659-48B1-8657-AFED10BEDCF7}"/>
+                <a16:creationId xmlns:a16="http://schemas.microsoft.com/office/drawing/2014/main" id="{7BBB6492-4B16-4568-B42C-DAB473AFA46B}"/>
               </a:ext>
             </a:extLst>
           </p:cNvPr>
@@ -6112,7 +5996,7 @@
           <p:cNvPr id="5" name="">
             <a:extLst xmlns:a="http://schemas.openxmlformats.org/drawingml/2006/main">
               <a:ext uri="{FF2B5EF4-FFF2-40B4-BE49-F238E27FC236}">
-                <a16:creationId xmlns:a16="http://schemas.microsoft.com/office/drawing/2014/main" id="{B6B6110B-3B5C-4863-9425-77A97525E9B0}"/>
+                <a16:creationId xmlns:a16="http://schemas.microsoft.com/office/drawing/2014/main" id="{F3C930B4-AE0D-40F0-8D10-9400E515C045}"/>
               </a:ext>
             </a:extLst>
           </p:cNvPr>
@@ -6170,7 +6054,7 @@
           <p:cNvPr id="6" name="">
             <a:extLst xmlns:a="http://schemas.openxmlformats.org/drawingml/2006/main">
               <a:ext uri="{FF2B5EF4-FFF2-40B4-BE49-F238E27FC236}">
-                <a16:creationId xmlns:a16="http://schemas.microsoft.com/office/drawing/2014/main" id="{84335AB3-5DFB-4083-A97B-4350173768F4}"/>
+                <a16:creationId xmlns:a16="http://schemas.microsoft.com/office/drawing/2014/main" id="{437EAAD2-CF64-43C8-B2FF-76FCC712C4DA}"/>
               </a:ext>
             </a:extLst>
           </p:cNvPr>
@@ -6203,7 +6087,7 @@
           <p:cNvPr id="7" name="">
             <a:extLst xmlns:a="http://schemas.openxmlformats.org/drawingml/2006/main">
               <a:ext uri="{FF2B5EF4-FFF2-40B4-BE49-F238E27FC236}">
-                <a16:creationId xmlns:a16="http://schemas.microsoft.com/office/drawing/2014/main" id="{85AD5607-C693-4118-951C-31EB552128E1}"/>
+                <a16:creationId xmlns:a16="http://schemas.microsoft.com/office/drawing/2014/main" id="{AA16E484-25C9-4A41-931A-2CFA1F94434D}"/>
               </a:ext>
             </a:extLst>
           </p:cNvPr>
@@ -6261,7 +6145,7 @@
           <p:cNvPr id="8" name="">
             <a:extLst xmlns:a="http://schemas.openxmlformats.org/drawingml/2006/main">
               <a:ext uri="{FF2B5EF4-FFF2-40B4-BE49-F238E27FC236}">
-                <a16:creationId xmlns:a16="http://schemas.microsoft.com/office/drawing/2014/main" id="{EC562871-667D-4772-9F45-3EAE37FE5BD7}"/>
+                <a16:creationId xmlns:a16="http://schemas.microsoft.com/office/drawing/2014/main" id="{D7BB3744-4AE3-4EF4-80E1-3CDFF5F53CFE}"/>
               </a:ext>
             </a:extLst>
           </p:cNvPr>
@@ -6294,7 +6178,7 @@
           <p:cNvPr id="9" name="">
             <a:extLst xmlns:a="http://schemas.openxmlformats.org/drawingml/2006/main">
               <a:ext uri="{FF2B5EF4-FFF2-40B4-BE49-F238E27FC236}">
-                <a16:creationId xmlns:a16="http://schemas.microsoft.com/office/drawing/2014/main" id="{6C1E400C-3F53-4462-9525-D15D5D9A808C}"/>
+                <a16:creationId xmlns:a16="http://schemas.microsoft.com/office/drawing/2014/main" id="{37C3F707-0C83-47F7-838A-C5C492DAC730}"/>
               </a:ext>
             </a:extLst>
           </p:cNvPr>
@@ -6352,7 +6236,7 @@
           <p:cNvPr id="10" name="">
             <a:extLst xmlns:a="http://schemas.openxmlformats.org/drawingml/2006/main">
               <a:ext uri="{FF2B5EF4-FFF2-40B4-BE49-F238E27FC236}">
-                <a16:creationId xmlns:a16="http://schemas.microsoft.com/office/drawing/2014/main" id="{E19125B7-D6D7-42C1-BD84-784FAB1B687D}"/>
+                <a16:creationId xmlns:a16="http://schemas.microsoft.com/office/drawing/2014/main" id="{CAC74FE8-2D3C-451C-80B7-172064A93EDD}"/>
               </a:ext>
             </a:extLst>
           </p:cNvPr>
@@ -6385,7 +6269,7 @@
           <p:cNvPr id="11" name="">
             <a:extLst xmlns:a="http://schemas.openxmlformats.org/drawingml/2006/main">
               <a:ext uri="{FF2B5EF4-FFF2-40B4-BE49-F238E27FC236}">
-                <a16:creationId xmlns:a16="http://schemas.microsoft.com/office/drawing/2014/main" id="{D8EB7E6B-1E1D-44A3-A5DB-568FE7DC6E53}"/>
+                <a16:creationId xmlns:a16="http://schemas.microsoft.com/office/drawing/2014/main" id="{455E7A1C-DE95-434C-ABD6-A36755AB7A21}"/>
               </a:ext>
             </a:extLst>
           </p:cNvPr>
@@ -6443,7 +6327,7 @@
           <p:cNvPr id="12" name="">
             <a:extLst xmlns:a="http://schemas.openxmlformats.org/drawingml/2006/main">
               <a:ext uri="{FF2B5EF4-FFF2-40B4-BE49-F238E27FC236}">
-                <a16:creationId xmlns:a16="http://schemas.microsoft.com/office/drawing/2014/main" id="{6E86DF83-A7D4-4B4F-AEF3-346AF071D143}"/>
+                <a16:creationId xmlns:a16="http://schemas.microsoft.com/office/drawing/2014/main" id="{4F48B98C-DC41-468D-A2F2-478D9F51F704}"/>
               </a:ext>
             </a:extLst>
           </p:cNvPr>
@@ -6476,7 +6360,7 @@
           <p:cNvPr id="13" name="">
             <a:extLst xmlns:a="http://schemas.openxmlformats.org/drawingml/2006/main">
               <a:ext uri="{FF2B5EF4-FFF2-40B4-BE49-F238E27FC236}">
-                <a16:creationId xmlns:a16="http://schemas.microsoft.com/office/drawing/2014/main" id="{157F42BD-60F6-4361-ABB4-0808BC272650}"/>
+                <a16:creationId xmlns:a16="http://schemas.microsoft.com/office/drawing/2014/main" id="{CF5CB9D3-7C77-437F-B6AF-7FE290FC4B4C}"/>
               </a:ext>
             </a:extLst>
           </p:cNvPr>
@@ -6534,7 +6418,7 @@
           <p:cNvPr id="14" name="">
             <a:extLst xmlns:a="http://schemas.openxmlformats.org/drawingml/2006/main">
               <a:ext uri="{FF2B5EF4-FFF2-40B4-BE49-F238E27FC236}">
-                <a16:creationId xmlns:a16="http://schemas.microsoft.com/office/drawing/2014/main" id="{5C137647-0680-40B0-A9C2-2FBA1277778A}"/>
+                <a16:creationId xmlns:a16="http://schemas.microsoft.com/office/drawing/2014/main" id="{EA8E89AA-A575-4828-96F4-C8CBE243E0A0}"/>
               </a:ext>
             </a:extLst>
           </p:cNvPr>
@@ -6567,7 +6451,7 @@
           <p:cNvPr id="15" name="">
             <a:extLst xmlns:a="http://schemas.openxmlformats.org/drawingml/2006/main">
               <a:ext uri="{FF2B5EF4-FFF2-40B4-BE49-F238E27FC236}">
-                <a16:creationId xmlns:a16="http://schemas.microsoft.com/office/drawing/2014/main" id="{72798870-6222-426B-9098-927B309A597E}"/>
+                <a16:creationId xmlns:a16="http://schemas.microsoft.com/office/drawing/2014/main" id="{E6258620-5EF2-4B76-90F1-EA27F5BFFA15}"/>
               </a:ext>
             </a:extLst>
           </p:cNvPr>
@@ -6625,7 +6509,7 @@
           <p:cNvPr id="16" name="">
             <a:extLst xmlns:a="http://schemas.openxmlformats.org/drawingml/2006/main">
               <a:ext uri="{FF2B5EF4-FFF2-40B4-BE49-F238E27FC236}">
-                <a16:creationId xmlns:a16="http://schemas.microsoft.com/office/drawing/2014/main" id="{93947A90-3215-418F-8941-B0C540C08F82}"/>
+                <a16:creationId xmlns:a16="http://schemas.microsoft.com/office/drawing/2014/main" id="{77A9498F-410A-4228-A115-9E36CEF93075}"/>
               </a:ext>
             </a:extLst>
           </p:cNvPr>
@@ -6673,7 +6557,7 @@
                 <a:ea typeface="Helvetica Neue"/>
                 <a:cs typeface="Helvetica Neue"/>
               </a:rPr>
-              <a:t>It scores cached prefixes using reuse likelihood, rebuild cost, and expected replay timing. SGLang's native radix eviction path then chooses what to evict.</a:t>
+              <a:t>It helps SGLang avoid evicting KV that a soon-returning agent is likely to need.</a:t>
             </a:r>
           </a:p>
         </p:txBody>
@@ -6683,7 +6567,7 @@
           <p:cNvPr id="17" name="">
             <a:extLst xmlns:a="http://schemas.openxmlformats.org/drawingml/2006/main">
               <a:ext uri="{FF2B5EF4-FFF2-40B4-BE49-F238E27FC236}">
-                <a16:creationId xmlns:a16="http://schemas.microsoft.com/office/drawing/2014/main" id="{7697BA95-4842-449B-9880-5ABC358A879E}"/>
+                <a16:creationId xmlns:a16="http://schemas.microsoft.com/office/drawing/2014/main" id="{945391F8-6C40-4021-9F1C-216A52726F58}"/>
               </a:ext>
             </a:extLst>
           </p:cNvPr>
@@ -6741,7 +6625,7 @@
           <p:cNvPr id="18" name="">
             <a:extLst xmlns:a="http://schemas.openxmlformats.org/drawingml/2006/main">
               <a:ext uri="{FF2B5EF4-FFF2-40B4-BE49-F238E27FC236}">
-                <a16:creationId xmlns:a16="http://schemas.microsoft.com/office/drawing/2014/main" id="{A8DDD8C4-6A97-4297-A1CA-B4F90612DD14}"/>
+                <a16:creationId xmlns:a16="http://schemas.microsoft.com/office/drawing/2014/main" id="{213AE853-BEF8-4A90-87EF-62BB4F7ED1F2}"/>
               </a:ext>
             </a:extLst>
           </p:cNvPr>
@@ -6799,7 +6683,7 @@
           <p:cNvPr id="19" name="">
             <a:extLst xmlns:a="http://schemas.openxmlformats.org/drawingml/2006/main">
               <a:ext uri="{FF2B5EF4-FFF2-40B4-BE49-F238E27FC236}">
-                <a16:creationId xmlns:a16="http://schemas.microsoft.com/office/drawing/2014/main" id="{DE8B9931-788F-425D-8D4B-83B5BC2167DA}"/>
+                <a16:creationId xmlns:a16="http://schemas.microsoft.com/office/drawing/2014/main" id="{4A1BA7F2-EFF1-4773-BD20-A0C7A5EF60C1}"/>
               </a:ext>
             </a:extLst>
           </p:cNvPr>
@@ -6832,7 +6716,7 @@
           <p:cNvPr id="20" name="">
             <a:extLst xmlns:a="http://schemas.openxmlformats.org/drawingml/2006/main">
               <a:ext uri="{FF2B5EF4-FFF2-40B4-BE49-F238E27FC236}">
-                <a16:creationId xmlns:a16="http://schemas.microsoft.com/office/drawing/2014/main" id="{CAD07384-0548-489F-8F03-1808A75A0882}"/>
+                <a16:creationId xmlns:a16="http://schemas.microsoft.com/office/drawing/2014/main" id="{8EDB372D-F998-4D24-B530-3B7AE82EB47F}"/>
               </a:ext>
             </a:extLst>
           </p:cNvPr>
@@ -6890,7 +6774,7 @@
           <p:cNvPr id="21" name="">
             <a:extLst xmlns:a="http://schemas.openxmlformats.org/drawingml/2006/main">
               <a:ext uri="{FF2B5EF4-FFF2-40B4-BE49-F238E27FC236}">
-                <a16:creationId xmlns:a16="http://schemas.microsoft.com/office/drawing/2014/main" id="{B77DE799-1EF8-4ADA-9282-59528F257143}"/>
+                <a16:creationId xmlns:a16="http://schemas.microsoft.com/office/drawing/2014/main" id="{362683B2-5554-4DC2-805C-F6F39D304593}"/>
               </a:ext>
             </a:extLst>
           </p:cNvPr>
@@ -6948,7 +6832,7 @@
           <p:cNvPr id="22" name="">
             <a:extLst xmlns:a="http://schemas.openxmlformats.org/drawingml/2006/main">
               <a:ext uri="{FF2B5EF4-FFF2-40B4-BE49-F238E27FC236}">
-                <a16:creationId xmlns:a16="http://schemas.microsoft.com/office/drawing/2014/main" id="{DAA67374-DBEE-42E1-9608-881070C58FB7}"/>
+                <a16:creationId xmlns:a16="http://schemas.microsoft.com/office/drawing/2014/main" id="{BA5E1028-2CDA-43F9-8521-ACD281EA612A}"/>
               </a:ext>
             </a:extLst>
           </p:cNvPr>
@@ -7006,7 +6890,7 @@
           <p:cNvPr id="23" name="">
             <a:extLst xmlns:a="http://schemas.openxmlformats.org/drawingml/2006/main">
               <a:ext uri="{FF2B5EF4-FFF2-40B4-BE49-F238E27FC236}">
-                <a16:creationId xmlns:a16="http://schemas.microsoft.com/office/drawing/2014/main" id="{0610C4E4-89E4-4D13-B108-5272E9E4E32E}"/>
+                <a16:creationId xmlns:a16="http://schemas.microsoft.com/office/drawing/2014/main" id="{A1E8DE04-040D-45F1-88D6-4978E36EAD91}"/>
               </a:ext>
             </a:extLst>
           </p:cNvPr>
@@ -7039,7 +6923,7 @@
           <p:cNvPr id="24" name="">
             <a:extLst xmlns:a="http://schemas.openxmlformats.org/drawingml/2006/main">
               <a:ext uri="{FF2B5EF4-FFF2-40B4-BE49-F238E27FC236}">
-                <a16:creationId xmlns:a16="http://schemas.microsoft.com/office/drawing/2014/main" id="{EB1557D0-9D75-440E-9F83-AF35BAD05D68}"/>
+                <a16:creationId xmlns:a16="http://schemas.microsoft.com/office/drawing/2014/main" id="{32DA7544-B06B-451D-8A9D-CD014419E4BE}"/>
               </a:ext>
             </a:extLst>
           </p:cNvPr>
@@ -7097,7 +6981,7 @@
           <p:cNvPr id="25" name="">
             <a:extLst xmlns:a="http://schemas.openxmlformats.org/drawingml/2006/main">
               <a:ext uri="{FF2B5EF4-FFF2-40B4-BE49-F238E27FC236}">
-                <a16:creationId xmlns:a16="http://schemas.microsoft.com/office/drawing/2014/main" id="{FD76D413-3275-4DA3-A6C3-480CCCE2ED08}"/>
+                <a16:creationId xmlns:a16="http://schemas.microsoft.com/office/drawing/2014/main" id="{4D5BF6C0-B395-446B-A0CB-390D2AD63F40}"/>
               </a:ext>
             </a:extLst>
           </p:cNvPr>
@@ -7155,7 +7039,7 @@
           <p:cNvPr id="26" name="">
             <a:extLst xmlns:a="http://schemas.openxmlformats.org/drawingml/2006/main">
               <a:ext uri="{FF2B5EF4-FFF2-40B4-BE49-F238E27FC236}">
-                <a16:creationId xmlns:a16="http://schemas.microsoft.com/office/drawing/2014/main" id="{1282039E-9247-42E1-8B7F-6C0E03DA2B11}"/>
+                <a16:creationId xmlns:a16="http://schemas.microsoft.com/office/drawing/2014/main" id="{1D4BEB4A-126B-4AC2-A517-2BF6E1411E22}"/>
               </a:ext>
             </a:extLst>
           </p:cNvPr>
@@ -7213,7 +7097,7 @@
           <p:cNvPr id="27" name="">
             <a:extLst xmlns:a="http://schemas.openxmlformats.org/drawingml/2006/main">
               <a:ext uri="{FF2B5EF4-FFF2-40B4-BE49-F238E27FC236}">
-                <a16:creationId xmlns:a16="http://schemas.microsoft.com/office/drawing/2014/main" id="{AFAA961E-34FF-4851-A27D-39E29FBD8A9F}"/>
+                <a16:creationId xmlns:a16="http://schemas.microsoft.com/office/drawing/2014/main" id="{059F9114-AD2D-4C92-9ACB-1B781E4D3A68}"/>
               </a:ext>
             </a:extLst>
           </p:cNvPr>
@@ -7246,7 +7130,7 @@
           <p:cNvPr id="28" name="">
             <a:extLst xmlns:a="http://schemas.openxmlformats.org/drawingml/2006/main">
               <a:ext uri="{FF2B5EF4-FFF2-40B4-BE49-F238E27FC236}">
-                <a16:creationId xmlns:a16="http://schemas.microsoft.com/office/drawing/2014/main" id="{6FD8BF38-AB7C-4F34-A188-4772585E61DF}"/>
+                <a16:creationId xmlns:a16="http://schemas.microsoft.com/office/drawing/2014/main" id="{A8871EB0-F1D1-4E5D-B78A-5312CCE07BDD}"/>
               </a:ext>
             </a:extLst>
           </p:cNvPr>
@@ -7304,7 +7188,7 @@
           <p:cNvPr id="29" name="">
             <a:extLst xmlns:a="http://schemas.openxmlformats.org/drawingml/2006/main">
               <a:ext uri="{FF2B5EF4-FFF2-40B4-BE49-F238E27FC236}">
-                <a16:creationId xmlns:a16="http://schemas.microsoft.com/office/drawing/2014/main" id="{762B32F7-029C-47C4-9908-CDDB0BBDFF06}"/>
+                <a16:creationId xmlns:a16="http://schemas.microsoft.com/office/drawing/2014/main" id="{DBB0CA62-815D-4539-9C51-2DC4EE67ACB6}"/>
               </a:ext>
             </a:extLst>
           </p:cNvPr>
@@ -7362,7 +7246,7 @@
           <p:cNvPr id="30" name="">
             <a:extLst xmlns:a="http://schemas.openxmlformats.org/drawingml/2006/main">
               <a:ext uri="{FF2B5EF4-FFF2-40B4-BE49-F238E27FC236}">
-                <a16:creationId xmlns:a16="http://schemas.microsoft.com/office/drawing/2014/main" id="{CE742687-7808-4E35-ABE5-E298740861BD}"/>
+                <a16:creationId xmlns:a16="http://schemas.microsoft.com/office/drawing/2014/main" id="{54C1C0F2-21B6-4F31-B521-14C2D11B0FC3}"/>
               </a:ext>
             </a:extLst>
           </p:cNvPr>
@@ -7420,7 +7304,7 @@
           <p:cNvPr id="31" name="">
             <a:extLst xmlns:a="http://schemas.openxmlformats.org/drawingml/2006/main">
               <a:ext uri="{FF2B5EF4-FFF2-40B4-BE49-F238E27FC236}">
-                <a16:creationId xmlns:a16="http://schemas.microsoft.com/office/drawing/2014/main" id="{814EA06F-7EBE-4240-B7A5-0E403049D78B}"/>
+                <a16:creationId xmlns:a16="http://schemas.microsoft.com/office/drawing/2014/main" id="{0E26FF9A-A29E-4ECC-A59D-A05DC80A900D}"/>
               </a:ext>
             </a:extLst>
           </p:cNvPr>
@@ -7453,7 +7337,7 @@
           <p:cNvPr id="32" name="">
             <a:extLst xmlns:a="http://schemas.openxmlformats.org/drawingml/2006/main">
               <a:ext uri="{FF2B5EF4-FFF2-40B4-BE49-F238E27FC236}">
-                <a16:creationId xmlns:a16="http://schemas.microsoft.com/office/drawing/2014/main" id="{45AC1C30-A9D3-4BE5-B45B-A8778AAA151B}"/>
+                <a16:creationId xmlns:a16="http://schemas.microsoft.com/office/drawing/2014/main" id="{52BE7D65-C37B-492B-AE78-21D0C1C055BE}"/>
               </a:ext>
             </a:extLst>
           </p:cNvPr>
@@ -7511,7 +7395,7 @@
           <p:cNvPr id="33" name="">
             <a:extLst xmlns:a="http://schemas.openxmlformats.org/drawingml/2006/main">
               <a:ext uri="{FF2B5EF4-FFF2-40B4-BE49-F238E27FC236}">
-                <a16:creationId xmlns:a16="http://schemas.microsoft.com/office/drawing/2014/main" id="{CB8D7A2A-840D-4DF3-B07F-50A85CD38D20}"/>
+                <a16:creationId xmlns:a16="http://schemas.microsoft.com/office/drawing/2014/main" id="{4B97EBDA-8DA6-472F-B6CC-7EA758E4E43C}"/>
               </a:ext>
             </a:extLst>
           </p:cNvPr>
@@ -7569,7 +7453,7 @@
           <p:cNvPr id="34" name="">
             <a:extLst xmlns:a="http://schemas.openxmlformats.org/drawingml/2006/main">
               <a:ext uri="{FF2B5EF4-FFF2-40B4-BE49-F238E27FC236}">
-                <a16:creationId xmlns:a16="http://schemas.microsoft.com/office/drawing/2014/main" id="{EE8F60F8-8B90-4454-95A4-8205EE6BC092}"/>
+                <a16:creationId xmlns:a16="http://schemas.microsoft.com/office/drawing/2014/main" id="{D62D33BD-2B10-4FBE-83AD-217176D544C9}"/>
               </a:ext>
             </a:extLst>
           </p:cNvPr>
@@ -7627,7 +7511,7 @@
           <p:cNvPr id="35" name="">
             <a:extLst xmlns:a="http://schemas.openxmlformats.org/drawingml/2006/main">
               <a:ext uri="{FF2B5EF4-FFF2-40B4-BE49-F238E27FC236}">
-                <a16:creationId xmlns:a16="http://schemas.microsoft.com/office/drawing/2014/main" id="{7544E251-D6B3-43CD-A363-D3E6E4B7E06E}"/>
+                <a16:creationId xmlns:a16="http://schemas.microsoft.com/office/drawing/2014/main" id="{9D580103-00F6-4099-A98C-DBC08D2E15EB}"/>
               </a:ext>
             </a:extLst>
           </p:cNvPr>
@@ -7660,7 +7544,7 @@
           <p:cNvPr id="36" name="">
             <a:extLst xmlns:a="http://schemas.openxmlformats.org/drawingml/2006/main">
               <a:ext uri="{FF2B5EF4-FFF2-40B4-BE49-F238E27FC236}">
-                <a16:creationId xmlns:a16="http://schemas.microsoft.com/office/drawing/2014/main" id="{886472C4-A6DB-4378-B67C-104B943900C0}"/>
+                <a16:creationId xmlns:a16="http://schemas.microsoft.com/office/drawing/2014/main" id="{AE726626-823C-4362-A4DF-CF673D868D0B}"/>
               </a:ext>
             </a:extLst>
           </p:cNvPr>
@@ -7718,7 +7602,7 @@
           <p:cNvPr id="37" name="">
             <a:extLst xmlns:a="http://schemas.openxmlformats.org/drawingml/2006/main">
               <a:ext uri="{FF2B5EF4-FFF2-40B4-BE49-F238E27FC236}">
-                <a16:creationId xmlns:a16="http://schemas.microsoft.com/office/drawing/2014/main" id="{9FFA927D-9D01-4DBC-97FE-CB4A56222053}"/>
+                <a16:creationId xmlns:a16="http://schemas.microsoft.com/office/drawing/2014/main" id="{1727EC70-F149-466B-B9E8-8277FD18AB8A}"/>
               </a:ext>
             </a:extLst>
           </p:cNvPr>
@@ -7776,7 +7660,7 @@
           <p:cNvPr id="38" name="">
             <a:extLst xmlns:a="http://schemas.openxmlformats.org/drawingml/2006/main">
               <a:ext uri="{FF2B5EF4-FFF2-40B4-BE49-F238E27FC236}">
-                <a16:creationId xmlns:a16="http://schemas.microsoft.com/office/drawing/2014/main" id="{E8ECD6AD-DF55-4DB9-B7D3-2EDE05A1C62E}"/>
+                <a16:creationId xmlns:a16="http://schemas.microsoft.com/office/drawing/2014/main" id="{82A7E9EB-44BB-4756-9952-A2A2EF53471B}"/>
               </a:ext>
             </a:extLst>
           </p:cNvPr>
@@ -7834,7 +7718,7 @@
           <p:cNvPr id="39" name="">
             <a:extLst xmlns:a="http://schemas.openxmlformats.org/drawingml/2006/main">
               <a:ext uri="{FF2B5EF4-FFF2-40B4-BE49-F238E27FC236}">
-                <a16:creationId xmlns:a16="http://schemas.microsoft.com/office/drawing/2014/main" id="{BB18FF7F-AA02-423C-A20B-1AA8F07C030B}"/>
+                <a16:creationId xmlns:a16="http://schemas.microsoft.com/office/drawing/2014/main" id="{C61E8276-C2C4-4780-8039-124F5438B088}"/>
               </a:ext>
             </a:extLst>
           </p:cNvPr>
@@ -7867,7 +7751,7 @@
           <p:cNvPr id="40" name="">
             <a:extLst xmlns:a="http://schemas.openxmlformats.org/drawingml/2006/main">
               <a:ext uri="{FF2B5EF4-FFF2-40B4-BE49-F238E27FC236}">
-                <a16:creationId xmlns:a16="http://schemas.microsoft.com/office/drawing/2014/main" id="{E2BABE59-ACD5-427A-9E70-9EE6CF96930C}"/>
+                <a16:creationId xmlns:a16="http://schemas.microsoft.com/office/drawing/2014/main" id="{27AAEACD-DE54-4A49-8D3B-546A38AFC2C0}"/>
               </a:ext>
             </a:extLst>
           </p:cNvPr>
@@ -7925,7 +7809,7 @@
           <p:cNvPr id="41" name="">
             <a:extLst xmlns:a="http://schemas.openxmlformats.org/drawingml/2006/main">
               <a:ext uri="{FF2B5EF4-FFF2-40B4-BE49-F238E27FC236}">
-                <a16:creationId xmlns:a16="http://schemas.microsoft.com/office/drawing/2014/main" id="{5E8E2AC0-BED7-469F-AE13-CB4A8A59C9FB}"/>
+                <a16:creationId xmlns:a16="http://schemas.microsoft.com/office/drawing/2014/main" id="{884AE589-2D73-447C-979B-F7BB3A3A51B9}"/>
               </a:ext>
             </a:extLst>
           </p:cNvPr>
@@ -7983,7 +7867,7 @@
           <p:cNvPr id="42" name="">
             <a:extLst xmlns:a="http://schemas.openxmlformats.org/drawingml/2006/main">
               <a:ext uri="{FF2B5EF4-FFF2-40B4-BE49-F238E27FC236}">
-                <a16:creationId xmlns:a16="http://schemas.microsoft.com/office/drawing/2014/main" id="{1BE9BD20-1615-42B2-8839-709F291438CA}"/>
+                <a16:creationId xmlns:a16="http://schemas.microsoft.com/office/drawing/2014/main" id="{F82C7011-4DD2-4633-AA79-003590F50BF8}"/>
               </a:ext>
             </a:extLst>
           </p:cNvPr>
@@ -8041,7 +7925,7 @@
           <p:cNvPr id="43" name="">
             <a:extLst xmlns:a="http://schemas.openxmlformats.org/drawingml/2006/main">
               <a:ext uri="{FF2B5EF4-FFF2-40B4-BE49-F238E27FC236}">
-                <a16:creationId xmlns:a16="http://schemas.microsoft.com/office/drawing/2014/main" id="{77406B22-02D6-4E1A-83F6-5DE2CD9BCE71}"/>
+                <a16:creationId xmlns:a16="http://schemas.microsoft.com/office/drawing/2014/main" id="{BFA12C8E-6C14-4EBC-8BB9-BECE3A578BEC}"/>
               </a:ext>
             </a:extLst>
           </p:cNvPr>
@@ -8072,7 +7956,7 @@
           <p:cNvPr id="44" name="">
             <a:extLst xmlns:a="http://schemas.openxmlformats.org/drawingml/2006/main">
               <a:ext uri="{FF2B5EF4-FFF2-40B4-BE49-F238E27FC236}">
-                <a16:creationId xmlns:a16="http://schemas.microsoft.com/office/drawing/2014/main" id="{2FCB5BCC-464C-4951-9873-C4C01EA46015}"/>
+                <a16:creationId xmlns:a16="http://schemas.microsoft.com/office/drawing/2014/main" id="{BAF16DBE-AF0E-4239-9549-4C47282E4680}"/>
               </a:ext>
             </a:extLst>
           </p:cNvPr>
@@ -8130,7 +8014,7 @@
           <p:cNvPr id="45" name="">
             <a:extLst xmlns:a="http://schemas.openxmlformats.org/drawingml/2006/main">
               <a:ext uri="{FF2B5EF4-FFF2-40B4-BE49-F238E27FC236}">
-                <a16:creationId xmlns:a16="http://schemas.microsoft.com/office/drawing/2014/main" id="{A693DF3D-3AAB-4A35-8991-185295377983}"/>
+                <a16:creationId xmlns:a16="http://schemas.microsoft.com/office/drawing/2014/main" id="{CF83D383-44FE-4BC7-9479-BC3D1496200B}"/>
               </a:ext>
             </a:extLst>
           </p:cNvPr>
@@ -8179,64 +8063,6 @@
                 <a:cs typeface="Helvetica Neue"/>
               </a:rPr>
               <a:t>Value classes reached SGLang with zero mismatches, and native HiCache eviction events were observed.</a:t>
-            </a:r>
-          </a:p>
-        </p:txBody>
-      </p:sp>
-      <p:sp>
-        <p:nvSpPr>
-          <p:cNvPr id="46" name="">
-            <a:extLst xmlns:a="http://schemas.openxmlformats.org/drawingml/2006/main">
-              <a:ext uri="{FF2B5EF4-FFF2-40B4-BE49-F238E27FC236}">
-                <a16:creationId xmlns:a16="http://schemas.microsoft.com/office/drawing/2014/main" id="{5E6F8568-07F9-4366-B2AC-3790A3BFF37D}"/>
-              </a:ext>
-            </a:extLst>
-          </p:cNvPr>
-          <p:cNvSpPr>
-            <a:spLocks xmlns:a="http://schemas.openxmlformats.org/drawingml/2006/main" noGrp="1"/>
-          </p:cNvSpPr>
-          <p:nvPr/>
-        </p:nvSpPr>
-        <p:spPr>
-          <a:xfrm xmlns:a="http://schemas.openxmlformats.org/drawingml/2006/main">
-            <a:off x="552450" y="6419850"/>
-            <a:ext cx="4191000" cy="190500"/>
-          </a:xfrm>
-          <a:prstGeom xmlns:a="http://schemas.openxmlformats.org/drawingml/2006/main" prst="rect">
-            <a:avLst/>
-          </a:prstGeom>
-          <a:noFill xmlns:a="http://schemas.openxmlformats.org/drawingml/2006/main"/>
-          <a:ln xmlns:a="http://schemas.openxmlformats.org/drawingml/2006/main" w="0">
-            <a:noFill/>
-            <a:prstDash val="solid"/>
-          </a:ln>
-        </p:spPr>
-        <p:txBody>
-          <a:bodyPr xmlns:a="http://schemas.openxmlformats.org/drawingml/2006/main" anchor="t">
-            <a:noAutofit/>
-          </a:bodyPr>
-          <a:lstStyle xmlns:a="http://schemas.openxmlformats.org/drawingml/2006/main"/>
-          <a:p xmlns:a="http://schemas.openxmlformats.org/drawingml/2006/main">
-            <a:pPr algn="l">
-              <a:defRPr sz="900" b="0">
-                <a:solidFill>
-                  <a:srgbClr val="64748B"/>
-                </a:solidFill>
-                <a:latin typeface="Helvetica Neue"/>
-                <a:ea typeface="Helvetica Neue"/>
-                <a:cs typeface="Helvetica Neue"/>
-              </a:defRPr>
-            </a:pPr>
-            <a:r>
-              <a:rPr sz="900" b="0">
-                <a:solidFill>
-                  <a:srgbClr val="64748B"/>
-                </a:solidFill>
-                <a:latin typeface="Helvetica Neue"/>
-                <a:ea typeface="Helvetica Neue"/>
-                <a:cs typeface="Helvetica Neue"/>
-              </a:rPr>
-              <a:t>Source: Harness-Aware Scenario Tracker</a:t>
             </a:r>
           </a:p>
         </p:txBody>
@@ -8244,7 +8070,7 @@
     </p:spTree>
     <p:extLst>
       <p:ext uri="{BB962C8B-B14F-4D97-AF65-F5344CB8AC3E}">
-        <p14:creationId xmlns:p14="http://schemas.microsoft.com/office/powerpoint/2010/main" val="1227081678"/>
+        <p14:creationId xmlns:p14="http://schemas.microsoft.com/office/powerpoint/2010/main" val="1996609993"/>
       </p:ext>
     </p:extLst>
   </p:cSld>

</xml_diff>

<commit_message>
Add semantic metric colors to scenario deck
</commit_message>
<xml_diff>
--- a/presentation/harness_aware_scenario_results_master.pptx
+++ b/presentation/harness_aware_scenario_results_master.pptx
@@ -2,15 +2,15 @@
 <file path=ppt/presentation.xml><?xml version="1.0" encoding="utf-8"?>
 <p:presentation xmlns:p="http://schemas.openxmlformats.org/presentationml/2006/main">
   <p:sldMasterIdLst>
-    <p:sldMasterId xmlns:r="http://schemas.openxmlformats.org/officeDocument/2006/relationships" id="2147483648" r:id="Rd3430611585f41e0"/>
+    <p:sldMasterId xmlns:r="http://schemas.openxmlformats.org/officeDocument/2006/relationships" id="2147483648" r:id="Ra1db504f55eb4c31"/>
   </p:sldMasterIdLst>
   <p:notesMasterIdLst>
-    <p:notesMasterId xmlns:r="http://schemas.openxmlformats.org/officeDocument/2006/relationships" r:id="Rfc158a5a535e4f49"/>
+    <p:notesMasterId xmlns:r="http://schemas.openxmlformats.org/officeDocument/2006/relationships" r:id="Rcc61203fe8db4e01"/>
   </p:notesMasterIdLst>
   <p:sldIdLst>
-    <p:sldId xmlns:r="http://schemas.openxmlformats.org/officeDocument/2006/relationships" id="256" r:id="R502070d3edc84f4c"/>
-    <p:sldId xmlns:r="http://schemas.openxmlformats.org/officeDocument/2006/relationships" id="257" r:id="R2dc0e0d833f84dd4"/>
-    <p:sldId xmlns:r="http://schemas.openxmlformats.org/officeDocument/2006/relationships" id="258" r:id="R90dd9ea0edc94f2f"/>
+    <p:sldId xmlns:r="http://schemas.openxmlformats.org/officeDocument/2006/relationships" id="256" r:id="R1d73b7ad6b7a4f0c"/>
+    <p:sldId xmlns:r="http://schemas.openxmlformats.org/officeDocument/2006/relationships" id="257" r:id="R4d00ed3613d54671"/>
+    <p:sldId xmlns:r="http://schemas.openxmlformats.org/officeDocument/2006/relationships" id="258" r:id="R731de0f5a89a4790"/>
   </p:sldIdLst>
   <p:sldSz cx="12192000" cy="6858000"/>
   <p:notesSz cx="6858000" cy="9144000"/>
@@ -827,7 +827,7 @@
   </p:cSld>
   <p:clrMap bg1="lt1" tx1="dk1" bg2="lt2" tx2="dk2" accent1="accent1" accent2="accent2" accent3="accent3" accent4="accent4" accent5="accent5" accent6="accent6" hlink="hlink" folHlink="folHlink"/>
   <p:sldLayoutIdLst>
-    <p:sldLayoutId xmlns:r="http://schemas.openxmlformats.org/officeDocument/2006/relationships" id="2147483649" r:id="Rb7d4ae351270489b"/>
+    <p:sldLayoutId xmlns:r="http://schemas.openxmlformats.org/officeDocument/2006/relationships" id="2147483649" r:id="Rc2f7c7e734574f95"/>
   </p:sldLayoutIdLst>
   <p:txStyles>
     <p:titleStyle>
@@ -1378,7 +1378,7 @@
           <p:cNvPr id="42" name="">
             <a:extLst xmlns:a="http://schemas.openxmlformats.org/drawingml/2006/main">
               <a:ext uri="{FF2B5EF4-FFF2-40B4-BE49-F238E27FC236}">
-                <a16:creationId xmlns:a16="http://schemas.microsoft.com/office/drawing/2014/main" id="{8F4B2ECE-115D-4993-A3C4-BA1DEE4D6C5C}"/>
+                <a16:creationId xmlns:a16="http://schemas.microsoft.com/office/drawing/2014/main" id="{801EB77E-1566-49A4-9685-E72A6FF6D68E}"/>
               </a:ext>
             </a:extLst>
           </p:cNvPr>
@@ -1436,7 +1436,7 @@
           <p:cNvPr id="2" name="">
             <a:extLst xmlns:a="http://schemas.openxmlformats.org/drawingml/2006/main">
               <a:ext uri="{FF2B5EF4-FFF2-40B4-BE49-F238E27FC236}">
-                <a16:creationId xmlns:a16="http://schemas.microsoft.com/office/drawing/2014/main" id="{1D6C82F7-484A-45ED-901F-586F444AB848}"/>
+                <a16:creationId xmlns:a16="http://schemas.microsoft.com/office/drawing/2014/main" id="{EB6148C7-63A2-495D-BCCF-C07D285D24A5}"/>
               </a:ext>
             </a:extLst>
           </p:cNvPr>
@@ -1494,7 +1494,7 @@
           <p:cNvPr id="3" name="">
             <a:extLst xmlns:a="http://schemas.openxmlformats.org/drawingml/2006/main">
               <a:ext uri="{FF2B5EF4-FFF2-40B4-BE49-F238E27FC236}">
-                <a16:creationId xmlns:a16="http://schemas.microsoft.com/office/drawing/2014/main" id="{95459873-7E4C-4058-A1C6-1934B925FEAB}"/>
+                <a16:creationId xmlns:a16="http://schemas.microsoft.com/office/drawing/2014/main" id="{38368425-228A-4AD9-8D6C-E8ABD085EAF9}"/>
               </a:ext>
             </a:extLst>
           </p:cNvPr>
@@ -1552,7 +1552,7 @@
           <p:cNvPr id="4" name="">
             <a:extLst xmlns:a="http://schemas.openxmlformats.org/drawingml/2006/main">
               <a:ext uri="{FF2B5EF4-FFF2-40B4-BE49-F238E27FC236}">
-                <a16:creationId xmlns:a16="http://schemas.microsoft.com/office/drawing/2014/main" id="{469EB804-552C-42A9-9BBE-140D9197B9EE}"/>
+                <a16:creationId xmlns:a16="http://schemas.microsoft.com/office/drawing/2014/main" id="{6CFFC6C1-A16E-40E4-8DD1-DDAF37A72EFB}"/>
               </a:ext>
             </a:extLst>
           </p:cNvPr>
@@ -1583,7 +1583,7 @@
           <p:cNvPr id="5" name="">
             <a:extLst xmlns:a="http://schemas.openxmlformats.org/drawingml/2006/main">
               <a:ext uri="{FF2B5EF4-FFF2-40B4-BE49-F238E27FC236}">
-                <a16:creationId xmlns:a16="http://schemas.microsoft.com/office/drawing/2014/main" id="{0E9FB1D1-4F8E-45CA-95CF-5BF64B38BDDE}"/>
+                <a16:creationId xmlns:a16="http://schemas.microsoft.com/office/drawing/2014/main" id="{6D93678A-5656-4530-B35C-D21274BEEFF9}"/>
               </a:ext>
             </a:extLst>
           </p:cNvPr>
@@ -1641,7 +1641,7 @@
           <p:cNvPr id="6" name="">
             <a:extLst xmlns:a="http://schemas.openxmlformats.org/drawingml/2006/main">
               <a:ext uri="{FF2B5EF4-FFF2-40B4-BE49-F238E27FC236}">
-                <a16:creationId xmlns:a16="http://schemas.microsoft.com/office/drawing/2014/main" id="{84B7B279-32DD-475A-9DDD-7C9B57E89B02}"/>
+                <a16:creationId xmlns:a16="http://schemas.microsoft.com/office/drawing/2014/main" id="{82D49B1B-4CE7-455F-B682-84470D9593B9}"/>
               </a:ext>
             </a:extLst>
           </p:cNvPr>
@@ -1674,7 +1674,7 @@
           <p:cNvPr id="7" name="">
             <a:extLst xmlns:a="http://schemas.openxmlformats.org/drawingml/2006/main">
               <a:ext uri="{FF2B5EF4-FFF2-40B4-BE49-F238E27FC236}">
-                <a16:creationId xmlns:a16="http://schemas.microsoft.com/office/drawing/2014/main" id="{EEB52D7E-602F-4D94-A247-B1570BA1CB0E}"/>
+                <a16:creationId xmlns:a16="http://schemas.microsoft.com/office/drawing/2014/main" id="{1988A3AC-DE11-405D-BB01-D9C6722104C0}"/>
               </a:ext>
             </a:extLst>
           </p:cNvPr>
@@ -1732,7 +1732,7 @@
           <p:cNvPr id="8" name="">
             <a:extLst xmlns:a="http://schemas.openxmlformats.org/drawingml/2006/main">
               <a:ext uri="{FF2B5EF4-FFF2-40B4-BE49-F238E27FC236}">
-                <a16:creationId xmlns:a16="http://schemas.microsoft.com/office/drawing/2014/main" id="{BA253EBA-3329-40E6-9629-D4924F71288B}"/>
+                <a16:creationId xmlns:a16="http://schemas.microsoft.com/office/drawing/2014/main" id="{5C2ED572-7291-44DD-A49A-48713C4A523D}"/>
               </a:ext>
             </a:extLst>
           </p:cNvPr>
@@ -1765,7 +1765,7 @@
           <p:cNvPr id="9" name="">
             <a:extLst xmlns:a="http://schemas.openxmlformats.org/drawingml/2006/main">
               <a:ext uri="{FF2B5EF4-FFF2-40B4-BE49-F238E27FC236}">
-                <a16:creationId xmlns:a16="http://schemas.microsoft.com/office/drawing/2014/main" id="{54A7607E-E2A7-46B3-A252-5D40E8B7E0D8}"/>
+                <a16:creationId xmlns:a16="http://schemas.microsoft.com/office/drawing/2014/main" id="{CDFBC1A4-824B-4495-AC34-C522E494DDE5}"/>
               </a:ext>
             </a:extLst>
           </p:cNvPr>
@@ -1823,7 +1823,7 @@
           <p:cNvPr id="10" name="">
             <a:extLst xmlns:a="http://schemas.openxmlformats.org/drawingml/2006/main">
               <a:ext uri="{FF2B5EF4-FFF2-40B4-BE49-F238E27FC236}">
-                <a16:creationId xmlns:a16="http://schemas.microsoft.com/office/drawing/2014/main" id="{7DB83571-CD51-403C-87AA-E67756FB66D2}"/>
+                <a16:creationId xmlns:a16="http://schemas.microsoft.com/office/drawing/2014/main" id="{E51857F0-0691-4CE6-85C6-E2AD21899EB2}"/>
               </a:ext>
             </a:extLst>
           </p:cNvPr>
@@ -1856,7 +1856,7 @@
           <p:cNvPr id="11" name="">
             <a:extLst xmlns:a="http://schemas.openxmlformats.org/drawingml/2006/main">
               <a:ext uri="{FF2B5EF4-FFF2-40B4-BE49-F238E27FC236}">
-                <a16:creationId xmlns:a16="http://schemas.microsoft.com/office/drawing/2014/main" id="{61B2C6BE-FF5F-46D3-99B1-7879F29735A1}"/>
+                <a16:creationId xmlns:a16="http://schemas.microsoft.com/office/drawing/2014/main" id="{A30198A4-C24B-4064-BCEB-E4CC6145857D}"/>
               </a:ext>
             </a:extLst>
           </p:cNvPr>
@@ -1914,7 +1914,7 @@
           <p:cNvPr id="12" name="">
             <a:extLst xmlns:a="http://schemas.openxmlformats.org/drawingml/2006/main">
               <a:ext uri="{FF2B5EF4-FFF2-40B4-BE49-F238E27FC236}">
-                <a16:creationId xmlns:a16="http://schemas.microsoft.com/office/drawing/2014/main" id="{830230FF-999E-4312-9207-929B9AC776A6}"/>
+                <a16:creationId xmlns:a16="http://schemas.microsoft.com/office/drawing/2014/main" id="{016C033A-6DC6-4777-98C3-D2F00849887D}"/>
               </a:ext>
             </a:extLst>
           </p:cNvPr>
@@ -1947,7 +1947,7 @@
           <p:cNvPr id="13" name="">
             <a:extLst xmlns:a="http://schemas.openxmlformats.org/drawingml/2006/main">
               <a:ext uri="{FF2B5EF4-FFF2-40B4-BE49-F238E27FC236}">
-                <a16:creationId xmlns:a16="http://schemas.microsoft.com/office/drawing/2014/main" id="{C9ACC71A-94FA-4870-9F17-2F7D4D49DDED}"/>
+                <a16:creationId xmlns:a16="http://schemas.microsoft.com/office/drawing/2014/main" id="{A4FE9A18-1214-44C3-A95A-40FE532E3D50}"/>
               </a:ext>
             </a:extLst>
           </p:cNvPr>
@@ -2005,7 +2005,7 @@
           <p:cNvPr id="14" name="">
             <a:extLst xmlns:a="http://schemas.openxmlformats.org/drawingml/2006/main">
               <a:ext uri="{FF2B5EF4-FFF2-40B4-BE49-F238E27FC236}">
-                <a16:creationId xmlns:a16="http://schemas.microsoft.com/office/drawing/2014/main" id="{3C58996B-2D32-42E6-817E-27E64B22CD60}"/>
+                <a16:creationId xmlns:a16="http://schemas.microsoft.com/office/drawing/2014/main" id="{DAE09535-3119-4871-B249-11EDBC19B9E8}"/>
               </a:ext>
             </a:extLst>
           </p:cNvPr>
@@ -2038,7 +2038,7 @@
           <p:cNvPr id="15" name="">
             <a:extLst xmlns:a="http://schemas.openxmlformats.org/drawingml/2006/main">
               <a:ext uri="{FF2B5EF4-FFF2-40B4-BE49-F238E27FC236}">
-                <a16:creationId xmlns:a16="http://schemas.microsoft.com/office/drawing/2014/main" id="{B0844033-B973-45FA-AB91-7862B83B5B5D}"/>
+                <a16:creationId xmlns:a16="http://schemas.microsoft.com/office/drawing/2014/main" id="{4D8101FE-7DEF-4842-90D3-CEF5C1661227}"/>
               </a:ext>
             </a:extLst>
           </p:cNvPr>
@@ -2096,7 +2096,7 @@
           <p:cNvPr id="16" name="">
             <a:extLst xmlns:a="http://schemas.openxmlformats.org/drawingml/2006/main">
               <a:ext uri="{FF2B5EF4-FFF2-40B4-BE49-F238E27FC236}">
-                <a16:creationId xmlns:a16="http://schemas.microsoft.com/office/drawing/2014/main" id="{B72EC854-09FA-4117-851D-F3D343AEEEDD}"/>
+                <a16:creationId xmlns:a16="http://schemas.microsoft.com/office/drawing/2014/main" id="{1359DD1A-5771-47FF-BE57-E0A53E4B1724}"/>
               </a:ext>
             </a:extLst>
           </p:cNvPr>
@@ -2154,7 +2154,7 @@
           <p:cNvPr id="17" name="">
             <a:extLst xmlns:a="http://schemas.openxmlformats.org/drawingml/2006/main">
               <a:ext uri="{FF2B5EF4-FFF2-40B4-BE49-F238E27FC236}">
-                <a16:creationId xmlns:a16="http://schemas.microsoft.com/office/drawing/2014/main" id="{96D0166A-518C-4B27-8A3C-1D6D8095A634}"/>
+                <a16:creationId xmlns:a16="http://schemas.microsoft.com/office/drawing/2014/main" id="{E2A8B5D1-0D5F-48BE-8E3C-049C5D8DEF6A}"/>
               </a:ext>
             </a:extLst>
           </p:cNvPr>
@@ -2212,7 +2212,7 @@
           <p:cNvPr id="18" name="">
             <a:extLst xmlns:a="http://schemas.openxmlformats.org/drawingml/2006/main">
               <a:ext uri="{FF2B5EF4-FFF2-40B4-BE49-F238E27FC236}">
-                <a16:creationId xmlns:a16="http://schemas.microsoft.com/office/drawing/2014/main" id="{3ABB5872-AB11-4A52-BFE9-F9ADDF381D45}"/>
+                <a16:creationId xmlns:a16="http://schemas.microsoft.com/office/drawing/2014/main" id="{6C844DBD-E477-48B0-B88E-A977650AC04B}"/>
               </a:ext>
             </a:extLst>
           </p:cNvPr>
@@ -2270,7 +2270,7 @@
           <p:cNvPr id="19" name="">
             <a:extLst xmlns:a="http://schemas.openxmlformats.org/drawingml/2006/main">
               <a:ext uri="{FF2B5EF4-FFF2-40B4-BE49-F238E27FC236}">
-                <a16:creationId xmlns:a16="http://schemas.microsoft.com/office/drawing/2014/main" id="{DBBCE9A5-8E66-406D-97B2-32C0CC6FEE48}"/>
+                <a16:creationId xmlns:a16="http://schemas.microsoft.com/office/drawing/2014/main" id="{E2318A49-D7AC-427F-971B-15BA42C220B9}"/>
               </a:ext>
             </a:extLst>
           </p:cNvPr>
@@ -2288,7 +2288,7 @@
             <a:avLst/>
           </a:prstGeom>
           <a:solidFill xmlns:a="http://schemas.openxmlformats.org/drawingml/2006/main">
-            <a:srgbClr val="F8FAFC"/>
+            <a:srgbClr val="EEF7F1"/>
           </a:solidFill>
           <a:ln xmlns:a="http://schemas.openxmlformats.org/drawingml/2006/main" w="9525">
             <a:solidFill>
@@ -2303,7 +2303,7 @@
           <p:cNvPr id="20" name="">
             <a:extLst xmlns:a="http://schemas.openxmlformats.org/drawingml/2006/main">
               <a:ext uri="{FF2B5EF4-FFF2-40B4-BE49-F238E27FC236}">
-                <a16:creationId xmlns:a16="http://schemas.microsoft.com/office/drawing/2014/main" id="{438ECA5A-7A93-44C8-A21E-5A9C2F3A14AE}"/>
+                <a16:creationId xmlns:a16="http://schemas.microsoft.com/office/drawing/2014/main" id="{8C788D18-DE5C-4432-95CD-0C3C77A9F790}"/>
               </a:ext>
             </a:extLst>
           </p:cNvPr>
@@ -2361,7 +2361,7 @@
           <p:cNvPr id="21" name="">
             <a:extLst xmlns:a="http://schemas.openxmlformats.org/drawingml/2006/main">
               <a:ext uri="{FF2B5EF4-FFF2-40B4-BE49-F238E27FC236}">
-                <a16:creationId xmlns:a16="http://schemas.microsoft.com/office/drawing/2014/main" id="{B0F06B2A-0FD9-4EA5-A80B-9CF9F41F0193}"/>
+                <a16:creationId xmlns:a16="http://schemas.microsoft.com/office/drawing/2014/main" id="{3FF9124D-323C-420D-8105-187FB3286750}"/>
               </a:ext>
             </a:extLst>
           </p:cNvPr>
@@ -2419,7 +2419,7 @@
           <p:cNvPr id="22" name="">
             <a:extLst xmlns:a="http://schemas.openxmlformats.org/drawingml/2006/main">
               <a:ext uri="{FF2B5EF4-FFF2-40B4-BE49-F238E27FC236}">
-                <a16:creationId xmlns:a16="http://schemas.microsoft.com/office/drawing/2014/main" id="{2A278566-BC36-4653-B331-6C1991A56ED1}"/>
+                <a16:creationId xmlns:a16="http://schemas.microsoft.com/office/drawing/2014/main" id="{B8D15C29-9505-49ED-A37F-BFF7F3A5F95E}"/>
               </a:ext>
             </a:extLst>
           </p:cNvPr>
@@ -2477,7 +2477,7 @@
           <p:cNvPr id="23" name="">
             <a:extLst xmlns:a="http://schemas.openxmlformats.org/drawingml/2006/main">
               <a:ext uri="{FF2B5EF4-FFF2-40B4-BE49-F238E27FC236}">
-                <a16:creationId xmlns:a16="http://schemas.microsoft.com/office/drawing/2014/main" id="{51E1225A-9BF1-45FC-BA84-A3194B3BCD10}"/>
+                <a16:creationId xmlns:a16="http://schemas.microsoft.com/office/drawing/2014/main" id="{960ECA07-24A0-4A51-BBF3-D79F9CE2CCF8}"/>
               </a:ext>
             </a:extLst>
           </p:cNvPr>
@@ -2495,7 +2495,7 @@
             <a:avLst/>
           </a:prstGeom>
           <a:solidFill xmlns:a="http://schemas.openxmlformats.org/drawingml/2006/main">
-            <a:srgbClr val="F8FAFC"/>
+            <a:srgbClr val="EEF7F1"/>
           </a:solidFill>
           <a:ln xmlns:a="http://schemas.openxmlformats.org/drawingml/2006/main" w="9525">
             <a:solidFill>
@@ -2510,7 +2510,7 @@
           <p:cNvPr id="24" name="">
             <a:extLst xmlns:a="http://schemas.openxmlformats.org/drawingml/2006/main">
               <a:ext uri="{FF2B5EF4-FFF2-40B4-BE49-F238E27FC236}">
-                <a16:creationId xmlns:a16="http://schemas.microsoft.com/office/drawing/2014/main" id="{478478E7-C175-4E7F-ADD2-1F4DB7A2DCB8}"/>
+                <a16:creationId xmlns:a16="http://schemas.microsoft.com/office/drawing/2014/main" id="{895B3299-83CD-4D8A-BEA0-E443FD655104}"/>
               </a:ext>
             </a:extLst>
           </p:cNvPr>
@@ -2568,7 +2568,7 @@
           <p:cNvPr id="25" name="">
             <a:extLst xmlns:a="http://schemas.openxmlformats.org/drawingml/2006/main">
               <a:ext uri="{FF2B5EF4-FFF2-40B4-BE49-F238E27FC236}">
-                <a16:creationId xmlns:a16="http://schemas.microsoft.com/office/drawing/2014/main" id="{477F0875-C473-4A11-9FEE-ECC9405141E4}"/>
+                <a16:creationId xmlns:a16="http://schemas.microsoft.com/office/drawing/2014/main" id="{A0D70C18-4F5B-4C97-A11F-BC08E5329440}"/>
               </a:ext>
             </a:extLst>
           </p:cNvPr>
@@ -2626,7 +2626,7 @@
           <p:cNvPr id="26" name="">
             <a:extLst xmlns:a="http://schemas.openxmlformats.org/drawingml/2006/main">
               <a:ext uri="{FF2B5EF4-FFF2-40B4-BE49-F238E27FC236}">
-                <a16:creationId xmlns:a16="http://schemas.microsoft.com/office/drawing/2014/main" id="{3CE9ACA3-B7BB-4FF9-A191-F232037A14D3}"/>
+                <a16:creationId xmlns:a16="http://schemas.microsoft.com/office/drawing/2014/main" id="{941F5798-0097-4EAE-A5C2-0772884B500E}"/>
               </a:ext>
             </a:extLst>
           </p:cNvPr>
@@ -2684,7 +2684,7 @@
           <p:cNvPr id="27" name="">
             <a:extLst xmlns:a="http://schemas.openxmlformats.org/drawingml/2006/main">
               <a:ext uri="{FF2B5EF4-FFF2-40B4-BE49-F238E27FC236}">
-                <a16:creationId xmlns:a16="http://schemas.microsoft.com/office/drawing/2014/main" id="{51E64235-4F3A-4A22-B1E1-9D7D86C5103D}"/>
+                <a16:creationId xmlns:a16="http://schemas.microsoft.com/office/drawing/2014/main" id="{7C36E52E-AB72-477D-9BC0-E2B496ACDDCB}"/>
               </a:ext>
             </a:extLst>
           </p:cNvPr>
@@ -2702,7 +2702,7 @@
             <a:avLst/>
           </a:prstGeom>
           <a:solidFill xmlns:a="http://schemas.openxmlformats.org/drawingml/2006/main">
-            <a:srgbClr val="F8FAFC"/>
+            <a:srgbClr val="EEF7F1"/>
           </a:solidFill>
           <a:ln xmlns:a="http://schemas.openxmlformats.org/drawingml/2006/main" w="9525">
             <a:solidFill>
@@ -2717,7 +2717,7 @@
           <p:cNvPr id="28" name="">
             <a:extLst xmlns:a="http://schemas.openxmlformats.org/drawingml/2006/main">
               <a:ext uri="{FF2B5EF4-FFF2-40B4-BE49-F238E27FC236}">
-                <a16:creationId xmlns:a16="http://schemas.microsoft.com/office/drawing/2014/main" id="{0CDB006B-C022-4B4C-86C3-F0F2430A761E}"/>
+                <a16:creationId xmlns:a16="http://schemas.microsoft.com/office/drawing/2014/main" id="{34EECF94-00D1-47C1-B685-E0920EEB821F}"/>
               </a:ext>
             </a:extLst>
           </p:cNvPr>
@@ -2775,7 +2775,7 @@
           <p:cNvPr id="29" name="">
             <a:extLst xmlns:a="http://schemas.openxmlformats.org/drawingml/2006/main">
               <a:ext uri="{FF2B5EF4-FFF2-40B4-BE49-F238E27FC236}">
-                <a16:creationId xmlns:a16="http://schemas.microsoft.com/office/drawing/2014/main" id="{996AAD88-B06A-4EE3-8413-3749575E7472}"/>
+                <a16:creationId xmlns:a16="http://schemas.microsoft.com/office/drawing/2014/main" id="{7196E3B4-409E-4A92-A313-7C9459622750}"/>
               </a:ext>
             </a:extLst>
           </p:cNvPr>
@@ -2833,7 +2833,7 @@
           <p:cNvPr id="30" name="">
             <a:extLst xmlns:a="http://schemas.openxmlformats.org/drawingml/2006/main">
               <a:ext uri="{FF2B5EF4-FFF2-40B4-BE49-F238E27FC236}">
-                <a16:creationId xmlns:a16="http://schemas.microsoft.com/office/drawing/2014/main" id="{CB706888-A01A-40F3-AFA5-4C7B240F2C00}"/>
+                <a16:creationId xmlns:a16="http://schemas.microsoft.com/office/drawing/2014/main" id="{BA88E524-A9A2-40B0-8C9A-B57AC1A6889D}"/>
               </a:ext>
             </a:extLst>
           </p:cNvPr>
@@ -2891,7 +2891,7 @@
           <p:cNvPr id="31" name="">
             <a:extLst xmlns:a="http://schemas.openxmlformats.org/drawingml/2006/main">
               <a:ext uri="{FF2B5EF4-FFF2-40B4-BE49-F238E27FC236}">
-                <a16:creationId xmlns:a16="http://schemas.microsoft.com/office/drawing/2014/main" id="{C3D4BE72-C7DC-437E-B09C-A98C919ED5D8}"/>
+                <a16:creationId xmlns:a16="http://schemas.microsoft.com/office/drawing/2014/main" id="{9D656E4B-4142-45D1-BAA9-A0BC54693742}"/>
               </a:ext>
             </a:extLst>
           </p:cNvPr>
@@ -2909,7 +2909,7 @@
             <a:avLst/>
           </a:prstGeom>
           <a:solidFill xmlns:a="http://schemas.openxmlformats.org/drawingml/2006/main">
-            <a:srgbClr val="F8FAFC"/>
+            <a:srgbClr val="EEF7F1"/>
           </a:solidFill>
           <a:ln xmlns:a="http://schemas.openxmlformats.org/drawingml/2006/main" w="9525">
             <a:solidFill>
@@ -2924,7 +2924,7 @@
           <p:cNvPr id="32" name="">
             <a:extLst xmlns:a="http://schemas.openxmlformats.org/drawingml/2006/main">
               <a:ext uri="{FF2B5EF4-FFF2-40B4-BE49-F238E27FC236}">
-                <a16:creationId xmlns:a16="http://schemas.microsoft.com/office/drawing/2014/main" id="{2A663CEC-FB15-4647-95E3-F0C997B4CD1D}"/>
+                <a16:creationId xmlns:a16="http://schemas.microsoft.com/office/drawing/2014/main" id="{8DF10837-69FE-4D46-B845-62B3C8185744}"/>
               </a:ext>
             </a:extLst>
           </p:cNvPr>
@@ -2982,7 +2982,7 @@
           <p:cNvPr id="33" name="">
             <a:extLst xmlns:a="http://schemas.openxmlformats.org/drawingml/2006/main">
               <a:ext uri="{FF2B5EF4-FFF2-40B4-BE49-F238E27FC236}">
-                <a16:creationId xmlns:a16="http://schemas.microsoft.com/office/drawing/2014/main" id="{86ED39A9-0574-4F21-979C-F6CB5DEE38BE}"/>
+                <a16:creationId xmlns:a16="http://schemas.microsoft.com/office/drawing/2014/main" id="{B650DA0D-C0AB-4A18-8CF0-D65D5C9D7640}"/>
               </a:ext>
             </a:extLst>
           </p:cNvPr>
@@ -3040,7 +3040,7 @@
           <p:cNvPr id="34" name="">
             <a:extLst xmlns:a="http://schemas.openxmlformats.org/drawingml/2006/main">
               <a:ext uri="{FF2B5EF4-FFF2-40B4-BE49-F238E27FC236}">
-                <a16:creationId xmlns:a16="http://schemas.microsoft.com/office/drawing/2014/main" id="{7F43590F-0D16-4072-B5F9-A3798650783A}"/>
+                <a16:creationId xmlns:a16="http://schemas.microsoft.com/office/drawing/2014/main" id="{76D33D72-902B-48F7-B245-CE8216CA801C}"/>
               </a:ext>
             </a:extLst>
           </p:cNvPr>
@@ -3098,7 +3098,7 @@
           <p:cNvPr id="35" name="">
             <a:extLst xmlns:a="http://schemas.openxmlformats.org/drawingml/2006/main">
               <a:ext uri="{FF2B5EF4-FFF2-40B4-BE49-F238E27FC236}">
-                <a16:creationId xmlns:a16="http://schemas.microsoft.com/office/drawing/2014/main" id="{FE2C81DD-F2F1-4740-AF1F-A3AD3C3F90AC}"/>
+                <a16:creationId xmlns:a16="http://schemas.microsoft.com/office/drawing/2014/main" id="{8BBEBA62-D3A1-48EF-8BDB-6925681A54C6}"/>
               </a:ext>
             </a:extLst>
           </p:cNvPr>
@@ -3116,7 +3116,7 @@
             <a:avLst/>
           </a:prstGeom>
           <a:solidFill xmlns:a="http://schemas.openxmlformats.org/drawingml/2006/main">
-            <a:srgbClr val="F3F6FA"/>
+            <a:srgbClr val="FFF1F1"/>
           </a:solidFill>
           <a:ln xmlns:a="http://schemas.openxmlformats.org/drawingml/2006/main" w="9525">
             <a:solidFill>
@@ -3131,7 +3131,7 @@
           <p:cNvPr id="36" name="">
             <a:extLst xmlns:a="http://schemas.openxmlformats.org/drawingml/2006/main">
               <a:ext uri="{FF2B5EF4-FFF2-40B4-BE49-F238E27FC236}">
-                <a16:creationId xmlns:a16="http://schemas.microsoft.com/office/drawing/2014/main" id="{63BD16C4-D808-4777-85ED-F87F24B4F6A5}"/>
+                <a16:creationId xmlns:a16="http://schemas.microsoft.com/office/drawing/2014/main" id="{B40DF8CD-3532-46CE-9C13-70E85119708D}"/>
               </a:ext>
             </a:extLst>
           </p:cNvPr>
@@ -3189,7 +3189,7 @@
           <p:cNvPr id="37" name="">
             <a:extLst xmlns:a="http://schemas.openxmlformats.org/drawingml/2006/main">
               <a:ext uri="{FF2B5EF4-FFF2-40B4-BE49-F238E27FC236}">
-                <a16:creationId xmlns:a16="http://schemas.microsoft.com/office/drawing/2014/main" id="{62CEC689-E314-46AA-B20F-A66A10C4236C}"/>
+                <a16:creationId xmlns:a16="http://schemas.microsoft.com/office/drawing/2014/main" id="{2F397AB8-D9F5-47C5-8BF0-9D76FEEA0972}"/>
               </a:ext>
             </a:extLst>
           </p:cNvPr>
@@ -3221,7 +3221,7 @@
             <a:pPr algn="l">
               <a:defRPr sz="1725" b="1">
                 <a:solidFill>
-                  <a:srgbClr val="334155"/>
+                  <a:srgbClr val="7F1D1D"/>
                 </a:solidFill>
                 <a:latin typeface="Helvetica Neue"/>
                 <a:ea typeface="Helvetica Neue"/>
@@ -3231,7 +3231,7 @@
             <a:r>
               <a:rPr sz="1725" b="1">
                 <a:solidFill>
-                  <a:srgbClr val="334155"/>
+                  <a:srgbClr val="7F1D1D"/>
                 </a:solidFill>
                 <a:latin typeface="Helvetica Neue"/>
                 <a:ea typeface="Helvetica Neue"/>
@@ -3247,7 +3247,7 @@
           <p:cNvPr id="38" name="">
             <a:extLst xmlns:a="http://schemas.openxmlformats.org/drawingml/2006/main">
               <a:ext uri="{FF2B5EF4-FFF2-40B4-BE49-F238E27FC236}">
-                <a16:creationId xmlns:a16="http://schemas.microsoft.com/office/drawing/2014/main" id="{7CEBBADD-8404-4C1A-BE7E-A3F83CC6EB9A}"/>
+                <a16:creationId xmlns:a16="http://schemas.microsoft.com/office/drawing/2014/main" id="{DDC42009-7DF8-476B-A05D-8255ED0F89C6}"/>
               </a:ext>
             </a:extLst>
           </p:cNvPr>
@@ -3305,7 +3305,7 @@
           <p:cNvPr id="39" name="">
             <a:extLst xmlns:a="http://schemas.openxmlformats.org/drawingml/2006/main">
               <a:ext uri="{FF2B5EF4-FFF2-40B4-BE49-F238E27FC236}">
-                <a16:creationId xmlns:a16="http://schemas.microsoft.com/office/drawing/2014/main" id="{E60DBC8F-A793-4641-9955-AFD627D7464F}"/>
+                <a16:creationId xmlns:a16="http://schemas.microsoft.com/office/drawing/2014/main" id="{77F7AD42-6CA9-4E22-A5B1-84A4AC9F9A4D}"/>
               </a:ext>
             </a:extLst>
           </p:cNvPr>
@@ -3336,7 +3336,7 @@
           <p:cNvPr id="40" name="">
             <a:extLst xmlns:a="http://schemas.openxmlformats.org/drawingml/2006/main">
               <a:ext uri="{FF2B5EF4-FFF2-40B4-BE49-F238E27FC236}">
-                <a16:creationId xmlns:a16="http://schemas.microsoft.com/office/drawing/2014/main" id="{242389B1-3BEB-4656-9EE8-AC89BC49E3EB}"/>
+                <a16:creationId xmlns:a16="http://schemas.microsoft.com/office/drawing/2014/main" id="{AF63F025-7136-43F5-9BF2-0C8DD4F39169}"/>
               </a:ext>
             </a:extLst>
           </p:cNvPr>
@@ -3394,7 +3394,7 @@
           <p:cNvPr id="41" name="">
             <a:extLst xmlns:a="http://schemas.openxmlformats.org/drawingml/2006/main">
               <a:ext uri="{FF2B5EF4-FFF2-40B4-BE49-F238E27FC236}">
-                <a16:creationId xmlns:a16="http://schemas.microsoft.com/office/drawing/2014/main" id="{00926EB6-E7E8-4154-83FC-50E0194B7BC5}"/>
+                <a16:creationId xmlns:a16="http://schemas.microsoft.com/office/drawing/2014/main" id="{D0C47DE3-8475-41BB-81AC-161FE4528C71}"/>
               </a:ext>
             </a:extLst>
           </p:cNvPr>
@@ -3450,7 +3450,7 @@
     </p:spTree>
     <p:extLst>
       <p:ext uri="{BB962C8B-B14F-4D97-AF65-F5344CB8AC3E}">
-        <p14:creationId xmlns:p14="http://schemas.microsoft.com/office/powerpoint/2010/main" val="1030562307"/>
+        <p14:creationId xmlns:p14="http://schemas.microsoft.com/office/powerpoint/2010/main" val="1593947935"/>
       </p:ext>
     </p:extLst>
   </p:cSld>
@@ -3481,7 +3481,7 @@
           <p:cNvPr id="46" name="">
             <a:extLst xmlns:a="http://schemas.openxmlformats.org/drawingml/2006/main">
               <a:ext uri="{FF2B5EF4-FFF2-40B4-BE49-F238E27FC236}">
-                <a16:creationId xmlns:a16="http://schemas.microsoft.com/office/drawing/2014/main" id="{82E4480A-87B2-4E2F-8878-3A18A99A34BC}"/>
+                <a16:creationId xmlns:a16="http://schemas.microsoft.com/office/drawing/2014/main" id="{19BB3C98-5C5F-45A5-BAD3-7DBA14B7B9ED}"/>
               </a:ext>
             </a:extLst>
           </p:cNvPr>
@@ -3539,7 +3539,7 @@
           <p:cNvPr id="2" name="">
             <a:extLst xmlns:a="http://schemas.openxmlformats.org/drawingml/2006/main">
               <a:ext uri="{FF2B5EF4-FFF2-40B4-BE49-F238E27FC236}">
-                <a16:creationId xmlns:a16="http://schemas.microsoft.com/office/drawing/2014/main" id="{1C5AD24F-F87C-4735-A79F-C436BBF21D0D}"/>
+                <a16:creationId xmlns:a16="http://schemas.microsoft.com/office/drawing/2014/main" id="{560337DC-DB72-4C4F-9072-8FCA617FBEFB}"/>
               </a:ext>
             </a:extLst>
           </p:cNvPr>
@@ -3597,7 +3597,7 @@
           <p:cNvPr id="3" name="">
             <a:extLst xmlns:a="http://schemas.openxmlformats.org/drawingml/2006/main">
               <a:ext uri="{FF2B5EF4-FFF2-40B4-BE49-F238E27FC236}">
-                <a16:creationId xmlns:a16="http://schemas.microsoft.com/office/drawing/2014/main" id="{920DF99C-2C7B-4D77-B5C2-145D80145535}"/>
+                <a16:creationId xmlns:a16="http://schemas.microsoft.com/office/drawing/2014/main" id="{982BBC0A-46EF-44D0-85FD-A365B91BDD23}"/>
               </a:ext>
             </a:extLst>
           </p:cNvPr>
@@ -3655,7 +3655,7 @@
           <p:cNvPr id="4" name="">
             <a:extLst xmlns:a="http://schemas.openxmlformats.org/drawingml/2006/main">
               <a:ext uri="{FF2B5EF4-FFF2-40B4-BE49-F238E27FC236}">
-                <a16:creationId xmlns:a16="http://schemas.microsoft.com/office/drawing/2014/main" id="{85229626-C939-479B-92A5-D9D31E7D6303}"/>
+                <a16:creationId xmlns:a16="http://schemas.microsoft.com/office/drawing/2014/main" id="{46A068CB-94B0-4E1F-9C67-5F737EF486B9}"/>
               </a:ext>
             </a:extLst>
           </p:cNvPr>
@@ -3686,7 +3686,7 @@
           <p:cNvPr id="5" name="">
             <a:extLst xmlns:a="http://schemas.openxmlformats.org/drawingml/2006/main">
               <a:ext uri="{FF2B5EF4-FFF2-40B4-BE49-F238E27FC236}">
-                <a16:creationId xmlns:a16="http://schemas.microsoft.com/office/drawing/2014/main" id="{C3100907-53B3-4D6A-A458-B07DCD5F137C}"/>
+                <a16:creationId xmlns:a16="http://schemas.microsoft.com/office/drawing/2014/main" id="{4BA62652-7AC9-43C7-A566-5B0A4BAE0399}"/>
               </a:ext>
             </a:extLst>
           </p:cNvPr>
@@ -3744,7 +3744,7 @@
           <p:cNvPr id="6" name="">
             <a:extLst xmlns:a="http://schemas.openxmlformats.org/drawingml/2006/main">
               <a:ext uri="{FF2B5EF4-FFF2-40B4-BE49-F238E27FC236}">
-                <a16:creationId xmlns:a16="http://schemas.microsoft.com/office/drawing/2014/main" id="{229E30BC-8828-4DE3-9298-7A1FD44D2F4A}"/>
+                <a16:creationId xmlns:a16="http://schemas.microsoft.com/office/drawing/2014/main" id="{77CAD1F2-D9BA-4AD5-ACB8-41D9BFAE7184}"/>
               </a:ext>
             </a:extLst>
           </p:cNvPr>
@@ -3777,7 +3777,7 @@
           <p:cNvPr id="7" name="">
             <a:extLst xmlns:a="http://schemas.openxmlformats.org/drawingml/2006/main">
               <a:ext uri="{FF2B5EF4-FFF2-40B4-BE49-F238E27FC236}">
-                <a16:creationId xmlns:a16="http://schemas.microsoft.com/office/drawing/2014/main" id="{F36455BC-4E64-4054-ABC9-B1E6C0A9634A}"/>
+                <a16:creationId xmlns:a16="http://schemas.microsoft.com/office/drawing/2014/main" id="{1C92597F-E223-4C8F-A43E-45434F75D285}"/>
               </a:ext>
             </a:extLst>
           </p:cNvPr>
@@ -3835,7 +3835,7 @@
           <p:cNvPr id="8" name="">
             <a:extLst xmlns:a="http://schemas.openxmlformats.org/drawingml/2006/main">
               <a:ext uri="{FF2B5EF4-FFF2-40B4-BE49-F238E27FC236}">
-                <a16:creationId xmlns:a16="http://schemas.microsoft.com/office/drawing/2014/main" id="{F9F50004-5024-40E6-92A1-1A7B2A5D4156}"/>
+                <a16:creationId xmlns:a16="http://schemas.microsoft.com/office/drawing/2014/main" id="{02C3F006-7E0B-42CC-810A-7B43208FEA40}"/>
               </a:ext>
             </a:extLst>
           </p:cNvPr>
@@ -3868,7 +3868,7 @@
           <p:cNvPr id="9" name="">
             <a:extLst xmlns:a="http://schemas.openxmlformats.org/drawingml/2006/main">
               <a:ext uri="{FF2B5EF4-FFF2-40B4-BE49-F238E27FC236}">
-                <a16:creationId xmlns:a16="http://schemas.microsoft.com/office/drawing/2014/main" id="{2E0DAE7C-2B48-4C10-909E-9B5C3E533CBE}"/>
+                <a16:creationId xmlns:a16="http://schemas.microsoft.com/office/drawing/2014/main" id="{35C5E69F-F928-4A03-B907-8D59B91EA926}"/>
               </a:ext>
             </a:extLst>
           </p:cNvPr>
@@ -3926,7 +3926,7 @@
           <p:cNvPr id="10" name="">
             <a:extLst xmlns:a="http://schemas.openxmlformats.org/drawingml/2006/main">
               <a:ext uri="{FF2B5EF4-FFF2-40B4-BE49-F238E27FC236}">
-                <a16:creationId xmlns:a16="http://schemas.microsoft.com/office/drawing/2014/main" id="{FA84A3D0-0E1C-4685-B427-616DC8C553AA}"/>
+                <a16:creationId xmlns:a16="http://schemas.microsoft.com/office/drawing/2014/main" id="{F6B47E7A-2DEB-4BAB-9AC2-8233D5537175}"/>
               </a:ext>
             </a:extLst>
           </p:cNvPr>
@@ -3959,7 +3959,7 @@
           <p:cNvPr id="11" name="">
             <a:extLst xmlns:a="http://schemas.openxmlformats.org/drawingml/2006/main">
               <a:ext uri="{FF2B5EF4-FFF2-40B4-BE49-F238E27FC236}">
-                <a16:creationId xmlns:a16="http://schemas.microsoft.com/office/drawing/2014/main" id="{1D7E6DAF-0080-4121-98D6-2C7E6C38054E}"/>
+                <a16:creationId xmlns:a16="http://schemas.microsoft.com/office/drawing/2014/main" id="{A3D1CE0A-EC11-4822-8C7C-5B697C884CFE}"/>
               </a:ext>
             </a:extLst>
           </p:cNvPr>
@@ -4017,7 +4017,7 @@
           <p:cNvPr id="12" name="">
             <a:extLst xmlns:a="http://schemas.openxmlformats.org/drawingml/2006/main">
               <a:ext uri="{FF2B5EF4-FFF2-40B4-BE49-F238E27FC236}">
-                <a16:creationId xmlns:a16="http://schemas.microsoft.com/office/drawing/2014/main" id="{459A21C7-E6B9-4C18-A53A-E1B65B04BB8D}"/>
+                <a16:creationId xmlns:a16="http://schemas.microsoft.com/office/drawing/2014/main" id="{304358CB-1664-440C-B1EF-887456AF72BB}"/>
               </a:ext>
             </a:extLst>
           </p:cNvPr>
@@ -4050,7 +4050,7 @@
           <p:cNvPr id="13" name="">
             <a:extLst xmlns:a="http://schemas.openxmlformats.org/drawingml/2006/main">
               <a:ext uri="{FF2B5EF4-FFF2-40B4-BE49-F238E27FC236}">
-                <a16:creationId xmlns:a16="http://schemas.microsoft.com/office/drawing/2014/main" id="{932F6CB3-021B-4501-A172-28B0195BE06C}"/>
+                <a16:creationId xmlns:a16="http://schemas.microsoft.com/office/drawing/2014/main" id="{9AF3B1C8-1955-409B-9DE6-EE2196EAA725}"/>
               </a:ext>
             </a:extLst>
           </p:cNvPr>
@@ -4108,7 +4108,7 @@
           <p:cNvPr id="14" name="">
             <a:extLst xmlns:a="http://schemas.openxmlformats.org/drawingml/2006/main">
               <a:ext uri="{FF2B5EF4-FFF2-40B4-BE49-F238E27FC236}">
-                <a16:creationId xmlns:a16="http://schemas.microsoft.com/office/drawing/2014/main" id="{36FCE11F-16C5-4D49-A9A4-DA406387ABD7}"/>
+                <a16:creationId xmlns:a16="http://schemas.microsoft.com/office/drawing/2014/main" id="{4BF3B9D9-CBB9-4E64-AE36-430B8B5807CC}"/>
               </a:ext>
             </a:extLst>
           </p:cNvPr>
@@ -4141,7 +4141,7 @@
           <p:cNvPr id="15" name="">
             <a:extLst xmlns:a="http://schemas.openxmlformats.org/drawingml/2006/main">
               <a:ext uri="{FF2B5EF4-FFF2-40B4-BE49-F238E27FC236}">
-                <a16:creationId xmlns:a16="http://schemas.microsoft.com/office/drawing/2014/main" id="{3F7046EF-783F-404A-BF13-8E630D56E2E9}"/>
+                <a16:creationId xmlns:a16="http://schemas.microsoft.com/office/drawing/2014/main" id="{55B60AEC-2392-497A-8F2A-E2406B58C534}"/>
               </a:ext>
             </a:extLst>
           </p:cNvPr>
@@ -4199,7 +4199,7 @@
           <p:cNvPr id="16" name="">
             <a:extLst xmlns:a="http://schemas.openxmlformats.org/drawingml/2006/main">
               <a:ext uri="{FF2B5EF4-FFF2-40B4-BE49-F238E27FC236}">
-                <a16:creationId xmlns:a16="http://schemas.microsoft.com/office/drawing/2014/main" id="{A910AD24-32DB-4AC0-A7C3-9F6F7D694FC6}"/>
+                <a16:creationId xmlns:a16="http://schemas.microsoft.com/office/drawing/2014/main" id="{E9471C54-3693-4807-978D-2CD92EB5805E}"/>
               </a:ext>
             </a:extLst>
           </p:cNvPr>
@@ -4257,7 +4257,7 @@
           <p:cNvPr id="17" name="">
             <a:extLst xmlns:a="http://schemas.openxmlformats.org/drawingml/2006/main">
               <a:ext uri="{FF2B5EF4-FFF2-40B4-BE49-F238E27FC236}">
-                <a16:creationId xmlns:a16="http://schemas.microsoft.com/office/drawing/2014/main" id="{FF4E7246-B99D-4165-B7A9-9E49BE00076B}"/>
+                <a16:creationId xmlns:a16="http://schemas.microsoft.com/office/drawing/2014/main" id="{A60112BF-D2A7-4D14-93C1-12E202CE668E}"/>
               </a:ext>
             </a:extLst>
           </p:cNvPr>
@@ -4315,7 +4315,7 @@
           <p:cNvPr id="18" name="">
             <a:extLst xmlns:a="http://schemas.openxmlformats.org/drawingml/2006/main">
               <a:ext uri="{FF2B5EF4-FFF2-40B4-BE49-F238E27FC236}">
-                <a16:creationId xmlns:a16="http://schemas.microsoft.com/office/drawing/2014/main" id="{D1A7667C-366F-40C5-9C60-13D5A3572D19}"/>
+                <a16:creationId xmlns:a16="http://schemas.microsoft.com/office/drawing/2014/main" id="{364B2094-6AED-4A54-A095-260FE00A2A09}"/>
               </a:ext>
             </a:extLst>
           </p:cNvPr>
@@ -4373,7 +4373,7 @@
           <p:cNvPr id="19" name="">
             <a:extLst xmlns:a="http://schemas.openxmlformats.org/drawingml/2006/main">
               <a:ext uri="{FF2B5EF4-FFF2-40B4-BE49-F238E27FC236}">
-                <a16:creationId xmlns:a16="http://schemas.microsoft.com/office/drawing/2014/main" id="{E4606827-F561-4750-BBC8-9AC23A797603}"/>
+                <a16:creationId xmlns:a16="http://schemas.microsoft.com/office/drawing/2014/main" id="{0E4855AB-8EEF-425D-9EAD-03105B9A5961}"/>
               </a:ext>
             </a:extLst>
           </p:cNvPr>
@@ -4391,7 +4391,7 @@
             <a:avLst/>
           </a:prstGeom>
           <a:solidFill xmlns:a="http://schemas.openxmlformats.org/drawingml/2006/main">
-            <a:srgbClr val="F8FAFC"/>
+            <a:srgbClr val="EEF7F1"/>
           </a:solidFill>
           <a:ln xmlns:a="http://schemas.openxmlformats.org/drawingml/2006/main" w="9525">
             <a:solidFill>
@@ -4406,7 +4406,7 @@
           <p:cNvPr id="20" name="">
             <a:extLst xmlns:a="http://schemas.openxmlformats.org/drawingml/2006/main">
               <a:ext uri="{FF2B5EF4-FFF2-40B4-BE49-F238E27FC236}">
-                <a16:creationId xmlns:a16="http://schemas.microsoft.com/office/drawing/2014/main" id="{105C80CE-BA01-4C99-B1B9-C26D20099028}"/>
+                <a16:creationId xmlns:a16="http://schemas.microsoft.com/office/drawing/2014/main" id="{CCF527A9-C14C-4577-922C-1ED45B8A6233}"/>
               </a:ext>
             </a:extLst>
           </p:cNvPr>
@@ -4464,7 +4464,7 @@
           <p:cNvPr id="21" name="">
             <a:extLst xmlns:a="http://schemas.openxmlformats.org/drawingml/2006/main">
               <a:ext uri="{FF2B5EF4-FFF2-40B4-BE49-F238E27FC236}">
-                <a16:creationId xmlns:a16="http://schemas.microsoft.com/office/drawing/2014/main" id="{C39A9229-AD60-492D-AE56-8CED28BD88D2}"/>
+                <a16:creationId xmlns:a16="http://schemas.microsoft.com/office/drawing/2014/main" id="{EBF9A284-C9A9-4E18-AE0A-80B86048D4C7}"/>
               </a:ext>
             </a:extLst>
           </p:cNvPr>
@@ -4522,7 +4522,7 @@
           <p:cNvPr id="22" name="">
             <a:extLst xmlns:a="http://schemas.openxmlformats.org/drawingml/2006/main">
               <a:ext uri="{FF2B5EF4-FFF2-40B4-BE49-F238E27FC236}">
-                <a16:creationId xmlns:a16="http://schemas.microsoft.com/office/drawing/2014/main" id="{B67F5F1F-E580-4473-968B-A890D6D82188}"/>
+                <a16:creationId xmlns:a16="http://schemas.microsoft.com/office/drawing/2014/main" id="{1BCF3D38-5829-4DAF-BD58-0BB5CC18ACCA}"/>
               </a:ext>
             </a:extLst>
           </p:cNvPr>
@@ -4580,7 +4580,7 @@
           <p:cNvPr id="23" name="">
             <a:extLst xmlns:a="http://schemas.openxmlformats.org/drawingml/2006/main">
               <a:ext uri="{FF2B5EF4-FFF2-40B4-BE49-F238E27FC236}">
-                <a16:creationId xmlns:a16="http://schemas.microsoft.com/office/drawing/2014/main" id="{8F56C1A4-FA38-4CFC-98B6-610F5D4E0FA4}"/>
+                <a16:creationId xmlns:a16="http://schemas.microsoft.com/office/drawing/2014/main" id="{86EF24C9-3233-4747-BD08-881E641B8C77}"/>
               </a:ext>
             </a:extLst>
           </p:cNvPr>
@@ -4598,7 +4598,7 @@
             <a:avLst/>
           </a:prstGeom>
           <a:solidFill xmlns:a="http://schemas.openxmlformats.org/drawingml/2006/main">
-            <a:srgbClr val="F8FAFC"/>
+            <a:srgbClr val="EEF7F1"/>
           </a:solidFill>
           <a:ln xmlns:a="http://schemas.openxmlformats.org/drawingml/2006/main" w="9525">
             <a:solidFill>
@@ -4613,7 +4613,7 @@
           <p:cNvPr id="24" name="">
             <a:extLst xmlns:a="http://schemas.openxmlformats.org/drawingml/2006/main">
               <a:ext uri="{FF2B5EF4-FFF2-40B4-BE49-F238E27FC236}">
-                <a16:creationId xmlns:a16="http://schemas.microsoft.com/office/drawing/2014/main" id="{86F8D778-9B2D-457D-A5DA-6ACFEBF82820}"/>
+                <a16:creationId xmlns:a16="http://schemas.microsoft.com/office/drawing/2014/main" id="{A8CAF7DD-7837-4420-AC7E-FEC955DEEC89}"/>
               </a:ext>
             </a:extLst>
           </p:cNvPr>
@@ -4671,7 +4671,7 @@
           <p:cNvPr id="25" name="">
             <a:extLst xmlns:a="http://schemas.openxmlformats.org/drawingml/2006/main">
               <a:ext uri="{FF2B5EF4-FFF2-40B4-BE49-F238E27FC236}">
-                <a16:creationId xmlns:a16="http://schemas.microsoft.com/office/drawing/2014/main" id="{D17A01C4-B481-4139-B9C1-30109C6956AD}"/>
+                <a16:creationId xmlns:a16="http://schemas.microsoft.com/office/drawing/2014/main" id="{C14D484B-A785-4E2C-A8B7-EF70A51B125A}"/>
               </a:ext>
             </a:extLst>
           </p:cNvPr>
@@ -4729,7 +4729,7 @@
           <p:cNvPr id="26" name="">
             <a:extLst xmlns:a="http://schemas.openxmlformats.org/drawingml/2006/main">
               <a:ext uri="{FF2B5EF4-FFF2-40B4-BE49-F238E27FC236}">
-                <a16:creationId xmlns:a16="http://schemas.microsoft.com/office/drawing/2014/main" id="{EAB603A9-C948-4D07-B5DE-9E07BD1C0C03}"/>
+                <a16:creationId xmlns:a16="http://schemas.microsoft.com/office/drawing/2014/main" id="{A28AEA18-7D58-43F5-B883-AD37DA6E1600}"/>
               </a:ext>
             </a:extLst>
           </p:cNvPr>
@@ -4787,7 +4787,7 @@
           <p:cNvPr id="27" name="">
             <a:extLst xmlns:a="http://schemas.openxmlformats.org/drawingml/2006/main">
               <a:ext uri="{FF2B5EF4-FFF2-40B4-BE49-F238E27FC236}">
-                <a16:creationId xmlns:a16="http://schemas.microsoft.com/office/drawing/2014/main" id="{3189E6F0-30CE-4F0C-9BF7-AD6738F77B52}"/>
+                <a16:creationId xmlns:a16="http://schemas.microsoft.com/office/drawing/2014/main" id="{7DB18BFC-C386-4C04-AF09-2869B54D09C1}"/>
               </a:ext>
             </a:extLst>
           </p:cNvPr>
@@ -4805,7 +4805,7 @@
             <a:avLst/>
           </a:prstGeom>
           <a:solidFill xmlns:a="http://schemas.openxmlformats.org/drawingml/2006/main">
-            <a:srgbClr val="F8FAFC"/>
+            <a:srgbClr val="EEF7F1"/>
           </a:solidFill>
           <a:ln xmlns:a="http://schemas.openxmlformats.org/drawingml/2006/main" w="9525">
             <a:solidFill>
@@ -4820,7 +4820,7 @@
           <p:cNvPr id="28" name="">
             <a:extLst xmlns:a="http://schemas.openxmlformats.org/drawingml/2006/main">
               <a:ext uri="{FF2B5EF4-FFF2-40B4-BE49-F238E27FC236}">
-                <a16:creationId xmlns:a16="http://schemas.microsoft.com/office/drawing/2014/main" id="{9A5A80E3-1C9A-4E24-ACD0-CCF29035C563}"/>
+                <a16:creationId xmlns:a16="http://schemas.microsoft.com/office/drawing/2014/main" id="{FDC1E768-C904-4531-BE68-446246394B2A}"/>
               </a:ext>
             </a:extLst>
           </p:cNvPr>
@@ -4878,7 +4878,7 @@
           <p:cNvPr id="29" name="">
             <a:extLst xmlns:a="http://schemas.openxmlformats.org/drawingml/2006/main">
               <a:ext uri="{FF2B5EF4-FFF2-40B4-BE49-F238E27FC236}">
-                <a16:creationId xmlns:a16="http://schemas.microsoft.com/office/drawing/2014/main" id="{E888F9DE-A87A-46FF-BA2F-E96576C4CBF6}"/>
+                <a16:creationId xmlns:a16="http://schemas.microsoft.com/office/drawing/2014/main" id="{7C04CA44-556C-4D5C-AF6C-2A71FE7BCA29}"/>
               </a:ext>
             </a:extLst>
           </p:cNvPr>
@@ -4936,7 +4936,7 @@
           <p:cNvPr id="30" name="">
             <a:extLst xmlns:a="http://schemas.openxmlformats.org/drawingml/2006/main">
               <a:ext uri="{FF2B5EF4-FFF2-40B4-BE49-F238E27FC236}">
-                <a16:creationId xmlns:a16="http://schemas.microsoft.com/office/drawing/2014/main" id="{7EABB104-0C78-4F01-B972-C6650F7D57D7}"/>
+                <a16:creationId xmlns:a16="http://schemas.microsoft.com/office/drawing/2014/main" id="{B7CEB619-0A81-45E7-B44D-8AA3FF494027}"/>
               </a:ext>
             </a:extLst>
           </p:cNvPr>
@@ -4994,7 +4994,7 @@
           <p:cNvPr id="31" name="">
             <a:extLst xmlns:a="http://schemas.openxmlformats.org/drawingml/2006/main">
               <a:ext uri="{FF2B5EF4-FFF2-40B4-BE49-F238E27FC236}">
-                <a16:creationId xmlns:a16="http://schemas.microsoft.com/office/drawing/2014/main" id="{447D4768-5EE4-4277-8659-0C1BA9196C7A}"/>
+                <a16:creationId xmlns:a16="http://schemas.microsoft.com/office/drawing/2014/main" id="{26C89788-B437-49A5-A73F-1CF668491B37}"/>
               </a:ext>
             </a:extLst>
           </p:cNvPr>
@@ -5012,7 +5012,7 @@
             <a:avLst/>
           </a:prstGeom>
           <a:solidFill xmlns:a="http://schemas.openxmlformats.org/drawingml/2006/main">
-            <a:srgbClr val="F8FAFC"/>
+            <a:srgbClr val="EEF7F1"/>
           </a:solidFill>
           <a:ln xmlns:a="http://schemas.openxmlformats.org/drawingml/2006/main" w="9525">
             <a:solidFill>
@@ -5027,7 +5027,7 @@
           <p:cNvPr id="32" name="">
             <a:extLst xmlns:a="http://schemas.openxmlformats.org/drawingml/2006/main">
               <a:ext uri="{FF2B5EF4-FFF2-40B4-BE49-F238E27FC236}">
-                <a16:creationId xmlns:a16="http://schemas.microsoft.com/office/drawing/2014/main" id="{6B567F73-BE44-40B7-855A-94469D60698B}"/>
+                <a16:creationId xmlns:a16="http://schemas.microsoft.com/office/drawing/2014/main" id="{971E1CC9-A121-4C71-8E46-34B69F31FEB0}"/>
               </a:ext>
             </a:extLst>
           </p:cNvPr>
@@ -5085,7 +5085,7 @@
           <p:cNvPr id="33" name="">
             <a:extLst xmlns:a="http://schemas.openxmlformats.org/drawingml/2006/main">
               <a:ext uri="{FF2B5EF4-FFF2-40B4-BE49-F238E27FC236}">
-                <a16:creationId xmlns:a16="http://schemas.microsoft.com/office/drawing/2014/main" id="{7C216768-7EB0-4CFB-8C56-4B2D5AAA4F19}"/>
+                <a16:creationId xmlns:a16="http://schemas.microsoft.com/office/drawing/2014/main" id="{1930C303-2688-42C7-8FEB-7AF9C640BB39}"/>
               </a:ext>
             </a:extLst>
           </p:cNvPr>
@@ -5143,7 +5143,7 @@
           <p:cNvPr id="34" name="">
             <a:extLst xmlns:a="http://schemas.openxmlformats.org/drawingml/2006/main">
               <a:ext uri="{FF2B5EF4-FFF2-40B4-BE49-F238E27FC236}">
-                <a16:creationId xmlns:a16="http://schemas.microsoft.com/office/drawing/2014/main" id="{AF952594-74CA-4A86-990B-EE3A1AA51AC5}"/>
+                <a16:creationId xmlns:a16="http://schemas.microsoft.com/office/drawing/2014/main" id="{F585CE36-2C5E-41C0-AF5F-0CD84551EB79}"/>
               </a:ext>
             </a:extLst>
           </p:cNvPr>
@@ -5201,7 +5201,7 @@
           <p:cNvPr id="35" name="">
             <a:extLst xmlns:a="http://schemas.openxmlformats.org/drawingml/2006/main">
               <a:ext uri="{FF2B5EF4-FFF2-40B4-BE49-F238E27FC236}">
-                <a16:creationId xmlns:a16="http://schemas.microsoft.com/office/drawing/2014/main" id="{A94AAAD5-EA54-4BFA-9DB4-8506BB455419}"/>
+                <a16:creationId xmlns:a16="http://schemas.microsoft.com/office/drawing/2014/main" id="{62000B82-269B-4111-BC3B-D051B99E655B}"/>
               </a:ext>
             </a:extLst>
           </p:cNvPr>
@@ -5213,6 +5213,213 @@
         <p:spPr>
           <a:xfrm xmlns:a="http://schemas.openxmlformats.org/drawingml/2006/main">
             <a:off x="5619750" y="4191000"/>
+            <a:ext cx="2571750" cy="838200"/>
+          </a:xfrm>
+          <a:prstGeom xmlns:a="http://schemas.openxmlformats.org/drawingml/2006/main" prst="rect">
+            <a:avLst/>
+          </a:prstGeom>
+          <a:solidFill xmlns:a="http://schemas.openxmlformats.org/drawingml/2006/main">
+            <a:srgbClr val="FFF1F1"/>
+          </a:solidFill>
+          <a:ln xmlns:a="http://schemas.openxmlformats.org/drawingml/2006/main" w="9525">
+            <a:solidFill>
+              <a:srgbClr val="DBE4EF"/>
+            </a:solidFill>
+            <a:prstDash val="solid"/>
+          </a:ln>
+        </p:spPr>
+      </p:sp>
+      <p:sp>
+        <p:nvSpPr>
+          <p:cNvPr id="36" name="">
+            <a:extLst xmlns:a="http://schemas.openxmlformats.org/drawingml/2006/main">
+              <a:ext uri="{FF2B5EF4-FFF2-40B4-BE49-F238E27FC236}">
+                <a16:creationId xmlns:a16="http://schemas.microsoft.com/office/drawing/2014/main" id="{4C810792-9F27-45B5-8799-5A8048EC4002}"/>
+              </a:ext>
+            </a:extLst>
+          </p:cNvPr>
+          <p:cNvSpPr>
+            <a:spLocks xmlns:a="http://schemas.openxmlformats.org/drawingml/2006/main" noGrp="1"/>
+          </p:cNvSpPr>
+          <p:nvPr/>
+        </p:nvSpPr>
+        <p:spPr>
+          <a:xfrm xmlns:a="http://schemas.openxmlformats.org/drawingml/2006/main">
+            <a:off x="5772150" y="4305300"/>
+            <a:ext cx="2266950" cy="209550"/>
+          </a:xfrm>
+          <a:prstGeom xmlns:a="http://schemas.openxmlformats.org/drawingml/2006/main" prst="rect">
+            <a:avLst/>
+          </a:prstGeom>
+          <a:noFill xmlns:a="http://schemas.openxmlformats.org/drawingml/2006/main"/>
+          <a:ln xmlns:a="http://schemas.openxmlformats.org/drawingml/2006/main" w="0">
+            <a:noFill/>
+            <a:prstDash val="solid"/>
+          </a:ln>
+        </p:spPr>
+        <p:txBody>
+          <a:bodyPr xmlns:a="http://schemas.openxmlformats.org/drawingml/2006/main" anchor="t">
+            <a:noAutofit/>
+          </a:bodyPr>
+          <a:lstStyle xmlns:a="http://schemas.openxmlformats.org/drawingml/2006/main"/>
+          <a:p xmlns:a="http://schemas.openxmlformats.org/drawingml/2006/main">
+            <a:pPr algn="l">
+              <a:defRPr sz="1050" b="1">
+                <a:solidFill>
+                  <a:srgbClr val="64748B"/>
+                </a:solidFill>
+                <a:latin typeface="Helvetica Neue"/>
+                <a:ea typeface="Helvetica Neue"/>
+                <a:cs typeface="Helvetica Neue"/>
+              </a:defRPr>
+            </a:pPr>
+            <a:r>
+              <a:rPr sz="1050" b="1">
+                <a:solidFill>
+                  <a:srgbClr val="64748B"/>
+                </a:solidFill>
+                <a:latin typeface="Helvetica Neue"/>
+                <a:ea typeface="Helvetica Neue"/>
+                <a:cs typeface="Helvetica Neue"/>
+              </a:rPr>
+              <a:t>P95 lateness</a:t>
+            </a:r>
+          </a:p>
+        </p:txBody>
+      </p:sp>
+      <p:sp>
+        <p:nvSpPr>
+          <p:cNvPr id="37" name="">
+            <a:extLst xmlns:a="http://schemas.openxmlformats.org/drawingml/2006/main">
+              <a:ext uri="{FF2B5EF4-FFF2-40B4-BE49-F238E27FC236}">
+                <a16:creationId xmlns:a16="http://schemas.microsoft.com/office/drawing/2014/main" id="{CCE1CD41-DE2D-47C9-8D5C-AA4EEBB11A83}"/>
+              </a:ext>
+            </a:extLst>
+          </p:cNvPr>
+          <p:cNvSpPr>
+            <a:spLocks xmlns:a="http://schemas.openxmlformats.org/drawingml/2006/main" noGrp="1"/>
+          </p:cNvSpPr>
+          <p:nvPr/>
+        </p:nvSpPr>
+        <p:spPr>
+          <a:xfrm xmlns:a="http://schemas.openxmlformats.org/drawingml/2006/main">
+            <a:off x="5772150" y="4533900"/>
+            <a:ext cx="2266950" cy="266700"/>
+          </a:xfrm>
+          <a:prstGeom xmlns:a="http://schemas.openxmlformats.org/drawingml/2006/main" prst="rect">
+            <a:avLst/>
+          </a:prstGeom>
+          <a:noFill xmlns:a="http://schemas.openxmlformats.org/drawingml/2006/main"/>
+          <a:ln xmlns:a="http://schemas.openxmlformats.org/drawingml/2006/main" w="0">
+            <a:noFill/>
+            <a:prstDash val="solid"/>
+          </a:ln>
+        </p:spPr>
+        <p:txBody>
+          <a:bodyPr xmlns:a="http://schemas.openxmlformats.org/drawingml/2006/main" anchor="t">
+            <a:noAutofit/>
+          </a:bodyPr>
+          <a:lstStyle xmlns:a="http://schemas.openxmlformats.org/drawingml/2006/main"/>
+          <a:p xmlns:a="http://schemas.openxmlformats.org/drawingml/2006/main">
+            <a:pPr algn="l">
+              <a:defRPr sz="1725" b="1">
+                <a:solidFill>
+                  <a:srgbClr val="7F1D1D"/>
+                </a:solidFill>
+                <a:latin typeface="Helvetica Neue"/>
+                <a:ea typeface="Helvetica Neue"/>
+                <a:cs typeface="Helvetica Neue"/>
+              </a:defRPr>
+            </a:pPr>
+            <a:r>
+              <a:rPr sz="1725" b="1">
+                <a:solidFill>
+                  <a:srgbClr val="7F1D1D"/>
+                </a:solidFill>
+                <a:latin typeface="Helvetica Neue"/>
+                <a:ea typeface="Helvetica Neue"/>
+                <a:cs typeface="Helvetica Neue"/>
+              </a:rPr>
+              <a:t>0.1 s worse</a:t>
+            </a:r>
+          </a:p>
+        </p:txBody>
+      </p:sp>
+      <p:sp>
+        <p:nvSpPr>
+          <p:cNvPr id="38" name="">
+            <a:extLst xmlns:a="http://schemas.openxmlformats.org/drawingml/2006/main">
+              <a:ext uri="{FF2B5EF4-FFF2-40B4-BE49-F238E27FC236}">
+                <a16:creationId xmlns:a16="http://schemas.microsoft.com/office/drawing/2014/main" id="{C5968E8F-1C7C-428A-9462-CF353760BF23}"/>
+              </a:ext>
+            </a:extLst>
+          </p:cNvPr>
+          <p:cNvSpPr>
+            <a:spLocks xmlns:a="http://schemas.openxmlformats.org/drawingml/2006/main" noGrp="1"/>
+          </p:cNvSpPr>
+          <p:nvPr/>
+        </p:nvSpPr>
+        <p:spPr>
+          <a:xfrm xmlns:a="http://schemas.openxmlformats.org/drawingml/2006/main">
+            <a:off x="5772150" y="4819650"/>
+            <a:ext cx="2266950" cy="171450"/>
+          </a:xfrm>
+          <a:prstGeom xmlns:a="http://schemas.openxmlformats.org/drawingml/2006/main" prst="rect">
+            <a:avLst/>
+          </a:prstGeom>
+          <a:noFill xmlns:a="http://schemas.openxmlformats.org/drawingml/2006/main"/>
+          <a:ln xmlns:a="http://schemas.openxmlformats.org/drawingml/2006/main" w="0">
+            <a:noFill/>
+            <a:prstDash val="solid"/>
+          </a:ln>
+        </p:spPr>
+        <p:txBody>
+          <a:bodyPr xmlns:a="http://schemas.openxmlformats.org/drawingml/2006/main" anchor="t">
+            <a:noAutofit/>
+          </a:bodyPr>
+          <a:lstStyle xmlns:a="http://schemas.openxmlformats.org/drawingml/2006/main"/>
+          <a:p xmlns:a="http://schemas.openxmlformats.org/drawingml/2006/main">
+            <a:pPr algn="l">
+              <a:defRPr sz="938" b="0">
+                <a:solidFill>
+                  <a:srgbClr val="334155"/>
+                </a:solidFill>
+                <a:latin typeface="Helvetica Neue"/>
+                <a:ea typeface="Helvetica Neue"/>
+                <a:cs typeface="Helvetica Neue"/>
+              </a:defRPr>
+            </a:pPr>
+            <a:r>
+              <a:rPr sz="938" b="0">
+                <a:solidFill>
+                  <a:srgbClr val="334155"/>
+                </a:solidFill>
+                <a:latin typeface="Helvetica Neue"/>
+                <a:ea typeface="Helvetica Neue"/>
+                <a:cs typeface="Helvetica Neue"/>
+              </a:rPr>
+              <a:t>Roughly flat: 7.3 s to 7.4 s</a:t>
+            </a:r>
+          </a:p>
+        </p:txBody>
+      </p:sp>
+      <p:sp>
+        <p:nvSpPr>
+          <p:cNvPr id="39" name="">
+            <a:extLst xmlns:a="http://schemas.openxmlformats.org/drawingml/2006/main">
+              <a:ext uri="{FF2B5EF4-FFF2-40B4-BE49-F238E27FC236}">
+                <a16:creationId xmlns:a16="http://schemas.microsoft.com/office/drawing/2014/main" id="{FDA0BB84-58BB-4527-BF9C-15EEFDEE53FD}"/>
+              </a:ext>
+            </a:extLst>
+          </p:cNvPr>
+          <p:cNvSpPr>
+            <a:spLocks xmlns:a="http://schemas.openxmlformats.org/drawingml/2006/main" noGrp="1"/>
+          </p:cNvSpPr>
+          <p:nvPr/>
+        </p:nvSpPr>
+        <p:spPr>
+          <a:xfrm xmlns:a="http://schemas.openxmlformats.org/drawingml/2006/main">
+            <a:off x="8401050" y="4191000"/>
             <a:ext cx="2571750" cy="838200"/>
           </a:xfrm>
           <a:prstGeom xmlns:a="http://schemas.openxmlformats.org/drawingml/2006/main" prst="rect">
@@ -5231,217 +5438,10 @@
       </p:sp>
       <p:sp>
         <p:nvSpPr>
-          <p:cNvPr id="36" name="">
-            <a:extLst xmlns:a="http://schemas.openxmlformats.org/drawingml/2006/main">
-              <a:ext uri="{FF2B5EF4-FFF2-40B4-BE49-F238E27FC236}">
-                <a16:creationId xmlns:a16="http://schemas.microsoft.com/office/drawing/2014/main" id="{F7557246-4F5C-4AD7-BCC3-808BB19E11A7}"/>
-              </a:ext>
-            </a:extLst>
-          </p:cNvPr>
-          <p:cNvSpPr>
-            <a:spLocks xmlns:a="http://schemas.openxmlformats.org/drawingml/2006/main" noGrp="1"/>
-          </p:cNvSpPr>
-          <p:nvPr/>
-        </p:nvSpPr>
-        <p:spPr>
-          <a:xfrm xmlns:a="http://schemas.openxmlformats.org/drawingml/2006/main">
-            <a:off x="5772150" y="4305300"/>
-            <a:ext cx="2266950" cy="209550"/>
-          </a:xfrm>
-          <a:prstGeom xmlns:a="http://schemas.openxmlformats.org/drawingml/2006/main" prst="rect">
-            <a:avLst/>
-          </a:prstGeom>
-          <a:noFill xmlns:a="http://schemas.openxmlformats.org/drawingml/2006/main"/>
-          <a:ln xmlns:a="http://schemas.openxmlformats.org/drawingml/2006/main" w="0">
-            <a:noFill/>
-            <a:prstDash val="solid"/>
-          </a:ln>
-        </p:spPr>
-        <p:txBody>
-          <a:bodyPr xmlns:a="http://schemas.openxmlformats.org/drawingml/2006/main" anchor="t">
-            <a:noAutofit/>
-          </a:bodyPr>
-          <a:lstStyle xmlns:a="http://schemas.openxmlformats.org/drawingml/2006/main"/>
-          <a:p xmlns:a="http://schemas.openxmlformats.org/drawingml/2006/main">
-            <a:pPr algn="l">
-              <a:defRPr sz="1050" b="1">
-                <a:solidFill>
-                  <a:srgbClr val="64748B"/>
-                </a:solidFill>
-                <a:latin typeface="Helvetica Neue"/>
-                <a:ea typeface="Helvetica Neue"/>
-                <a:cs typeface="Helvetica Neue"/>
-              </a:defRPr>
-            </a:pPr>
-            <a:r>
-              <a:rPr sz="1050" b="1">
-                <a:solidFill>
-                  <a:srgbClr val="64748B"/>
-                </a:solidFill>
-                <a:latin typeface="Helvetica Neue"/>
-                <a:ea typeface="Helvetica Neue"/>
-                <a:cs typeface="Helvetica Neue"/>
-              </a:rPr>
-              <a:t>P95 lateness</a:t>
-            </a:r>
-          </a:p>
-        </p:txBody>
-      </p:sp>
-      <p:sp>
-        <p:nvSpPr>
-          <p:cNvPr id="37" name="">
-            <a:extLst xmlns:a="http://schemas.openxmlformats.org/drawingml/2006/main">
-              <a:ext uri="{FF2B5EF4-FFF2-40B4-BE49-F238E27FC236}">
-                <a16:creationId xmlns:a16="http://schemas.microsoft.com/office/drawing/2014/main" id="{EAD4D930-038D-4C12-9B6F-B152B267A28F}"/>
-              </a:ext>
-            </a:extLst>
-          </p:cNvPr>
-          <p:cNvSpPr>
-            <a:spLocks xmlns:a="http://schemas.openxmlformats.org/drawingml/2006/main" noGrp="1"/>
-          </p:cNvSpPr>
-          <p:nvPr/>
-        </p:nvSpPr>
-        <p:spPr>
-          <a:xfrm xmlns:a="http://schemas.openxmlformats.org/drawingml/2006/main">
-            <a:off x="5772150" y="4533900"/>
-            <a:ext cx="2266950" cy="266700"/>
-          </a:xfrm>
-          <a:prstGeom xmlns:a="http://schemas.openxmlformats.org/drawingml/2006/main" prst="rect">
-            <a:avLst/>
-          </a:prstGeom>
-          <a:noFill xmlns:a="http://schemas.openxmlformats.org/drawingml/2006/main"/>
-          <a:ln xmlns:a="http://schemas.openxmlformats.org/drawingml/2006/main" w="0">
-            <a:noFill/>
-            <a:prstDash val="solid"/>
-          </a:ln>
-        </p:spPr>
-        <p:txBody>
-          <a:bodyPr xmlns:a="http://schemas.openxmlformats.org/drawingml/2006/main" anchor="t">
-            <a:noAutofit/>
-          </a:bodyPr>
-          <a:lstStyle xmlns:a="http://schemas.openxmlformats.org/drawingml/2006/main"/>
-          <a:p xmlns:a="http://schemas.openxmlformats.org/drawingml/2006/main">
-            <a:pPr algn="l">
-              <a:defRPr sz="1725" b="1">
-                <a:solidFill>
-                  <a:srgbClr val="334155"/>
-                </a:solidFill>
-                <a:latin typeface="Helvetica Neue"/>
-                <a:ea typeface="Helvetica Neue"/>
-                <a:cs typeface="Helvetica Neue"/>
-              </a:defRPr>
-            </a:pPr>
-            <a:r>
-              <a:rPr sz="1725" b="1">
-                <a:solidFill>
-                  <a:srgbClr val="334155"/>
-                </a:solidFill>
-                <a:latin typeface="Helvetica Neue"/>
-                <a:ea typeface="Helvetica Neue"/>
-                <a:cs typeface="Helvetica Neue"/>
-              </a:rPr>
-              <a:t>0.1 s worse</a:t>
-            </a:r>
-          </a:p>
-        </p:txBody>
-      </p:sp>
-      <p:sp>
-        <p:nvSpPr>
-          <p:cNvPr id="38" name="">
-            <a:extLst xmlns:a="http://schemas.openxmlformats.org/drawingml/2006/main">
-              <a:ext uri="{FF2B5EF4-FFF2-40B4-BE49-F238E27FC236}">
-                <a16:creationId xmlns:a16="http://schemas.microsoft.com/office/drawing/2014/main" id="{58520918-860B-4246-86CF-AE2D6DD9B718}"/>
-              </a:ext>
-            </a:extLst>
-          </p:cNvPr>
-          <p:cNvSpPr>
-            <a:spLocks xmlns:a="http://schemas.openxmlformats.org/drawingml/2006/main" noGrp="1"/>
-          </p:cNvSpPr>
-          <p:nvPr/>
-        </p:nvSpPr>
-        <p:spPr>
-          <a:xfrm xmlns:a="http://schemas.openxmlformats.org/drawingml/2006/main">
-            <a:off x="5772150" y="4819650"/>
-            <a:ext cx="2266950" cy="171450"/>
-          </a:xfrm>
-          <a:prstGeom xmlns:a="http://schemas.openxmlformats.org/drawingml/2006/main" prst="rect">
-            <a:avLst/>
-          </a:prstGeom>
-          <a:noFill xmlns:a="http://schemas.openxmlformats.org/drawingml/2006/main"/>
-          <a:ln xmlns:a="http://schemas.openxmlformats.org/drawingml/2006/main" w="0">
-            <a:noFill/>
-            <a:prstDash val="solid"/>
-          </a:ln>
-        </p:spPr>
-        <p:txBody>
-          <a:bodyPr xmlns:a="http://schemas.openxmlformats.org/drawingml/2006/main" anchor="t">
-            <a:noAutofit/>
-          </a:bodyPr>
-          <a:lstStyle xmlns:a="http://schemas.openxmlformats.org/drawingml/2006/main"/>
-          <a:p xmlns:a="http://schemas.openxmlformats.org/drawingml/2006/main">
-            <a:pPr algn="l">
-              <a:defRPr sz="938" b="0">
-                <a:solidFill>
-                  <a:srgbClr val="334155"/>
-                </a:solidFill>
-                <a:latin typeface="Helvetica Neue"/>
-                <a:ea typeface="Helvetica Neue"/>
-                <a:cs typeface="Helvetica Neue"/>
-              </a:defRPr>
-            </a:pPr>
-            <a:r>
-              <a:rPr sz="938" b="0">
-                <a:solidFill>
-                  <a:srgbClr val="334155"/>
-                </a:solidFill>
-                <a:latin typeface="Helvetica Neue"/>
-                <a:ea typeface="Helvetica Neue"/>
-                <a:cs typeface="Helvetica Neue"/>
-              </a:rPr>
-              <a:t>Roughly flat: 7.3 s to 7.4 s</a:t>
-            </a:r>
-          </a:p>
-        </p:txBody>
-      </p:sp>
-      <p:sp>
-        <p:nvSpPr>
-          <p:cNvPr id="39" name="">
-            <a:extLst xmlns:a="http://schemas.openxmlformats.org/drawingml/2006/main">
-              <a:ext uri="{FF2B5EF4-FFF2-40B4-BE49-F238E27FC236}">
-                <a16:creationId xmlns:a16="http://schemas.microsoft.com/office/drawing/2014/main" id="{5C4B5848-4531-4B5A-92A9-B1B2A398A870}"/>
-              </a:ext>
-            </a:extLst>
-          </p:cNvPr>
-          <p:cNvSpPr>
-            <a:spLocks xmlns:a="http://schemas.openxmlformats.org/drawingml/2006/main" noGrp="1"/>
-          </p:cNvSpPr>
-          <p:nvPr/>
-        </p:nvSpPr>
-        <p:spPr>
-          <a:xfrm xmlns:a="http://schemas.openxmlformats.org/drawingml/2006/main">
-            <a:off x="8401050" y="4191000"/>
-            <a:ext cx="2571750" cy="838200"/>
-          </a:xfrm>
-          <a:prstGeom xmlns:a="http://schemas.openxmlformats.org/drawingml/2006/main" prst="rect">
-            <a:avLst/>
-          </a:prstGeom>
-          <a:solidFill xmlns:a="http://schemas.openxmlformats.org/drawingml/2006/main">
-            <a:srgbClr val="F3F6FA"/>
-          </a:solidFill>
-          <a:ln xmlns:a="http://schemas.openxmlformats.org/drawingml/2006/main" w="9525">
-            <a:solidFill>
-              <a:srgbClr val="DBE4EF"/>
-            </a:solidFill>
-            <a:prstDash val="solid"/>
-          </a:ln>
-        </p:spPr>
-      </p:sp>
-      <p:sp>
-        <p:nvSpPr>
           <p:cNvPr id="40" name="">
             <a:extLst xmlns:a="http://schemas.openxmlformats.org/drawingml/2006/main">
               <a:ext uri="{FF2B5EF4-FFF2-40B4-BE49-F238E27FC236}">
-                <a16:creationId xmlns:a16="http://schemas.microsoft.com/office/drawing/2014/main" id="{CCC259D8-247A-4D45-9B4A-7AF1D6E06F25}"/>
+                <a16:creationId xmlns:a16="http://schemas.microsoft.com/office/drawing/2014/main" id="{DCD5CDD2-7FFC-4064-AB9A-41061D57906D}"/>
               </a:ext>
             </a:extLst>
           </p:cNvPr>
@@ -5499,7 +5499,7 @@
           <p:cNvPr id="41" name="">
             <a:extLst xmlns:a="http://schemas.openxmlformats.org/drawingml/2006/main">
               <a:ext uri="{FF2B5EF4-FFF2-40B4-BE49-F238E27FC236}">
-                <a16:creationId xmlns:a16="http://schemas.microsoft.com/office/drawing/2014/main" id="{0FB13AFF-DFF7-450E-9874-A8F385226659}"/>
+                <a16:creationId xmlns:a16="http://schemas.microsoft.com/office/drawing/2014/main" id="{A114540B-BE18-4192-A606-88A742F541CA}"/>
               </a:ext>
             </a:extLst>
           </p:cNvPr>
@@ -5557,7 +5557,7 @@
           <p:cNvPr id="42" name="">
             <a:extLst xmlns:a="http://schemas.openxmlformats.org/drawingml/2006/main">
               <a:ext uri="{FF2B5EF4-FFF2-40B4-BE49-F238E27FC236}">
-                <a16:creationId xmlns:a16="http://schemas.microsoft.com/office/drawing/2014/main" id="{8342A5A5-2222-411D-98F4-872830772D71}"/>
+                <a16:creationId xmlns:a16="http://schemas.microsoft.com/office/drawing/2014/main" id="{0F2DF7AE-2A3D-46BF-AEF7-710FC32A6AB0}"/>
               </a:ext>
             </a:extLst>
           </p:cNvPr>
@@ -5615,7 +5615,7 @@
           <p:cNvPr id="43" name="">
             <a:extLst xmlns:a="http://schemas.openxmlformats.org/drawingml/2006/main">
               <a:ext uri="{FF2B5EF4-FFF2-40B4-BE49-F238E27FC236}">
-                <a16:creationId xmlns:a16="http://schemas.microsoft.com/office/drawing/2014/main" id="{900D5DB9-0CC3-4BFA-B648-0BDA26DE8679}"/>
+                <a16:creationId xmlns:a16="http://schemas.microsoft.com/office/drawing/2014/main" id="{FE6252FA-5961-494F-A9BB-8EA34B092310}"/>
               </a:ext>
             </a:extLst>
           </p:cNvPr>
@@ -5646,7 +5646,7 @@
           <p:cNvPr id="44" name="">
             <a:extLst xmlns:a="http://schemas.openxmlformats.org/drawingml/2006/main">
               <a:ext uri="{FF2B5EF4-FFF2-40B4-BE49-F238E27FC236}">
-                <a16:creationId xmlns:a16="http://schemas.microsoft.com/office/drawing/2014/main" id="{9161CF86-BF21-49AD-A056-8752A4E1EEEB}"/>
+                <a16:creationId xmlns:a16="http://schemas.microsoft.com/office/drawing/2014/main" id="{74C5B5CA-875D-477A-8DB4-959ECEED3444}"/>
               </a:ext>
             </a:extLst>
           </p:cNvPr>
@@ -5704,7 +5704,7 @@
           <p:cNvPr id="45" name="">
             <a:extLst xmlns:a="http://schemas.openxmlformats.org/drawingml/2006/main">
               <a:ext uri="{FF2B5EF4-FFF2-40B4-BE49-F238E27FC236}">
-                <a16:creationId xmlns:a16="http://schemas.microsoft.com/office/drawing/2014/main" id="{7355603A-55F7-4998-AC98-9EC82B451062}"/>
+                <a16:creationId xmlns:a16="http://schemas.microsoft.com/office/drawing/2014/main" id="{E94D99ED-5630-4E62-AAB5-FA5C0A40C2CE}"/>
               </a:ext>
             </a:extLst>
           </p:cNvPr>
@@ -5760,7 +5760,7 @@
     </p:spTree>
     <p:extLst>
       <p:ext uri="{BB962C8B-B14F-4D97-AF65-F5344CB8AC3E}">
-        <p14:creationId xmlns:p14="http://schemas.microsoft.com/office/powerpoint/2010/main" val="791965220"/>
+        <p14:creationId xmlns:p14="http://schemas.microsoft.com/office/powerpoint/2010/main" val="2095082422"/>
       </p:ext>
     </p:extLst>
   </p:cSld>
@@ -5791,7 +5791,7 @@
           <p:cNvPr id="46" name="">
             <a:extLst xmlns:a="http://schemas.openxmlformats.org/drawingml/2006/main">
               <a:ext uri="{FF2B5EF4-FFF2-40B4-BE49-F238E27FC236}">
-                <a16:creationId xmlns:a16="http://schemas.microsoft.com/office/drawing/2014/main" id="{D00922CC-CE90-4843-95C4-841E50AEE8EA}"/>
+                <a16:creationId xmlns:a16="http://schemas.microsoft.com/office/drawing/2014/main" id="{BE7050B1-5B2B-47CB-A761-E600F32AE931}"/>
               </a:ext>
             </a:extLst>
           </p:cNvPr>
@@ -5849,7 +5849,7 @@
           <p:cNvPr id="2" name="">
             <a:extLst xmlns:a="http://schemas.openxmlformats.org/drawingml/2006/main">
               <a:ext uri="{FF2B5EF4-FFF2-40B4-BE49-F238E27FC236}">
-                <a16:creationId xmlns:a16="http://schemas.microsoft.com/office/drawing/2014/main" id="{20A46475-E478-468F-B55B-B06AC33E0122}"/>
+                <a16:creationId xmlns:a16="http://schemas.microsoft.com/office/drawing/2014/main" id="{FB30F90A-912D-4C61-A78F-27A7224870B8}"/>
               </a:ext>
             </a:extLst>
           </p:cNvPr>
@@ -5907,7 +5907,7 @@
           <p:cNvPr id="3" name="">
             <a:extLst xmlns:a="http://schemas.openxmlformats.org/drawingml/2006/main">
               <a:ext uri="{FF2B5EF4-FFF2-40B4-BE49-F238E27FC236}">
-                <a16:creationId xmlns:a16="http://schemas.microsoft.com/office/drawing/2014/main" id="{C9B7B45B-3084-4E88-B488-97B4D32AC120}"/>
+                <a16:creationId xmlns:a16="http://schemas.microsoft.com/office/drawing/2014/main" id="{B52D9656-5458-442B-84ED-50A2056A09A9}"/>
               </a:ext>
             </a:extLst>
           </p:cNvPr>
@@ -5965,7 +5965,7 @@
           <p:cNvPr id="4" name="">
             <a:extLst xmlns:a="http://schemas.openxmlformats.org/drawingml/2006/main">
               <a:ext uri="{FF2B5EF4-FFF2-40B4-BE49-F238E27FC236}">
-                <a16:creationId xmlns:a16="http://schemas.microsoft.com/office/drawing/2014/main" id="{7BBB6492-4B16-4568-B42C-DAB473AFA46B}"/>
+                <a16:creationId xmlns:a16="http://schemas.microsoft.com/office/drawing/2014/main" id="{20726760-9F5A-4FD1-BDF7-F080137CCB02}"/>
               </a:ext>
             </a:extLst>
           </p:cNvPr>
@@ -5996,7 +5996,7 @@
           <p:cNvPr id="5" name="">
             <a:extLst xmlns:a="http://schemas.openxmlformats.org/drawingml/2006/main">
               <a:ext uri="{FF2B5EF4-FFF2-40B4-BE49-F238E27FC236}">
-                <a16:creationId xmlns:a16="http://schemas.microsoft.com/office/drawing/2014/main" id="{F3C930B4-AE0D-40F0-8D10-9400E515C045}"/>
+                <a16:creationId xmlns:a16="http://schemas.microsoft.com/office/drawing/2014/main" id="{E69F9612-EEAD-4D50-B1C5-701A9F4285C2}"/>
               </a:ext>
             </a:extLst>
           </p:cNvPr>
@@ -6054,7 +6054,7 @@
           <p:cNvPr id="6" name="">
             <a:extLst xmlns:a="http://schemas.openxmlformats.org/drawingml/2006/main">
               <a:ext uri="{FF2B5EF4-FFF2-40B4-BE49-F238E27FC236}">
-                <a16:creationId xmlns:a16="http://schemas.microsoft.com/office/drawing/2014/main" id="{437EAAD2-CF64-43C8-B2FF-76FCC712C4DA}"/>
+                <a16:creationId xmlns:a16="http://schemas.microsoft.com/office/drawing/2014/main" id="{D8855396-A1C9-4048-A5DC-4B3B9A11E192}"/>
               </a:ext>
             </a:extLst>
           </p:cNvPr>
@@ -6087,7 +6087,7 @@
           <p:cNvPr id="7" name="">
             <a:extLst xmlns:a="http://schemas.openxmlformats.org/drawingml/2006/main">
               <a:ext uri="{FF2B5EF4-FFF2-40B4-BE49-F238E27FC236}">
-                <a16:creationId xmlns:a16="http://schemas.microsoft.com/office/drawing/2014/main" id="{AA16E484-25C9-4A41-931A-2CFA1F94434D}"/>
+                <a16:creationId xmlns:a16="http://schemas.microsoft.com/office/drawing/2014/main" id="{F1E7F3D5-728C-4378-A23C-0EB4B60C7B8A}"/>
               </a:ext>
             </a:extLst>
           </p:cNvPr>
@@ -6145,7 +6145,7 @@
           <p:cNvPr id="8" name="">
             <a:extLst xmlns:a="http://schemas.openxmlformats.org/drawingml/2006/main">
               <a:ext uri="{FF2B5EF4-FFF2-40B4-BE49-F238E27FC236}">
-                <a16:creationId xmlns:a16="http://schemas.microsoft.com/office/drawing/2014/main" id="{D7BB3744-4AE3-4EF4-80E1-3CDFF5F53CFE}"/>
+                <a16:creationId xmlns:a16="http://schemas.microsoft.com/office/drawing/2014/main" id="{C3F1FB89-1BB8-4C11-BC42-061FF8E5D2C5}"/>
               </a:ext>
             </a:extLst>
           </p:cNvPr>
@@ -6178,7 +6178,7 @@
           <p:cNvPr id="9" name="">
             <a:extLst xmlns:a="http://schemas.openxmlformats.org/drawingml/2006/main">
               <a:ext uri="{FF2B5EF4-FFF2-40B4-BE49-F238E27FC236}">
-                <a16:creationId xmlns:a16="http://schemas.microsoft.com/office/drawing/2014/main" id="{37C3F707-0C83-47F7-838A-C5C492DAC730}"/>
+                <a16:creationId xmlns:a16="http://schemas.microsoft.com/office/drawing/2014/main" id="{015947CA-8197-479A-8BD6-A5859768CE9E}"/>
               </a:ext>
             </a:extLst>
           </p:cNvPr>
@@ -6236,7 +6236,7 @@
           <p:cNvPr id="10" name="">
             <a:extLst xmlns:a="http://schemas.openxmlformats.org/drawingml/2006/main">
               <a:ext uri="{FF2B5EF4-FFF2-40B4-BE49-F238E27FC236}">
-                <a16:creationId xmlns:a16="http://schemas.microsoft.com/office/drawing/2014/main" id="{CAC74FE8-2D3C-451C-80B7-172064A93EDD}"/>
+                <a16:creationId xmlns:a16="http://schemas.microsoft.com/office/drawing/2014/main" id="{BA356334-CE21-427A-A8DC-7D196B5E8AAC}"/>
               </a:ext>
             </a:extLst>
           </p:cNvPr>
@@ -6269,7 +6269,7 @@
           <p:cNvPr id="11" name="">
             <a:extLst xmlns:a="http://schemas.openxmlformats.org/drawingml/2006/main">
               <a:ext uri="{FF2B5EF4-FFF2-40B4-BE49-F238E27FC236}">
-                <a16:creationId xmlns:a16="http://schemas.microsoft.com/office/drawing/2014/main" id="{455E7A1C-DE95-434C-ABD6-A36755AB7A21}"/>
+                <a16:creationId xmlns:a16="http://schemas.microsoft.com/office/drawing/2014/main" id="{1CE11A09-10C8-4925-BF96-A4606AAF773D}"/>
               </a:ext>
             </a:extLst>
           </p:cNvPr>
@@ -6327,7 +6327,7 @@
           <p:cNvPr id="12" name="">
             <a:extLst xmlns:a="http://schemas.openxmlformats.org/drawingml/2006/main">
               <a:ext uri="{FF2B5EF4-FFF2-40B4-BE49-F238E27FC236}">
-                <a16:creationId xmlns:a16="http://schemas.microsoft.com/office/drawing/2014/main" id="{4F48B98C-DC41-468D-A2F2-478D9F51F704}"/>
+                <a16:creationId xmlns:a16="http://schemas.microsoft.com/office/drawing/2014/main" id="{0A877E49-95E6-48F3-98CF-90A611777EC8}"/>
               </a:ext>
             </a:extLst>
           </p:cNvPr>
@@ -6360,7 +6360,7 @@
           <p:cNvPr id="13" name="">
             <a:extLst xmlns:a="http://schemas.openxmlformats.org/drawingml/2006/main">
               <a:ext uri="{FF2B5EF4-FFF2-40B4-BE49-F238E27FC236}">
-                <a16:creationId xmlns:a16="http://schemas.microsoft.com/office/drawing/2014/main" id="{CF5CB9D3-7C77-437F-B6AF-7FE290FC4B4C}"/>
+                <a16:creationId xmlns:a16="http://schemas.microsoft.com/office/drawing/2014/main" id="{E4B1FFD6-6222-43E9-9D45-378A17AA4FD9}"/>
               </a:ext>
             </a:extLst>
           </p:cNvPr>
@@ -6418,7 +6418,7 @@
           <p:cNvPr id="14" name="">
             <a:extLst xmlns:a="http://schemas.openxmlformats.org/drawingml/2006/main">
               <a:ext uri="{FF2B5EF4-FFF2-40B4-BE49-F238E27FC236}">
-                <a16:creationId xmlns:a16="http://schemas.microsoft.com/office/drawing/2014/main" id="{EA8E89AA-A575-4828-96F4-C8CBE243E0A0}"/>
+                <a16:creationId xmlns:a16="http://schemas.microsoft.com/office/drawing/2014/main" id="{016BB31B-D251-46B8-8BBF-E5B59BCB2D37}"/>
               </a:ext>
             </a:extLst>
           </p:cNvPr>
@@ -6451,7 +6451,7 @@
           <p:cNvPr id="15" name="">
             <a:extLst xmlns:a="http://schemas.openxmlformats.org/drawingml/2006/main">
               <a:ext uri="{FF2B5EF4-FFF2-40B4-BE49-F238E27FC236}">
-                <a16:creationId xmlns:a16="http://schemas.microsoft.com/office/drawing/2014/main" id="{E6258620-5EF2-4B76-90F1-EA27F5BFFA15}"/>
+                <a16:creationId xmlns:a16="http://schemas.microsoft.com/office/drawing/2014/main" id="{634AF9C7-6E3B-4420-B4C4-A53D57C91E18}"/>
               </a:ext>
             </a:extLst>
           </p:cNvPr>
@@ -6509,7 +6509,7 @@
           <p:cNvPr id="16" name="">
             <a:extLst xmlns:a="http://schemas.openxmlformats.org/drawingml/2006/main">
               <a:ext uri="{FF2B5EF4-FFF2-40B4-BE49-F238E27FC236}">
-                <a16:creationId xmlns:a16="http://schemas.microsoft.com/office/drawing/2014/main" id="{77A9498F-410A-4228-A115-9E36CEF93075}"/>
+                <a16:creationId xmlns:a16="http://schemas.microsoft.com/office/drawing/2014/main" id="{44CB479C-342C-47BD-8264-0CA10F29C47C}"/>
               </a:ext>
             </a:extLst>
           </p:cNvPr>
@@ -6567,7 +6567,7 @@
           <p:cNvPr id="17" name="">
             <a:extLst xmlns:a="http://schemas.openxmlformats.org/drawingml/2006/main">
               <a:ext uri="{FF2B5EF4-FFF2-40B4-BE49-F238E27FC236}">
-                <a16:creationId xmlns:a16="http://schemas.microsoft.com/office/drawing/2014/main" id="{945391F8-6C40-4021-9F1C-216A52726F58}"/>
+                <a16:creationId xmlns:a16="http://schemas.microsoft.com/office/drawing/2014/main" id="{E020E44D-DDE4-490C-BEFC-04562C85C83A}"/>
               </a:ext>
             </a:extLst>
           </p:cNvPr>
@@ -6625,7 +6625,7 @@
           <p:cNvPr id="18" name="">
             <a:extLst xmlns:a="http://schemas.openxmlformats.org/drawingml/2006/main">
               <a:ext uri="{FF2B5EF4-FFF2-40B4-BE49-F238E27FC236}">
-                <a16:creationId xmlns:a16="http://schemas.microsoft.com/office/drawing/2014/main" id="{213AE853-BEF8-4A90-87EF-62BB4F7ED1F2}"/>
+                <a16:creationId xmlns:a16="http://schemas.microsoft.com/office/drawing/2014/main" id="{9DCB5B17-4C4B-4D58-928B-765FA65DA388}"/>
               </a:ext>
             </a:extLst>
           </p:cNvPr>
@@ -6683,7 +6683,7 @@
           <p:cNvPr id="19" name="">
             <a:extLst xmlns:a="http://schemas.openxmlformats.org/drawingml/2006/main">
               <a:ext uri="{FF2B5EF4-FFF2-40B4-BE49-F238E27FC236}">
-                <a16:creationId xmlns:a16="http://schemas.microsoft.com/office/drawing/2014/main" id="{4A1BA7F2-EFF1-4773-BD20-A0C7A5EF60C1}"/>
+                <a16:creationId xmlns:a16="http://schemas.microsoft.com/office/drawing/2014/main" id="{7216BDA5-FFDC-4F2D-BD4D-89A581010DCB}"/>
               </a:ext>
             </a:extLst>
           </p:cNvPr>
@@ -6701,7 +6701,7 @@
             <a:avLst/>
           </a:prstGeom>
           <a:solidFill xmlns:a="http://schemas.openxmlformats.org/drawingml/2006/main">
-            <a:srgbClr val="F8FAFC"/>
+            <a:srgbClr val="EEF7F1"/>
           </a:solidFill>
           <a:ln xmlns:a="http://schemas.openxmlformats.org/drawingml/2006/main" w="9525">
             <a:solidFill>
@@ -6716,7 +6716,7 @@
           <p:cNvPr id="20" name="">
             <a:extLst xmlns:a="http://schemas.openxmlformats.org/drawingml/2006/main">
               <a:ext uri="{FF2B5EF4-FFF2-40B4-BE49-F238E27FC236}">
-                <a16:creationId xmlns:a16="http://schemas.microsoft.com/office/drawing/2014/main" id="{8EDB372D-F998-4D24-B530-3B7AE82EB47F}"/>
+                <a16:creationId xmlns:a16="http://schemas.microsoft.com/office/drawing/2014/main" id="{174ADA37-9C89-471F-ACC7-AB500992F04C}"/>
               </a:ext>
             </a:extLst>
           </p:cNvPr>
@@ -6774,7 +6774,7 @@
           <p:cNvPr id="21" name="">
             <a:extLst xmlns:a="http://schemas.openxmlformats.org/drawingml/2006/main">
               <a:ext uri="{FF2B5EF4-FFF2-40B4-BE49-F238E27FC236}">
-                <a16:creationId xmlns:a16="http://schemas.microsoft.com/office/drawing/2014/main" id="{362683B2-5554-4DC2-805C-F6F39D304593}"/>
+                <a16:creationId xmlns:a16="http://schemas.microsoft.com/office/drawing/2014/main" id="{F92E07ED-BFE9-4768-BF0E-E999052B09FA}"/>
               </a:ext>
             </a:extLst>
           </p:cNvPr>
@@ -6832,7 +6832,7 @@
           <p:cNvPr id="22" name="">
             <a:extLst xmlns:a="http://schemas.openxmlformats.org/drawingml/2006/main">
               <a:ext uri="{FF2B5EF4-FFF2-40B4-BE49-F238E27FC236}">
-                <a16:creationId xmlns:a16="http://schemas.microsoft.com/office/drawing/2014/main" id="{BA5E1028-2CDA-43F9-8521-ACD281EA612A}"/>
+                <a16:creationId xmlns:a16="http://schemas.microsoft.com/office/drawing/2014/main" id="{759DFED0-E9F8-4839-92FB-F3B4919FC5E7}"/>
               </a:ext>
             </a:extLst>
           </p:cNvPr>
@@ -6890,7 +6890,7 @@
           <p:cNvPr id="23" name="">
             <a:extLst xmlns:a="http://schemas.openxmlformats.org/drawingml/2006/main">
               <a:ext uri="{FF2B5EF4-FFF2-40B4-BE49-F238E27FC236}">
-                <a16:creationId xmlns:a16="http://schemas.microsoft.com/office/drawing/2014/main" id="{A1E8DE04-040D-45F1-88D6-4978E36EAD91}"/>
+                <a16:creationId xmlns:a16="http://schemas.microsoft.com/office/drawing/2014/main" id="{8512867D-F0A9-4FD0-B74B-FB3FA60DE2F4}"/>
               </a:ext>
             </a:extLst>
           </p:cNvPr>
@@ -6908,7 +6908,7 @@
             <a:avLst/>
           </a:prstGeom>
           <a:solidFill xmlns:a="http://schemas.openxmlformats.org/drawingml/2006/main">
-            <a:srgbClr val="F8FAFC"/>
+            <a:srgbClr val="EEF7F1"/>
           </a:solidFill>
           <a:ln xmlns:a="http://schemas.openxmlformats.org/drawingml/2006/main" w="9525">
             <a:solidFill>
@@ -6923,7 +6923,7 @@
           <p:cNvPr id="24" name="">
             <a:extLst xmlns:a="http://schemas.openxmlformats.org/drawingml/2006/main">
               <a:ext uri="{FF2B5EF4-FFF2-40B4-BE49-F238E27FC236}">
-                <a16:creationId xmlns:a16="http://schemas.microsoft.com/office/drawing/2014/main" id="{32DA7544-B06B-451D-8A9D-CD014419E4BE}"/>
+                <a16:creationId xmlns:a16="http://schemas.microsoft.com/office/drawing/2014/main" id="{211722D5-3E95-41C2-952B-446A6C50E431}"/>
               </a:ext>
             </a:extLst>
           </p:cNvPr>
@@ -6981,7 +6981,7 @@
           <p:cNvPr id="25" name="">
             <a:extLst xmlns:a="http://schemas.openxmlformats.org/drawingml/2006/main">
               <a:ext uri="{FF2B5EF4-FFF2-40B4-BE49-F238E27FC236}">
-                <a16:creationId xmlns:a16="http://schemas.microsoft.com/office/drawing/2014/main" id="{4D5BF6C0-B395-446B-A0CB-390D2AD63F40}"/>
+                <a16:creationId xmlns:a16="http://schemas.microsoft.com/office/drawing/2014/main" id="{499A6254-EF89-497C-AAF0-239EB5271E6B}"/>
               </a:ext>
             </a:extLst>
           </p:cNvPr>
@@ -7039,7 +7039,7 @@
           <p:cNvPr id="26" name="">
             <a:extLst xmlns:a="http://schemas.openxmlformats.org/drawingml/2006/main">
               <a:ext uri="{FF2B5EF4-FFF2-40B4-BE49-F238E27FC236}">
-                <a16:creationId xmlns:a16="http://schemas.microsoft.com/office/drawing/2014/main" id="{1D4BEB4A-126B-4AC2-A517-2BF6E1411E22}"/>
+                <a16:creationId xmlns:a16="http://schemas.microsoft.com/office/drawing/2014/main" id="{C595E681-AA0A-4612-B971-571BB80C4B85}"/>
               </a:ext>
             </a:extLst>
           </p:cNvPr>
@@ -7097,7 +7097,7 @@
           <p:cNvPr id="27" name="">
             <a:extLst xmlns:a="http://schemas.openxmlformats.org/drawingml/2006/main">
               <a:ext uri="{FF2B5EF4-FFF2-40B4-BE49-F238E27FC236}">
-                <a16:creationId xmlns:a16="http://schemas.microsoft.com/office/drawing/2014/main" id="{059F9114-AD2D-4C92-9ACB-1B781E4D3A68}"/>
+                <a16:creationId xmlns:a16="http://schemas.microsoft.com/office/drawing/2014/main" id="{4E199AAC-9B10-4CDB-8B33-FA0989690FE9}"/>
               </a:ext>
             </a:extLst>
           </p:cNvPr>
@@ -7115,7 +7115,7 @@
             <a:avLst/>
           </a:prstGeom>
           <a:solidFill xmlns:a="http://schemas.openxmlformats.org/drawingml/2006/main">
-            <a:srgbClr val="F8FAFC"/>
+            <a:srgbClr val="EEF7F1"/>
           </a:solidFill>
           <a:ln xmlns:a="http://schemas.openxmlformats.org/drawingml/2006/main" w="9525">
             <a:solidFill>
@@ -7130,7 +7130,7 @@
           <p:cNvPr id="28" name="">
             <a:extLst xmlns:a="http://schemas.openxmlformats.org/drawingml/2006/main">
               <a:ext uri="{FF2B5EF4-FFF2-40B4-BE49-F238E27FC236}">
-                <a16:creationId xmlns:a16="http://schemas.microsoft.com/office/drawing/2014/main" id="{A8871EB0-F1D1-4E5D-B78A-5312CCE07BDD}"/>
+                <a16:creationId xmlns:a16="http://schemas.microsoft.com/office/drawing/2014/main" id="{068EAD3F-B4E6-424F-A55C-46C0C2CE4D5D}"/>
               </a:ext>
             </a:extLst>
           </p:cNvPr>
@@ -7188,7 +7188,7 @@
           <p:cNvPr id="29" name="">
             <a:extLst xmlns:a="http://schemas.openxmlformats.org/drawingml/2006/main">
               <a:ext uri="{FF2B5EF4-FFF2-40B4-BE49-F238E27FC236}">
-                <a16:creationId xmlns:a16="http://schemas.microsoft.com/office/drawing/2014/main" id="{DBB0CA62-815D-4539-9C51-2DC4EE67ACB6}"/>
+                <a16:creationId xmlns:a16="http://schemas.microsoft.com/office/drawing/2014/main" id="{0A75E9BC-D2BB-4954-813D-E4F7A6A00B09}"/>
               </a:ext>
             </a:extLst>
           </p:cNvPr>
@@ -7246,7 +7246,7 @@
           <p:cNvPr id="30" name="">
             <a:extLst xmlns:a="http://schemas.openxmlformats.org/drawingml/2006/main">
               <a:ext uri="{FF2B5EF4-FFF2-40B4-BE49-F238E27FC236}">
-                <a16:creationId xmlns:a16="http://schemas.microsoft.com/office/drawing/2014/main" id="{54C1C0F2-21B6-4F31-B521-14C2D11B0FC3}"/>
+                <a16:creationId xmlns:a16="http://schemas.microsoft.com/office/drawing/2014/main" id="{B52E2109-E002-41BE-9D20-48CBBDA1BFAD}"/>
               </a:ext>
             </a:extLst>
           </p:cNvPr>
@@ -7304,7 +7304,7 @@
           <p:cNvPr id="31" name="">
             <a:extLst xmlns:a="http://schemas.openxmlformats.org/drawingml/2006/main">
               <a:ext uri="{FF2B5EF4-FFF2-40B4-BE49-F238E27FC236}">
-                <a16:creationId xmlns:a16="http://schemas.microsoft.com/office/drawing/2014/main" id="{0E26FF9A-A29E-4ECC-A59D-A05DC80A900D}"/>
+                <a16:creationId xmlns:a16="http://schemas.microsoft.com/office/drawing/2014/main" id="{06BF0351-5250-42F2-91CB-6E05876E8115}"/>
               </a:ext>
             </a:extLst>
           </p:cNvPr>
@@ -7322,7 +7322,7 @@
             <a:avLst/>
           </a:prstGeom>
           <a:solidFill xmlns:a="http://schemas.openxmlformats.org/drawingml/2006/main">
-            <a:srgbClr val="F8FAFC"/>
+            <a:srgbClr val="EEF7F1"/>
           </a:solidFill>
           <a:ln xmlns:a="http://schemas.openxmlformats.org/drawingml/2006/main" w="9525">
             <a:solidFill>
@@ -7337,7 +7337,7 @@
           <p:cNvPr id="32" name="">
             <a:extLst xmlns:a="http://schemas.openxmlformats.org/drawingml/2006/main">
               <a:ext uri="{FF2B5EF4-FFF2-40B4-BE49-F238E27FC236}">
-                <a16:creationId xmlns:a16="http://schemas.microsoft.com/office/drawing/2014/main" id="{52BE7D65-C37B-492B-AE78-21D0C1C055BE}"/>
+                <a16:creationId xmlns:a16="http://schemas.microsoft.com/office/drawing/2014/main" id="{0E45DDDF-1BE1-46AC-91BF-61962EBE1A63}"/>
               </a:ext>
             </a:extLst>
           </p:cNvPr>
@@ -7395,7 +7395,7 @@
           <p:cNvPr id="33" name="">
             <a:extLst xmlns:a="http://schemas.openxmlformats.org/drawingml/2006/main">
               <a:ext uri="{FF2B5EF4-FFF2-40B4-BE49-F238E27FC236}">
-                <a16:creationId xmlns:a16="http://schemas.microsoft.com/office/drawing/2014/main" id="{4B97EBDA-8DA6-472F-B6CC-7EA758E4E43C}"/>
+                <a16:creationId xmlns:a16="http://schemas.microsoft.com/office/drawing/2014/main" id="{4BAB8322-9032-4B44-9A58-6FC9B8171405}"/>
               </a:ext>
             </a:extLst>
           </p:cNvPr>
@@ -7453,7 +7453,7 @@
           <p:cNvPr id="34" name="">
             <a:extLst xmlns:a="http://schemas.openxmlformats.org/drawingml/2006/main">
               <a:ext uri="{FF2B5EF4-FFF2-40B4-BE49-F238E27FC236}">
-                <a16:creationId xmlns:a16="http://schemas.microsoft.com/office/drawing/2014/main" id="{D62D33BD-2B10-4FBE-83AD-217176D544C9}"/>
+                <a16:creationId xmlns:a16="http://schemas.microsoft.com/office/drawing/2014/main" id="{1AB87823-1179-4DB3-80C7-68FF6A6DEB8F}"/>
               </a:ext>
             </a:extLst>
           </p:cNvPr>
@@ -7511,7 +7511,7 @@
           <p:cNvPr id="35" name="">
             <a:extLst xmlns:a="http://schemas.openxmlformats.org/drawingml/2006/main">
               <a:ext uri="{FF2B5EF4-FFF2-40B4-BE49-F238E27FC236}">
-                <a16:creationId xmlns:a16="http://schemas.microsoft.com/office/drawing/2014/main" id="{9D580103-00F6-4099-A98C-DBC08D2E15EB}"/>
+                <a16:creationId xmlns:a16="http://schemas.microsoft.com/office/drawing/2014/main" id="{DA824C80-D8E4-4844-B1EA-AE0BC67DF27B}"/>
               </a:ext>
             </a:extLst>
           </p:cNvPr>
@@ -7529,7 +7529,7 @@
             <a:avLst/>
           </a:prstGeom>
           <a:solidFill xmlns:a="http://schemas.openxmlformats.org/drawingml/2006/main">
-            <a:srgbClr val="F8FAFC"/>
+            <a:srgbClr val="EEF7F1"/>
           </a:solidFill>
           <a:ln xmlns:a="http://schemas.openxmlformats.org/drawingml/2006/main" w="9525">
             <a:solidFill>
@@ -7544,7 +7544,7 @@
           <p:cNvPr id="36" name="">
             <a:extLst xmlns:a="http://schemas.openxmlformats.org/drawingml/2006/main">
               <a:ext uri="{FF2B5EF4-FFF2-40B4-BE49-F238E27FC236}">
-                <a16:creationId xmlns:a16="http://schemas.microsoft.com/office/drawing/2014/main" id="{AE726626-823C-4362-A4DF-CF673D868D0B}"/>
+                <a16:creationId xmlns:a16="http://schemas.microsoft.com/office/drawing/2014/main" id="{889ABDDF-4BE9-4704-A273-6FEC44BB27CB}"/>
               </a:ext>
             </a:extLst>
           </p:cNvPr>
@@ -7602,7 +7602,7 @@
           <p:cNvPr id="37" name="">
             <a:extLst xmlns:a="http://schemas.openxmlformats.org/drawingml/2006/main">
               <a:ext uri="{FF2B5EF4-FFF2-40B4-BE49-F238E27FC236}">
-                <a16:creationId xmlns:a16="http://schemas.microsoft.com/office/drawing/2014/main" id="{1727EC70-F149-466B-B9E8-8277FD18AB8A}"/>
+                <a16:creationId xmlns:a16="http://schemas.microsoft.com/office/drawing/2014/main" id="{BAF974F3-5B1F-481F-B6A4-0823ED147D66}"/>
               </a:ext>
             </a:extLst>
           </p:cNvPr>
@@ -7660,7 +7660,7 @@
           <p:cNvPr id="38" name="">
             <a:extLst xmlns:a="http://schemas.openxmlformats.org/drawingml/2006/main">
               <a:ext uri="{FF2B5EF4-FFF2-40B4-BE49-F238E27FC236}">
-                <a16:creationId xmlns:a16="http://schemas.microsoft.com/office/drawing/2014/main" id="{82A7E9EB-44BB-4756-9952-A2A2EF53471B}"/>
+                <a16:creationId xmlns:a16="http://schemas.microsoft.com/office/drawing/2014/main" id="{6F133A1F-804D-4BF6-AF3A-E2DD31585B51}"/>
               </a:ext>
             </a:extLst>
           </p:cNvPr>
@@ -7718,7 +7718,7 @@
           <p:cNvPr id="39" name="">
             <a:extLst xmlns:a="http://schemas.openxmlformats.org/drawingml/2006/main">
               <a:ext uri="{FF2B5EF4-FFF2-40B4-BE49-F238E27FC236}">
-                <a16:creationId xmlns:a16="http://schemas.microsoft.com/office/drawing/2014/main" id="{C61E8276-C2C4-4780-8039-124F5438B088}"/>
+                <a16:creationId xmlns:a16="http://schemas.microsoft.com/office/drawing/2014/main" id="{8F5B18A0-BB25-4A7A-AE82-E4D6277CA64B}"/>
               </a:ext>
             </a:extLst>
           </p:cNvPr>
@@ -7736,7 +7736,7 @@
             <a:avLst/>
           </a:prstGeom>
           <a:solidFill xmlns:a="http://schemas.openxmlformats.org/drawingml/2006/main">
-            <a:srgbClr val="F3F6FA"/>
+            <a:srgbClr val="FFF1F1"/>
           </a:solidFill>
           <a:ln xmlns:a="http://schemas.openxmlformats.org/drawingml/2006/main" w="9525">
             <a:solidFill>
@@ -7751,7 +7751,7 @@
           <p:cNvPr id="40" name="">
             <a:extLst xmlns:a="http://schemas.openxmlformats.org/drawingml/2006/main">
               <a:ext uri="{FF2B5EF4-FFF2-40B4-BE49-F238E27FC236}">
-                <a16:creationId xmlns:a16="http://schemas.microsoft.com/office/drawing/2014/main" id="{27AAEACD-DE54-4A49-8D3B-546A38AFC2C0}"/>
+                <a16:creationId xmlns:a16="http://schemas.microsoft.com/office/drawing/2014/main" id="{9AC28609-F301-47B0-98F2-0840305FDE20}"/>
               </a:ext>
             </a:extLst>
           </p:cNvPr>
@@ -7809,7 +7809,7 @@
           <p:cNvPr id="41" name="">
             <a:extLst xmlns:a="http://schemas.openxmlformats.org/drawingml/2006/main">
               <a:ext uri="{FF2B5EF4-FFF2-40B4-BE49-F238E27FC236}">
-                <a16:creationId xmlns:a16="http://schemas.microsoft.com/office/drawing/2014/main" id="{884AE589-2D73-447C-979B-F7BB3A3A51B9}"/>
+                <a16:creationId xmlns:a16="http://schemas.microsoft.com/office/drawing/2014/main" id="{2A1893E1-40E0-44E4-B9A9-18C8A8A37BD2}"/>
               </a:ext>
             </a:extLst>
           </p:cNvPr>
@@ -7841,7 +7841,7 @@
             <a:pPr algn="l">
               <a:defRPr sz="1725" b="1">
                 <a:solidFill>
-                  <a:srgbClr val="334155"/>
+                  <a:srgbClr val="7F1D1D"/>
                 </a:solidFill>
                 <a:latin typeface="Helvetica Neue"/>
                 <a:ea typeface="Helvetica Neue"/>
@@ -7851,7 +7851,7 @@
             <a:r>
               <a:rPr sz="1725" b="1">
                 <a:solidFill>
-                  <a:srgbClr val="334155"/>
+                  <a:srgbClr val="7F1D1D"/>
                 </a:solidFill>
                 <a:latin typeface="Helvetica Neue"/>
                 <a:ea typeface="Helvetica Neue"/>
@@ -7867,7 +7867,7 @@
           <p:cNvPr id="42" name="">
             <a:extLst xmlns:a="http://schemas.openxmlformats.org/drawingml/2006/main">
               <a:ext uri="{FF2B5EF4-FFF2-40B4-BE49-F238E27FC236}">
-                <a16:creationId xmlns:a16="http://schemas.microsoft.com/office/drawing/2014/main" id="{F82C7011-4DD2-4633-AA79-003590F50BF8}"/>
+                <a16:creationId xmlns:a16="http://schemas.microsoft.com/office/drawing/2014/main" id="{09F2F8ED-7A2D-4B68-9781-42FAF8EC535F}"/>
               </a:ext>
             </a:extLst>
           </p:cNvPr>
@@ -7925,7 +7925,7 @@
           <p:cNvPr id="43" name="">
             <a:extLst xmlns:a="http://schemas.openxmlformats.org/drawingml/2006/main">
               <a:ext uri="{FF2B5EF4-FFF2-40B4-BE49-F238E27FC236}">
-                <a16:creationId xmlns:a16="http://schemas.microsoft.com/office/drawing/2014/main" id="{BFA12C8E-6C14-4EBC-8BB9-BECE3A578BEC}"/>
+                <a16:creationId xmlns:a16="http://schemas.microsoft.com/office/drawing/2014/main" id="{F5A231C2-D41E-437A-BCA9-4C89EF0893B8}"/>
               </a:ext>
             </a:extLst>
           </p:cNvPr>
@@ -7956,7 +7956,7 @@
           <p:cNvPr id="44" name="">
             <a:extLst xmlns:a="http://schemas.openxmlformats.org/drawingml/2006/main">
               <a:ext uri="{FF2B5EF4-FFF2-40B4-BE49-F238E27FC236}">
-                <a16:creationId xmlns:a16="http://schemas.microsoft.com/office/drawing/2014/main" id="{BAF16DBE-AF0E-4239-9549-4C47282E4680}"/>
+                <a16:creationId xmlns:a16="http://schemas.microsoft.com/office/drawing/2014/main" id="{B5F4BDA3-6E20-4030-9FFB-0C2BB7E89E90}"/>
               </a:ext>
             </a:extLst>
           </p:cNvPr>
@@ -8014,7 +8014,7 @@
           <p:cNvPr id="45" name="">
             <a:extLst xmlns:a="http://schemas.openxmlformats.org/drawingml/2006/main">
               <a:ext uri="{FF2B5EF4-FFF2-40B4-BE49-F238E27FC236}">
-                <a16:creationId xmlns:a16="http://schemas.microsoft.com/office/drawing/2014/main" id="{CF83D383-44FE-4BC7-9479-BC3D1496200B}"/>
+                <a16:creationId xmlns:a16="http://schemas.microsoft.com/office/drawing/2014/main" id="{B6D07FEF-D7F4-4B86-9ECB-48590DC39EEF}"/>
               </a:ext>
             </a:extLst>
           </p:cNvPr>
@@ -8070,7 +8070,7 @@
     </p:spTree>
     <p:extLst>
       <p:ext uri="{BB962C8B-B14F-4D97-AF65-F5344CB8AC3E}">
-        <p14:creationId xmlns:p14="http://schemas.microsoft.com/office/powerpoint/2010/main" val="1996609993"/>
+        <p14:creationId xmlns:p14="http://schemas.microsoft.com/office/powerpoint/2010/main" val="552952581"/>
       </p:ext>
     </p:extLst>
   </p:cSld>

</xml_diff>

<commit_message>
Show harness signals in scenario deck
</commit_message>
<xml_diff>
--- a/presentation/harness_aware_scenario_results_master.pptx
+++ b/presentation/harness_aware_scenario_results_master.pptx
@@ -2,15 +2,15 @@
 <file path=ppt/presentation.xml><?xml version="1.0" encoding="utf-8"?>
 <p:presentation xmlns:p="http://schemas.openxmlformats.org/presentationml/2006/main">
   <p:sldMasterIdLst>
-    <p:sldMasterId xmlns:r="http://schemas.openxmlformats.org/officeDocument/2006/relationships" id="2147483648" r:id="Ra1db504f55eb4c31"/>
+    <p:sldMasterId xmlns:r="http://schemas.openxmlformats.org/officeDocument/2006/relationships" id="2147483648" r:id="R10a245d2f69f46c7"/>
   </p:sldMasterIdLst>
   <p:notesMasterIdLst>
-    <p:notesMasterId xmlns:r="http://schemas.openxmlformats.org/officeDocument/2006/relationships" r:id="Rcc61203fe8db4e01"/>
+    <p:notesMasterId xmlns:r="http://schemas.openxmlformats.org/officeDocument/2006/relationships" r:id="Rafaff5f36abb4cb7"/>
   </p:notesMasterIdLst>
   <p:sldIdLst>
-    <p:sldId xmlns:r="http://schemas.openxmlformats.org/officeDocument/2006/relationships" id="256" r:id="R1d73b7ad6b7a4f0c"/>
-    <p:sldId xmlns:r="http://schemas.openxmlformats.org/officeDocument/2006/relationships" id="257" r:id="R4d00ed3613d54671"/>
-    <p:sldId xmlns:r="http://schemas.openxmlformats.org/officeDocument/2006/relationships" id="258" r:id="R731de0f5a89a4790"/>
+    <p:sldId xmlns:r="http://schemas.openxmlformats.org/officeDocument/2006/relationships" id="256" r:id="R9c03230f92d54e19"/>
+    <p:sldId xmlns:r="http://schemas.openxmlformats.org/officeDocument/2006/relationships" id="257" r:id="Rb50ecf08e1454e1d"/>
+    <p:sldId xmlns:r="http://schemas.openxmlformats.org/officeDocument/2006/relationships" id="258" r:id="R4f1fb68c7cf54ee2"/>
   </p:sldIdLst>
   <p:sldSz cx="12192000" cy="6858000"/>
   <p:notesSz cx="6858000" cy="9144000"/>
@@ -827,7 +827,7 @@
   </p:cSld>
   <p:clrMap bg1="lt1" tx1="dk1" bg2="lt2" tx2="dk2" accent1="accent1" accent2="accent2" accent3="accent3" accent4="accent4" accent5="accent5" accent6="accent6" hlink="hlink" folHlink="folHlink"/>
   <p:sldLayoutIdLst>
-    <p:sldLayoutId xmlns:r="http://schemas.openxmlformats.org/officeDocument/2006/relationships" id="2147483649" r:id="Rc2f7c7e734574f95"/>
+    <p:sldLayoutId xmlns:r="http://schemas.openxmlformats.org/officeDocument/2006/relationships" id="2147483649" r:id="Rfc56408c10b74417"/>
   </p:sldLayoutIdLst>
   <p:txStyles>
     <p:titleStyle>
@@ -1378,7 +1378,7 @@
           <p:cNvPr id="42" name="">
             <a:extLst xmlns:a="http://schemas.openxmlformats.org/drawingml/2006/main">
               <a:ext uri="{FF2B5EF4-FFF2-40B4-BE49-F238E27FC236}">
-                <a16:creationId xmlns:a16="http://schemas.microsoft.com/office/drawing/2014/main" id="{801EB77E-1566-49A4-9685-E72A6FF6D68E}"/>
+                <a16:creationId xmlns:a16="http://schemas.microsoft.com/office/drawing/2014/main" id="{351CBF5E-A5FE-4967-BD90-4976E6A95CC4}"/>
               </a:ext>
             </a:extLst>
           </p:cNvPr>
@@ -1436,7 +1436,7 @@
           <p:cNvPr id="2" name="">
             <a:extLst xmlns:a="http://schemas.openxmlformats.org/drawingml/2006/main">
               <a:ext uri="{FF2B5EF4-FFF2-40B4-BE49-F238E27FC236}">
-                <a16:creationId xmlns:a16="http://schemas.microsoft.com/office/drawing/2014/main" id="{EB6148C7-63A2-495D-BCCF-C07D285D24A5}"/>
+                <a16:creationId xmlns:a16="http://schemas.microsoft.com/office/drawing/2014/main" id="{D0EBDD80-F7D3-429E-9555-8B7790B0667C}"/>
               </a:ext>
             </a:extLst>
           </p:cNvPr>
@@ -1494,7 +1494,7 @@
           <p:cNvPr id="3" name="">
             <a:extLst xmlns:a="http://schemas.openxmlformats.org/drawingml/2006/main">
               <a:ext uri="{FF2B5EF4-FFF2-40B4-BE49-F238E27FC236}">
-                <a16:creationId xmlns:a16="http://schemas.microsoft.com/office/drawing/2014/main" id="{38368425-228A-4AD9-8D6C-E8ABD085EAF9}"/>
+                <a16:creationId xmlns:a16="http://schemas.microsoft.com/office/drawing/2014/main" id="{F8FE4A39-DDAB-47FE-8C76-653EA7F5BC37}"/>
               </a:ext>
             </a:extLst>
           </p:cNvPr>
@@ -1552,7 +1552,7 @@
           <p:cNvPr id="4" name="">
             <a:extLst xmlns:a="http://schemas.openxmlformats.org/drawingml/2006/main">
               <a:ext uri="{FF2B5EF4-FFF2-40B4-BE49-F238E27FC236}">
-                <a16:creationId xmlns:a16="http://schemas.microsoft.com/office/drawing/2014/main" id="{6CFFC6C1-A16E-40E4-8DD1-DDAF37A72EFB}"/>
+                <a16:creationId xmlns:a16="http://schemas.microsoft.com/office/drawing/2014/main" id="{B2BE20B3-5D5F-4FE0-9F12-DAA29906AAE4}"/>
               </a:ext>
             </a:extLst>
           </p:cNvPr>
@@ -1583,7 +1583,7 @@
           <p:cNvPr id="5" name="">
             <a:extLst xmlns:a="http://schemas.openxmlformats.org/drawingml/2006/main">
               <a:ext uri="{FF2B5EF4-FFF2-40B4-BE49-F238E27FC236}">
-                <a16:creationId xmlns:a16="http://schemas.microsoft.com/office/drawing/2014/main" id="{6D93678A-5656-4530-B35C-D21274BEEFF9}"/>
+                <a16:creationId xmlns:a16="http://schemas.microsoft.com/office/drawing/2014/main" id="{96061511-120F-4498-890E-555FD8DC7E48}"/>
               </a:ext>
             </a:extLst>
           </p:cNvPr>
@@ -1641,7 +1641,7 @@
           <p:cNvPr id="6" name="">
             <a:extLst xmlns:a="http://schemas.openxmlformats.org/drawingml/2006/main">
               <a:ext uri="{FF2B5EF4-FFF2-40B4-BE49-F238E27FC236}">
-                <a16:creationId xmlns:a16="http://schemas.microsoft.com/office/drawing/2014/main" id="{82D49B1B-4CE7-455F-B682-84470D9593B9}"/>
+                <a16:creationId xmlns:a16="http://schemas.microsoft.com/office/drawing/2014/main" id="{2647319C-4DED-4325-ADC4-D5A01E41F27A}"/>
               </a:ext>
             </a:extLst>
           </p:cNvPr>
@@ -1674,7 +1674,7 @@
           <p:cNvPr id="7" name="">
             <a:extLst xmlns:a="http://schemas.openxmlformats.org/drawingml/2006/main">
               <a:ext uri="{FF2B5EF4-FFF2-40B4-BE49-F238E27FC236}">
-                <a16:creationId xmlns:a16="http://schemas.microsoft.com/office/drawing/2014/main" id="{1988A3AC-DE11-405D-BB01-D9C6722104C0}"/>
+                <a16:creationId xmlns:a16="http://schemas.microsoft.com/office/drawing/2014/main" id="{B84B0E55-834B-4942-BAE1-344B231EC40B}"/>
               </a:ext>
             </a:extLst>
           </p:cNvPr>
@@ -1732,7 +1732,7 @@
           <p:cNvPr id="8" name="">
             <a:extLst xmlns:a="http://schemas.openxmlformats.org/drawingml/2006/main">
               <a:ext uri="{FF2B5EF4-FFF2-40B4-BE49-F238E27FC236}">
-                <a16:creationId xmlns:a16="http://schemas.microsoft.com/office/drawing/2014/main" id="{5C2ED572-7291-44DD-A49A-48713C4A523D}"/>
+                <a16:creationId xmlns:a16="http://schemas.microsoft.com/office/drawing/2014/main" id="{B8843939-FA4C-47E6-9D3C-54691A9E6ACA}"/>
               </a:ext>
             </a:extLst>
           </p:cNvPr>
@@ -1765,7 +1765,7 @@
           <p:cNvPr id="9" name="">
             <a:extLst xmlns:a="http://schemas.openxmlformats.org/drawingml/2006/main">
               <a:ext uri="{FF2B5EF4-FFF2-40B4-BE49-F238E27FC236}">
-                <a16:creationId xmlns:a16="http://schemas.microsoft.com/office/drawing/2014/main" id="{CDFBC1A4-824B-4495-AC34-C522E494DDE5}"/>
+                <a16:creationId xmlns:a16="http://schemas.microsoft.com/office/drawing/2014/main" id="{4A328FAF-A715-4B1E-8FE5-25B8194E0A0B}"/>
               </a:ext>
             </a:extLst>
           </p:cNvPr>
@@ -1823,7 +1823,7 @@
           <p:cNvPr id="10" name="">
             <a:extLst xmlns:a="http://schemas.openxmlformats.org/drawingml/2006/main">
               <a:ext uri="{FF2B5EF4-FFF2-40B4-BE49-F238E27FC236}">
-                <a16:creationId xmlns:a16="http://schemas.microsoft.com/office/drawing/2014/main" id="{E51857F0-0691-4CE6-85C6-E2AD21899EB2}"/>
+                <a16:creationId xmlns:a16="http://schemas.microsoft.com/office/drawing/2014/main" id="{711A868D-C769-4D6A-9561-CAAB687A5242}"/>
               </a:ext>
             </a:extLst>
           </p:cNvPr>
@@ -1856,7 +1856,7 @@
           <p:cNvPr id="11" name="">
             <a:extLst xmlns:a="http://schemas.openxmlformats.org/drawingml/2006/main">
               <a:ext uri="{FF2B5EF4-FFF2-40B4-BE49-F238E27FC236}">
-                <a16:creationId xmlns:a16="http://schemas.microsoft.com/office/drawing/2014/main" id="{A30198A4-C24B-4064-BCEB-E4CC6145857D}"/>
+                <a16:creationId xmlns:a16="http://schemas.microsoft.com/office/drawing/2014/main" id="{77ADCDE7-C0F0-4E7B-A0E4-64493B51C9DC}"/>
               </a:ext>
             </a:extLst>
           </p:cNvPr>
@@ -1914,7 +1914,7 @@
           <p:cNvPr id="12" name="">
             <a:extLst xmlns:a="http://schemas.openxmlformats.org/drawingml/2006/main">
               <a:ext uri="{FF2B5EF4-FFF2-40B4-BE49-F238E27FC236}">
-                <a16:creationId xmlns:a16="http://schemas.microsoft.com/office/drawing/2014/main" id="{016C033A-6DC6-4777-98C3-D2F00849887D}"/>
+                <a16:creationId xmlns:a16="http://schemas.microsoft.com/office/drawing/2014/main" id="{57CC7EA0-9024-49D3-959F-8FE1F9453675}"/>
               </a:ext>
             </a:extLst>
           </p:cNvPr>
@@ -1947,7 +1947,7 @@
           <p:cNvPr id="13" name="">
             <a:extLst xmlns:a="http://schemas.openxmlformats.org/drawingml/2006/main">
               <a:ext uri="{FF2B5EF4-FFF2-40B4-BE49-F238E27FC236}">
-                <a16:creationId xmlns:a16="http://schemas.microsoft.com/office/drawing/2014/main" id="{A4FE9A18-1214-44C3-A95A-40FE532E3D50}"/>
+                <a16:creationId xmlns:a16="http://schemas.microsoft.com/office/drawing/2014/main" id="{24712C2E-AB57-4D17-A349-33BEA65F7324}"/>
               </a:ext>
             </a:extLst>
           </p:cNvPr>
@@ -2005,7 +2005,7 @@
           <p:cNvPr id="14" name="">
             <a:extLst xmlns:a="http://schemas.openxmlformats.org/drawingml/2006/main">
               <a:ext uri="{FF2B5EF4-FFF2-40B4-BE49-F238E27FC236}">
-                <a16:creationId xmlns:a16="http://schemas.microsoft.com/office/drawing/2014/main" id="{DAE09535-3119-4871-B249-11EDBC19B9E8}"/>
+                <a16:creationId xmlns:a16="http://schemas.microsoft.com/office/drawing/2014/main" id="{810D290F-5C27-4F6E-A6F5-B2FB9DDD5455}"/>
               </a:ext>
             </a:extLst>
           </p:cNvPr>
@@ -2038,7 +2038,7 @@
           <p:cNvPr id="15" name="">
             <a:extLst xmlns:a="http://schemas.openxmlformats.org/drawingml/2006/main">
               <a:ext uri="{FF2B5EF4-FFF2-40B4-BE49-F238E27FC236}">
-                <a16:creationId xmlns:a16="http://schemas.microsoft.com/office/drawing/2014/main" id="{4D8101FE-7DEF-4842-90D3-CEF5C1661227}"/>
+                <a16:creationId xmlns:a16="http://schemas.microsoft.com/office/drawing/2014/main" id="{350F4ECD-3AF1-41B8-96D3-8415E7047EA1}"/>
               </a:ext>
             </a:extLst>
           </p:cNvPr>
@@ -2096,7 +2096,7 @@
           <p:cNvPr id="16" name="">
             <a:extLst xmlns:a="http://schemas.openxmlformats.org/drawingml/2006/main">
               <a:ext uri="{FF2B5EF4-FFF2-40B4-BE49-F238E27FC236}">
-                <a16:creationId xmlns:a16="http://schemas.microsoft.com/office/drawing/2014/main" id="{1359DD1A-5771-47FF-BE57-E0A53E4B1724}"/>
+                <a16:creationId xmlns:a16="http://schemas.microsoft.com/office/drawing/2014/main" id="{6560C1D4-792E-4F02-A357-821428105473}"/>
               </a:ext>
             </a:extLst>
           </p:cNvPr>
@@ -2154,7 +2154,7 @@
           <p:cNvPr id="17" name="">
             <a:extLst xmlns:a="http://schemas.openxmlformats.org/drawingml/2006/main">
               <a:ext uri="{FF2B5EF4-FFF2-40B4-BE49-F238E27FC236}">
-                <a16:creationId xmlns:a16="http://schemas.microsoft.com/office/drawing/2014/main" id="{E2A8B5D1-0D5F-48BE-8E3C-049C5D8DEF6A}"/>
+                <a16:creationId xmlns:a16="http://schemas.microsoft.com/office/drawing/2014/main" id="{9B3A69C4-5406-427E-A145-7DFF9B3FD7BE}"/>
               </a:ext>
             </a:extLst>
           </p:cNvPr>
@@ -2212,7 +2212,7 @@
           <p:cNvPr id="18" name="">
             <a:extLst xmlns:a="http://schemas.openxmlformats.org/drawingml/2006/main">
               <a:ext uri="{FF2B5EF4-FFF2-40B4-BE49-F238E27FC236}">
-                <a16:creationId xmlns:a16="http://schemas.microsoft.com/office/drawing/2014/main" id="{6C844DBD-E477-48B0-B88E-A977650AC04B}"/>
+                <a16:creationId xmlns:a16="http://schemas.microsoft.com/office/drawing/2014/main" id="{6AC2C310-6E3C-4042-8B23-583A2A3ED0E5}"/>
               </a:ext>
             </a:extLst>
           </p:cNvPr>
@@ -2270,7 +2270,7 @@
           <p:cNvPr id="19" name="">
             <a:extLst xmlns:a="http://schemas.openxmlformats.org/drawingml/2006/main">
               <a:ext uri="{FF2B5EF4-FFF2-40B4-BE49-F238E27FC236}">
-                <a16:creationId xmlns:a16="http://schemas.microsoft.com/office/drawing/2014/main" id="{E2318A49-D7AC-427F-971B-15BA42C220B9}"/>
+                <a16:creationId xmlns:a16="http://schemas.microsoft.com/office/drawing/2014/main" id="{E923956B-BA24-4F82-8B22-AEA63776EA93}"/>
               </a:ext>
             </a:extLst>
           </p:cNvPr>
@@ -2303,7 +2303,7 @@
           <p:cNvPr id="20" name="">
             <a:extLst xmlns:a="http://schemas.openxmlformats.org/drawingml/2006/main">
               <a:ext uri="{FF2B5EF4-FFF2-40B4-BE49-F238E27FC236}">
-                <a16:creationId xmlns:a16="http://schemas.microsoft.com/office/drawing/2014/main" id="{8C788D18-DE5C-4432-95CD-0C3C77A9F790}"/>
+                <a16:creationId xmlns:a16="http://schemas.microsoft.com/office/drawing/2014/main" id="{77091770-4741-4BEE-B494-7E4ABA18BDCB}"/>
               </a:ext>
             </a:extLst>
           </p:cNvPr>
@@ -2361,7 +2361,7 @@
           <p:cNvPr id="21" name="">
             <a:extLst xmlns:a="http://schemas.openxmlformats.org/drawingml/2006/main">
               <a:ext uri="{FF2B5EF4-FFF2-40B4-BE49-F238E27FC236}">
-                <a16:creationId xmlns:a16="http://schemas.microsoft.com/office/drawing/2014/main" id="{3FF9124D-323C-420D-8105-187FB3286750}"/>
+                <a16:creationId xmlns:a16="http://schemas.microsoft.com/office/drawing/2014/main" id="{0AD94024-BDD7-429B-B784-033B1F92B2F1}"/>
               </a:ext>
             </a:extLst>
           </p:cNvPr>
@@ -2419,7 +2419,7 @@
           <p:cNvPr id="22" name="">
             <a:extLst xmlns:a="http://schemas.openxmlformats.org/drawingml/2006/main">
               <a:ext uri="{FF2B5EF4-FFF2-40B4-BE49-F238E27FC236}">
-                <a16:creationId xmlns:a16="http://schemas.microsoft.com/office/drawing/2014/main" id="{B8D15C29-9505-49ED-A37F-BFF7F3A5F95E}"/>
+                <a16:creationId xmlns:a16="http://schemas.microsoft.com/office/drawing/2014/main" id="{EB2B8E07-D0E9-4FAD-A2CC-C1D3D18E6CFE}"/>
               </a:ext>
             </a:extLst>
           </p:cNvPr>
@@ -2477,7 +2477,7 @@
           <p:cNvPr id="23" name="">
             <a:extLst xmlns:a="http://schemas.openxmlformats.org/drawingml/2006/main">
               <a:ext uri="{FF2B5EF4-FFF2-40B4-BE49-F238E27FC236}">
-                <a16:creationId xmlns:a16="http://schemas.microsoft.com/office/drawing/2014/main" id="{960ECA07-24A0-4A51-BBF3-D79F9CE2CCF8}"/>
+                <a16:creationId xmlns:a16="http://schemas.microsoft.com/office/drawing/2014/main" id="{AA50A1FD-63B0-4083-9D76-E3F66DDD21BF}"/>
               </a:ext>
             </a:extLst>
           </p:cNvPr>
@@ -2510,7 +2510,7 @@
           <p:cNvPr id="24" name="">
             <a:extLst xmlns:a="http://schemas.openxmlformats.org/drawingml/2006/main">
               <a:ext uri="{FF2B5EF4-FFF2-40B4-BE49-F238E27FC236}">
-                <a16:creationId xmlns:a16="http://schemas.microsoft.com/office/drawing/2014/main" id="{895B3299-83CD-4D8A-BEA0-E443FD655104}"/>
+                <a16:creationId xmlns:a16="http://schemas.microsoft.com/office/drawing/2014/main" id="{5605468B-8F0C-443E-8C3A-5CC61FD564EC}"/>
               </a:ext>
             </a:extLst>
           </p:cNvPr>
@@ -2568,7 +2568,7 @@
           <p:cNvPr id="25" name="">
             <a:extLst xmlns:a="http://schemas.openxmlformats.org/drawingml/2006/main">
               <a:ext uri="{FF2B5EF4-FFF2-40B4-BE49-F238E27FC236}">
-                <a16:creationId xmlns:a16="http://schemas.microsoft.com/office/drawing/2014/main" id="{A0D70C18-4F5B-4C97-A11F-BC08E5329440}"/>
+                <a16:creationId xmlns:a16="http://schemas.microsoft.com/office/drawing/2014/main" id="{021762E1-0AE6-43FE-8C90-D41485A257D4}"/>
               </a:ext>
             </a:extLst>
           </p:cNvPr>
@@ -2626,7 +2626,7 @@
           <p:cNvPr id="26" name="">
             <a:extLst xmlns:a="http://schemas.openxmlformats.org/drawingml/2006/main">
               <a:ext uri="{FF2B5EF4-FFF2-40B4-BE49-F238E27FC236}">
-                <a16:creationId xmlns:a16="http://schemas.microsoft.com/office/drawing/2014/main" id="{941F5798-0097-4EAE-A5C2-0772884B500E}"/>
+                <a16:creationId xmlns:a16="http://schemas.microsoft.com/office/drawing/2014/main" id="{D4251926-0D85-463E-A38C-44BAA00A64EB}"/>
               </a:ext>
             </a:extLst>
           </p:cNvPr>
@@ -2684,7 +2684,7 @@
           <p:cNvPr id="27" name="">
             <a:extLst xmlns:a="http://schemas.openxmlformats.org/drawingml/2006/main">
               <a:ext uri="{FF2B5EF4-FFF2-40B4-BE49-F238E27FC236}">
-                <a16:creationId xmlns:a16="http://schemas.microsoft.com/office/drawing/2014/main" id="{7C36E52E-AB72-477D-9BC0-E2B496ACDDCB}"/>
+                <a16:creationId xmlns:a16="http://schemas.microsoft.com/office/drawing/2014/main" id="{1D678412-E07D-435E-8BBF-78363DE03E11}"/>
               </a:ext>
             </a:extLst>
           </p:cNvPr>
@@ -2717,7 +2717,7 @@
           <p:cNvPr id="28" name="">
             <a:extLst xmlns:a="http://schemas.openxmlformats.org/drawingml/2006/main">
               <a:ext uri="{FF2B5EF4-FFF2-40B4-BE49-F238E27FC236}">
-                <a16:creationId xmlns:a16="http://schemas.microsoft.com/office/drawing/2014/main" id="{34EECF94-00D1-47C1-B685-E0920EEB821F}"/>
+                <a16:creationId xmlns:a16="http://schemas.microsoft.com/office/drawing/2014/main" id="{FBF3D323-A5A8-463C-A2E0-ABC27EBB5E14}"/>
               </a:ext>
             </a:extLst>
           </p:cNvPr>
@@ -2775,7 +2775,7 @@
           <p:cNvPr id="29" name="">
             <a:extLst xmlns:a="http://schemas.openxmlformats.org/drawingml/2006/main">
               <a:ext uri="{FF2B5EF4-FFF2-40B4-BE49-F238E27FC236}">
-                <a16:creationId xmlns:a16="http://schemas.microsoft.com/office/drawing/2014/main" id="{7196E3B4-409E-4A92-A313-7C9459622750}"/>
+                <a16:creationId xmlns:a16="http://schemas.microsoft.com/office/drawing/2014/main" id="{266EB6CA-B95F-4CB9-A341-975CC3A3F0B3}"/>
               </a:ext>
             </a:extLst>
           </p:cNvPr>
@@ -2833,7 +2833,7 @@
           <p:cNvPr id="30" name="">
             <a:extLst xmlns:a="http://schemas.openxmlformats.org/drawingml/2006/main">
               <a:ext uri="{FF2B5EF4-FFF2-40B4-BE49-F238E27FC236}">
-                <a16:creationId xmlns:a16="http://schemas.microsoft.com/office/drawing/2014/main" id="{BA88E524-A9A2-40B0-8C9A-B57AC1A6889D}"/>
+                <a16:creationId xmlns:a16="http://schemas.microsoft.com/office/drawing/2014/main" id="{DF650663-0A09-4BA9-9372-F1237FE85E28}"/>
               </a:ext>
             </a:extLst>
           </p:cNvPr>
@@ -2891,7 +2891,7 @@
           <p:cNvPr id="31" name="">
             <a:extLst xmlns:a="http://schemas.openxmlformats.org/drawingml/2006/main">
               <a:ext uri="{FF2B5EF4-FFF2-40B4-BE49-F238E27FC236}">
-                <a16:creationId xmlns:a16="http://schemas.microsoft.com/office/drawing/2014/main" id="{9D656E4B-4142-45D1-BAA9-A0BC54693742}"/>
+                <a16:creationId xmlns:a16="http://schemas.microsoft.com/office/drawing/2014/main" id="{4E30C288-1FE1-441C-B3FA-9AD5C73ECE32}"/>
               </a:ext>
             </a:extLst>
           </p:cNvPr>
@@ -2924,7 +2924,7 @@
           <p:cNvPr id="32" name="">
             <a:extLst xmlns:a="http://schemas.openxmlformats.org/drawingml/2006/main">
               <a:ext uri="{FF2B5EF4-FFF2-40B4-BE49-F238E27FC236}">
-                <a16:creationId xmlns:a16="http://schemas.microsoft.com/office/drawing/2014/main" id="{8DF10837-69FE-4D46-B845-62B3C8185744}"/>
+                <a16:creationId xmlns:a16="http://schemas.microsoft.com/office/drawing/2014/main" id="{72CAEF76-E4DF-4090-93CA-D7B7F4797AE0}"/>
               </a:ext>
             </a:extLst>
           </p:cNvPr>
@@ -2982,7 +2982,7 @@
           <p:cNvPr id="33" name="">
             <a:extLst xmlns:a="http://schemas.openxmlformats.org/drawingml/2006/main">
               <a:ext uri="{FF2B5EF4-FFF2-40B4-BE49-F238E27FC236}">
-                <a16:creationId xmlns:a16="http://schemas.microsoft.com/office/drawing/2014/main" id="{B650DA0D-C0AB-4A18-8CF0-D65D5C9D7640}"/>
+                <a16:creationId xmlns:a16="http://schemas.microsoft.com/office/drawing/2014/main" id="{0A606A53-88D3-4E4B-B990-66E8275D1FF9}"/>
               </a:ext>
             </a:extLst>
           </p:cNvPr>
@@ -3040,7 +3040,7 @@
           <p:cNvPr id="34" name="">
             <a:extLst xmlns:a="http://schemas.openxmlformats.org/drawingml/2006/main">
               <a:ext uri="{FF2B5EF4-FFF2-40B4-BE49-F238E27FC236}">
-                <a16:creationId xmlns:a16="http://schemas.microsoft.com/office/drawing/2014/main" id="{76D33D72-902B-48F7-B245-CE8216CA801C}"/>
+                <a16:creationId xmlns:a16="http://schemas.microsoft.com/office/drawing/2014/main" id="{C06F47DF-8B5D-43EF-B02E-F0C8DC7B18DB}"/>
               </a:ext>
             </a:extLst>
           </p:cNvPr>
@@ -3098,7 +3098,7 @@
           <p:cNvPr id="35" name="">
             <a:extLst xmlns:a="http://schemas.openxmlformats.org/drawingml/2006/main">
               <a:ext uri="{FF2B5EF4-FFF2-40B4-BE49-F238E27FC236}">
-                <a16:creationId xmlns:a16="http://schemas.microsoft.com/office/drawing/2014/main" id="{8BBEBA62-D3A1-48EF-8BDB-6925681A54C6}"/>
+                <a16:creationId xmlns:a16="http://schemas.microsoft.com/office/drawing/2014/main" id="{C1264C39-C0E5-4020-8E33-8971067DCEAE}"/>
               </a:ext>
             </a:extLst>
           </p:cNvPr>
@@ -3131,7 +3131,7 @@
           <p:cNvPr id="36" name="">
             <a:extLst xmlns:a="http://schemas.openxmlformats.org/drawingml/2006/main">
               <a:ext uri="{FF2B5EF4-FFF2-40B4-BE49-F238E27FC236}">
-                <a16:creationId xmlns:a16="http://schemas.microsoft.com/office/drawing/2014/main" id="{B40DF8CD-3532-46CE-9C13-70E85119708D}"/>
+                <a16:creationId xmlns:a16="http://schemas.microsoft.com/office/drawing/2014/main" id="{170EA3D8-4982-4C8C-8C64-193BB909B447}"/>
               </a:ext>
             </a:extLst>
           </p:cNvPr>
@@ -3189,7 +3189,7 @@
           <p:cNvPr id="37" name="">
             <a:extLst xmlns:a="http://schemas.openxmlformats.org/drawingml/2006/main">
               <a:ext uri="{FF2B5EF4-FFF2-40B4-BE49-F238E27FC236}">
-                <a16:creationId xmlns:a16="http://schemas.microsoft.com/office/drawing/2014/main" id="{2F397AB8-D9F5-47C5-8BF0-9D76FEEA0972}"/>
+                <a16:creationId xmlns:a16="http://schemas.microsoft.com/office/drawing/2014/main" id="{9E423F39-2720-4FF0-AD5B-1BAF907E6640}"/>
               </a:ext>
             </a:extLst>
           </p:cNvPr>
@@ -3247,7 +3247,7 @@
           <p:cNvPr id="38" name="">
             <a:extLst xmlns:a="http://schemas.openxmlformats.org/drawingml/2006/main">
               <a:ext uri="{FF2B5EF4-FFF2-40B4-BE49-F238E27FC236}">
-                <a16:creationId xmlns:a16="http://schemas.microsoft.com/office/drawing/2014/main" id="{DDC42009-7DF8-476B-A05D-8255ED0F89C6}"/>
+                <a16:creationId xmlns:a16="http://schemas.microsoft.com/office/drawing/2014/main" id="{CF6C9CC6-1D0B-49E0-BC94-BD04FA452B20}"/>
               </a:ext>
             </a:extLst>
           </p:cNvPr>
@@ -3305,7 +3305,7 @@
           <p:cNvPr id="39" name="">
             <a:extLst xmlns:a="http://schemas.openxmlformats.org/drawingml/2006/main">
               <a:ext uri="{FF2B5EF4-FFF2-40B4-BE49-F238E27FC236}">
-                <a16:creationId xmlns:a16="http://schemas.microsoft.com/office/drawing/2014/main" id="{77F7AD42-6CA9-4E22-A5B1-84A4AC9F9A4D}"/>
+                <a16:creationId xmlns:a16="http://schemas.microsoft.com/office/drawing/2014/main" id="{1A63C2C7-C7C6-4750-9B41-8BC34BDDCB99}"/>
               </a:ext>
             </a:extLst>
           </p:cNvPr>
@@ -3336,7 +3336,7 @@
           <p:cNvPr id="40" name="">
             <a:extLst xmlns:a="http://schemas.openxmlformats.org/drawingml/2006/main">
               <a:ext uri="{FF2B5EF4-FFF2-40B4-BE49-F238E27FC236}">
-                <a16:creationId xmlns:a16="http://schemas.microsoft.com/office/drawing/2014/main" id="{AF63F025-7136-43F5-9BF2-0C8DD4F39169}"/>
+                <a16:creationId xmlns:a16="http://schemas.microsoft.com/office/drawing/2014/main" id="{3B2EF161-C74B-4148-AB6F-257CE2FFF8F1}"/>
               </a:ext>
             </a:extLst>
           </p:cNvPr>
@@ -3348,7 +3348,7 @@
         <p:spPr>
           <a:xfrm xmlns:a="http://schemas.openxmlformats.org/drawingml/2006/main">
             <a:off x="628650" y="5791200"/>
-            <a:ext cx="1333500" cy="266700"/>
+            <a:ext cx="1809750" cy="266700"/>
           </a:xfrm>
           <a:prstGeom xmlns:a="http://schemas.openxmlformats.org/drawingml/2006/main" prst="rect">
             <a:avLst/>
@@ -3384,7 +3384,7 @@
                 <a:ea typeface="Helvetica Neue"/>
                 <a:cs typeface="Helvetica Neue"/>
               </a:rPr>
-              <a:t>Takeaway</a:t>
+              <a:t>Harness signals</a:t>
             </a:r>
           </a:p>
         </p:txBody>
@@ -3394,37 +3394,37 @@
           <p:cNvPr id="41" name="">
             <a:extLst xmlns:a="http://schemas.openxmlformats.org/drawingml/2006/main">
               <a:ext uri="{FF2B5EF4-FFF2-40B4-BE49-F238E27FC236}">
-                <a16:creationId xmlns:a16="http://schemas.microsoft.com/office/drawing/2014/main" id="{D0C47DE3-8475-41BB-81AC-161FE4528C71}"/>
-              </a:ext>
-            </a:extLst>
-          </p:cNvPr>
-          <p:cNvSpPr>
-            <a:spLocks xmlns:a="http://schemas.openxmlformats.org/drawingml/2006/main" noGrp="1"/>
-          </p:cNvSpPr>
-          <p:nvPr/>
-        </p:nvSpPr>
-        <p:spPr>
-          <a:xfrm xmlns:a="http://schemas.openxmlformats.org/drawingml/2006/main">
-            <a:off x="1962150" y="5791200"/>
-            <a:ext cx="8572500" cy="361950"/>
-          </a:xfrm>
-          <a:prstGeom xmlns:a="http://schemas.openxmlformats.org/drawingml/2006/main" prst="rect">
-            <a:avLst/>
-          </a:prstGeom>
-          <a:noFill xmlns:a="http://schemas.openxmlformats.org/drawingml/2006/main"/>
-          <a:ln xmlns:a="http://schemas.openxmlformats.org/drawingml/2006/main" w="0">
-            <a:noFill/>
-            <a:prstDash val="solid"/>
-          </a:ln>
-        </p:spPr>
-        <p:txBody>
-          <a:bodyPr xmlns:a="http://schemas.openxmlformats.org/drawingml/2006/main" anchor="t">
-            <a:noAutofit/>
-          </a:bodyPr>
-          <a:lstStyle xmlns:a="http://schemas.openxmlformats.org/drawingml/2006/main"/>
-          <a:p xmlns:a="http://schemas.openxmlformats.org/drawingml/2006/main">
-            <a:pPr algn="l">
-              <a:defRPr sz="1575" b="1">
+                <a16:creationId xmlns:a16="http://schemas.microsoft.com/office/drawing/2014/main" id="{CEF2A735-1B23-493E-A1C5-3CDE9A112A6D}"/>
+              </a:ext>
+            </a:extLst>
+          </p:cNvPr>
+          <p:cNvSpPr>
+            <a:spLocks xmlns:a="http://schemas.openxmlformats.org/drawingml/2006/main" noGrp="1"/>
+          </p:cNvSpPr>
+          <p:nvPr/>
+        </p:nvSpPr>
+        <p:spPr>
+          <a:xfrm xmlns:a="http://schemas.openxmlformats.org/drawingml/2006/main">
+            <a:off x="2438400" y="5772150"/>
+            <a:ext cx="8572500" cy="438150"/>
+          </a:xfrm>
+          <a:prstGeom xmlns:a="http://schemas.openxmlformats.org/drawingml/2006/main" prst="rect">
+            <a:avLst/>
+          </a:prstGeom>
+          <a:noFill xmlns:a="http://schemas.openxmlformats.org/drawingml/2006/main"/>
+          <a:ln xmlns:a="http://schemas.openxmlformats.org/drawingml/2006/main" w="0">
+            <a:noFill/>
+            <a:prstDash val="solid"/>
+          </a:ln>
+        </p:spPr>
+        <p:txBody>
+          <a:bodyPr xmlns:a="http://schemas.openxmlformats.org/drawingml/2006/main" anchor="t">
+            <a:noAutofit/>
+          </a:bodyPr>
+          <a:lstStyle xmlns:a="http://schemas.openxmlformats.org/drawingml/2006/main"/>
+          <a:p xmlns:a="http://schemas.openxmlformats.org/drawingml/2006/main">
+            <a:pPr algn="l">
+              <a:defRPr sz="1350" b="1">
                 <a:solidFill>
                   <a:srgbClr val="111827"/>
                 </a:solidFill>
@@ -3434,7 +3434,7 @@
               </a:defRPr>
             </a:pPr>
             <a:r>
-              <a:rPr sz="1575" b="1">
+              <a:rPr sz="1350" b="1">
                 <a:solidFill>
                   <a:srgbClr val="111827"/>
                 </a:solidFill>
@@ -3442,7 +3442,7 @@
                 <a:ea typeface="Helvetica Neue"/>
                 <a:cs typeface="Helvetica Neue"/>
               </a:rPr>
-              <a:t>Using harness timing to order replay work reduced replay delay across the full workload.</a:t>
+              <a:t>Session ID, tool-wait phase, expected return time, replay deadline, wait class, replay steps.</a:t>
             </a:r>
           </a:p>
         </p:txBody>
@@ -3450,7 +3450,7 @@
     </p:spTree>
     <p:extLst>
       <p:ext uri="{BB962C8B-B14F-4D97-AF65-F5344CB8AC3E}">
-        <p14:creationId xmlns:p14="http://schemas.microsoft.com/office/powerpoint/2010/main" val="1593947935"/>
+        <p14:creationId xmlns:p14="http://schemas.microsoft.com/office/powerpoint/2010/main" val="1373292222"/>
       </p:ext>
     </p:extLst>
   </p:cSld>
@@ -3481,7 +3481,7 @@
           <p:cNvPr id="46" name="">
             <a:extLst xmlns:a="http://schemas.openxmlformats.org/drawingml/2006/main">
               <a:ext uri="{FF2B5EF4-FFF2-40B4-BE49-F238E27FC236}">
-                <a16:creationId xmlns:a16="http://schemas.microsoft.com/office/drawing/2014/main" id="{19BB3C98-5C5F-45A5-BAD3-7DBA14B7B9ED}"/>
+                <a16:creationId xmlns:a16="http://schemas.microsoft.com/office/drawing/2014/main" id="{0CE734BA-4C93-4905-9E3D-D106BFD36582}"/>
               </a:ext>
             </a:extLst>
           </p:cNvPr>
@@ -3539,7 +3539,7 @@
           <p:cNvPr id="2" name="">
             <a:extLst xmlns:a="http://schemas.openxmlformats.org/drawingml/2006/main">
               <a:ext uri="{FF2B5EF4-FFF2-40B4-BE49-F238E27FC236}">
-                <a16:creationId xmlns:a16="http://schemas.microsoft.com/office/drawing/2014/main" id="{560337DC-DB72-4C4F-9072-8FCA617FBEFB}"/>
+                <a16:creationId xmlns:a16="http://schemas.microsoft.com/office/drawing/2014/main" id="{E73B69DF-5A8B-4254-8C12-35858AECB46A}"/>
               </a:ext>
             </a:extLst>
           </p:cNvPr>
@@ -3597,7 +3597,7 @@
           <p:cNvPr id="3" name="">
             <a:extLst xmlns:a="http://schemas.openxmlformats.org/drawingml/2006/main">
               <a:ext uri="{FF2B5EF4-FFF2-40B4-BE49-F238E27FC236}">
-                <a16:creationId xmlns:a16="http://schemas.microsoft.com/office/drawing/2014/main" id="{982BBC0A-46EF-44D0-85FD-A365B91BDD23}"/>
+                <a16:creationId xmlns:a16="http://schemas.microsoft.com/office/drawing/2014/main" id="{4C4F34B5-D238-455D-9A06-EA3FF2CCE4A4}"/>
               </a:ext>
             </a:extLst>
           </p:cNvPr>
@@ -3655,7 +3655,7 @@
           <p:cNvPr id="4" name="">
             <a:extLst xmlns:a="http://schemas.openxmlformats.org/drawingml/2006/main">
               <a:ext uri="{FF2B5EF4-FFF2-40B4-BE49-F238E27FC236}">
-                <a16:creationId xmlns:a16="http://schemas.microsoft.com/office/drawing/2014/main" id="{46A068CB-94B0-4E1F-9C67-5F737EF486B9}"/>
+                <a16:creationId xmlns:a16="http://schemas.microsoft.com/office/drawing/2014/main" id="{45672B8C-98C5-48AC-9751-13AB73C5CFC0}"/>
               </a:ext>
             </a:extLst>
           </p:cNvPr>
@@ -3686,7 +3686,7 @@
           <p:cNvPr id="5" name="">
             <a:extLst xmlns:a="http://schemas.openxmlformats.org/drawingml/2006/main">
               <a:ext uri="{FF2B5EF4-FFF2-40B4-BE49-F238E27FC236}">
-                <a16:creationId xmlns:a16="http://schemas.microsoft.com/office/drawing/2014/main" id="{4BA62652-7AC9-43C7-A566-5B0A4BAE0399}"/>
+                <a16:creationId xmlns:a16="http://schemas.microsoft.com/office/drawing/2014/main" id="{85EC5554-3229-440D-994A-1BD4C2296976}"/>
               </a:ext>
             </a:extLst>
           </p:cNvPr>
@@ -3744,7 +3744,7 @@
           <p:cNvPr id="6" name="">
             <a:extLst xmlns:a="http://schemas.openxmlformats.org/drawingml/2006/main">
               <a:ext uri="{FF2B5EF4-FFF2-40B4-BE49-F238E27FC236}">
-                <a16:creationId xmlns:a16="http://schemas.microsoft.com/office/drawing/2014/main" id="{77CAD1F2-D9BA-4AD5-ACB8-41D9BFAE7184}"/>
+                <a16:creationId xmlns:a16="http://schemas.microsoft.com/office/drawing/2014/main" id="{BFB5CF6F-F964-4A86-970E-5FB30EA3B7FA}"/>
               </a:ext>
             </a:extLst>
           </p:cNvPr>
@@ -3777,7 +3777,7 @@
           <p:cNvPr id="7" name="">
             <a:extLst xmlns:a="http://schemas.openxmlformats.org/drawingml/2006/main">
               <a:ext uri="{FF2B5EF4-FFF2-40B4-BE49-F238E27FC236}">
-                <a16:creationId xmlns:a16="http://schemas.microsoft.com/office/drawing/2014/main" id="{1C92597F-E223-4C8F-A43E-45434F75D285}"/>
+                <a16:creationId xmlns:a16="http://schemas.microsoft.com/office/drawing/2014/main" id="{23A29F6E-DD21-4C0F-937B-6C3A8EA76533}"/>
               </a:ext>
             </a:extLst>
           </p:cNvPr>
@@ -3835,7 +3835,7 @@
           <p:cNvPr id="8" name="">
             <a:extLst xmlns:a="http://schemas.openxmlformats.org/drawingml/2006/main">
               <a:ext uri="{FF2B5EF4-FFF2-40B4-BE49-F238E27FC236}">
-                <a16:creationId xmlns:a16="http://schemas.microsoft.com/office/drawing/2014/main" id="{02C3F006-7E0B-42CC-810A-7B43208FEA40}"/>
+                <a16:creationId xmlns:a16="http://schemas.microsoft.com/office/drawing/2014/main" id="{0AB34A60-C455-48DA-B33C-81D32024CB34}"/>
               </a:ext>
             </a:extLst>
           </p:cNvPr>
@@ -3868,7 +3868,7 @@
           <p:cNvPr id="9" name="">
             <a:extLst xmlns:a="http://schemas.openxmlformats.org/drawingml/2006/main">
               <a:ext uri="{FF2B5EF4-FFF2-40B4-BE49-F238E27FC236}">
-                <a16:creationId xmlns:a16="http://schemas.microsoft.com/office/drawing/2014/main" id="{35C5E69F-F928-4A03-B907-8D59B91EA926}"/>
+                <a16:creationId xmlns:a16="http://schemas.microsoft.com/office/drawing/2014/main" id="{5CCB9363-A3FD-4888-A576-91885507E2AA}"/>
               </a:ext>
             </a:extLst>
           </p:cNvPr>
@@ -3926,7 +3926,7 @@
           <p:cNvPr id="10" name="">
             <a:extLst xmlns:a="http://schemas.openxmlformats.org/drawingml/2006/main">
               <a:ext uri="{FF2B5EF4-FFF2-40B4-BE49-F238E27FC236}">
-                <a16:creationId xmlns:a16="http://schemas.microsoft.com/office/drawing/2014/main" id="{F6B47E7A-2DEB-4BAB-9AC2-8233D5537175}"/>
+                <a16:creationId xmlns:a16="http://schemas.microsoft.com/office/drawing/2014/main" id="{400C8D8A-95ED-4E2C-8B76-6EA88E427E0A}"/>
               </a:ext>
             </a:extLst>
           </p:cNvPr>
@@ -3959,7 +3959,7 @@
           <p:cNvPr id="11" name="">
             <a:extLst xmlns:a="http://schemas.openxmlformats.org/drawingml/2006/main">
               <a:ext uri="{FF2B5EF4-FFF2-40B4-BE49-F238E27FC236}">
-                <a16:creationId xmlns:a16="http://schemas.microsoft.com/office/drawing/2014/main" id="{A3D1CE0A-EC11-4822-8C7C-5B697C884CFE}"/>
+                <a16:creationId xmlns:a16="http://schemas.microsoft.com/office/drawing/2014/main" id="{5B4BCBB7-757D-4F42-B436-3734F5921421}"/>
               </a:ext>
             </a:extLst>
           </p:cNvPr>
@@ -4017,7 +4017,7 @@
           <p:cNvPr id="12" name="">
             <a:extLst xmlns:a="http://schemas.openxmlformats.org/drawingml/2006/main">
               <a:ext uri="{FF2B5EF4-FFF2-40B4-BE49-F238E27FC236}">
-                <a16:creationId xmlns:a16="http://schemas.microsoft.com/office/drawing/2014/main" id="{304358CB-1664-440C-B1EF-887456AF72BB}"/>
+                <a16:creationId xmlns:a16="http://schemas.microsoft.com/office/drawing/2014/main" id="{65277F56-5BC9-4CD7-BD00-BF24C45B6354}"/>
               </a:ext>
             </a:extLst>
           </p:cNvPr>
@@ -4050,7 +4050,7 @@
           <p:cNvPr id="13" name="">
             <a:extLst xmlns:a="http://schemas.openxmlformats.org/drawingml/2006/main">
               <a:ext uri="{FF2B5EF4-FFF2-40B4-BE49-F238E27FC236}">
-                <a16:creationId xmlns:a16="http://schemas.microsoft.com/office/drawing/2014/main" id="{9AF3B1C8-1955-409B-9DE6-EE2196EAA725}"/>
+                <a16:creationId xmlns:a16="http://schemas.microsoft.com/office/drawing/2014/main" id="{1D72D7AF-D12A-42FB-A1FA-6647B6E3F184}"/>
               </a:ext>
             </a:extLst>
           </p:cNvPr>
@@ -4108,7 +4108,7 @@
           <p:cNvPr id="14" name="">
             <a:extLst xmlns:a="http://schemas.openxmlformats.org/drawingml/2006/main">
               <a:ext uri="{FF2B5EF4-FFF2-40B4-BE49-F238E27FC236}">
-                <a16:creationId xmlns:a16="http://schemas.microsoft.com/office/drawing/2014/main" id="{4BF3B9D9-CBB9-4E64-AE36-430B8B5807CC}"/>
+                <a16:creationId xmlns:a16="http://schemas.microsoft.com/office/drawing/2014/main" id="{22238A49-C63C-4DF7-8079-7656D3E91942}"/>
               </a:ext>
             </a:extLst>
           </p:cNvPr>
@@ -4141,7 +4141,7 @@
           <p:cNvPr id="15" name="">
             <a:extLst xmlns:a="http://schemas.openxmlformats.org/drawingml/2006/main">
               <a:ext uri="{FF2B5EF4-FFF2-40B4-BE49-F238E27FC236}">
-                <a16:creationId xmlns:a16="http://schemas.microsoft.com/office/drawing/2014/main" id="{55B60AEC-2392-497A-8F2A-E2406B58C534}"/>
+                <a16:creationId xmlns:a16="http://schemas.microsoft.com/office/drawing/2014/main" id="{49B31492-66FC-4912-9E19-8C93F9E8520B}"/>
               </a:ext>
             </a:extLst>
           </p:cNvPr>
@@ -4199,7 +4199,7 @@
           <p:cNvPr id="16" name="">
             <a:extLst xmlns:a="http://schemas.openxmlformats.org/drawingml/2006/main">
               <a:ext uri="{FF2B5EF4-FFF2-40B4-BE49-F238E27FC236}">
-                <a16:creationId xmlns:a16="http://schemas.microsoft.com/office/drawing/2014/main" id="{E9471C54-3693-4807-978D-2CD92EB5805E}"/>
+                <a16:creationId xmlns:a16="http://schemas.microsoft.com/office/drawing/2014/main" id="{F551312C-00C6-4967-BE58-68DAF33CADC5}"/>
               </a:ext>
             </a:extLst>
           </p:cNvPr>
@@ -4257,7 +4257,7 @@
           <p:cNvPr id="17" name="">
             <a:extLst xmlns:a="http://schemas.openxmlformats.org/drawingml/2006/main">
               <a:ext uri="{FF2B5EF4-FFF2-40B4-BE49-F238E27FC236}">
-                <a16:creationId xmlns:a16="http://schemas.microsoft.com/office/drawing/2014/main" id="{A60112BF-D2A7-4D14-93C1-12E202CE668E}"/>
+                <a16:creationId xmlns:a16="http://schemas.microsoft.com/office/drawing/2014/main" id="{B49B2975-81B9-44C3-8863-7CE090EC8264}"/>
               </a:ext>
             </a:extLst>
           </p:cNvPr>
@@ -4315,7 +4315,7 @@
           <p:cNvPr id="18" name="">
             <a:extLst xmlns:a="http://schemas.openxmlformats.org/drawingml/2006/main">
               <a:ext uri="{FF2B5EF4-FFF2-40B4-BE49-F238E27FC236}">
-                <a16:creationId xmlns:a16="http://schemas.microsoft.com/office/drawing/2014/main" id="{364B2094-6AED-4A54-A095-260FE00A2A09}"/>
+                <a16:creationId xmlns:a16="http://schemas.microsoft.com/office/drawing/2014/main" id="{4E12A7A0-15F4-4613-9530-300136BFF7E6}"/>
               </a:ext>
             </a:extLst>
           </p:cNvPr>
@@ -4373,7 +4373,7 @@
           <p:cNvPr id="19" name="">
             <a:extLst xmlns:a="http://schemas.openxmlformats.org/drawingml/2006/main">
               <a:ext uri="{FF2B5EF4-FFF2-40B4-BE49-F238E27FC236}">
-                <a16:creationId xmlns:a16="http://schemas.microsoft.com/office/drawing/2014/main" id="{0E4855AB-8EEF-425D-9EAD-03105B9A5961}"/>
+                <a16:creationId xmlns:a16="http://schemas.microsoft.com/office/drawing/2014/main" id="{FF2412A5-6D5A-4A9D-ADB9-C115C3DC1F60}"/>
               </a:ext>
             </a:extLst>
           </p:cNvPr>
@@ -4406,7 +4406,7 @@
           <p:cNvPr id="20" name="">
             <a:extLst xmlns:a="http://schemas.openxmlformats.org/drawingml/2006/main">
               <a:ext uri="{FF2B5EF4-FFF2-40B4-BE49-F238E27FC236}">
-                <a16:creationId xmlns:a16="http://schemas.microsoft.com/office/drawing/2014/main" id="{CCF527A9-C14C-4577-922C-1ED45B8A6233}"/>
+                <a16:creationId xmlns:a16="http://schemas.microsoft.com/office/drawing/2014/main" id="{E310C6B4-7B3D-4563-A397-14169E04B846}"/>
               </a:ext>
             </a:extLst>
           </p:cNvPr>
@@ -4464,7 +4464,7 @@
           <p:cNvPr id="21" name="">
             <a:extLst xmlns:a="http://schemas.openxmlformats.org/drawingml/2006/main">
               <a:ext uri="{FF2B5EF4-FFF2-40B4-BE49-F238E27FC236}">
-                <a16:creationId xmlns:a16="http://schemas.microsoft.com/office/drawing/2014/main" id="{EBF9A284-C9A9-4E18-AE0A-80B86048D4C7}"/>
+                <a16:creationId xmlns:a16="http://schemas.microsoft.com/office/drawing/2014/main" id="{5DEF2B5D-DAC9-4E5D-9ABE-2614F4A1F69B}"/>
               </a:ext>
             </a:extLst>
           </p:cNvPr>
@@ -4522,7 +4522,7 @@
           <p:cNvPr id="22" name="">
             <a:extLst xmlns:a="http://schemas.openxmlformats.org/drawingml/2006/main">
               <a:ext uri="{FF2B5EF4-FFF2-40B4-BE49-F238E27FC236}">
-                <a16:creationId xmlns:a16="http://schemas.microsoft.com/office/drawing/2014/main" id="{1BCF3D38-5829-4DAF-BD58-0BB5CC18ACCA}"/>
+                <a16:creationId xmlns:a16="http://schemas.microsoft.com/office/drawing/2014/main" id="{3952364B-BBF3-43E7-829A-83159880F36C}"/>
               </a:ext>
             </a:extLst>
           </p:cNvPr>
@@ -4580,7 +4580,7 @@
           <p:cNvPr id="23" name="">
             <a:extLst xmlns:a="http://schemas.openxmlformats.org/drawingml/2006/main">
               <a:ext uri="{FF2B5EF4-FFF2-40B4-BE49-F238E27FC236}">
-                <a16:creationId xmlns:a16="http://schemas.microsoft.com/office/drawing/2014/main" id="{86EF24C9-3233-4747-BD08-881E641B8C77}"/>
+                <a16:creationId xmlns:a16="http://schemas.microsoft.com/office/drawing/2014/main" id="{F2F16A22-171E-4532-A692-800045254C1B}"/>
               </a:ext>
             </a:extLst>
           </p:cNvPr>
@@ -4613,7 +4613,7 @@
           <p:cNvPr id="24" name="">
             <a:extLst xmlns:a="http://schemas.openxmlformats.org/drawingml/2006/main">
               <a:ext uri="{FF2B5EF4-FFF2-40B4-BE49-F238E27FC236}">
-                <a16:creationId xmlns:a16="http://schemas.microsoft.com/office/drawing/2014/main" id="{A8CAF7DD-7837-4420-AC7E-FEC955DEEC89}"/>
+                <a16:creationId xmlns:a16="http://schemas.microsoft.com/office/drawing/2014/main" id="{B8D19B57-21D5-43A0-ABB1-D1A1A2C3415E}"/>
               </a:ext>
             </a:extLst>
           </p:cNvPr>
@@ -4671,7 +4671,7 @@
           <p:cNvPr id="25" name="">
             <a:extLst xmlns:a="http://schemas.openxmlformats.org/drawingml/2006/main">
               <a:ext uri="{FF2B5EF4-FFF2-40B4-BE49-F238E27FC236}">
-                <a16:creationId xmlns:a16="http://schemas.microsoft.com/office/drawing/2014/main" id="{C14D484B-A785-4E2C-A8B7-EF70A51B125A}"/>
+                <a16:creationId xmlns:a16="http://schemas.microsoft.com/office/drawing/2014/main" id="{A39F2569-457C-4CC1-9790-2B2B3048C788}"/>
               </a:ext>
             </a:extLst>
           </p:cNvPr>
@@ -4729,7 +4729,7 @@
           <p:cNvPr id="26" name="">
             <a:extLst xmlns:a="http://schemas.openxmlformats.org/drawingml/2006/main">
               <a:ext uri="{FF2B5EF4-FFF2-40B4-BE49-F238E27FC236}">
-                <a16:creationId xmlns:a16="http://schemas.microsoft.com/office/drawing/2014/main" id="{A28AEA18-7D58-43F5-B883-AD37DA6E1600}"/>
+                <a16:creationId xmlns:a16="http://schemas.microsoft.com/office/drawing/2014/main" id="{ED8979BC-9099-4718-812A-198A1743F5B6}"/>
               </a:ext>
             </a:extLst>
           </p:cNvPr>
@@ -4787,7 +4787,7 @@
           <p:cNvPr id="27" name="">
             <a:extLst xmlns:a="http://schemas.openxmlformats.org/drawingml/2006/main">
               <a:ext uri="{FF2B5EF4-FFF2-40B4-BE49-F238E27FC236}">
-                <a16:creationId xmlns:a16="http://schemas.microsoft.com/office/drawing/2014/main" id="{7DB18BFC-C386-4C04-AF09-2869B54D09C1}"/>
+                <a16:creationId xmlns:a16="http://schemas.microsoft.com/office/drawing/2014/main" id="{9BD35CD0-11DE-49EC-A736-88636B1E3877}"/>
               </a:ext>
             </a:extLst>
           </p:cNvPr>
@@ -4820,7 +4820,7 @@
           <p:cNvPr id="28" name="">
             <a:extLst xmlns:a="http://schemas.openxmlformats.org/drawingml/2006/main">
               <a:ext uri="{FF2B5EF4-FFF2-40B4-BE49-F238E27FC236}">
-                <a16:creationId xmlns:a16="http://schemas.microsoft.com/office/drawing/2014/main" id="{FDC1E768-C904-4531-BE68-446246394B2A}"/>
+                <a16:creationId xmlns:a16="http://schemas.microsoft.com/office/drawing/2014/main" id="{80590175-B6F1-4C9B-87B5-F5D59A69735B}"/>
               </a:ext>
             </a:extLst>
           </p:cNvPr>
@@ -4878,7 +4878,7 @@
           <p:cNvPr id="29" name="">
             <a:extLst xmlns:a="http://schemas.openxmlformats.org/drawingml/2006/main">
               <a:ext uri="{FF2B5EF4-FFF2-40B4-BE49-F238E27FC236}">
-                <a16:creationId xmlns:a16="http://schemas.microsoft.com/office/drawing/2014/main" id="{7C04CA44-556C-4D5C-AF6C-2A71FE7BCA29}"/>
+                <a16:creationId xmlns:a16="http://schemas.microsoft.com/office/drawing/2014/main" id="{36C8135B-ED58-46EE-A31B-99A20039216B}"/>
               </a:ext>
             </a:extLst>
           </p:cNvPr>
@@ -4936,7 +4936,7 @@
           <p:cNvPr id="30" name="">
             <a:extLst xmlns:a="http://schemas.openxmlformats.org/drawingml/2006/main">
               <a:ext uri="{FF2B5EF4-FFF2-40B4-BE49-F238E27FC236}">
-                <a16:creationId xmlns:a16="http://schemas.microsoft.com/office/drawing/2014/main" id="{B7CEB619-0A81-45E7-B44D-8AA3FF494027}"/>
+                <a16:creationId xmlns:a16="http://schemas.microsoft.com/office/drawing/2014/main" id="{BAEC6EC8-3186-440E-870F-4C1B85838213}"/>
               </a:ext>
             </a:extLst>
           </p:cNvPr>
@@ -4994,7 +4994,7 @@
           <p:cNvPr id="31" name="">
             <a:extLst xmlns:a="http://schemas.openxmlformats.org/drawingml/2006/main">
               <a:ext uri="{FF2B5EF4-FFF2-40B4-BE49-F238E27FC236}">
-                <a16:creationId xmlns:a16="http://schemas.microsoft.com/office/drawing/2014/main" id="{26C89788-B437-49A5-A73F-1CF668491B37}"/>
+                <a16:creationId xmlns:a16="http://schemas.microsoft.com/office/drawing/2014/main" id="{18C9CE89-283F-4F6E-A214-0CC54FF2BBD1}"/>
               </a:ext>
             </a:extLst>
           </p:cNvPr>
@@ -5027,7 +5027,7 @@
           <p:cNvPr id="32" name="">
             <a:extLst xmlns:a="http://schemas.openxmlformats.org/drawingml/2006/main">
               <a:ext uri="{FF2B5EF4-FFF2-40B4-BE49-F238E27FC236}">
-                <a16:creationId xmlns:a16="http://schemas.microsoft.com/office/drawing/2014/main" id="{971E1CC9-A121-4C71-8E46-34B69F31FEB0}"/>
+                <a16:creationId xmlns:a16="http://schemas.microsoft.com/office/drawing/2014/main" id="{15A20E81-4F37-4059-9B27-065CB9A63728}"/>
               </a:ext>
             </a:extLst>
           </p:cNvPr>
@@ -5085,7 +5085,7 @@
           <p:cNvPr id="33" name="">
             <a:extLst xmlns:a="http://schemas.openxmlformats.org/drawingml/2006/main">
               <a:ext uri="{FF2B5EF4-FFF2-40B4-BE49-F238E27FC236}">
-                <a16:creationId xmlns:a16="http://schemas.microsoft.com/office/drawing/2014/main" id="{1930C303-2688-42C7-8FEB-7AF9C640BB39}"/>
+                <a16:creationId xmlns:a16="http://schemas.microsoft.com/office/drawing/2014/main" id="{AA901807-2A29-4637-8990-D86E325D8DE1}"/>
               </a:ext>
             </a:extLst>
           </p:cNvPr>
@@ -5143,7 +5143,7 @@
           <p:cNvPr id="34" name="">
             <a:extLst xmlns:a="http://schemas.openxmlformats.org/drawingml/2006/main">
               <a:ext uri="{FF2B5EF4-FFF2-40B4-BE49-F238E27FC236}">
-                <a16:creationId xmlns:a16="http://schemas.microsoft.com/office/drawing/2014/main" id="{F585CE36-2C5E-41C0-AF5F-0CD84551EB79}"/>
+                <a16:creationId xmlns:a16="http://schemas.microsoft.com/office/drawing/2014/main" id="{1A7277DB-2A6F-49BC-8091-18F4611FD8DF}"/>
               </a:ext>
             </a:extLst>
           </p:cNvPr>
@@ -5201,7 +5201,7 @@
           <p:cNvPr id="35" name="">
             <a:extLst xmlns:a="http://schemas.openxmlformats.org/drawingml/2006/main">
               <a:ext uri="{FF2B5EF4-FFF2-40B4-BE49-F238E27FC236}">
-                <a16:creationId xmlns:a16="http://schemas.microsoft.com/office/drawing/2014/main" id="{62000B82-269B-4111-BC3B-D051B99E655B}"/>
+                <a16:creationId xmlns:a16="http://schemas.microsoft.com/office/drawing/2014/main" id="{BDE5677E-6EBC-40BE-A457-A4BF6EC03E19}"/>
               </a:ext>
             </a:extLst>
           </p:cNvPr>
@@ -5234,7 +5234,7 @@
           <p:cNvPr id="36" name="">
             <a:extLst xmlns:a="http://schemas.openxmlformats.org/drawingml/2006/main">
               <a:ext uri="{FF2B5EF4-FFF2-40B4-BE49-F238E27FC236}">
-                <a16:creationId xmlns:a16="http://schemas.microsoft.com/office/drawing/2014/main" id="{4C810792-9F27-45B5-8799-5A8048EC4002}"/>
+                <a16:creationId xmlns:a16="http://schemas.microsoft.com/office/drawing/2014/main" id="{6418C016-8A08-483C-8B7B-8038A973A617}"/>
               </a:ext>
             </a:extLst>
           </p:cNvPr>
@@ -5292,7 +5292,7 @@
           <p:cNvPr id="37" name="">
             <a:extLst xmlns:a="http://schemas.openxmlformats.org/drawingml/2006/main">
               <a:ext uri="{FF2B5EF4-FFF2-40B4-BE49-F238E27FC236}">
-                <a16:creationId xmlns:a16="http://schemas.microsoft.com/office/drawing/2014/main" id="{CCE1CD41-DE2D-47C9-8D5C-AA4EEBB11A83}"/>
+                <a16:creationId xmlns:a16="http://schemas.microsoft.com/office/drawing/2014/main" id="{9D9340ED-4A07-495D-836B-56E2E63F2CEC}"/>
               </a:ext>
             </a:extLst>
           </p:cNvPr>
@@ -5350,7 +5350,7 @@
           <p:cNvPr id="38" name="">
             <a:extLst xmlns:a="http://schemas.openxmlformats.org/drawingml/2006/main">
               <a:ext uri="{FF2B5EF4-FFF2-40B4-BE49-F238E27FC236}">
-                <a16:creationId xmlns:a16="http://schemas.microsoft.com/office/drawing/2014/main" id="{C5968E8F-1C7C-428A-9462-CF353760BF23}"/>
+                <a16:creationId xmlns:a16="http://schemas.microsoft.com/office/drawing/2014/main" id="{F0E9551B-F1C4-4A03-A305-1036DED12F66}"/>
               </a:ext>
             </a:extLst>
           </p:cNvPr>
@@ -5408,7 +5408,7 @@
           <p:cNvPr id="39" name="">
             <a:extLst xmlns:a="http://schemas.openxmlformats.org/drawingml/2006/main">
               <a:ext uri="{FF2B5EF4-FFF2-40B4-BE49-F238E27FC236}">
-                <a16:creationId xmlns:a16="http://schemas.microsoft.com/office/drawing/2014/main" id="{FDA0BB84-58BB-4527-BF9C-15EEFDEE53FD}"/>
+                <a16:creationId xmlns:a16="http://schemas.microsoft.com/office/drawing/2014/main" id="{D8E255E5-12E3-4B03-A848-1005F8B99363}"/>
               </a:ext>
             </a:extLst>
           </p:cNvPr>
@@ -5441,7 +5441,7 @@
           <p:cNvPr id="40" name="">
             <a:extLst xmlns:a="http://schemas.openxmlformats.org/drawingml/2006/main">
               <a:ext uri="{FF2B5EF4-FFF2-40B4-BE49-F238E27FC236}">
-                <a16:creationId xmlns:a16="http://schemas.microsoft.com/office/drawing/2014/main" id="{DCD5CDD2-7FFC-4064-AB9A-41061D57906D}"/>
+                <a16:creationId xmlns:a16="http://schemas.microsoft.com/office/drawing/2014/main" id="{763006BD-9D6D-4603-ABDA-EA7B2ADCA632}"/>
               </a:ext>
             </a:extLst>
           </p:cNvPr>
@@ -5499,7 +5499,7 @@
           <p:cNvPr id="41" name="">
             <a:extLst xmlns:a="http://schemas.openxmlformats.org/drawingml/2006/main">
               <a:ext uri="{FF2B5EF4-FFF2-40B4-BE49-F238E27FC236}">
-                <a16:creationId xmlns:a16="http://schemas.microsoft.com/office/drawing/2014/main" id="{A114540B-BE18-4192-A606-88A742F541CA}"/>
+                <a16:creationId xmlns:a16="http://schemas.microsoft.com/office/drawing/2014/main" id="{363D1144-9E9B-4B12-8EC4-7CAE785A9C52}"/>
               </a:ext>
             </a:extLst>
           </p:cNvPr>
@@ -5557,7 +5557,7 @@
           <p:cNvPr id="42" name="">
             <a:extLst xmlns:a="http://schemas.openxmlformats.org/drawingml/2006/main">
               <a:ext uri="{FF2B5EF4-FFF2-40B4-BE49-F238E27FC236}">
-                <a16:creationId xmlns:a16="http://schemas.microsoft.com/office/drawing/2014/main" id="{0F2DF7AE-2A3D-46BF-AEF7-710FC32A6AB0}"/>
+                <a16:creationId xmlns:a16="http://schemas.microsoft.com/office/drawing/2014/main" id="{6C19DFF7-CDCD-4356-89C6-C691640C696F}"/>
               </a:ext>
             </a:extLst>
           </p:cNvPr>
@@ -5615,7 +5615,7 @@
           <p:cNvPr id="43" name="">
             <a:extLst xmlns:a="http://schemas.openxmlformats.org/drawingml/2006/main">
               <a:ext uri="{FF2B5EF4-FFF2-40B4-BE49-F238E27FC236}">
-                <a16:creationId xmlns:a16="http://schemas.microsoft.com/office/drawing/2014/main" id="{FE6252FA-5961-494F-A9BB-8EA34B092310}"/>
+                <a16:creationId xmlns:a16="http://schemas.microsoft.com/office/drawing/2014/main" id="{427F3182-32A9-43AE-BDCA-B0CD02B22C14}"/>
               </a:ext>
             </a:extLst>
           </p:cNvPr>
@@ -5646,18 +5646,18 @@
           <p:cNvPr id="44" name="">
             <a:extLst xmlns:a="http://schemas.openxmlformats.org/drawingml/2006/main">
               <a:ext uri="{FF2B5EF4-FFF2-40B4-BE49-F238E27FC236}">
-                <a16:creationId xmlns:a16="http://schemas.microsoft.com/office/drawing/2014/main" id="{74C5B5CA-875D-477A-8DB4-959ECEED3444}"/>
-              </a:ext>
-            </a:extLst>
-          </p:cNvPr>
-          <p:cNvSpPr>
-            <a:spLocks xmlns:a="http://schemas.openxmlformats.org/drawingml/2006/main" noGrp="1"/>
-          </p:cNvSpPr>
-          <p:nvPr/>
-        </p:nvSpPr>
-        <p:spPr>
-          <a:xfrm xmlns:a="http://schemas.openxmlformats.org/drawingml/2006/main">
-            <a:off x="628650" y="5753100"/>
+                <a16:creationId xmlns:a16="http://schemas.microsoft.com/office/drawing/2014/main" id="{BDFA571A-23D0-4015-B3EB-5E5FD4A1AA27}"/>
+              </a:ext>
+            </a:extLst>
+          </p:cNvPr>
+          <p:cNvSpPr>
+            <a:spLocks xmlns:a="http://schemas.openxmlformats.org/drawingml/2006/main" noGrp="1"/>
+          </p:cNvSpPr>
+          <p:nvPr/>
+        </p:nvSpPr>
+        <p:spPr>
+          <a:xfrm xmlns:a="http://schemas.openxmlformats.org/drawingml/2006/main">
+            <a:off x="628650" y="5791200"/>
             <a:ext cx="1809750" cy="266700"/>
           </a:xfrm>
           <a:prstGeom xmlns:a="http://schemas.openxmlformats.org/drawingml/2006/main" prst="rect">
@@ -5694,7 +5694,7 @@
                 <a:ea typeface="Helvetica Neue"/>
                 <a:cs typeface="Helvetica Neue"/>
               </a:rPr>
-              <a:t>Mechanism proof</a:t>
+              <a:t>Harness signals</a:t>
             </a:r>
           </a:p>
         </p:txBody>
@@ -5704,37 +5704,37 @@
           <p:cNvPr id="45" name="">
             <a:extLst xmlns:a="http://schemas.openxmlformats.org/drawingml/2006/main">
               <a:ext uri="{FF2B5EF4-FFF2-40B4-BE49-F238E27FC236}">
-                <a16:creationId xmlns:a16="http://schemas.microsoft.com/office/drawing/2014/main" id="{E94D99ED-5630-4E62-AAB5-FA5C0A40C2CE}"/>
-              </a:ext>
-            </a:extLst>
-          </p:cNvPr>
-          <p:cNvSpPr>
-            <a:spLocks xmlns:a="http://schemas.openxmlformats.org/drawingml/2006/main" noGrp="1"/>
-          </p:cNvSpPr>
-          <p:nvPr/>
-        </p:nvSpPr>
-        <p:spPr>
-          <a:xfrm xmlns:a="http://schemas.openxmlformats.org/drawingml/2006/main">
-            <a:off x="2438400" y="5753100"/>
-            <a:ext cx="8191500" cy="400050"/>
-          </a:xfrm>
-          <a:prstGeom xmlns:a="http://schemas.openxmlformats.org/drawingml/2006/main" prst="rect">
-            <a:avLst/>
-          </a:prstGeom>
-          <a:noFill xmlns:a="http://schemas.openxmlformats.org/drawingml/2006/main"/>
-          <a:ln xmlns:a="http://schemas.openxmlformats.org/drawingml/2006/main" w="0">
-            <a:noFill/>
-            <a:prstDash val="solid"/>
-          </a:ln>
-        </p:spPr>
-        <p:txBody>
-          <a:bodyPr xmlns:a="http://schemas.openxmlformats.org/drawingml/2006/main" anchor="t">
-            <a:noAutofit/>
-          </a:bodyPr>
-          <a:lstStyle xmlns:a="http://schemas.openxmlformats.org/drawingml/2006/main"/>
-          <a:p xmlns:a="http://schemas.openxmlformats.org/drawingml/2006/main">
-            <a:pPr algn="l">
-              <a:defRPr sz="1500" b="1">
+                <a16:creationId xmlns:a16="http://schemas.microsoft.com/office/drawing/2014/main" id="{F1CBF313-13DA-4EA1-B2B2-C117F8D8046A}"/>
+              </a:ext>
+            </a:extLst>
+          </p:cNvPr>
+          <p:cNvSpPr>
+            <a:spLocks xmlns:a="http://schemas.openxmlformats.org/drawingml/2006/main" noGrp="1"/>
+          </p:cNvSpPr>
+          <p:nvPr/>
+        </p:nvSpPr>
+        <p:spPr>
+          <a:xfrm xmlns:a="http://schemas.openxmlformats.org/drawingml/2006/main">
+            <a:off x="2438400" y="5772150"/>
+            <a:ext cx="8572500" cy="438150"/>
+          </a:xfrm>
+          <a:prstGeom xmlns:a="http://schemas.openxmlformats.org/drawingml/2006/main" prst="rect">
+            <a:avLst/>
+          </a:prstGeom>
+          <a:noFill xmlns:a="http://schemas.openxmlformats.org/drawingml/2006/main"/>
+          <a:ln xmlns:a="http://schemas.openxmlformats.org/drawingml/2006/main" w="0">
+            <a:noFill/>
+            <a:prstDash val="solid"/>
+          </a:ln>
+        </p:spPr>
+        <p:txBody>
+          <a:bodyPr xmlns:a="http://schemas.openxmlformats.org/drawingml/2006/main" anchor="t">
+            <a:noAutofit/>
+          </a:bodyPr>
+          <a:lstStyle xmlns:a="http://schemas.openxmlformats.org/drawingml/2006/main"/>
+          <a:p xmlns:a="http://schemas.openxmlformats.org/drawingml/2006/main">
+            <a:pPr algn="l">
+              <a:defRPr sz="1350" b="1">
                 <a:solidFill>
                   <a:srgbClr val="111827"/>
                 </a:solidFill>
@@ -5744,7 +5744,7 @@
               </a:defRPr>
             </a:pPr>
             <a:r>
-              <a:rPr sz="1500" b="1">
+              <a:rPr sz="1350" b="1">
                 <a:solidFill>
                   <a:srgbClr val="111827"/>
                 </a:solidFill>
@@ -5752,7 +5752,7 @@
                 <a:ea typeface="Helvetica Neue"/>
                 <a:cs typeface="Helvetica Neue"/>
               </a:rPr>
-              <a:t>21 cache checks, 6 admitted direct loads, 48,889 prepared tokens, and 560 H2D copy events before replay compute.</a:t>
+              <a:t>Session ID, prefix ID, expected return time, ETA uncertainty, replay deadline, reuse probability, recompute cost.</a:t>
             </a:r>
           </a:p>
         </p:txBody>
@@ -5760,7 +5760,7 @@
     </p:spTree>
     <p:extLst>
       <p:ext uri="{BB962C8B-B14F-4D97-AF65-F5344CB8AC3E}">
-        <p14:creationId xmlns:p14="http://schemas.microsoft.com/office/powerpoint/2010/main" val="2095082422"/>
+        <p14:creationId xmlns:p14="http://schemas.microsoft.com/office/powerpoint/2010/main" val="873540808"/>
       </p:ext>
     </p:extLst>
   </p:cSld>
@@ -5791,7 +5791,7 @@
           <p:cNvPr id="46" name="">
             <a:extLst xmlns:a="http://schemas.openxmlformats.org/drawingml/2006/main">
               <a:ext uri="{FF2B5EF4-FFF2-40B4-BE49-F238E27FC236}">
-                <a16:creationId xmlns:a16="http://schemas.microsoft.com/office/drawing/2014/main" id="{BE7050B1-5B2B-47CB-A761-E600F32AE931}"/>
+                <a16:creationId xmlns:a16="http://schemas.microsoft.com/office/drawing/2014/main" id="{313FAC35-5D8F-4779-8123-52BB6124F238}"/>
               </a:ext>
             </a:extLst>
           </p:cNvPr>
@@ -5849,7 +5849,7 @@
           <p:cNvPr id="2" name="">
             <a:extLst xmlns:a="http://schemas.openxmlformats.org/drawingml/2006/main">
               <a:ext uri="{FF2B5EF4-FFF2-40B4-BE49-F238E27FC236}">
-                <a16:creationId xmlns:a16="http://schemas.microsoft.com/office/drawing/2014/main" id="{FB30F90A-912D-4C61-A78F-27A7224870B8}"/>
+                <a16:creationId xmlns:a16="http://schemas.microsoft.com/office/drawing/2014/main" id="{E3ED03CD-A47D-46C7-B689-D260D7023998}"/>
               </a:ext>
             </a:extLst>
           </p:cNvPr>
@@ -5907,7 +5907,7 @@
           <p:cNvPr id="3" name="">
             <a:extLst xmlns:a="http://schemas.openxmlformats.org/drawingml/2006/main">
               <a:ext uri="{FF2B5EF4-FFF2-40B4-BE49-F238E27FC236}">
-                <a16:creationId xmlns:a16="http://schemas.microsoft.com/office/drawing/2014/main" id="{B52D9656-5458-442B-84ED-50A2056A09A9}"/>
+                <a16:creationId xmlns:a16="http://schemas.microsoft.com/office/drawing/2014/main" id="{80DC1A91-4400-4C18-A715-9F8BC00D9750}"/>
               </a:ext>
             </a:extLst>
           </p:cNvPr>
@@ -5965,7 +5965,7 @@
           <p:cNvPr id="4" name="">
             <a:extLst xmlns:a="http://schemas.openxmlformats.org/drawingml/2006/main">
               <a:ext uri="{FF2B5EF4-FFF2-40B4-BE49-F238E27FC236}">
-                <a16:creationId xmlns:a16="http://schemas.microsoft.com/office/drawing/2014/main" id="{20726760-9F5A-4FD1-BDF7-F080137CCB02}"/>
+                <a16:creationId xmlns:a16="http://schemas.microsoft.com/office/drawing/2014/main" id="{35204F46-042C-4E20-B0F5-3D1F08AAC253}"/>
               </a:ext>
             </a:extLst>
           </p:cNvPr>
@@ -5996,7 +5996,7 @@
           <p:cNvPr id="5" name="">
             <a:extLst xmlns:a="http://schemas.openxmlformats.org/drawingml/2006/main">
               <a:ext uri="{FF2B5EF4-FFF2-40B4-BE49-F238E27FC236}">
-                <a16:creationId xmlns:a16="http://schemas.microsoft.com/office/drawing/2014/main" id="{E69F9612-EEAD-4D50-B1C5-701A9F4285C2}"/>
+                <a16:creationId xmlns:a16="http://schemas.microsoft.com/office/drawing/2014/main" id="{34C7DCB1-E7CB-4D96-BDC4-0D189763CFCF}"/>
               </a:ext>
             </a:extLst>
           </p:cNvPr>
@@ -6054,7 +6054,7 @@
           <p:cNvPr id="6" name="">
             <a:extLst xmlns:a="http://schemas.openxmlformats.org/drawingml/2006/main">
               <a:ext uri="{FF2B5EF4-FFF2-40B4-BE49-F238E27FC236}">
-                <a16:creationId xmlns:a16="http://schemas.microsoft.com/office/drawing/2014/main" id="{D8855396-A1C9-4048-A5DC-4B3B9A11E192}"/>
+                <a16:creationId xmlns:a16="http://schemas.microsoft.com/office/drawing/2014/main" id="{E42662F7-B7F4-44B8-8E78-7B96CA1F860E}"/>
               </a:ext>
             </a:extLst>
           </p:cNvPr>
@@ -6087,7 +6087,7 @@
           <p:cNvPr id="7" name="">
             <a:extLst xmlns:a="http://schemas.openxmlformats.org/drawingml/2006/main">
               <a:ext uri="{FF2B5EF4-FFF2-40B4-BE49-F238E27FC236}">
-                <a16:creationId xmlns:a16="http://schemas.microsoft.com/office/drawing/2014/main" id="{F1E7F3D5-728C-4378-A23C-0EB4B60C7B8A}"/>
+                <a16:creationId xmlns:a16="http://schemas.microsoft.com/office/drawing/2014/main" id="{A4941D5F-8B1B-42EA-AD5A-754FDD3D86FF}"/>
               </a:ext>
             </a:extLst>
           </p:cNvPr>
@@ -6145,7 +6145,7 @@
           <p:cNvPr id="8" name="">
             <a:extLst xmlns:a="http://schemas.openxmlformats.org/drawingml/2006/main">
               <a:ext uri="{FF2B5EF4-FFF2-40B4-BE49-F238E27FC236}">
-                <a16:creationId xmlns:a16="http://schemas.microsoft.com/office/drawing/2014/main" id="{C3F1FB89-1BB8-4C11-BC42-061FF8E5D2C5}"/>
+                <a16:creationId xmlns:a16="http://schemas.microsoft.com/office/drawing/2014/main" id="{F0013C4F-DA8B-4FCC-9B8E-ABE25806D649}"/>
               </a:ext>
             </a:extLst>
           </p:cNvPr>
@@ -6178,7 +6178,7 @@
           <p:cNvPr id="9" name="">
             <a:extLst xmlns:a="http://schemas.openxmlformats.org/drawingml/2006/main">
               <a:ext uri="{FF2B5EF4-FFF2-40B4-BE49-F238E27FC236}">
-                <a16:creationId xmlns:a16="http://schemas.microsoft.com/office/drawing/2014/main" id="{015947CA-8197-479A-8BD6-A5859768CE9E}"/>
+                <a16:creationId xmlns:a16="http://schemas.microsoft.com/office/drawing/2014/main" id="{43064551-888F-492B-8CDB-886D5A270692}"/>
               </a:ext>
             </a:extLst>
           </p:cNvPr>
@@ -6236,7 +6236,7 @@
           <p:cNvPr id="10" name="">
             <a:extLst xmlns:a="http://schemas.openxmlformats.org/drawingml/2006/main">
               <a:ext uri="{FF2B5EF4-FFF2-40B4-BE49-F238E27FC236}">
-                <a16:creationId xmlns:a16="http://schemas.microsoft.com/office/drawing/2014/main" id="{BA356334-CE21-427A-A8DC-7D196B5E8AAC}"/>
+                <a16:creationId xmlns:a16="http://schemas.microsoft.com/office/drawing/2014/main" id="{AE712F8C-1770-4C6F-9985-256480BBA8FF}"/>
               </a:ext>
             </a:extLst>
           </p:cNvPr>
@@ -6269,7 +6269,7 @@
           <p:cNvPr id="11" name="">
             <a:extLst xmlns:a="http://schemas.openxmlformats.org/drawingml/2006/main">
               <a:ext uri="{FF2B5EF4-FFF2-40B4-BE49-F238E27FC236}">
-                <a16:creationId xmlns:a16="http://schemas.microsoft.com/office/drawing/2014/main" id="{1CE11A09-10C8-4925-BF96-A4606AAF773D}"/>
+                <a16:creationId xmlns:a16="http://schemas.microsoft.com/office/drawing/2014/main" id="{247D8B4B-D4A5-49BD-ABAE-D578BC421A50}"/>
               </a:ext>
             </a:extLst>
           </p:cNvPr>
@@ -6327,7 +6327,7 @@
           <p:cNvPr id="12" name="">
             <a:extLst xmlns:a="http://schemas.openxmlformats.org/drawingml/2006/main">
               <a:ext uri="{FF2B5EF4-FFF2-40B4-BE49-F238E27FC236}">
-                <a16:creationId xmlns:a16="http://schemas.microsoft.com/office/drawing/2014/main" id="{0A877E49-95E6-48F3-98CF-90A611777EC8}"/>
+                <a16:creationId xmlns:a16="http://schemas.microsoft.com/office/drawing/2014/main" id="{C88D2894-5BCB-4063-A46A-9747C1472DE6}"/>
               </a:ext>
             </a:extLst>
           </p:cNvPr>
@@ -6360,7 +6360,7 @@
           <p:cNvPr id="13" name="">
             <a:extLst xmlns:a="http://schemas.openxmlformats.org/drawingml/2006/main">
               <a:ext uri="{FF2B5EF4-FFF2-40B4-BE49-F238E27FC236}">
-                <a16:creationId xmlns:a16="http://schemas.microsoft.com/office/drawing/2014/main" id="{E4B1FFD6-6222-43E9-9D45-378A17AA4FD9}"/>
+                <a16:creationId xmlns:a16="http://schemas.microsoft.com/office/drawing/2014/main" id="{C5032191-2732-4089-A931-54D925AD0280}"/>
               </a:ext>
             </a:extLst>
           </p:cNvPr>
@@ -6418,7 +6418,7 @@
           <p:cNvPr id="14" name="">
             <a:extLst xmlns:a="http://schemas.openxmlformats.org/drawingml/2006/main">
               <a:ext uri="{FF2B5EF4-FFF2-40B4-BE49-F238E27FC236}">
-                <a16:creationId xmlns:a16="http://schemas.microsoft.com/office/drawing/2014/main" id="{016BB31B-D251-46B8-8BBF-E5B59BCB2D37}"/>
+                <a16:creationId xmlns:a16="http://schemas.microsoft.com/office/drawing/2014/main" id="{17F220ED-A380-42DF-87FA-5280C39C0C8F}"/>
               </a:ext>
             </a:extLst>
           </p:cNvPr>
@@ -6451,7 +6451,7 @@
           <p:cNvPr id="15" name="">
             <a:extLst xmlns:a="http://schemas.openxmlformats.org/drawingml/2006/main">
               <a:ext uri="{FF2B5EF4-FFF2-40B4-BE49-F238E27FC236}">
-                <a16:creationId xmlns:a16="http://schemas.microsoft.com/office/drawing/2014/main" id="{634AF9C7-6E3B-4420-B4C4-A53D57C91E18}"/>
+                <a16:creationId xmlns:a16="http://schemas.microsoft.com/office/drawing/2014/main" id="{EBF2F2F3-0985-4581-AB19-B6173BA5B67E}"/>
               </a:ext>
             </a:extLst>
           </p:cNvPr>
@@ -6509,7 +6509,7 @@
           <p:cNvPr id="16" name="">
             <a:extLst xmlns:a="http://schemas.openxmlformats.org/drawingml/2006/main">
               <a:ext uri="{FF2B5EF4-FFF2-40B4-BE49-F238E27FC236}">
-                <a16:creationId xmlns:a16="http://schemas.microsoft.com/office/drawing/2014/main" id="{44CB479C-342C-47BD-8264-0CA10F29C47C}"/>
+                <a16:creationId xmlns:a16="http://schemas.microsoft.com/office/drawing/2014/main" id="{DA3F2CC6-C842-48F3-B4C9-3157B8BB3542}"/>
               </a:ext>
             </a:extLst>
           </p:cNvPr>
@@ -6567,7 +6567,7 @@
           <p:cNvPr id="17" name="">
             <a:extLst xmlns:a="http://schemas.openxmlformats.org/drawingml/2006/main">
               <a:ext uri="{FF2B5EF4-FFF2-40B4-BE49-F238E27FC236}">
-                <a16:creationId xmlns:a16="http://schemas.microsoft.com/office/drawing/2014/main" id="{E020E44D-DDE4-490C-BEFC-04562C85C83A}"/>
+                <a16:creationId xmlns:a16="http://schemas.microsoft.com/office/drawing/2014/main" id="{39406EA0-99A6-4C66-BDC4-4B522FEDD12F}"/>
               </a:ext>
             </a:extLst>
           </p:cNvPr>
@@ -6625,7 +6625,7 @@
           <p:cNvPr id="18" name="">
             <a:extLst xmlns:a="http://schemas.openxmlformats.org/drawingml/2006/main">
               <a:ext uri="{FF2B5EF4-FFF2-40B4-BE49-F238E27FC236}">
-                <a16:creationId xmlns:a16="http://schemas.microsoft.com/office/drawing/2014/main" id="{9DCB5B17-4C4B-4D58-928B-765FA65DA388}"/>
+                <a16:creationId xmlns:a16="http://schemas.microsoft.com/office/drawing/2014/main" id="{A70A3DBF-5262-4232-9C88-624A6AF6FE79}"/>
               </a:ext>
             </a:extLst>
           </p:cNvPr>
@@ -6683,7 +6683,7 @@
           <p:cNvPr id="19" name="">
             <a:extLst xmlns:a="http://schemas.openxmlformats.org/drawingml/2006/main">
               <a:ext uri="{FF2B5EF4-FFF2-40B4-BE49-F238E27FC236}">
-                <a16:creationId xmlns:a16="http://schemas.microsoft.com/office/drawing/2014/main" id="{7216BDA5-FFDC-4F2D-BD4D-89A581010DCB}"/>
+                <a16:creationId xmlns:a16="http://schemas.microsoft.com/office/drawing/2014/main" id="{B82FF7C3-83B2-4BF7-AF1E-81EE8AB3E8DF}"/>
               </a:ext>
             </a:extLst>
           </p:cNvPr>
@@ -6716,7 +6716,7 @@
           <p:cNvPr id="20" name="">
             <a:extLst xmlns:a="http://schemas.openxmlformats.org/drawingml/2006/main">
               <a:ext uri="{FF2B5EF4-FFF2-40B4-BE49-F238E27FC236}">
-                <a16:creationId xmlns:a16="http://schemas.microsoft.com/office/drawing/2014/main" id="{174ADA37-9C89-471F-ACC7-AB500992F04C}"/>
+                <a16:creationId xmlns:a16="http://schemas.microsoft.com/office/drawing/2014/main" id="{88A07401-7DD0-4CA8-8066-1F3CFEBF43EB}"/>
               </a:ext>
             </a:extLst>
           </p:cNvPr>
@@ -6774,7 +6774,7 @@
           <p:cNvPr id="21" name="">
             <a:extLst xmlns:a="http://schemas.openxmlformats.org/drawingml/2006/main">
               <a:ext uri="{FF2B5EF4-FFF2-40B4-BE49-F238E27FC236}">
-                <a16:creationId xmlns:a16="http://schemas.microsoft.com/office/drawing/2014/main" id="{F92E07ED-BFE9-4768-BF0E-E999052B09FA}"/>
+                <a16:creationId xmlns:a16="http://schemas.microsoft.com/office/drawing/2014/main" id="{F91D0EB0-A843-4693-9D05-13302B70449A}"/>
               </a:ext>
             </a:extLst>
           </p:cNvPr>
@@ -6832,7 +6832,7 @@
           <p:cNvPr id="22" name="">
             <a:extLst xmlns:a="http://schemas.openxmlformats.org/drawingml/2006/main">
               <a:ext uri="{FF2B5EF4-FFF2-40B4-BE49-F238E27FC236}">
-                <a16:creationId xmlns:a16="http://schemas.microsoft.com/office/drawing/2014/main" id="{759DFED0-E9F8-4839-92FB-F3B4919FC5E7}"/>
+                <a16:creationId xmlns:a16="http://schemas.microsoft.com/office/drawing/2014/main" id="{0FFEE098-45AC-45E9-B254-48607BBFD197}"/>
               </a:ext>
             </a:extLst>
           </p:cNvPr>
@@ -6890,7 +6890,7 @@
           <p:cNvPr id="23" name="">
             <a:extLst xmlns:a="http://schemas.openxmlformats.org/drawingml/2006/main">
               <a:ext uri="{FF2B5EF4-FFF2-40B4-BE49-F238E27FC236}">
-                <a16:creationId xmlns:a16="http://schemas.microsoft.com/office/drawing/2014/main" id="{8512867D-F0A9-4FD0-B74B-FB3FA60DE2F4}"/>
+                <a16:creationId xmlns:a16="http://schemas.microsoft.com/office/drawing/2014/main" id="{15D337AB-D23D-402A-A522-391644D477F8}"/>
               </a:ext>
             </a:extLst>
           </p:cNvPr>
@@ -6923,7 +6923,7 @@
           <p:cNvPr id="24" name="">
             <a:extLst xmlns:a="http://schemas.openxmlformats.org/drawingml/2006/main">
               <a:ext uri="{FF2B5EF4-FFF2-40B4-BE49-F238E27FC236}">
-                <a16:creationId xmlns:a16="http://schemas.microsoft.com/office/drawing/2014/main" id="{211722D5-3E95-41C2-952B-446A6C50E431}"/>
+                <a16:creationId xmlns:a16="http://schemas.microsoft.com/office/drawing/2014/main" id="{85CB24BA-33F7-426F-BB85-53C37D5AFE66}"/>
               </a:ext>
             </a:extLst>
           </p:cNvPr>
@@ -6981,7 +6981,7 @@
           <p:cNvPr id="25" name="">
             <a:extLst xmlns:a="http://schemas.openxmlformats.org/drawingml/2006/main">
               <a:ext uri="{FF2B5EF4-FFF2-40B4-BE49-F238E27FC236}">
-                <a16:creationId xmlns:a16="http://schemas.microsoft.com/office/drawing/2014/main" id="{499A6254-EF89-497C-AAF0-239EB5271E6B}"/>
+                <a16:creationId xmlns:a16="http://schemas.microsoft.com/office/drawing/2014/main" id="{16ED7A24-9D83-4BD4-B2E2-22A7540EE9B4}"/>
               </a:ext>
             </a:extLst>
           </p:cNvPr>
@@ -7039,7 +7039,7 @@
           <p:cNvPr id="26" name="">
             <a:extLst xmlns:a="http://schemas.openxmlformats.org/drawingml/2006/main">
               <a:ext uri="{FF2B5EF4-FFF2-40B4-BE49-F238E27FC236}">
-                <a16:creationId xmlns:a16="http://schemas.microsoft.com/office/drawing/2014/main" id="{C595E681-AA0A-4612-B971-571BB80C4B85}"/>
+                <a16:creationId xmlns:a16="http://schemas.microsoft.com/office/drawing/2014/main" id="{617F0F91-6D85-4F90-AD2A-23EDCE16A111}"/>
               </a:ext>
             </a:extLst>
           </p:cNvPr>
@@ -7097,7 +7097,7 @@
           <p:cNvPr id="27" name="">
             <a:extLst xmlns:a="http://schemas.openxmlformats.org/drawingml/2006/main">
               <a:ext uri="{FF2B5EF4-FFF2-40B4-BE49-F238E27FC236}">
-                <a16:creationId xmlns:a16="http://schemas.microsoft.com/office/drawing/2014/main" id="{4E199AAC-9B10-4CDB-8B33-FA0989690FE9}"/>
+                <a16:creationId xmlns:a16="http://schemas.microsoft.com/office/drawing/2014/main" id="{EEAF03EE-5E8A-4EB4-ABEB-83B9CAC95AF0}"/>
               </a:ext>
             </a:extLst>
           </p:cNvPr>
@@ -7130,7 +7130,7 @@
           <p:cNvPr id="28" name="">
             <a:extLst xmlns:a="http://schemas.openxmlformats.org/drawingml/2006/main">
               <a:ext uri="{FF2B5EF4-FFF2-40B4-BE49-F238E27FC236}">
-                <a16:creationId xmlns:a16="http://schemas.microsoft.com/office/drawing/2014/main" id="{068EAD3F-B4E6-424F-A55C-46C0C2CE4D5D}"/>
+                <a16:creationId xmlns:a16="http://schemas.microsoft.com/office/drawing/2014/main" id="{8E7765D8-E703-46DF-B4DF-ED048D302702}"/>
               </a:ext>
             </a:extLst>
           </p:cNvPr>
@@ -7188,7 +7188,7 @@
           <p:cNvPr id="29" name="">
             <a:extLst xmlns:a="http://schemas.openxmlformats.org/drawingml/2006/main">
               <a:ext uri="{FF2B5EF4-FFF2-40B4-BE49-F238E27FC236}">
-                <a16:creationId xmlns:a16="http://schemas.microsoft.com/office/drawing/2014/main" id="{0A75E9BC-D2BB-4954-813D-E4F7A6A00B09}"/>
+                <a16:creationId xmlns:a16="http://schemas.microsoft.com/office/drawing/2014/main" id="{9FF0D895-1DD1-439D-A336-75FB287CE776}"/>
               </a:ext>
             </a:extLst>
           </p:cNvPr>
@@ -7246,7 +7246,7 @@
           <p:cNvPr id="30" name="">
             <a:extLst xmlns:a="http://schemas.openxmlformats.org/drawingml/2006/main">
               <a:ext uri="{FF2B5EF4-FFF2-40B4-BE49-F238E27FC236}">
-                <a16:creationId xmlns:a16="http://schemas.microsoft.com/office/drawing/2014/main" id="{B52E2109-E002-41BE-9D20-48CBBDA1BFAD}"/>
+                <a16:creationId xmlns:a16="http://schemas.microsoft.com/office/drawing/2014/main" id="{28099813-CABE-45DB-A3DC-082BDBFC3FEC}"/>
               </a:ext>
             </a:extLst>
           </p:cNvPr>
@@ -7304,7 +7304,7 @@
           <p:cNvPr id="31" name="">
             <a:extLst xmlns:a="http://schemas.openxmlformats.org/drawingml/2006/main">
               <a:ext uri="{FF2B5EF4-FFF2-40B4-BE49-F238E27FC236}">
-                <a16:creationId xmlns:a16="http://schemas.microsoft.com/office/drawing/2014/main" id="{06BF0351-5250-42F2-91CB-6E05876E8115}"/>
+                <a16:creationId xmlns:a16="http://schemas.microsoft.com/office/drawing/2014/main" id="{43B9CF01-37D5-4661-BD9F-66C206346159}"/>
               </a:ext>
             </a:extLst>
           </p:cNvPr>
@@ -7337,7 +7337,7 @@
           <p:cNvPr id="32" name="">
             <a:extLst xmlns:a="http://schemas.openxmlformats.org/drawingml/2006/main">
               <a:ext uri="{FF2B5EF4-FFF2-40B4-BE49-F238E27FC236}">
-                <a16:creationId xmlns:a16="http://schemas.microsoft.com/office/drawing/2014/main" id="{0E45DDDF-1BE1-46AC-91BF-61962EBE1A63}"/>
+                <a16:creationId xmlns:a16="http://schemas.microsoft.com/office/drawing/2014/main" id="{25BE47F4-0EBA-4B73-BD88-6FD29301B967}"/>
               </a:ext>
             </a:extLst>
           </p:cNvPr>
@@ -7395,7 +7395,7 @@
           <p:cNvPr id="33" name="">
             <a:extLst xmlns:a="http://schemas.openxmlformats.org/drawingml/2006/main">
               <a:ext uri="{FF2B5EF4-FFF2-40B4-BE49-F238E27FC236}">
-                <a16:creationId xmlns:a16="http://schemas.microsoft.com/office/drawing/2014/main" id="{4BAB8322-9032-4B44-9A58-6FC9B8171405}"/>
+                <a16:creationId xmlns:a16="http://schemas.microsoft.com/office/drawing/2014/main" id="{619CBC93-AADC-4BF8-B1AE-03C07430EE20}"/>
               </a:ext>
             </a:extLst>
           </p:cNvPr>
@@ -7453,7 +7453,7 @@
           <p:cNvPr id="34" name="">
             <a:extLst xmlns:a="http://schemas.openxmlformats.org/drawingml/2006/main">
               <a:ext uri="{FF2B5EF4-FFF2-40B4-BE49-F238E27FC236}">
-                <a16:creationId xmlns:a16="http://schemas.microsoft.com/office/drawing/2014/main" id="{1AB87823-1179-4DB3-80C7-68FF6A6DEB8F}"/>
+                <a16:creationId xmlns:a16="http://schemas.microsoft.com/office/drawing/2014/main" id="{4C4E0D91-611A-40D5-89A0-8CC437CE3AA9}"/>
               </a:ext>
             </a:extLst>
           </p:cNvPr>
@@ -7511,7 +7511,7 @@
           <p:cNvPr id="35" name="">
             <a:extLst xmlns:a="http://schemas.openxmlformats.org/drawingml/2006/main">
               <a:ext uri="{FF2B5EF4-FFF2-40B4-BE49-F238E27FC236}">
-                <a16:creationId xmlns:a16="http://schemas.microsoft.com/office/drawing/2014/main" id="{DA824C80-D8E4-4844-B1EA-AE0BC67DF27B}"/>
+                <a16:creationId xmlns:a16="http://schemas.microsoft.com/office/drawing/2014/main" id="{AB745E20-DB2A-4B40-9421-DD5A29B951F0}"/>
               </a:ext>
             </a:extLst>
           </p:cNvPr>
@@ -7544,7 +7544,7 @@
           <p:cNvPr id="36" name="">
             <a:extLst xmlns:a="http://schemas.openxmlformats.org/drawingml/2006/main">
               <a:ext uri="{FF2B5EF4-FFF2-40B4-BE49-F238E27FC236}">
-                <a16:creationId xmlns:a16="http://schemas.microsoft.com/office/drawing/2014/main" id="{889ABDDF-4BE9-4704-A273-6FEC44BB27CB}"/>
+                <a16:creationId xmlns:a16="http://schemas.microsoft.com/office/drawing/2014/main" id="{A0CA865E-67FD-4EF1-A34E-47B73BDB3309}"/>
               </a:ext>
             </a:extLst>
           </p:cNvPr>
@@ -7602,7 +7602,7 @@
           <p:cNvPr id="37" name="">
             <a:extLst xmlns:a="http://schemas.openxmlformats.org/drawingml/2006/main">
               <a:ext uri="{FF2B5EF4-FFF2-40B4-BE49-F238E27FC236}">
-                <a16:creationId xmlns:a16="http://schemas.microsoft.com/office/drawing/2014/main" id="{BAF974F3-5B1F-481F-B6A4-0823ED147D66}"/>
+                <a16:creationId xmlns:a16="http://schemas.microsoft.com/office/drawing/2014/main" id="{326C9846-3B10-4A42-B561-8139422E83CE}"/>
               </a:ext>
             </a:extLst>
           </p:cNvPr>
@@ -7660,7 +7660,7 @@
           <p:cNvPr id="38" name="">
             <a:extLst xmlns:a="http://schemas.openxmlformats.org/drawingml/2006/main">
               <a:ext uri="{FF2B5EF4-FFF2-40B4-BE49-F238E27FC236}">
-                <a16:creationId xmlns:a16="http://schemas.microsoft.com/office/drawing/2014/main" id="{6F133A1F-804D-4BF6-AF3A-E2DD31585B51}"/>
+                <a16:creationId xmlns:a16="http://schemas.microsoft.com/office/drawing/2014/main" id="{CA829127-E71F-4275-A62B-05BF14C5F43A}"/>
               </a:ext>
             </a:extLst>
           </p:cNvPr>
@@ -7718,7 +7718,7 @@
           <p:cNvPr id="39" name="">
             <a:extLst xmlns:a="http://schemas.openxmlformats.org/drawingml/2006/main">
               <a:ext uri="{FF2B5EF4-FFF2-40B4-BE49-F238E27FC236}">
-                <a16:creationId xmlns:a16="http://schemas.microsoft.com/office/drawing/2014/main" id="{8F5B18A0-BB25-4A7A-AE82-E4D6277CA64B}"/>
+                <a16:creationId xmlns:a16="http://schemas.microsoft.com/office/drawing/2014/main" id="{07BFEDCF-1161-4BB5-B348-F97237F13A7F}"/>
               </a:ext>
             </a:extLst>
           </p:cNvPr>
@@ -7751,7 +7751,7 @@
           <p:cNvPr id="40" name="">
             <a:extLst xmlns:a="http://schemas.openxmlformats.org/drawingml/2006/main">
               <a:ext uri="{FF2B5EF4-FFF2-40B4-BE49-F238E27FC236}">
-                <a16:creationId xmlns:a16="http://schemas.microsoft.com/office/drawing/2014/main" id="{9AC28609-F301-47B0-98F2-0840305FDE20}"/>
+                <a16:creationId xmlns:a16="http://schemas.microsoft.com/office/drawing/2014/main" id="{DAA36133-752A-43A2-A2A5-0F01EBE0F65D}"/>
               </a:ext>
             </a:extLst>
           </p:cNvPr>
@@ -7809,7 +7809,7 @@
           <p:cNvPr id="41" name="">
             <a:extLst xmlns:a="http://schemas.openxmlformats.org/drawingml/2006/main">
               <a:ext uri="{FF2B5EF4-FFF2-40B4-BE49-F238E27FC236}">
-                <a16:creationId xmlns:a16="http://schemas.microsoft.com/office/drawing/2014/main" id="{2A1893E1-40E0-44E4-B9A9-18C8A8A37BD2}"/>
+                <a16:creationId xmlns:a16="http://schemas.microsoft.com/office/drawing/2014/main" id="{F10A439E-9B9D-4B01-8D5B-BB1B137F3544}"/>
               </a:ext>
             </a:extLst>
           </p:cNvPr>
@@ -7867,7 +7867,7 @@
           <p:cNvPr id="42" name="">
             <a:extLst xmlns:a="http://schemas.openxmlformats.org/drawingml/2006/main">
               <a:ext uri="{FF2B5EF4-FFF2-40B4-BE49-F238E27FC236}">
-                <a16:creationId xmlns:a16="http://schemas.microsoft.com/office/drawing/2014/main" id="{09F2F8ED-7A2D-4B68-9781-42FAF8EC535F}"/>
+                <a16:creationId xmlns:a16="http://schemas.microsoft.com/office/drawing/2014/main" id="{CFC0612A-AF1A-46D5-88B0-595A8D1BAE69}"/>
               </a:ext>
             </a:extLst>
           </p:cNvPr>
@@ -7925,7 +7925,7 @@
           <p:cNvPr id="43" name="">
             <a:extLst xmlns:a="http://schemas.openxmlformats.org/drawingml/2006/main">
               <a:ext uri="{FF2B5EF4-FFF2-40B4-BE49-F238E27FC236}">
-                <a16:creationId xmlns:a16="http://schemas.microsoft.com/office/drawing/2014/main" id="{F5A231C2-D41E-437A-BCA9-4C89EF0893B8}"/>
+                <a16:creationId xmlns:a16="http://schemas.microsoft.com/office/drawing/2014/main" id="{7C6FB5F8-DF48-412C-8E0D-D0036EA7B61C}"/>
               </a:ext>
             </a:extLst>
           </p:cNvPr>
@@ -7956,18 +7956,18 @@
           <p:cNvPr id="44" name="">
             <a:extLst xmlns:a="http://schemas.openxmlformats.org/drawingml/2006/main">
               <a:ext uri="{FF2B5EF4-FFF2-40B4-BE49-F238E27FC236}">
-                <a16:creationId xmlns:a16="http://schemas.microsoft.com/office/drawing/2014/main" id="{B5F4BDA3-6E20-4030-9FFB-0C2BB7E89E90}"/>
-              </a:ext>
-            </a:extLst>
-          </p:cNvPr>
-          <p:cNvSpPr>
-            <a:spLocks xmlns:a="http://schemas.openxmlformats.org/drawingml/2006/main" noGrp="1"/>
-          </p:cNvSpPr>
-          <p:nvPr/>
-        </p:nvSpPr>
-        <p:spPr>
-          <a:xfrm xmlns:a="http://schemas.openxmlformats.org/drawingml/2006/main">
-            <a:off x="628650" y="5753100"/>
+                <a16:creationId xmlns:a16="http://schemas.microsoft.com/office/drawing/2014/main" id="{0ECC6128-4AF9-4C07-9920-3ACDE59DA282}"/>
+              </a:ext>
+            </a:extLst>
+          </p:cNvPr>
+          <p:cNvSpPr>
+            <a:spLocks xmlns:a="http://schemas.openxmlformats.org/drawingml/2006/main" noGrp="1"/>
+          </p:cNvSpPr>
+          <p:nvPr/>
+        </p:nvSpPr>
+        <p:spPr>
+          <a:xfrm xmlns:a="http://schemas.openxmlformats.org/drawingml/2006/main">
+            <a:off x="628650" y="5791200"/>
             <a:ext cx="1809750" cy="266700"/>
           </a:xfrm>
           <a:prstGeom xmlns:a="http://schemas.openxmlformats.org/drawingml/2006/main" prst="rect">
@@ -8004,7 +8004,7 @@
                 <a:ea typeface="Helvetica Neue"/>
                 <a:cs typeface="Helvetica Neue"/>
               </a:rPr>
-              <a:t>Mechanism proof</a:t>
+              <a:t>Harness signals</a:t>
             </a:r>
           </a:p>
         </p:txBody>
@@ -8014,37 +8014,37 @@
           <p:cNvPr id="45" name="">
             <a:extLst xmlns:a="http://schemas.openxmlformats.org/drawingml/2006/main">
               <a:ext uri="{FF2B5EF4-FFF2-40B4-BE49-F238E27FC236}">
-                <a16:creationId xmlns:a16="http://schemas.microsoft.com/office/drawing/2014/main" id="{B6D07FEF-D7F4-4B86-9ECB-48590DC39EEF}"/>
-              </a:ext>
-            </a:extLst>
-          </p:cNvPr>
-          <p:cNvSpPr>
-            <a:spLocks xmlns:a="http://schemas.openxmlformats.org/drawingml/2006/main" noGrp="1"/>
-          </p:cNvSpPr>
-          <p:nvPr/>
-        </p:nvSpPr>
-        <p:spPr>
-          <a:xfrm xmlns:a="http://schemas.openxmlformats.org/drawingml/2006/main">
-            <a:off x="2438400" y="5753100"/>
-            <a:ext cx="8191500" cy="400050"/>
-          </a:xfrm>
-          <a:prstGeom xmlns:a="http://schemas.openxmlformats.org/drawingml/2006/main" prst="rect">
-            <a:avLst/>
-          </a:prstGeom>
-          <a:noFill xmlns:a="http://schemas.openxmlformats.org/drawingml/2006/main"/>
-          <a:ln xmlns:a="http://schemas.openxmlformats.org/drawingml/2006/main" w="0">
-            <a:noFill/>
-            <a:prstDash val="solid"/>
-          </a:ln>
-        </p:spPr>
-        <p:txBody>
-          <a:bodyPr xmlns:a="http://schemas.openxmlformats.org/drawingml/2006/main" anchor="t">
-            <a:noAutofit/>
-          </a:bodyPr>
-          <a:lstStyle xmlns:a="http://schemas.openxmlformats.org/drawingml/2006/main"/>
-          <a:p xmlns:a="http://schemas.openxmlformats.org/drawingml/2006/main">
-            <a:pPr algn="l">
-              <a:defRPr sz="1500" b="1">
+                <a16:creationId xmlns:a16="http://schemas.microsoft.com/office/drawing/2014/main" id="{9BFAF7B5-8F68-43E1-9298-85C133623CF9}"/>
+              </a:ext>
+            </a:extLst>
+          </p:cNvPr>
+          <p:cNvSpPr>
+            <a:spLocks xmlns:a="http://schemas.openxmlformats.org/drawingml/2006/main" noGrp="1"/>
+          </p:cNvSpPr>
+          <p:nvPr/>
+        </p:nvSpPr>
+        <p:spPr>
+          <a:xfrm xmlns:a="http://schemas.openxmlformats.org/drawingml/2006/main">
+            <a:off x="2438400" y="5772150"/>
+            <a:ext cx="8572500" cy="438150"/>
+          </a:xfrm>
+          <a:prstGeom xmlns:a="http://schemas.openxmlformats.org/drawingml/2006/main" prst="rect">
+            <a:avLst/>
+          </a:prstGeom>
+          <a:noFill xmlns:a="http://schemas.openxmlformats.org/drawingml/2006/main"/>
+          <a:ln xmlns:a="http://schemas.openxmlformats.org/drawingml/2006/main" w="0">
+            <a:noFill/>
+            <a:prstDash val="solid"/>
+          </a:ln>
+        </p:spPr>
+        <p:txBody>
+          <a:bodyPr xmlns:a="http://schemas.openxmlformats.org/drawingml/2006/main" anchor="t">
+            <a:noAutofit/>
+          </a:bodyPr>
+          <a:lstStyle xmlns:a="http://schemas.openxmlformats.org/drawingml/2006/main"/>
+          <a:p xmlns:a="http://schemas.openxmlformats.org/drawingml/2006/main">
+            <a:pPr algn="l">
+              <a:defRPr sz="1350" b="1">
                 <a:solidFill>
                   <a:srgbClr val="111827"/>
                 </a:solidFill>
@@ -8054,7 +8054,7 @@
               </a:defRPr>
             </a:pPr>
             <a:r>
-              <a:rPr sz="1500" b="1">
+              <a:rPr sz="1350" b="1">
                 <a:solidFill>
                   <a:srgbClr val="111827"/>
                 </a:solidFill>
@@ -8062,7 +8062,7 @@
                 <a:ea typeface="Helvetica Neue"/>
                 <a:cs typeface="Helvetica Neue"/>
               </a:rPr>
-              <a:t>Value classes reached SGLang with zero mismatches, and native HiCache eviction events were observed.</a:t>
+              <a:t>Session ID, prefix ID, expected return time, reuse probability, rebuild cost, replay deadline, work value, cancelable flag.</a:t>
             </a:r>
           </a:p>
         </p:txBody>
@@ -8070,7 +8070,7 @@
     </p:spTree>
     <p:extLst>
       <p:ext uri="{BB962C8B-B14F-4D97-AF65-F5344CB8AC3E}">
-        <p14:creationId xmlns:p14="http://schemas.microsoft.com/office/powerpoint/2010/main" val="552952581"/>
+        <p14:creationId xmlns:p14="http://schemas.microsoft.com/office/powerpoint/2010/main" val="798284948"/>
       </p:ext>
     </p:extLst>
   </p:cSld>

</xml_diff>

<commit_message>
Update scenario 1 results in master deck
</commit_message>
<xml_diff>
--- a/presentation/harness_aware_scenario_results_master.pptx
+++ b/presentation/harness_aware_scenario_results_master.pptx
@@ -2,15 +2,15 @@
 <file path=ppt/presentation.xml><?xml version="1.0" encoding="utf-8"?>
 <p:presentation xmlns:p="http://schemas.openxmlformats.org/presentationml/2006/main">
   <p:sldMasterIdLst>
-    <p:sldMasterId xmlns:r="http://schemas.openxmlformats.org/officeDocument/2006/relationships" id="2147483648" r:id="R10a245d2f69f46c7"/>
+    <p:sldMasterId xmlns:r="http://schemas.openxmlformats.org/officeDocument/2006/relationships" id="2147483648" r:id="R1846000c1a06466b"/>
   </p:sldMasterIdLst>
   <p:notesMasterIdLst>
-    <p:notesMasterId xmlns:r="http://schemas.openxmlformats.org/officeDocument/2006/relationships" r:id="Rafaff5f36abb4cb7"/>
+    <p:notesMasterId xmlns:r="http://schemas.openxmlformats.org/officeDocument/2006/relationships" r:id="R52a0847507394216"/>
   </p:notesMasterIdLst>
   <p:sldIdLst>
-    <p:sldId xmlns:r="http://schemas.openxmlformats.org/officeDocument/2006/relationships" id="256" r:id="R9c03230f92d54e19"/>
-    <p:sldId xmlns:r="http://schemas.openxmlformats.org/officeDocument/2006/relationships" id="257" r:id="Rb50ecf08e1454e1d"/>
-    <p:sldId xmlns:r="http://schemas.openxmlformats.org/officeDocument/2006/relationships" id="258" r:id="R4f1fb68c7cf54ee2"/>
+    <p:sldId xmlns:r="http://schemas.openxmlformats.org/officeDocument/2006/relationships" id="256" r:id="Rb74155c8cbdb46ef"/>
+    <p:sldId xmlns:r="http://schemas.openxmlformats.org/officeDocument/2006/relationships" id="257" r:id="R138d1589c912440e"/>
+    <p:sldId xmlns:r="http://schemas.openxmlformats.org/officeDocument/2006/relationships" id="258" r:id="R0f814b2aa5f945c7"/>
   </p:sldIdLst>
   <p:sldSz cx="12192000" cy="6858000"/>
   <p:notesSz cx="6858000" cy="9144000"/>
@@ -474,7 +474,17 @@
           </a:p>
           <a:p xmlns:a="http://schemas.openxmlformats.org/drawingml/2006/main">
             <a:r>
-              <a:t>Results: Total TTFT improved from 101.5 s to 86.2 s, or 15.1%. Average TTFT improved from 3.2 s to 2.7 s per replay request. Total lateness improved from 278.7 s to 217.1 s, or 22.1%. Average replay lateness improved from 8.7 s to 6.8 s. P95 lateness improved from 31.3 s to 19.5 s, or 37.6%. Max lateness improved from 31.6 s to 19.6 s, or 38.0%. Trade-off: full workload window increased from 234.7 s to 257.7 s, or 23.0 s longer.</a:t>
+              <a:t>Results: Total TTFT improved from 112.2 s to 74.4 s, or 33.7%. Average TTFT improved from 3.5 s to 2.3 s per replay request. Total lateness improved from 287.3 s to 213.6 s, or 25.7%. Average replay lateness improved from 9.0 s to 6.7 s. P95 lateness improved from 30.0 s to 18.2 s, or 39.4%. Max lateness improved from 31.6 s to 19.7 s, or 38.0%. Trade-off: full workload window increased from 37.1 s to 42.0 s, or 5.0 s longer.</a:t>
+            </a:r>
+          </a:p>
+          <a:p xmlns:a="http://schemas.openxmlformats.org/drawingml/2006/main">
+            <a:r>
+              <a:t/>
+            </a:r>
+          </a:p>
+          <a:p xmlns:a="http://schemas.openxmlformats.org/drawingml/2006/main">
+            <a:r>
+              <a:t>Mechanism evidence: early priorities assigned 32 / 32 replay requests, SGLang priority rows 32 / 32, local submission priority 32 / 32. Tool-wait buckets were 7 very short, 8 short, 14 medium, and 3 long. Replay friction deep dive was trace-rich for 64 / 64 rows. Controller average scheduler friction was 2.6 versus baseline 2.7, and controller average memory friction was 2.7 versus baseline 2.8. The main remaining issue was mixed scheduler and memory friction.</a:t>
             </a:r>
           </a:p>
           <a:p xmlns:a="http://schemas.openxmlformats.org/drawingml/2006/main">
@@ -827,7 +837,7 @@
   </p:cSld>
   <p:clrMap bg1="lt1" tx1="dk1" bg2="lt2" tx2="dk2" accent1="accent1" accent2="accent2" accent3="accent3" accent4="accent4" accent5="accent5" accent6="accent6" hlink="hlink" folHlink="folHlink"/>
   <p:sldLayoutIdLst>
-    <p:sldLayoutId xmlns:r="http://schemas.openxmlformats.org/officeDocument/2006/relationships" id="2147483649" r:id="Rfc56408c10b74417"/>
+    <p:sldLayoutId xmlns:r="http://schemas.openxmlformats.org/officeDocument/2006/relationships" id="2147483649" r:id="Ra7ff8dfd635f49aa"/>
   </p:sldLayoutIdLst>
   <p:txStyles>
     <p:titleStyle>
@@ -1375,10 +1385,10 @@
       </p:grpSpPr>
       <p:sp>
         <p:nvSpPr>
-          <p:cNvPr id="42" name="">
-            <a:extLst xmlns:a="http://schemas.openxmlformats.org/drawingml/2006/main">
-              <a:ext uri="{FF2B5EF4-FFF2-40B4-BE49-F238E27FC236}">
-                <a16:creationId xmlns:a16="http://schemas.microsoft.com/office/drawing/2014/main" id="{351CBF5E-A5FE-4967-BD90-4976E6A95CC4}"/>
+          <p:cNvPr id="46" name="">
+            <a:extLst xmlns:a="http://schemas.openxmlformats.org/drawingml/2006/main">
+              <a:ext uri="{FF2B5EF4-FFF2-40B4-BE49-F238E27FC236}">
+                <a16:creationId xmlns:a16="http://schemas.microsoft.com/office/drawing/2014/main" id="{5FEF9032-14CB-4611-BFAE-F9FD912DC336}"/>
               </a:ext>
             </a:extLst>
           </p:cNvPr>
@@ -1436,7 +1446,7 @@
           <p:cNvPr id="2" name="">
             <a:extLst xmlns:a="http://schemas.openxmlformats.org/drawingml/2006/main">
               <a:ext uri="{FF2B5EF4-FFF2-40B4-BE49-F238E27FC236}">
-                <a16:creationId xmlns:a16="http://schemas.microsoft.com/office/drawing/2014/main" id="{D0EBDD80-F7D3-429E-9555-8B7790B0667C}"/>
+                <a16:creationId xmlns:a16="http://schemas.microsoft.com/office/drawing/2014/main" id="{7893614C-BAF1-4178-84FB-C89060545A2C}"/>
               </a:ext>
             </a:extLst>
           </p:cNvPr>
@@ -1494,7 +1504,7 @@
           <p:cNvPr id="3" name="">
             <a:extLst xmlns:a="http://schemas.openxmlformats.org/drawingml/2006/main">
               <a:ext uri="{FF2B5EF4-FFF2-40B4-BE49-F238E27FC236}">
-                <a16:creationId xmlns:a16="http://schemas.microsoft.com/office/drawing/2014/main" id="{F8FE4A39-DDAB-47FE-8C76-653EA7F5BC37}"/>
+                <a16:creationId xmlns:a16="http://schemas.microsoft.com/office/drawing/2014/main" id="{A008747E-5F60-4951-95E5-E3684A183D61}"/>
               </a:ext>
             </a:extLst>
           </p:cNvPr>
@@ -1552,7 +1562,7 @@
           <p:cNvPr id="4" name="">
             <a:extLst xmlns:a="http://schemas.openxmlformats.org/drawingml/2006/main">
               <a:ext uri="{FF2B5EF4-FFF2-40B4-BE49-F238E27FC236}">
-                <a16:creationId xmlns:a16="http://schemas.microsoft.com/office/drawing/2014/main" id="{B2BE20B3-5D5F-4FE0-9F12-DAA29906AAE4}"/>
+                <a16:creationId xmlns:a16="http://schemas.microsoft.com/office/drawing/2014/main" id="{0EA58FBC-C468-4785-B208-EA1C78EDAB49}"/>
               </a:ext>
             </a:extLst>
           </p:cNvPr>
@@ -1583,7 +1593,7 @@
           <p:cNvPr id="5" name="">
             <a:extLst xmlns:a="http://schemas.openxmlformats.org/drawingml/2006/main">
               <a:ext uri="{FF2B5EF4-FFF2-40B4-BE49-F238E27FC236}">
-                <a16:creationId xmlns:a16="http://schemas.microsoft.com/office/drawing/2014/main" id="{96061511-120F-4498-890E-555FD8DC7E48}"/>
+                <a16:creationId xmlns:a16="http://schemas.microsoft.com/office/drawing/2014/main" id="{A4888AE9-8195-46F2-A38B-AE7FB7609491}"/>
               </a:ext>
             </a:extLst>
           </p:cNvPr>
@@ -1641,7 +1651,7 @@
           <p:cNvPr id="6" name="">
             <a:extLst xmlns:a="http://schemas.openxmlformats.org/drawingml/2006/main">
               <a:ext uri="{FF2B5EF4-FFF2-40B4-BE49-F238E27FC236}">
-                <a16:creationId xmlns:a16="http://schemas.microsoft.com/office/drawing/2014/main" id="{2647319C-4DED-4325-ADC4-D5A01E41F27A}"/>
+                <a16:creationId xmlns:a16="http://schemas.microsoft.com/office/drawing/2014/main" id="{878B6368-AF16-4BA7-B9BC-8F26041E6B62}"/>
               </a:ext>
             </a:extLst>
           </p:cNvPr>
@@ -1674,7 +1684,7 @@
           <p:cNvPr id="7" name="">
             <a:extLst xmlns:a="http://schemas.openxmlformats.org/drawingml/2006/main">
               <a:ext uri="{FF2B5EF4-FFF2-40B4-BE49-F238E27FC236}">
-                <a16:creationId xmlns:a16="http://schemas.microsoft.com/office/drawing/2014/main" id="{B84B0E55-834B-4942-BAE1-344B231EC40B}"/>
+                <a16:creationId xmlns:a16="http://schemas.microsoft.com/office/drawing/2014/main" id="{317FB1B8-3360-483C-B3E8-DD52894F1B83}"/>
               </a:ext>
             </a:extLst>
           </p:cNvPr>
@@ -1732,7 +1742,7 @@
           <p:cNvPr id="8" name="">
             <a:extLst xmlns:a="http://schemas.openxmlformats.org/drawingml/2006/main">
               <a:ext uri="{FF2B5EF4-FFF2-40B4-BE49-F238E27FC236}">
-                <a16:creationId xmlns:a16="http://schemas.microsoft.com/office/drawing/2014/main" id="{B8843939-FA4C-47E6-9D3C-54691A9E6ACA}"/>
+                <a16:creationId xmlns:a16="http://schemas.microsoft.com/office/drawing/2014/main" id="{F98A62EC-8AF1-4A6C-91C6-FD1938C7E684}"/>
               </a:ext>
             </a:extLst>
           </p:cNvPr>
@@ -1765,7 +1775,7 @@
           <p:cNvPr id="9" name="">
             <a:extLst xmlns:a="http://schemas.openxmlformats.org/drawingml/2006/main">
               <a:ext uri="{FF2B5EF4-FFF2-40B4-BE49-F238E27FC236}">
-                <a16:creationId xmlns:a16="http://schemas.microsoft.com/office/drawing/2014/main" id="{4A328FAF-A715-4B1E-8FE5-25B8194E0A0B}"/>
+                <a16:creationId xmlns:a16="http://schemas.microsoft.com/office/drawing/2014/main" id="{822E2D99-C452-45BA-A1EA-BDAEA406A347}"/>
               </a:ext>
             </a:extLst>
           </p:cNvPr>
@@ -1823,7 +1833,7 @@
           <p:cNvPr id="10" name="">
             <a:extLst xmlns:a="http://schemas.openxmlformats.org/drawingml/2006/main">
               <a:ext uri="{FF2B5EF4-FFF2-40B4-BE49-F238E27FC236}">
-                <a16:creationId xmlns:a16="http://schemas.microsoft.com/office/drawing/2014/main" id="{711A868D-C769-4D6A-9561-CAAB687A5242}"/>
+                <a16:creationId xmlns:a16="http://schemas.microsoft.com/office/drawing/2014/main" id="{C39A7921-DD87-4960-99F8-60F4D22B0BE1}"/>
               </a:ext>
             </a:extLst>
           </p:cNvPr>
@@ -1856,7 +1866,7 @@
           <p:cNvPr id="11" name="">
             <a:extLst xmlns:a="http://schemas.openxmlformats.org/drawingml/2006/main">
               <a:ext uri="{FF2B5EF4-FFF2-40B4-BE49-F238E27FC236}">
-                <a16:creationId xmlns:a16="http://schemas.microsoft.com/office/drawing/2014/main" id="{77ADCDE7-C0F0-4E7B-A0E4-64493B51C9DC}"/>
+                <a16:creationId xmlns:a16="http://schemas.microsoft.com/office/drawing/2014/main" id="{CF7FE237-7ED0-472C-B761-FAF98D9E40F3}"/>
               </a:ext>
             </a:extLst>
           </p:cNvPr>
@@ -1914,7 +1924,7 @@
           <p:cNvPr id="12" name="">
             <a:extLst xmlns:a="http://schemas.openxmlformats.org/drawingml/2006/main">
               <a:ext uri="{FF2B5EF4-FFF2-40B4-BE49-F238E27FC236}">
-                <a16:creationId xmlns:a16="http://schemas.microsoft.com/office/drawing/2014/main" id="{57CC7EA0-9024-49D3-959F-8FE1F9453675}"/>
+                <a16:creationId xmlns:a16="http://schemas.microsoft.com/office/drawing/2014/main" id="{73624CF0-04CE-4503-833D-B6E3E5CC4092}"/>
               </a:ext>
             </a:extLst>
           </p:cNvPr>
@@ -1947,7 +1957,7 @@
           <p:cNvPr id="13" name="">
             <a:extLst xmlns:a="http://schemas.openxmlformats.org/drawingml/2006/main">
               <a:ext uri="{FF2B5EF4-FFF2-40B4-BE49-F238E27FC236}">
-                <a16:creationId xmlns:a16="http://schemas.microsoft.com/office/drawing/2014/main" id="{24712C2E-AB57-4D17-A349-33BEA65F7324}"/>
+                <a16:creationId xmlns:a16="http://schemas.microsoft.com/office/drawing/2014/main" id="{C9D80407-B2CF-4295-B9C2-6B58E3100063}"/>
               </a:ext>
             </a:extLst>
           </p:cNvPr>
@@ -2005,7 +2015,7 @@
           <p:cNvPr id="14" name="">
             <a:extLst xmlns:a="http://schemas.openxmlformats.org/drawingml/2006/main">
               <a:ext uri="{FF2B5EF4-FFF2-40B4-BE49-F238E27FC236}">
-                <a16:creationId xmlns:a16="http://schemas.microsoft.com/office/drawing/2014/main" id="{810D290F-5C27-4F6E-A6F5-B2FB9DDD5455}"/>
+                <a16:creationId xmlns:a16="http://schemas.microsoft.com/office/drawing/2014/main" id="{3855A5C4-3B4C-4245-A404-8DDC1E957691}"/>
               </a:ext>
             </a:extLst>
           </p:cNvPr>
@@ -2038,7 +2048,7 @@
           <p:cNvPr id="15" name="">
             <a:extLst xmlns:a="http://schemas.openxmlformats.org/drawingml/2006/main">
               <a:ext uri="{FF2B5EF4-FFF2-40B4-BE49-F238E27FC236}">
-                <a16:creationId xmlns:a16="http://schemas.microsoft.com/office/drawing/2014/main" id="{350F4ECD-3AF1-41B8-96D3-8415E7047EA1}"/>
+                <a16:creationId xmlns:a16="http://schemas.microsoft.com/office/drawing/2014/main" id="{75324805-BF91-4C8C-94DF-308A6E79F0A8}"/>
               </a:ext>
             </a:extLst>
           </p:cNvPr>
@@ -2096,7 +2106,7 @@
           <p:cNvPr id="16" name="">
             <a:extLst xmlns:a="http://schemas.openxmlformats.org/drawingml/2006/main">
               <a:ext uri="{FF2B5EF4-FFF2-40B4-BE49-F238E27FC236}">
-                <a16:creationId xmlns:a16="http://schemas.microsoft.com/office/drawing/2014/main" id="{6560C1D4-792E-4F02-A357-821428105473}"/>
+                <a16:creationId xmlns:a16="http://schemas.microsoft.com/office/drawing/2014/main" id="{11C425E2-F647-4927-A946-6E3EB54CBE60}"/>
               </a:ext>
             </a:extLst>
           </p:cNvPr>
@@ -2154,7 +2164,7 @@
           <p:cNvPr id="17" name="">
             <a:extLst xmlns:a="http://schemas.openxmlformats.org/drawingml/2006/main">
               <a:ext uri="{FF2B5EF4-FFF2-40B4-BE49-F238E27FC236}">
-                <a16:creationId xmlns:a16="http://schemas.microsoft.com/office/drawing/2014/main" id="{9B3A69C4-5406-427E-A145-7DFF9B3FD7BE}"/>
+                <a16:creationId xmlns:a16="http://schemas.microsoft.com/office/drawing/2014/main" id="{C8D580B7-EDE9-4292-8AB6-7BAAC894DDF0}"/>
               </a:ext>
             </a:extLst>
           </p:cNvPr>
@@ -2212,7 +2222,7 @@
           <p:cNvPr id="18" name="">
             <a:extLst xmlns:a="http://schemas.openxmlformats.org/drawingml/2006/main">
               <a:ext uri="{FF2B5EF4-FFF2-40B4-BE49-F238E27FC236}">
-                <a16:creationId xmlns:a16="http://schemas.microsoft.com/office/drawing/2014/main" id="{6AC2C310-6E3C-4042-8B23-583A2A3ED0E5}"/>
+                <a16:creationId xmlns:a16="http://schemas.microsoft.com/office/drawing/2014/main" id="{8D8908F1-C889-405E-A00F-56860C64946F}"/>
               </a:ext>
             </a:extLst>
           </p:cNvPr>
@@ -2260,7 +2270,7 @@
                 <a:ea typeface="Helvetica Neue"/>
                 <a:cs typeface="Helvetica Neue"/>
               </a:rPr>
-              <a:t>Latest clear-win run: deadline_predictive_queue_submitprio_20260916_221604</a:t>
+              <a:t>Latest clear-win run: scenario1_replay_friction_20260917_192617</a:t>
             </a:r>
           </a:p>
         </p:txBody>
@@ -2270,7 +2280,7 @@
           <p:cNvPr id="19" name="">
             <a:extLst xmlns:a="http://schemas.openxmlformats.org/drawingml/2006/main">
               <a:ext uri="{FF2B5EF4-FFF2-40B4-BE49-F238E27FC236}">
-                <a16:creationId xmlns:a16="http://schemas.microsoft.com/office/drawing/2014/main" id="{E923956B-BA24-4F82-8B22-AEA63776EA93}"/>
+                <a16:creationId xmlns:a16="http://schemas.microsoft.com/office/drawing/2014/main" id="{AE6D7497-9764-4210-806D-54F5C4193859}"/>
               </a:ext>
             </a:extLst>
           </p:cNvPr>
@@ -2282,7 +2292,7 @@
         <p:spPr>
           <a:xfrm xmlns:a="http://schemas.openxmlformats.org/drawingml/2006/main">
             <a:off x="5619750" y="2171700"/>
-            <a:ext cx="2571750" cy="876300"/>
+            <a:ext cx="2571750" cy="838200"/>
           </a:xfrm>
           <a:prstGeom xmlns:a="http://schemas.openxmlformats.org/drawingml/2006/main" prst="rect">
             <a:avLst/>
@@ -2303,7 +2313,7 @@
           <p:cNvPr id="20" name="">
             <a:extLst xmlns:a="http://schemas.openxmlformats.org/drawingml/2006/main">
               <a:ext uri="{FF2B5EF4-FFF2-40B4-BE49-F238E27FC236}">
-                <a16:creationId xmlns:a16="http://schemas.microsoft.com/office/drawing/2014/main" id="{77091770-4741-4BEE-B494-7E4ABA18BDCB}"/>
+                <a16:creationId xmlns:a16="http://schemas.microsoft.com/office/drawing/2014/main" id="{47454E70-9D7F-4B90-87BB-7EFF52F9FA30}"/>
               </a:ext>
             </a:extLst>
           </p:cNvPr>
@@ -2361,7 +2371,7 @@
           <p:cNvPr id="21" name="">
             <a:extLst xmlns:a="http://schemas.openxmlformats.org/drawingml/2006/main">
               <a:ext uri="{FF2B5EF4-FFF2-40B4-BE49-F238E27FC236}">
-                <a16:creationId xmlns:a16="http://schemas.microsoft.com/office/drawing/2014/main" id="{0AD94024-BDD7-429B-B784-033B1F92B2F1}"/>
+                <a16:creationId xmlns:a16="http://schemas.microsoft.com/office/drawing/2014/main" id="{D7DE7D61-F82B-4921-98DE-A8C3A6EC65A1}"/>
               </a:ext>
             </a:extLst>
           </p:cNvPr>
@@ -2409,7 +2419,7 @@
                 <a:ea typeface="Helvetica Neue"/>
                 <a:cs typeface="Helvetica Neue"/>
               </a:rPr>
-              <a:t>15.1% better</a:t>
+              <a:t>33.7% better</a:t>
             </a:r>
           </a:p>
         </p:txBody>
@@ -2419,7 +2429,7 @@
           <p:cNvPr id="22" name="">
             <a:extLst xmlns:a="http://schemas.openxmlformats.org/drawingml/2006/main">
               <a:ext uri="{FF2B5EF4-FFF2-40B4-BE49-F238E27FC236}">
-                <a16:creationId xmlns:a16="http://schemas.microsoft.com/office/drawing/2014/main" id="{EB2B8E07-D0E9-4FAD-A2CC-C1D3D18E6CFE}"/>
+                <a16:creationId xmlns:a16="http://schemas.microsoft.com/office/drawing/2014/main" id="{C38E5A49-1566-4730-8F18-E4D337F2C085}"/>
               </a:ext>
             </a:extLst>
           </p:cNvPr>
@@ -2467,7 +2477,7 @@
                 <a:ea typeface="Helvetica Neue"/>
                 <a:cs typeface="Helvetica Neue"/>
               </a:rPr>
-              <a:t>101.5 s to 86.2 s</a:t>
+              <a:t>112.2 s to 74.4 s</a:t>
             </a:r>
           </a:p>
         </p:txBody>
@@ -2477,7 +2487,7 @@
           <p:cNvPr id="23" name="">
             <a:extLst xmlns:a="http://schemas.openxmlformats.org/drawingml/2006/main">
               <a:ext uri="{FF2B5EF4-FFF2-40B4-BE49-F238E27FC236}">
-                <a16:creationId xmlns:a16="http://schemas.microsoft.com/office/drawing/2014/main" id="{AA50A1FD-63B0-4083-9D76-E3F66DDD21BF}"/>
+                <a16:creationId xmlns:a16="http://schemas.microsoft.com/office/drawing/2014/main" id="{1E505ADF-83CC-4740-B8E6-50EE6A26DA97}"/>
               </a:ext>
             </a:extLst>
           </p:cNvPr>
@@ -2489,7 +2499,7 @@
         <p:spPr>
           <a:xfrm xmlns:a="http://schemas.openxmlformats.org/drawingml/2006/main">
             <a:off x="8401050" y="2171700"/>
-            <a:ext cx="2571750" cy="876300"/>
+            <a:ext cx="2571750" cy="838200"/>
           </a:xfrm>
           <a:prstGeom xmlns:a="http://schemas.openxmlformats.org/drawingml/2006/main" prst="rect">
             <a:avLst/>
@@ -2510,7 +2520,7 @@
           <p:cNvPr id="24" name="">
             <a:extLst xmlns:a="http://schemas.openxmlformats.org/drawingml/2006/main">
               <a:ext uri="{FF2B5EF4-FFF2-40B4-BE49-F238E27FC236}">
-                <a16:creationId xmlns:a16="http://schemas.microsoft.com/office/drawing/2014/main" id="{5605468B-8F0C-443E-8C3A-5CC61FD564EC}"/>
+                <a16:creationId xmlns:a16="http://schemas.microsoft.com/office/drawing/2014/main" id="{0956B340-BE79-470F-9585-4C9F83129EEA}"/>
               </a:ext>
             </a:extLst>
           </p:cNvPr>
@@ -2568,7 +2578,7 @@
           <p:cNvPr id="25" name="">
             <a:extLst xmlns:a="http://schemas.openxmlformats.org/drawingml/2006/main">
               <a:ext uri="{FF2B5EF4-FFF2-40B4-BE49-F238E27FC236}">
-                <a16:creationId xmlns:a16="http://schemas.microsoft.com/office/drawing/2014/main" id="{021762E1-0AE6-43FE-8C90-D41485A257D4}"/>
+                <a16:creationId xmlns:a16="http://schemas.microsoft.com/office/drawing/2014/main" id="{7255FB47-DF80-49A2-9576-46E57A71723A}"/>
               </a:ext>
             </a:extLst>
           </p:cNvPr>
@@ -2616,7 +2626,7 @@
                 <a:ea typeface="Helvetica Neue"/>
                 <a:cs typeface="Helvetica Neue"/>
               </a:rPr>
-              <a:t>0.5 s faster</a:t>
+              <a:t>1.2 s faster</a:t>
             </a:r>
           </a:p>
         </p:txBody>
@@ -2626,7 +2636,7 @@
           <p:cNvPr id="26" name="">
             <a:extLst xmlns:a="http://schemas.openxmlformats.org/drawingml/2006/main">
               <a:ext uri="{FF2B5EF4-FFF2-40B4-BE49-F238E27FC236}">
-                <a16:creationId xmlns:a16="http://schemas.microsoft.com/office/drawing/2014/main" id="{D4251926-0D85-463E-A38C-44BAA00A64EB}"/>
+                <a16:creationId xmlns:a16="http://schemas.microsoft.com/office/drawing/2014/main" id="{011FBD03-1C8E-4B13-A7B7-9A36BC122E2E}"/>
               </a:ext>
             </a:extLst>
           </p:cNvPr>
@@ -2674,7 +2684,7 @@
                 <a:ea typeface="Helvetica Neue"/>
                 <a:cs typeface="Helvetica Neue"/>
               </a:rPr>
-              <a:t>3.2 s to 2.7 s</a:t>
+              <a:t>3.5 s to 2.3 s</a:t>
             </a:r>
           </a:p>
         </p:txBody>
@@ -2684,19 +2694,19 @@
           <p:cNvPr id="27" name="">
             <a:extLst xmlns:a="http://schemas.openxmlformats.org/drawingml/2006/main">
               <a:ext uri="{FF2B5EF4-FFF2-40B4-BE49-F238E27FC236}">
-                <a16:creationId xmlns:a16="http://schemas.microsoft.com/office/drawing/2014/main" id="{1D678412-E07D-435E-8BBF-78363DE03E11}"/>
-              </a:ext>
-            </a:extLst>
-          </p:cNvPr>
-          <p:cNvSpPr>
-            <a:spLocks xmlns:a="http://schemas.openxmlformats.org/drawingml/2006/main" noGrp="1"/>
-          </p:cNvSpPr>
-          <p:nvPr/>
-        </p:nvSpPr>
-        <p:spPr>
-          <a:xfrm xmlns:a="http://schemas.openxmlformats.org/drawingml/2006/main">
-            <a:off x="5619750" y="3238500"/>
-            <a:ext cx="2571750" cy="876300"/>
+                <a16:creationId xmlns:a16="http://schemas.microsoft.com/office/drawing/2014/main" id="{82DC9926-FFD2-4C20-A56A-F77DE6424A72}"/>
+              </a:ext>
+            </a:extLst>
+          </p:cNvPr>
+          <p:cNvSpPr>
+            <a:spLocks xmlns:a="http://schemas.openxmlformats.org/drawingml/2006/main" noGrp="1"/>
+          </p:cNvSpPr>
+          <p:nvPr/>
+        </p:nvSpPr>
+        <p:spPr>
+          <a:xfrm xmlns:a="http://schemas.openxmlformats.org/drawingml/2006/main">
+            <a:off x="5619750" y="3181350"/>
+            <a:ext cx="2571750" cy="838200"/>
           </a:xfrm>
           <a:prstGeom xmlns:a="http://schemas.openxmlformats.org/drawingml/2006/main" prst="rect">
             <a:avLst/>
@@ -2717,18 +2727,18 @@
           <p:cNvPr id="28" name="">
             <a:extLst xmlns:a="http://schemas.openxmlformats.org/drawingml/2006/main">
               <a:ext uri="{FF2B5EF4-FFF2-40B4-BE49-F238E27FC236}">
-                <a16:creationId xmlns:a16="http://schemas.microsoft.com/office/drawing/2014/main" id="{FBF3D323-A5A8-463C-A2E0-ABC27EBB5E14}"/>
-              </a:ext>
-            </a:extLst>
-          </p:cNvPr>
-          <p:cNvSpPr>
-            <a:spLocks xmlns:a="http://schemas.openxmlformats.org/drawingml/2006/main" noGrp="1"/>
-          </p:cNvSpPr>
-          <p:nvPr/>
-        </p:nvSpPr>
-        <p:spPr>
-          <a:xfrm xmlns:a="http://schemas.openxmlformats.org/drawingml/2006/main">
-            <a:off x="5772150" y="3352800"/>
+                <a16:creationId xmlns:a16="http://schemas.microsoft.com/office/drawing/2014/main" id="{82DEC91A-C77C-4213-90C2-44CDFB5F32A0}"/>
+              </a:ext>
+            </a:extLst>
+          </p:cNvPr>
+          <p:cNvSpPr>
+            <a:spLocks xmlns:a="http://schemas.openxmlformats.org/drawingml/2006/main" noGrp="1"/>
+          </p:cNvSpPr>
+          <p:nvPr/>
+        </p:nvSpPr>
+        <p:spPr>
+          <a:xfrm xmlns:a="http://schemas.openxmlformats.org/drawingml/2006/main">
+            <a:off x="5772150" y="3295650"/>
             <a:ext cx="2266950" cy="209550"/>
           </a:xfrm>
           <a:prstGeom xmlns:a="http://schemas.openxmlformats.org/drawingml/2006/main" prst="rect">
@@ -2775,18 +2785,18 @@
           <p:cNvPr id="29" name="">
             <a:extLst xmlns:a="http://schemas.openxmlformats.org/drawingml/2006/main">
               <a:ext uri="{FF2B5EF4-FFF2-40B4-BE49-F238E27FC236}">
-                <a16:creationId xmlns:a16="http://schemas.microsoft.com/office/drawing/2014/main" id="{266EB6CA-B95F-4CB9-A341-975CC3A3F0B3}"/>
-              </a:ext>
-            </a:extLst>
-          </p:cNvPr>
-          <p:cNvSpPr>
-            <a:spLocks xmlns:a="http://schemas.openxmlformats.org/drawingml/2006/main" noGrp="1"/>
-          </p:cNvSpPr>
-          <p:nvPr/>
-        </p:nvSpPr>
-        <p:spPr>
-          <a:xfrm xmlns:a="http://schemas.openxmlformats.org/drawingml/2006/main">
-            <a:off x="5772150" y="3581400"/>
+                <a16:creationId xmlns:a16="http://schemas.microsoft.com/office/drawing/2014/main" id="{3392EA11-DE0B-4C28-8864-3F949E35E993}"/>
+              </a:ext>
+            </a:extLst>
+          </p:cNvPr>
+          <p:cNvSpPr>
+            <a:spLocks xmlns:a="http://schemas.openxmlformats.org/drawingml/2006/main" noGrp="1"/>
+          </p:cNvSpPr>
+          <p:nvPr/>
+        </p:nvSpPr>
+        <p:spPr>
+          <a:xfrm xmlns:a="http://schemas.openxmlformats.org/drawingml/2006/main">
+            <a:off x="5772150" y="3524250"/>
             <a:ext cx="2266950" cy="266700"/>
           </a:xfrm>
           <a:prstGeom xmlns:a="http://schemas.openxmlformats.org/drawingml/2006/main" prst="rect">
@@ -2823,7 +2833,7 @@
                 <a:ea typeface="Helvetica Neue"/>
                 <a:cs typeface="Helvetica Neue"/>
               </a:rPr>
-              <a:t>22.1% better</a:t>
+              <a:t>25.7% better</a:t>
             </a:r>
           </a:p>
         </p:txBody>
@@ -2833,18 +2843,18 @@
           <p:cNvPr id="30" name="">
             <a:extLst xmlns:a="http://schemas.openxmlformats.org/drawingml/2006/main">
               <a:ext uri="{FF2B5EF4-FFF2-40B4-BE49-F238E27FC236}">
-                <a16:creationId xmlns:a16="http://schemas.microsoft.com/office/drawing/2014/main" id="{DF650663-0A09-4BA9-9372-F1237FE85E28}"/>
-              </a:ext>
-            </a:extLst>
-          </p:cNvPr>
-          <p:cNvSpPr>
-            <a:spLocks xmlns:a="http://schemas.openxmlformats.org/drawingml/2006/main" noGrp="1"/>
-          </p:cNvSpPr>
-          <p:nvPr/>
-        </p:nvSpPr>
-        <p:spPr>
-          <a:xfrm xmlns:a="http://schemas.openxmlformats.org/drawingml/2006/main">
-            <a:off x="5772150" y="3867150"/>
+                <a16:creationId xmlns:a16="http://schemas.microsoft.com/office/drawing/2014/main" id="{19992F2F-4850-4916-9002-9E9A3DAEC046}"/>
+              </a:ext>
+            </a:extLst>
+          </p:cNvPr>
+          <p:cNvSpPr>
+            <a:spLocks xmlns:a="http://schemas.openxmlformats.org/drawingml/2006/main" noGrp="1"/>
+          </p:cNvSpPr>
+          <p:nvPr/>
+        </p:nvSpPr>
+        <p:spPr>
+          <a:xfrm xmlns:a="http://schemas.openxmlformats.org/drawingml/2006/main">
+            <a:off x="5772150" y="3810000"/>
             <a:ext cx="2266950" cy="171450"/>
           </a:xfrm>
           <a:prstGeom xmlns:a="http://schemas.openxmlformats.org/drawingml/2006/main" prst="rect">
@@ -2881,7 +2891,7 @@
                 <a:ea typeface="Helvetica Neue"/>
                 <a:cs typeface="Helvetica Neue"/>
               </a:rPr>
-              <a:t>278.7 s to 217.1 s</a:t>
+              <a:t>287.3 s to 213.6 s</a:t>
             </a:r>
           </a:p>
         </p:txBody>
@@ -2891,19 +2901,19 @@
           <p:cNvPr id="31" name="">
             <a:extLst xmlns:a="http://schemas.openxmlformats.org/drawingml/2006/main">
               <a:ext uri="{FF2B5EF4-FFF2-40B4-BE49-F238E27FC236}">
-                <a16:creationId xmlns:a16="http://schemas.microsoft.com/office/drawing/2014/main" id="{4E30C288-1FE1-441C-B3FA-9AD5C73ECE32}"/>
-              </a:ext>
-            </a:extLst>
-          </p:cNvPr>
-          <p:cNvSpPr>
-            <a:spLocks xmlns:a="http://schemas.openxmlformats.org/drawingml/2006/main" noGrp="1"/>
-          </p:cNvSpPr>
-          <p:nvPr/>
-        </p:nvSpPr>
-        <p:spPr>
-          <a:xfrm xmlns:a="http://schemas.openxmlformats.org/drawingml/2006/main">
-            <a:off x="8401050" y="3238500"/>
-            <a:ext cx="2571750" cy="876300"/>
+                <a16:creationId xmlns:a16="http://schemas.microsoft.com/office/drawing/2014/main" id="{00535A4D-640B-4290-9AD1-0B584AD73CB4}"/>
+              </a:ext>
+            </a:extLst>
+          </p:cNvPr>
+          <p:cNvSpPr>
+            <a:spLocks xmlns:a="http://schemas.openxmlformats.org/drawingml/2006/main" noGrp="1"/>
+          </p:cNvSpPr>
+          <p:nvPr/>
+        </p:nvSpPr>
+        <p:spPr>
+          <a:xfrm xmlns:a="http://schemas.openxmlformats.org/drawingml/2006/main">
+            <a:off x="8401050" y="3181350"/>
+            <a:ext cx="2571750" cy="838200"/>
           </a:xfrm>
           <a:prstGeom xmlns:a="http://schemas.openxmlformats.org/drawingml/2006/main" prst="rect">
             <a:avLst/>
@@ -2924,18 +2934,18 @@
           <p:cNvPr id="32" name="">
             <a:extLst xmlns:a="http://schemas.openxmlformats.org/drawingml/2006/main">
               <a:ext uri="{FF2B5EF4-FFF2-40B4-BE49-F238E27FC236}">
-                <a16:creationId xmlns:a16="http://schemas.microsoft.com/office/drawing/2014/main" id="{72CAEF76-E4DF-4090-93CA-D7B7F4797AE0}"/>
-              </a:ext>
-            </a:extLst>
-          </p:cNvPr>
-          <p:cNvSpPr>
-            <a:spLocks xmlns:a="http://schemas.openxmlformats.org/drawingml/2006/main" noGrp="1"/>
-          </p:cNvSpPr>
-          <p:nvPr/>
-        </p:nvSpPr>
-        <p:spPr>
-          <a:xfrm xmlns:a="http://schemas.openxmlformats.org/drawingml/2006/main">
-            <a:off x="8553450" y="3352800"/>
+                <a16:creationId xmlns:a16="http://schemas.microsoft.com/office/drawing/2014/main" id="{C0BD4AD6-67CC-49FD-8BEB-85EF514AC8AC}"/>
+              </a:ext>
+            </a:extLst>
+          </p:cNvPr>
+          <p:cNvSpPr>
+            <a:spLocks xmlns:a="http://schemas.openxmlformats.org/drawingml/2006/main" noGrp="1"/>
+          </p:cNvSpPr>
+          <p:nvPr/>
+        </p:nvSpPr>
+        <p:spPr>
+          <a:xfrm xmlns:a="http://schemas.openxmlformats.org/drawingml/2006/main">
+            <a:off x="8553450" y="3295650"/>
             <a:ext cx="2266950" cy="209550"/>
           </a:xfrm>
           <a:prstGeom xmlns:a="http://schemas.openxmlformats.org/drawingml/2006/main" prst="rect">
@@ -2982,18 +2992,18 @@
           <p:cNvPr id="33" name="">
             <a:extLst xmlns:a="http://schemas.openxmlformats.org/drawingml/2006/main">
               <a:ext uri="{FF2B5EF4-FFF2-40B4-BE49-F238E27FC236}">
-                <a16:creationId xmlns:a16="http://schemas.microsoft.com/office/drawing/2014/main" id="{0A606A53-88D3-4E4B-B990-66E8275D1FF9}"/>
-              </a:ext>
-            </a:extLst>
-          </p:cNvPr>
-          <p:cNvSpPr>
-            <a:spLocks xmlns:a="http://schemas.openxmlformats.org/drawingml/2006/main" noGrp="1"/>
-          </p:cNvSpPr>
-          <p:nvPr/>
-        </p:nvSpPr>
-        <p:spPr>
-          <a:xfrm xmlns:a="http://schemas.openxmlformats.org/drawingml/2006/main">
-            <a:off x="8553450" y="3581400"/>
+                <a16:creationId xmlns:a16="http://schemas.microsoft.com/office/drawing/2014/main" id="{B3740A6E-25E5-47A5-8852-56F9AB5E5347}"/>
+              </a:ext>
+            </a:extLst>
+          </p:cNvPr>
+          <p:cNvSpPr>
+            <a:spLocks xmlns:a="http://schemas.openxmlformats.org/drawingml/2006/main" noGrp="1"/>
+          </p:cNvSpPr>
+          <p:nvPr/>
+        </p:nvSpPr>
+        <p:spPr>
+          <a:xfrm xmlns:a="http://schemas.openxmlformats.org/drawingml/2006/main">
+            <a:off x="8553450" y="3524250"/>
             <a:ext cx="2266950" cy="266700"/>
           </a:xfrm>
           <a:prstGeom xmlns:a="http://schemas.openxmlformats.org/drawingml/2006/main" prst="rect">
@@ -3030,7 +3040,7 @@
                 <a:ea typeface="Helvetica Neue"/>
                 <a:cs typeface="Helvetica Neue"/>
               </a:rPr>
-              <a:t>37.6% better</a:t>
+              <a:t>39.4% better</a:t>
             </a:r>
           </a:p>
         </p:txBody>
@@ -3040,18 +3050,18 @@
           <p:cNvPr id="34" name="">
             <a:extLst xmlns:a="http://schemas.openxmlformats.org/drawingml/2006/main">
               <a:ext uri="{FF2B5EF4-FFF2-40B4-BE49-F238E27FC236}">
-                <a16:creationId xmlns:a16="http://schemas.microsoft.com/office/drawing/2014/main" id="{C06F47DF-8B5D-43EF-B02E-F0C8DC7B18DB}"/>
-              </a:ext>
-            </a:extLst>
-          </p:cNvPr>
-          <p:cNvSpPr>
-            <a:spLocks xmlns:a="http://schemas.openxmlformats.org/drawingml/2006/main" noGrp="1"/>
-          </p:cNvSpPr>
-          <p:nvPr/>
-        </p:nvSpPr>
-        <p:spPr>
-          <a:xfrm xmlns:a="http://schemas.openxmlformats.org/drawingml/2006/main">
-            <a:off x="8553450" y="3867150"/>
+                <a16:creationId xmlns:a16="http://schemas.microsoft.com/office/drawing/2014/main" id="{3D5CF11B-43EE-4158-A7C1-66202533F762}"/>
+              </a:ext>
+            </a:extLst>
+          </p:cNvPr>
+          <p:cNvSpPr>
+            <a:spLocks xmlns:a="http://schemas.openxmlformats.org/drawingml/2006/main" noGrp="1"/>
+          </p:cNvSpPr>
+          <p:nvPr/>
+        </p:nvSpPr>
+        <p:spPr>
+          <a:xfrm xmlns:a="http://schemas.openxmlformats.org/drawingml/2006/main">
+            <a:off x="8553450" y="3810000"/>
             <a:ext cx="2266950" cy="171450"/>
           </a:xfrm>
           <a:prstGeom xmlns:a="http://schemas.openxmlformats.org/drawingml/2006/main" prst="rect">
@@ -3088,7 +3098,7 @@
                 <a:ea typeface="Helvetica Neue"/>
                 <a:cs typeface="Helvetica Neue"/>
               </a:rPr>
-              <a:t>31.3 s to 19.5 s</a:t>
+              <a:t>30.0 s to 18.2 s</a:t>
             </a:r>
           </a:p>
         </p:txBody>
@@ -3098,19 +3108,226 @@
           <p:cNvPr id="35" name="">
             <a:extLst xmlns:a="http://schemas.openxmlformats.org/drawingml/2006/main">
               <a:ext uri="{FF2B5EF4-FFF2-40B4-BE49-F238E27FC236}">
-                <a16:creationId xmlns:a16="http://schemas.microsoft.com/office/drawing/2014/main" id="{C1264C39-C0E5-4020-8E33-8971067DCEAE}"/>
-              </a:ext>
-            </a:extLst>
-          </p:cNvPr>
-          <p:cNvSpPr>
-            <a:spLocks xmlns:a="http://schemas.openxmlformats.org/drawingml/2006/main" noGrp="1"/>
-          </p:cNvSpPr>
-          <p:nvPr/>
-        </p:nvSpPr>
-        <p:spPr>
-          <a:xfrm xmlns:a="http://schemas.openxmlformats.org/drawingml/2006/main">
-            <a:off x="5619750" y="4305300"/>
-            <a:ext cx="5353050" cy="876300"/>
+                <a16:creationId xmlns:a16="http://schemas.microsoft.com/office/drawing/2014/main" id="{88987FDF-6F7C-4825-9BDF-A033314C7988}"/>
+              </a:ext>
+            </a:extLst>
+          </p:cNvPr>
+          <p:cNvSpPr>
+            <a:spLocks xmlns:a="http://schemas.openxmlformats.org/drawingml/2006/main" noGrp="1"/>
+          </p:cNvSpPr>
+          <p:nvPr/>
+        </p:nvSpPr>
+        <p:spPr>
+          <a:xfrm xmlns:a="http://schemas.openxmlformats.org/drawingml/2006/main">
+            <a:off x="5619750" y="4191000"/>
+            <a:ext cx="2571750" cy="838200"/>
+          </a:xfrm>
+          <a:prstGeom xmlns:a="http://schemas.openxmlformats.org/drawingml/2006/main" prst="rect">
+            <a:avLst/>
+          </a:prstGeom>
+          <a:solidFill xmlns:a="http://schemas.openxmlformats.org/drawingml/2006/main">
+            <a:srgbClr val="EEF7F1"/>
+          </a:solidFill>
+          <a:ln xmlns:a="http://schemas.openxmlformats.org/drawingml/2006/main" w="9525">
+            <a:solidFill>
+              <a:srgbClr val="DBE4EF"/>
+            </a:solidFill>
+            <a:prstDash val="solid"/>
+          </a:ln>
+        </p:spPr>
+      </p:sp>
+      <p:sp>
+        <p:nvSpPr>
+          <p:cNvPr id="36" name="">
+            <a:extLst xmlns:a="http://schemas.openxmlformats.org/drawingml/2006/main">
+              <a:ext uri="{FF2B5EF4-FFF2-40B4-BE49-F238E27FC236}">
+                <a16:creationId xmlns:a16="http://schemas.microsoft.com/office/drawing/2014/main" id="{539CD843-E467-492A-B26E-44EB38656B37}"/>
+              </a:ext>
+            </a:extLst>
+          </p:cNvPr>
+          <p:cNvSpPr>
+            <a:spLocks xmlns:a="http://schemas.openxmlformats.org/drawingml/2006/main" noGrp="1"/>
+          </p:cNvSpPr>
+          <p:nvPr/>
+        </p:nvSpPr>
+        <p:spPr>
+          <a:xfrm xmlns:a="http://schemas.openxmlformats.org/drawingml/2006/main">
+            <a:off x="5772150" y="4305300"/>
+            <a:ext cx="2266950" cy="209550"/>
+          </a:xfrm>
+          <a:prstGeom xmlns:a="http://schemas.openxmlformats.org/drawingml/2006/main" prst="rect">
+            <a:avLst/>
+          </a:prstGeom>
+          <a:noFill xmlns:a="http://schemas.openxmlformats.org/drawingml/2006/main"/>
+          <a:ln xmlns:a="http://schemas.openxmlformats.org/drawingml/2006/main" w="0">
+            <a:noFill/>
+            <a:prstDash val="solid"/>
+          </a:ln>
+        </p:spPr>
+        <p:txBody>
+          <a:bodyPr xmlns:a="http://schemas.openxmlformats.org/drawingml/2006/main" anchor="t">
+            <a:noAutofit/>
+          </a:bodyPr>
+          <a:lstStyle xmlns:a="http://schemas.openxmlformats.org/drawingml/2006/main"/>
+          <a:p xmlns:a="http://schemas.openxmlformats.org/drawingml/2006/main">
+            <a:pPr algn="l">
+              <a:defRPr sz="1050" b="1">
+                <a:solidFill>
+                  <a:srgbClr val="64748B"/>
+                </a:solidFill>
+                <a:latin typeface="Helvetica Neue"/>
+                <a:ea typeface="Helvetica Neue"/>
+                <a:cs typeface="Helvetica Neue"/>
+              </a:defRPr>
+            </a:pPr>
+            <a:r>
+              <a:rPr sz="1050" b="1">
+                <a:solidFill>
+                  <a:srgbClr val="64748B"/>
+                </a:solidFill>
+                <a:latin typeface="Helvetica Neue"/>
+                <a:ea typeface="Helvetica Neue"/>
+                <a:cs typeface="Helvetica Neue"/>
+              </a:rPr>
+              <a:t>Max lateness</a:t>
+            </a:r>
+          </a:p>
+        </p:txBody>
+      </p:sp>
+      <p:sp>
+        <p:nvSpPr>
+          <p:cNvPr id="37" name="">
+            <a:extLst xmlns:a="http://schemas.openxmlformats.org/drawingml/2006/main">
+              <a:ext uri="{FF2B5EF4-FFF2-40B4-BE49-F238E27FC236}">
+                <a16:creationId xmlns:a16="http://schemas.microsoft.com/office/drawing/2014/main" id="{B770C058-AF96-41E9-9714-3F7B2260309E}"/>
+              </a:ext>
+            </a:extLst>
+          </p:cNvPr>
+          <p:cNvSpPr>
+            <a:spLocks xmlns:a="http://schemas.openxmlformats.org/drawingml/2006/main" noGrp="1"/>
+          </p:cNvSpPr>
+          <p:nvPr/>
+        </p:nvSpPr>
+        <p:spPr>
+          <a:xfrm xmlns:a="http://schemas.openxmlformats.org/drawingml/2006/main">
+            <a:off x="5772150" y="4533900"/>
+            <a:ext cx="2266950" cy="266700"/>
+          </a:xfrm>
+          <a:prstGeom xmlns:a="http://schemas.openxmlformats.org/drawingml/2006/main" prst="rect">
+            <a:avLst/>
+          </a:prstGeom>
+          <a:noFill xmlns:a="http://schemas.openxmlformats.org/drawingml/2006/main"/>
+          <a:ln xmlns:a="http://schemas.openxmlformats.org/drawingml/2006/main" w="0">
+            <a:noFill/>
+            <a:prstDash val="solid"/>
+          </a:ln>
+        </p:spPr>
+        <p:txBody>
+          <a:bodyPr xmlns:a="http://schemas.openxmlformats.org/drawingml/2006/main" anchor="t">
+            <a:noAutofit/>
+          </a:bodyPr>
+          <a:lstStyle xmlns:a="http://schemas.openxmlformats.org/drawingml/2006/main"/>
+          <a:p xmlns:a="http://schemas.openxmlformats.org/drawingml/2006/main">
+            <a:pPr algn="l">
+              <a:defRPr sz="1725" b="1">
+                <a:solidFill>
+                  <a:srgbClr val="111827"/>
+                </a:solidFill>
+                <a:latin typeface="Helvetica Neue"/>
+                <a:ea typeface="Helvetica Neue"/>
+                <a:cs typeface="Helvetica Neue"/>
+              </a:defRPr>
+            </a:pPr>
+            <a:r>
+              <a:rPr sz="1725" b="1">
+                <a:solidFill>
+                  <a:srgbClr val="111827"/>
+                </a:solidFill>
+                <a:latin typeface="Helvetica Neue"/>
+                <a:ea typeface="Helvetica Neue"/>
+                <a:cs typeface="Helvetica Neue"/>
+              </a:rPr>
+              <a:t>38.0% better</a:t>
+            </a:r>
+          </a:p>
+        </p:txBody>
+      </p:sp>
+      <p:sp>
+        <p:nvSpPr>
+          <p:cNvPr id="38" name="">
+            <a:extLst xmlns:a="http://schemas.openxmlformats.org/drawingml/2006/main">
+              <a:ext uri="{FF2B5EF4-FFF2-40B4-BE49-F238E27FC236}">
+                <a16:creationId xmlns:a16="http://schemas.microsoft.com/office/drawing/2014/main" id="{EF15CE0A-0993-4EF9-AE5C-A287110CA5D8}"/>
+              </a:ext>
+            </a:extLst>
+          </p:cNvPr>
+          <p:cNvSpPr>
+            <a:spLocks xmlns:a="http://schemas.openxmlformats.org/drawingml/2006/main" noGrp="1"/>
+          </p:cNvSpPr>
+          <p:nvPr/>
+        </p:nvSpPr>
+        <p:spPr>
+          <a:xfrm xmlns:a="http://schemas.openxmlformats.org/drawingml/2006/main">
+            <a:off x="5772150" y="4819650"/>
+            <a:ext cx="2266950" cy="171450"/>
+          </a:xfrm>
+          <a:prstGeom xmlns:a="http://schemas.openxmlformats.org/drawingml/2006/main" prst="rect">
+            <a:avLst/>
+          </a:prstGeom>
+          <a:noFill xmlns:a="http://schemas.openxmlformats.org/drawingml/2006/main"/>
+          <a:ln xmlns:a="http://schemas.openxmlformats.org/drawingml/2006/main" w="0">
+            <a:noFill/>
+            <a:prstDash val="solid"/>
+          </a:ln>
+        </p:spPr>
+        <p:txBody>
+          <a:bodyPr xmlns:a="http://schemas.openxmlformats.org/drawingml/2006/main" anchor="t">
+            <a:noAutofit/>
+          </a:bodyPr>
+          <a:lstStyle xmlns:a="http://schemas.openxmlformats.org/drawingml/2006/main"/>
+          <a:p xmlns:a="http://schemas.openxmlformats.org/drawingml/2006/main">
+            <a:pPr algn="l">
+              <a:defRPr sz="938" b="0">
+                <a:solidFill>
+                  <a:srgbClr val="334155"/>
+                </a:solidFill>
+                <a:latin typeface="Helvetica Neue"/>
+                <a:ea typeface="Helvetica Neue"/>
+                <a:cs typeface="Helvetica Neue"/>
+              </a:defRPr>
+            </a:pPr>
+            <a:r>
+              <a:rPr sz="938" b="0">
+                <a:solidFill>
+                  <a:srgbClr val="334155"/>
+                </a:solidFill>
+                <a:latin typeface="Helvetica Neue"/>
+                <a:ea typeface="Helvetica Neue"/>
+                <a:cs typeface="Helvetica Neue"/>
+              </a:rPr>
+              <a:t>31.6 s to 19.7 s</a:t>
+            </a:r>
+          </a:p>
+        </p:txBody>
+      </p:sp>
+      <p:sp>
+        <p:nvSpPr>
+          <p:cNvPr id="39" name="">
+            <a:extLst xmlns:a="http://schemas.openxmlformats.org/drawingml/2006/main">
+              <a:ext uri="{FF2B5EF4-FFF2-40B4-BE49-F238E27FC236}">
+                <a16:creationId xmlns:a16="http://schemas.microsoft.com/office/drawing/2014/main" id="{7B402887-5578-474F-93E0-AC239FBAEBB3}"/>
+              </a:ext>
+            </a:extLst>
+          </p:cNvPr>
+          <p:cNvSpPr>
+            <a:spLocks xmlns:a="http://schemas.openxmlformats.org/drawingml/2006/main" noGrp="1"/>
+          </p:cNvSpPr>
+          <p:nvPr/>
+        </p:nvSpPr>
+        <p:spPr>
+          <a:xfrm xmlns:a="http://schemas.openxmlformats.org/drawingml/2006/main">
+            <a:off x="8401050" y="4191000"/>
+            <a:ext cx="2571750" cy="838200"/>
           </a:xfrm>
           <a:prstGeom xmlns:a="http://schemas.openxmlformats.org/drawingml/2006/main" prst="rect">
             <a:avLst/>
@@ -3128,22 +3345,22 @@
       </p:sp>
       <p:sp>
         <p:nvSpPr>
-          <p:cNvPr id="36" name="">
-            <a:extLst xmlns:a="http://schemas.openxmlformats.org/drawingml/2006/main">
-              <a:ext uri="{FF2B5EF4-FFF2-40B4-BE49-F238E27FC236}">
-                <a16:creationId xmlns:a16="http://schemas.microsoft.com/office/drawing/2014/main" id="{170EA3D8-4982-4C8C-8C64-193BB909B447}"/>
-              </a:ext>
-            </a:extLst>
-          </p:cNvPr>
-          <p:cNvSpPr>
-            <a:spLocks xmlns:a="http://schemas.openxmlformats.org/drawingml/2006/main" noGrp="1"/>
-          </p:cNvSpPr>
-          <p:nvPr/>
-        </p:nvSpPr>
-        <p:spPr>
-          <a:xfrm xmlns:a="http://schemas.openxmlformats.org/drawingml/2006/main">
-            <a:off x="5772150" y="4419600"/>
-            <a:ext cx="5048250" cy="209550"/>
+          <p:cNvPr id="40" name="">
+            <a:extLst xmlns:a="http://schemas.openxmlformats.org/drawingml/2006/main">
+              <a:ext uri="{FF2B5EF4-FFF2-40B4-BE49-F238E27FC236}">
+                <a16:creationId xmlns:a16="http://schemas.microsoft.com/office/drawing/2014/main" id="{25E4731C-3413-41BF-B27B-6C47A90105E7}"/>
+              </a:ext>
+            </a:extLst>
+          </p:cNvPr>
+          <p:cNvSpPr>
+            <a:spLocks xmlns:a="http://schemas.openxmlformats.org/drawingml/2006/main" noGrp="1"/>
+          </p:cNvSpPr>
+          <p:nvPr/>
+        </p:nvSpPr>
+        <p:spPr>
+          <a:xfrm xmlns:a="http://schemas.openxmlformats.org/drawingml/2006/main">
+            <a:off x="8553450" y="4305300"/>
+            <a:ext cx="2266950" cy="209550"/>
           </a:xfrm>
           <a:prstGeom xmlns:a="http://schemas.openxmlformats.org/drawingml/2006/main" prst="rect">
             <a:avLst/>
@@ -3179,29 +3396,29 @@
                 <a:ea typeface="Helvetica Neue"/>
                 <a:cs typeface="Helvetica Neue"/>
               </a:rPr>
-              <a:t>Trade-off</a:t>
-            </a:r>
-          </a:p>
-        </p:txBody>
-      </p:sp>
-      <p:sp>
-        <p:nvSpPr>
-          <p:cNvPr id="37" name="">
-            <a:extLst xmlns:a="http://schemas.openxmlformats.org/drawingml/2006/main">
-              <a:ext uri="{FF2B5EF4-FFF2-40B4-BE49-F238E27FC236}">
-                <a16:creationId xmlns:a16="http://schemas.microsoft.com/office/drawing/2014/main" id="{9E423F39-2720-4FF0-AD5B-1BAF907E6640}"/>
-              </a:ext>
-            </a:extLst>
-          </p:cNvPr>
-          <p:cNvSpPr>
-            <a:spLocks xmlns:a="http://schemas.openxmlformats.org/drawingml/2006/main" noGrp="1"/>
-          </p:cNvSpPr>
-          <p:nvPr/>
-        </p:nvSpPr>
-        <p:spPr>
-          <a:xfrm xmlns:a="http://schemas.openxmlformats.org/drawingml/2006/main">
-            <a:off x="5772150" y="4648200"/>
-            <a:ext cx="5048250" cy="266700"/>
+              <a:t>Workload window</a:t>
+            </a:r>
+          </a:p>
+        </p:txBody>
+      </p:sp>
+      <p:sp>
+        <p:nvSpPr>
+          <p:cNvPr id="41" name="">
+            <a:extLst xmlns:a="http://schemas.openxmlformats.org/drawingml/2006/main">
+              <a:ext uri="{FF2B5EF4-FFF2-40B4-BE49-F238E27FC236}">
+                <a16:creationId xmlns:a16="http://schemas.microsoft.com/office/drawing/2014/main" id="{60213A7F-5F4A-4745-AEFD-8DB03769AB86}"/>
+              </a:ext>
+            </a:extLst>
+          </p:cNvPr>
+          <p:cNvSpPr>
+            <a:spLocks xmlns:a="http://schemas.openxmlformats.org/drawingml/2006/main" noGrp="1"/>
+          </p:cNvSpPr>
+          <p:nvPr/>
+        </p:nvSpPr>
+        <p:spPr>
+          <a:xfrm xmlns:a="http://schemas.openxmlformats.org/drawingml/2006/main">
+            <a:off x="8553450" y="4533900"/>
+            <a:ext cx="2266950" cy="266700"/>
           </a:xfrm>
           <a:prstGeom xmlns:a="http://schemas.openxmlformats.org/drawingml/2006/main" prst="rect">
             <a:avLst/>
@@ -3237,29 +3454,29 @@
                 <a:ea typeface="Helvetica Neue"/>
                 <a:cs typeface="Helvetica Neue"/>
               </a:rPr>
-              <a:t>23.0 s longer</a:t>
-            </a:r>
-          </a:p>
-        </p:txBody>
-      </p:sp>
-      <p:sp>
-        <p:nvSpPr>
-          <p:cNvPr id="38" name="">
-            <a:extLst xmlns:a="http://schemas.openxmlformats.org/drawingml/2006/main">
-              <a:ext uri="{FF2B5EF4-FFF2-40B4-BE49-F238E27FC236}">
-                <a16:creationId xmlns:a16="http://schemas.microsoft.com/office/drawing/2014/main" id="{CF6C9CC6-1D0B-49E0-BC94-BD04FA452B20}"/>
-              </a:ext>
-            </a:extLst>
-          </p:cNvPr>
-          <p:cNvSpPr>
-            <a:spLocks xmlns:a="http://schemas.openxmlformats.org/drawingml/2006/main" noGrp="1"/>
-          </p:cNvSpPr>
-          <p:nvPr/>
-        </p:nvSpPr>
-        <p:spPr>
-          <a:xfrm xmlns:a="http://schemas.openxmlformats.org/drawingml/2006/main">
-            <a:off x="5772150" y="4933950"/>
-            <a:ext cx="5048250" cy="171450"/>
+              <a:t>5.0 s longer</a:t>
+            </a:r>
+          </a:p>
+        </p:txBody>
+      </p:sp>
+      <p:sp>
+        <p:nvSpPr>
+          <p:cNvPr id="42" name="">
+            <a:extLst xmlns:a="http://schemas.openxmlformats.org/drawingml/2006/main">
+              <a:ext uri="{FF2B5EF4-FFF2-40B4-BE49-F238E27FC236}">
+                <a16:creationId xmlns:a16="http://schemas.microsoft.com/office/drawing/2014/main" id="{003FF456-E2C6-457E-9BFC-FB1331B2DC05}"/>
+              </a:ext>
+            </a:extLst>
+          </p:cNvPr>
+          <p:cNvSpPr>
+            <a:spLocks xmlns:a="http://schemas.openxmlformats.org/drawingml/2006/main" noGrp="1"/>
+          </p:cNvSpPr>
+          <p:nvPr/>
+        </p:nvSpPr>
+        <p:spPr>
+          <a:xfrm xmlns:a="http://schemas.openxmlformats.org/drawingml/2006/main">
+            <a:off x="8553450" y="4819650"/>
+            <a:ext cx="2266950" cy="171450"/>
           </a:xfrm>
           <a:prstGeom xmlns:a="http://schemas.openxmlformats.org/drawingml/2006/main" prst="rect">
             <a:avLst/>
@@ -3295,17 +3512,17 @@
                 <a:ea typeface="Helvetica Neue"/>
                 <a:cs typeface="Helvetica Neue"/>
               </a:rPr>
-              <a:t>Workload window: 234.7 s to 257.7 s</a:t>
-            </a:r>
-          </a:p>
-        </p:txBody>
-      </p:sp>
-      <p:sp>
-        <p:nvSpPr>
-          <p:cNvPr id="39" name="">
-            <a:extLst xmlns:a="http://schemas.openxmlformats.org/drawingml/2006/main">
-              <a:ext uri="{FF2B5EF4-FFF2-40B4-BE49-F238E27FC236}">
-                <a16:creationId xmlns:a16="http://schemas.microsoft.com/office/drawing/2014/main" id="{1A63C2C7-C7C6-4750-9B41-8BC34BDDCB99}"/>
+              <a:t>37.1 s to 42.0 s</a:t>
+            </a:r>
+          </a:p>
+        </p:txBody>
+      </p:sp>
+      <p:sp>
+        <p:nvSpPr>
+          <p:cNvPr id="43" name="">
+            <a:extLst xmlns:a="http://schemas.openxmlformats.org/drawingml/2006/main">
+              <a:ext uri="{FF2B5EF4-FFF2-40B4-BE49-F238E27FC236}">
+                <a16:creationId xmlns:a16="http://schemas.microsoft.com/office/drawing/2014/main" id="{2B053179-1009-4BE9-91B8-FCF13CF128BD}"/>
               </a:ext>
             </a:extLst>
           </p:cNvPr>
@@ -3333,10 +3550,10 @@
       </p:sp>
       <p:sp>
         <p:nvSpPr>
-          <p:cNvPr id="40" name="">
-            <a:extLst xmlns:a="http://schemas.openxmlformats.org/drawingml/2006/main">
-              <a:ext uri="{FF2B5EF4-FFF2-40B4-BE49-F238E27FC236}">
-                <a16:creationId xmlns:a16="http://schemas.microsoft.com/office/drawing/2014/main" id="{3B2EF161-C74B-4148-AB6F-257CE2FFF8F1}"/>
+          <p:cNvPr id="44" name="">
+            <a:extLst xmlns:a="http://schemas.openxmlformats.org/drawingml/2006/main">
+              <a:ext uri="{FF2B5EF4-FFF2-40B4-BE49-F238E27FC236}">
+                <a16:creationId xmlns:a16="http://schemas.microsoft.com/office/drawing/2014/main" id="{C4E28B85-D89E-4796-A45E-98380A5DBC4D}"/>
               </a:ext>
             </a:extLst>
           </p:cNvPr>
@@ -3391,10 +3608,10 @@
       </p:sp>
       <p:sp>
         <p:nvSpPr>
-          <p:cNvPr id="41" name="">
-            <a:extLst xmlns:a="http://schemas.openxmlformats.org/drawingml/2006/main">
-              <a:ext uri="{FF2B5EF4-FFF2-40B4-BE49-F238E27FC236}">
-                <a16:creationId xmlns:a16="http://schemas.microsoft.com/office/drawing/2014/main" id="{CEF2A735-1B23-493E-A1C5-3CDE9A112A6D}"/>
+          <p:cNvPr id="45" name="">
+            <a:extLst xmlns:a="http://schemas.openxmlformats.org/drawingml/2006/main">
+              <a:ext uri="{FF2B5EF4-FFF2-40B4-BE49-F238E27FC236}">
+                <a16:creationId xmlns:a16="http://schemas.microsoft.com/office/drawing/2014/main" id="{BD435A95-0702-47D9-9FE1-5F66CD8E4675}"/>
               </a:ext>
             </a:extLst>
           </p:cNvPr>
@@ -3450,7 +3667,7 @@
     </p:spTree>
     <p:extLst>
       <p:ext uri="{BB962C8B-B14F-4D97-AF65-F5344CB8AC3E}">
-        <p14:creationId xmlns:p14="http://schemas.microsoft.com/office/powerpoint/2010/main" val="1373292222"/>
+        <p14:creationId xmlns:p14="http://schemas.microsoft.com/office/powerpoint/2010/main" val="828340058"/>
       </p:ext>
     </p:extLst>
   </p:cSld>
@@ -3481,7 +3698,7 @@
           <p:cNvPr id="46" name="">
             <a:extLst xmlns:a="http://schemas.openxmlformats.org/drawingml/2006/main">
               <a:ext uri="{FF2B5EF4-FFF2-40B4-BE49-F238E27FC236}">
-                <a16:creationId xmlns:a16="http://schemas.microsoft.com/office/drawing/2014/main" id="{0CE734BA-4C93-4905-9E3D-D106BFD36582}"/>
+                <a16:creationId xmlns:a16="http://schemas.microsoft.com/office/drawing/2014/main" id="{FD5B3A10-9914-4386-AD99-C9A8FC29A6D3}"/>
               </a:ext>
             </a:extLst>
           </p:cNvPr>
@@ -3539,7 +3756,7 @@
           <p:cNvPr id="2" name="">
             <a:extLst xmlns:a="http://schemas.openxmlformats.org/drawingml/2006/main">
               <a:ext uri="{FF2B5EF4-FFF2-40B4-BE49-F238E27FC236}">
-                <a16:creationId xmlns:a16="http://schemas.microsoft.com/office/drawing/2014/main" id="{E73B69DF-5A8B-4254-8C12-35858AECB46A}"/>
+                <a16:creationId xmlns:a16="http://schemas.microsoft.com/office/drawing/2014/main" id="{30D163CF-2C52-4DF8-802E-D9AA32B4F719}"/>
               </a:ext>
             </a:extLst>
           </p:cNvPr>
@@ -3597,7 +3814,7 @@
           <p:cNvPr id="3" name="">
             <a:extLst xmlns:a="http://schemas.openxmlformats.org/drawingml/2006/main">
               <a:ext uri="{FF2B5EF4-FFF2-40B4-BE49-F238E27FC236}">
-                <a16:creationId xmlns:a16="http://schemas.microsoft.com/office/drawing/2014/main" id="{4C4F34B5-D238-455D-9A06-EA3FF2CCE4A4}"/>
+                <a16:creationId xmlns:a16="http://schemas.microsoft.com/office/drawing/2014/main" id="{17900986-0058-45DC-B97F-B561E540AA8A}"/>
               </a:ext>
             </a:extLst>
           </p:cNvPr>
@@ -3655,7 +3872,7 @@
           <p:cNvPr id="4" name="">
             <a:extLst xmlns:a="http://schemas.openxmlformats.org/drawingml/2006/main">
               <a:ext uri="{FF2B5EF4-FFF2-40B4-BE49-F238E27FC236}">
-                <a16:creationId xmlns:a16="http://schemas.microsoft.com/office/drawing/2014/main" id="{45672B8C-98C5-48AC-9751-13AB73C5CFC0}"/>
+                <a16:creationId xmlns:a16="http://schemas.microsoft.com/office/drawing/2014/main" id="{E236C548-98C8-4337-8F07-28B0FDB8AAC4}"/>
               </a:ext>
             </a:extLst>
           </p:cNvPr>
@@ -3686,7 +3903,7 @@
           <p:cNvPr id="5" name="">
             <a:extLst xmlns:a="http://schemas.openxmlformats.org/drawingml/2006/main">
               <a:ext uri="{FF2B5EF4-FFF2-40B4-BE49-F238E27FC236}">
-                <a16:creationId xmlns:a16="http://schemas.microsoft.com/office/drawing/2014/main" id="{85EC5554-3229-440D-994A-1BD4C2296976}"/>
+                <a16:creationId xmlns:a16="http://schemas.microsoft.com/office/drawing/2014/main" id="{1AD2FB66-19A1-4EEB-8F01-ECACBCE4945B}"/>
               </a:ext>
             </a:extLst>
           </p:cNvPr>
@@ -3744,7 +3961,7 @@
           <p:cNvPr id="6" name="">
             <a:extLst xmlns:a="http://schemas.openxmlformats.org/drawingml/2006/main">
               <a:ext uri="{FF2B5EF4-FFF2-40B4-BE49-F238E27FC236}">
-                <a16:creationId xmlns:a16="http://schemas.microsoft.com/office/drawing/2014/main" id="{BFB5CF6F-F964-4A86-970E-5FB30EA3B7FA}"/>
+                <a16:creationId xmlns:a16="http://schemas.microsoft.com/office/drawing/2014/main" id="{C045936F-994D-4710-ADE7-F871D783C4BD}"/>
               </a:ext>
             </a:extLst>
           </p:cNvPr>
@@ -3777,7 +3994,7 @@
           <p:cNvPr id="7" name="">
             <a:extLst xmlns:a="http://schemas.openxmlformats.org/drawingml/2006/main">
               <a:ext uri="{FF2B5EF4-FFF2-40B4-BE49-F238E27FC236}">
-                <a16:creationId xmlns:a16="http://schemas.microsoft.com/office/drawing/2014/main" id="{23A29F6E-DD21-4C0F-937B-6C3A8EA76533}"/>
+                <a16:creationId xmlns:a16="http://schemas.microsoft.com/office/drawing/2014/main" id="{B77DE99C-B085-4663-BFBA-EAB8007AB8AE}"/>
               </a:ext>
             </a:extLst>
           </p:cNvPr>
@@ -3835,7 +4052,7 @@
           <p:cNvPr id="8" name="">
             <a:extLst xmlns:a="http://schemas.openxmlformats.org/drawingml/2006/main">
               <a:ext uri="{FF2B5EF4-FFF2-40B4-BE49-F238E27FC236}">
-                <a16:creationId xmlns:a16="http://schemas.microsoft.com/office/drawing/2014/main" id="{0AB34A60-C455-48DA-B33C-81D32024CB34}"/>
+                <a16:creationId xmlns:a16="http://schemas.microsoft.com/office/drawing/2014/main" id="{14581B74-5328-4E19-BA42-E3B12959CBC7}"/>
               </a:ext>
             </a:extLst>
           </p:cNvPr>
@@ -3868,7 +4085,7 @@
           <p:cNvPr id="9" name="">
             <a:extLst xmlns:a="http://schemas.openxmlformats.org/drawingml/2006/main">
               <a:ext uri="{FF2B5EF4-FFF2-40B4-BE49-F238E27FC236}">
-                <a16:creationId xmlns:a16="http://schemas.microsoft.com/office/drawing/2014/main" id="{5CCB9363-A3FD-4888-A576-91885507E2AA}"/>
+                <a16:creationId xmlns:a16="http://schemas.microsoft.com/office/drawing/2014/main" id="{C5B9A627-CA0E-45FB-9F9F-BD1813D3B688}"/>
               </a:ext>
             </a:extLst>
           </p:cNvPr>
@@ -3926,7 +4143,7 @@
           <p:cNvPr id="10" name="">
             <a:extLst xmlns:a="http://schemas.openxmlformats.org/drawingml/2006/main">
               <a:ext uri="{FF2B5EF4-FFF2-40B4-BE49-F238E27FC236}">
-                <a16:creationId xmlns:a16="http://schemas.microsoft.com/office/drawing/2014/main" id="{400C8D8A-95ED-4E2C-8B76-6EA88E427E0A}"/>
+                <a16:creationId xmlns:a16="http://schemas.microsoft.com/office/drawing/2014/main" id="{8835DBA2-5CA8-4A80-8147-5D5F62A1F466}"/>
               </a:ext>
             </a:extLst>
           </p:cNvPr>
@@ -3959,7 +4176,7 @@
           <p:cNvPr id="11" name="">
             <a:extLst xmlns:a="http://schemas.openxmlformats.org/drawingml/2006/main">
               <a:ext uri="{FF2B5EF4-FFF2-40B4-BE49-F238E27FC236}">
-                <a16:creationId xmlns:a16="http://schemas.microsoft.com/office/drawing/2014/main" id="{5B4BCBB7-757D-4F42-B436-3734F5921421}"/>
+                <a16:creationId xmlns:a16="http://schemas.microsoft.com/office/drawing/2014/main" id="{FFCAA2F5-7677-407D-905F-C76AF8DC1BDF}"/>
               </a:ext>
             </a:extLst>
           </p:cNvPr>
@@ -4017,7 +4234,7 @@
           <p:cNvPr id="12" name="">
             <a:extLst xmlns:a="http://schemas.openxmlformats.org/drawingml/2006/main">
               <a:ext uri="{FF2B5EF4-FFF2-40B4-BE49-F238E27FC236}">
-                <a16:creationId xmlns:a16="http://schemas.microsoft.com/office/drawing/2014/main" id="{65277F56-5BC9-4CD7-BD00-BF24C45B6354}"/>
+                <a16:creationId xmlns:a16="http://schemas.microsoft.com/office/drawing/2014/main" id="{3A95434D-123D-4BBE-AD19-38F1E5C487DD}"/>
               </a:ext>
             </a:extLst>
           </p:cNvPr>
@@ -4050,7 +4267,7 @@
           <p:cNvPr id="13" name="">
             <a:extLst xmlns:a="http://schemas.openxmlformats.org/drawingml/2006/main">
               <a:ext uri="{FF2B5EF4-FFF2-40B4-BE49-F238E27FC236}">
-                <a16:creationId xmlns:a16="http://schemas.microsoft.com/office/drawing/2014/main" id="{1D72D7AF-D12A-42FB-A1FA-6647B6E3F184}"/>
+                <a16:creationId xmlns:a16="http://schemas.microsoft.com/office/drawing/2014/main" id="{44590154-2974-4C26-91A8-190912FC9774}"/>
               </a:ext>
             </a:extLst>
           </p:cNvPr>
@@ -4108,7 +4325,7 @@
           <p:cNvPr id="14" name="">
             <a:extLst xmlns:a="http://schemas.openxmlformats.org/drawingml/2006/main">
               <a:ext uri="{FF2B5EF4-FFF2-40B4-BE49-F238E27FC236}">
-                <a16:creationId xmlns:a16="http://schemas.microsoft.com/office/drawing/2014/main" id="{22238A49-C63C-4DF7-8079-7656D3E91942}"/>
+                <a16:creationId xmlns:a16="http://schemas.microsoft.com/office/drawing/2014/main" id="{57ED5C73-D921-4A21-BDA7-430AE34D9C75}"/>
               </a:ext>
             </a:extLst>
           </p:cNvPr>
@@ -4141,7 +4358,7 @@
           <p:cNvPr id="15" name="">
             <a:extLst xmlns:a="http://schemas.openxmlformats.org/drawingml/2006/main">
               <a:ext uri="{FF2B5EF4-FFF2-40B4-BE49-F238E27FC236}">
-                <a16:creationId xmlns:a16="http://schemas.microsoft.com/office/drawing/2014/main" id="{49B31492-66FC-4912-9E19-8C93F9E8520B}"/>
+                <a16:creationId xmlns:a16="http://schemas.microsoft.com/office/drawing/2014/main" id="{103B9FD0-6463-4594-99E8-D6376E6C61BD}"/>
               </a:ext>
             </a:extLst>
           </p:cNvPr>
@@ -4199,7 +4416,7 @@
           <p:cNvPr id="16" name="">
             <a:extLst xmlns:a="http://schemas.openxmlformats.org/drawingml/2006/main">
               <a:ext uri="{FF2B5EF4-FFF2-40B4-BE49-F238E27FC236}">
-                <a16:creationId xmlns:a16="http://schemas.microsoft.com/office/drawing/2014/main" id="{F551312C-00C6-4967-BE58-68DAF33CADC5}"/>
+                <a16:creationId xmlns:a16="http://schemas.microsoft.com/office/drawing/2014/main" id="{15362C3E-FAC2-43BD-AD2B-FFEC19B7D631}"/>
               </a:ext>
             </a:extLst>
           </p:cNvPr>
@@ -4257,7 +4474,7 @@
           <p:cNvPr id="17" name="">
             <a:extLst xmlns:a="http://schemas.openxmlformats.org/drawingml/2006/main">
               <a:ext uri="{FF2B5EF4-FFF2-40B4-BE49-F238E27FC236}">
-                <a16:creationId xmlns:a16="http://schemas.microsoft.com/office/drawing/2014/main" id="{B49B2975-81B9-44C3-8863-7CE090EC8264}"/>
+                <a16:creationId xmlns:a16="http://schemas.microsoft.com/office/drawing/2014/main" id="{832E92C2-67F4-40C9-8542-01A27878439F}"/>
               </a:ext>
             </a:extLst>
           </p:cNvPr>
@@ -4315,7 +4532,7 @@
           <p:cNvPr id="18" name="">
             <a:extLst xmlns:a="http://schemas.openxmlformats.org/drawingml/2006/main">
               <a:ext uri="{FF2B5EF4-FFF2-40B4-BE49-F238E27FC236}">
-                <a16:creationId xmlns:a16="http://schemas.microsoft.com/office/drawing/2014/main" id="{4E12A7A0-15F4-4613-9530-300136BFF7E6}"/>
+                <a16:creationId xmlns:a16="http://schemas.microsoft.com/office/drawing/2014/main" id="{BB5F54F7-E0CC-4029-A24B-982FB24F8B0C}"/>
               </a:ext>
             </a:extLst>
           </p:cNvPr>
@@ -4373,7 +4590,7 @@
           <p:cNvPr id="19" name="">
             <a:extLst xmlns:a="http://schemas.openxmlformats.org/drawingml/2006/main">
               <a:ext uri="{FF2B5EF4-FFF2-40B4-BE49-F238E27FC236}">
-                <a16:creationId xmlns:a16="http://schemas.microsoft.com/office/drawing/2014/main" id="{FF2412A5-6D5A-4A9D-ADB9-C115C3DC1F60}"/>
+                <a16:creationId xmlns:a16="http://schemas.microsoft.com/office/drawing/2014/main" id="{0CD49475-00E6-4E96-B469-A0C032CDEB67}"/>
               </a:ext>
             </a:extLst>
           </p:cNvPr>
@@ -4406,7 +4623,7 @@
           <p:cNvPr id="20" name="">
             <a:extLst xmlns:a="http://schemas.openxmlformats.org/drawingml/2006/main">
               <a:ext uri="{FF2B5EF4-FFF2-40B4-BE49-F238E27FC236}">
-                <a16:creationId xmlns:a16="http://schemas.microsoft.com/office/drawing/2014/main" id="{E310C6B4-7B3D-4563-A397-14169E04B846}"/>
+                <a16:creationId xmlns:a16="http://schemas.microsoft.com/office/drawing/2014/main" id="{8B4F136D-12EA-4D16-9DCA-F1F0ED5120B0}"/>
               </a:ext>
             </a:extLst>
           </p:cNvPr>
@@ -4464,7 +4681,7 @@
           <p:cNvPr id="21" name="">
             <a:extLst xmlns:a="http://schemas.openxmlformats.org/drawingml/2006/main">
               <a:ext uri="{FF2B5EF4-FFF2-40B4-BE49-F238E27FC236}">
-                <a16:creationId xmlns:a16="http://schemas.microsoft.com/office/drawing/2014/main" id="{5DEF2B5D-DAC9-4E5D-9ABE-2614F4A1F69B}"/>
+                <a16:creationId xmlns:a16="http://schemas.microsoft.com/office/drawing/2014/main" id="{8FBDF25E-928E-4F88-9A9A-E79B34138C8C}"/>
               </a:ext>
             </a:extLst>
           </p:cNvPr>
@@ -4522,7 +4739,7 @@
           <p:cNvPr id="22" name="">
             <a:extLst xmlns:a="http://schemas.openxmlformats.org/drawingml/2006/main">
               <a:ext uri="{FF2B5EF4-FFF2-40B4-BE49-F238E27FC236}">
-                <a16:creationId xmlns:a16="http://schemas.microsoft.com/office/drawing/2014/main" id="{3952364B-BBF3-43E7-829A-83159880F36C}"/>
+                <a16:creationId xmlns:a16="http://schemas.microsoft.com/office/drawing/2014/main" id="{1846E517-5242-44A3-B8A6-2E034F8B1EF7}"/>
               </a:ext>
             </a:extLst>
           </p:cNvPr>
@@ -4580,7 +4797,7 @@
           <p:cNvPr id="23" name="">
             <a:extLst xmlns:a="http://schemas.openxmlformats.org/drawingml/2006/main">
               <a:ext uri="{FF2B5EF4-FFF2-40B4-BE49-F238E27FC236}">
-                <a16:creationId xmlns:a16="http://schemas.microsoft.com/office/drawing/2014/main" id="{F2F16A22-171E-4532-A692-800045254C1B}"/>
+                <a16:creationId xmlns:a16="http://schemas.microsoft.com/office/drawing/2014/main" id="{27114151-38BD-4FE9-BEFA-E11AEB0E09ED}"/>
               </a:ext>
             </a:extLst>
           </p:cNvPr>
@@ -4613,7 +4830,7 @@
           <p:cNvPr id="24" name="">
             <a:extLst xmlns:a="http://schemas.openxmlformats.org/drawingml/2006/main">
               <a:ext uri="{FF2B5EF4-FFF2-40B4-BE49-F238E27FC236}">
-                <a16:creationId xmlns:a16="http://schemas.microsoft.com/office/drawing/2014/main" id="{B8D19B57-21D5-43A0-ABB1-D1A1A2C3415E}"/>
+                <a16:creationId xmlns:a16="http://schemas.microsoft.com/office/drawing/2014/main" id="{D785CA0F-6A19-4E56-A40F-0E20B2D869AD}"/>
               </a:ext>
             </a:extLst>
           </p:cNvPr>
@@ -4671,7 +4888,7 @@
           <p:cNvPr id="25" name="">
             <a:extLst xmlns:a="http://schemas.openxmlformats.org/drawingml/2006/main">
               <a:ext uri="{FF2B5EF4-FFF2-40B4-BE49-F238E27FC236}">
-                <a16:creationId xmlns:a16="http://schemas.microsoft.com/office/drawing/2014/main" id="{A39F2569-457C-4CC1-9790-2B2B3048C788}"/>
+                <a16:creationId xmlns:a16="http://schemas.microsoft.com/office/drawing/2014/main" id="{7D056C25-9D11-47AA-8AF7-F2F7A06B7D7B}"/>
               </a:ext>
             </a:extLst>
           </p:cNvPr>
@@ -4729,7 +4946,7 @@
           <p:cNvPr id="26" name="">
             <a:extLst xmlns:a="http://schemas.openxmlformats.org/drawingml/2006/main">
               <a:ext uri="{FF2B5EF4-FFF2-40B4-BE49-F238E27FC236}">
-                <a16:creationId xmlns:a16="http://schemas.microsoft.com/office/drawing/2014/main" id="{ED8979BC-9099-4718-812A-198A1743F5B6}"/>
+                <a16:creationId xmlns:a16="http://schemas.microsoft.com/office/drawing/2014/main" id="{D51C4ACE-E6F3-4087-BFC8-32345EA22662}"/>
               </a:ext>
             </a:extLst>
           </p:cNvPr>
@@ -4787,7 +5004,7 @@
           <p:cNvPr id="27" name="">
             <a:extLst xmlns:a="http://schemas.openxmlformats.org/drawingml/2006/main">
               <a:ext uri="{FF2B5EF4-FFF2-40B4-BE49-F238E27FC236}">
-                <a16:creationId xmlns:a16="http://schemas.microsoft.com/office/drawing/2014/main" id="{9BD35CD0-11DE-49EC-A736-88636B1E3877}"/>
+                <a16:creationId xmlns:a16="http://schemas.microsoft.com/office/drawing/2014/main" id="{D77CB6D3-9903-43BE-993E-96B068A97E92}"/>
               </a:ext>
             </a:extLst>
           </p:cNvPr>
@@ -4820,7 +5037,7 @@
           <p:cNvPr id="28" name="">
             <a:extLst xmlns:a="http://schemas.openxmlformats.org/drawingml/2006/main">
               <a:ext uri="{FF2B5EF4-FFF2-40B4-BE49-F238E27FC236}">
-                <a16:creationId xmlns:a16="http://schemas.microsoft.com/office/drawing/2014/main" id="{80590175-B6F1-4C9B-87B5-F5D59A69735B}"/>
+                <a16:creationId xmlns:a16="http://schemas.microsoft.com/office/drawing/2014/main" id="{6C59BF7B-7145-47A1-AFFE-3A589203135B}"/>
               </a:ext>
             </a:extLst>
           </p:cNvPr>
@@ -4878,7 +5095,7 @@
           <p:cNvPr id="29" name="">
             <a:extLst xmlns:a="http://schemas.openxmlformats.org/drawingml/2006/main">
               <a:ext uri="{FF2B5EF4-FFF2-40B4-BE49-F238E27FC236}">
-                <a16:creationId xmlns:a16="http://schemas.microsoft.com/office/drawing/2014/main" id="{36C8135B-ED58-46EE-A31B-99A20039216B}"/>
+                <a16:creationId xmlns:a16="http://schemas.microsoft.com/office/drawing/2014/main" id="{E41B23A2-E295-437B-9F74-50772587E6F8}"/>
               </a:ext>
             </a:extLst>
           </p:cNvPr>
@@ -4936,7 +5153,7 @@
           <p:cNvPr id="30" name="">
             <a:extLst xmlns:a="http://schemas.openxmlformats.org/drawingml/2006/main">
               <a:ext uri="{FF2B5EF4-FFF2-40B4-BE49-F238E27FC236}">
-                <a16:creationId xmlns:a16="http://schemas.microsoft.com/office/drawing/2014/main" id="{BAEC6EC8-3186-440E-870F-4C1B85838213}"/>
+                <a16:creationId xmlns:a16="http://schemas.microsoft.com/office/drawing/2014/main" id="{70E759DB-CB18-42F1-87C8-FA989A3948FB}"/>
               </a:ext>
             </a:extLst>
           </p:cNvPr>
@@ -4994,7 +5211,7 @@
           <p:cNvPr id="31" name="">
             <a:extLst xmlns:a="http://schemas.openxmlformats.org/drawingml/2006/main">
               <a:ext uri="{FF2B5EF4-FFF2-40B4-BE49-F238E27FC236}">
-                <a16:creationId xmlns:a16="http://schemas.microsoft.com/office/drawing/2014/main" id="{18C9CE89-283F-4F6E-A214-0CC54FF2BBD1}"/>
+                <a16:creationId xmlns:a16="http://schemas.microsoft.com/office/drawing/2014/main" id="{BD08FBFA-AB98-43CE-A4FE-57FFD415CB93}"/>
               </a:ext>
             </a:extLst>
           </p:cNvPr>
@@ -5027,7 +5244,7 @@
           <p:cNvPr id="32" name="">
             <a:extLst xmlns:a="http://schemas.openxmlformats.org/drawingml/2006/main">
               <a:ext uri="{FF2B5EF4-FFF2-40B4-BE49-F238E27FC236}">
-                <a16:creationId xmlns:a16="http://schemas.microsoft.com/office/drawing/2014/main" id="{15A20E81-4F37-4059-9B27-065CB9A63728}"/>
+                <a16:creationId xmlns:a16="http://schemas.microsoft.com/office/drawing/2014/main" id="{C7287680-471C-4B8E-8A9C-C21EA5D0A938}"/>
               </a:ext>
             </a:extLst>
           </p:cNvPr>
@@ -5085,7 +5302,7 @@
           <p:cNvPr id="33" name="">
             <a:extLst xmlns:a="http://schemas.openxmlformats.org/drawingml/2006/main">
               <a:ext uri="{FF2B5EF4-FFF2-40B4-BE49-F238E27FC236}">
-                <a16:creationId xmlns:a16="http://schemas.microsoft.com/office/drawing/2014/main" id="{AA901807-2A29-4637-8990-D86E325D8DE1}"/>
+                <a16:creationId xmlns:a16="http://schemas.microsoft.com/office/drawing/2014/main" id="{1EB3BB7E-C969-4368-ABE2-855CEBC37792}"/>
               </a:ext>
             </a:extLst>
           </p:cNvPr>
@@ -5143,7 +5360,7 @@
           <p:cNvPr id="34" name="">
             <a:extLst xmlns:a="http://schemas.openxmlformats.org/drawingml/2006/main">
               <a:ext uri="{FF2B5EF4-FFF2-40B4-BE49-F238E27FC236}">
-                <a16:creationId xmlns:a16="http://schemas.microsoft.com/office/drawing/2014/main" id="{1A7277DB-2A6F-49BC-8091-18F4611FD8DF}"/>
+                <a16:creationId xmlns:a16="http://schemas.microsoft.com/office/drawing/2014/main" id="{EB3C6FAB-B39D-47A6-A528-F142D7226208}"/>
               </a:ext>
             </a:extLst>
           </p:cNvPr>
@@ -5201,7 +5418,7 @@
           <p:cNvPr id="35" name="">
             <a:extLst xmlns:a="http://schemas.openxmlformats.org/drawingml/2006/main">
               <a:ext uri="{FF2B5EF4-FFF2-40B4-BE49-F238E27FC236}">
-                <a16:creationId xmlns:a16="http://schemas.microsoft.com/office/drawing/2014/main" id="{BDE5677E-6EBC-40BE-A457-A4BF6EC03E19}"/>
+                <a16:creationId xmlns:a16="http://schemas.microsoft.com/office/drawing/2014/main" id="{AAAE83CA-8AE0-47B1-AE33-30125B7B27AF}"/>
               </a:ext>
             </a:extLst>
           </p:cNvPr>
@@ -5234,7 +5451,7 @@
           <p:cNvPr id="36" name="">
             <a:extLst xmlns:a="http://schemas.openxmlformats.org/drawingml/2006/main">
               <a:ext uri="{FF2B5EF4-FFF2-40B4-BE49-F238E27FC236}">
-                <a16:creationId xmlns:a16="http://schemas.microsoft.com/office/drawing/2014/main" id="{6418C016-8A08-483C-8B7B-8038A973A617}"/>
+                <a16:creationId xmlns:a16="http://schemas.microsoft.com/office/drawing/2014/main" id="{71BE09F7-B4E4-423B-8FFB-97C82C078EAA}"/>
               </a:ext>
             </a:extLst>
           </p:cNvPr>
@@ -5292,7 +5509,7 @@
           <p:cNvPr id="37" name="">
             <a:extLst xmlns:a="http://schemas.openxmlformats.org/drawingml/2006/main">
               <a:ext uri="{FF2B5EF4-FFF2-40B4-BE49-F238E27FC236}">
-                <a16:creationId xmlns:a16="http://schemas.microsoft.com/office/drawing/2014/main" id="{9D9340ED-4A07-495D-836B-56E2E63F2CEC}"/>
+                <a16:creationId xmlns:a16="http://schemas.microsoft.com/office/drawing/2014/main" id="{2DEDD8BB-DCCD-4E7C-8006-16733F3ECE43}"/>
               </a:ext>
             </a:extLst>
           </p:cNvPr>
@@ -5350,7 +5567,7 @@
           <p:cNvPr id="38" name="">
             <a:extLst xmlns:a="http://schemas.openxmlformats.org/drawingml/2006/main">
               <a:ext uri="{FF2B5EF4-FFF2-40B4-BE49-F238E27FC236}">
-                <a16:creationId xmlns:a16="http://schemas.microsoft.com/office/drawing/2014/main" id="{F0E9551B-F1C4-4A03-A305-1036DED12F66}"/>
+                <a16:creationId xmlns:a16="http://schemas.microsoft.com/office/drawing/2014/main" id="{318FE187-AEA5-45A4-BEDF-4194875CEA6D}"/>
               </a:ext>
             </a:extLst>
           </p:cNvPr>
@@ -5408,7 +5625,7 @@
           <p:cNvPr id="39" name="">
             <a:extLst xmlns:a="http://schemas.openxmlformats.org/drawingml/2006/main">
               <a:ext uri="{FF2B5EF4-FFF2-40B4-BE49-F238E27FC236}">
-                <a16:creationId xmlns:a16="http://schemas.microsoft.com/office/drawing/2014/main" id="{D8E255E5-12E3-4B03-A848-1005F8B99363}"/>
+                <a16:creationId xmlns:a16="http://schemas.microsoft.com/office/drawing/2014/main" id="{2310558F-4D91-491C-AF02-CF05FEF4EF32}"/>
               </a:ext>
             </a:extLst>
           </p:cNvPr>
@@ -5441,7 +5658,7 @@
           <p:cNvPr id="40" name="">
             <a:extLst xmlns:a="http://schemas.openxmlformats.org/drawingml/2006/main">
               <a:ext uri="{FF2B5EF4-FFF2-40B4-BE49-F238E27FC236}">
-                <a16:creationId xmlns:a16="http://schemas.microsoft.com/office/drawing/2014/main" id="{763006BD-9D6D-4603-ABDA-EA7B2ADCA632}"/>
+                <a16:creationId xmlns:a16="http://schemas.microsoft.com/office/drawing/2014/main" id="{E8C59B95-B4DF-4B77-A179-FA03B146E85B}"/>
               </a:ext>
             </a:extLst>
           </p:cNvPr>
@@ -5499,7 +5716,7 @@
           <p:cNvPr id="41" name="">
             <a:extLst xmlns:a="http://schemas.openxmlformats.org/drawingml/2006/main">
               <a:ext uri="{FF2B5EF4-FFF2-40B4-BE49-F238E27FC236}">
-                <a16:creationId xmlns:a16="http://schemas.microsoft.com/office/drawing/2014/main" id="{363D1144-9E9B-4B12-8EC4-7CAE785A9C52}"/>
+                <a16:creationId xmlns:a16="http://schemas.microsoft.com/office/drawing/2014/main" id="{D1C227D4-A61A-41F9-A3B2-0A779647AF00}"/>
               </a:ext>
             </a:extLst>
           </p:cNvPr>
@@ -5557,7 +5774,7 @@
           <p:cNvPr id="42" name="">
             <a:extLst xmlns:a="http://schemas.openxmlformats.org/drawingml/2006/main">
               <a:ext uri="{FF2B5EF4-FFF2-40B4-BE49-F238E27FC236}">
-                <a16:creationId xmlns:a16="http://schemas.microsoft.com/office/drawing/2014/main" id="{6C19DFF7-CDCD-4356-89C6-C691640C696F}"/>
+                <a16:creationId xmlns:a16="http://schemas.microsoft.com/office/drawing/2014/main" id="{6CAFC1D4-0804-4913-9074-A6001298C46C}"/>
               </a:ext>
             </a:extLst>
           </p:cNvPr>
@@ -5615,7 +5832,7 @@
           <p:cNvPr id="43" name="">
             <a:extLst xmlns:a="http://schemas.openxmlformats.org/drawingml/2006/main">
               <a:ext uri="{FF2B5EF4-FFF2-40B4-BE49-F238E27FC236}">
-                <a16:creationId xmlns:a16="http://schemas.microsoft.com/office/drawing/2014/main" id="{427F3182-32A9-43AE-BDCA-B0CD02B22C14}"/>
+                <a16:creationId xmlns:a16="http://schemas.microsoft.com/office/drawing/2014/main" id="{C4434368-A672-40C6-8129-FA35FADCA341}"/>
               </a:ext>
             </a:extLst>
           </p:cNvPr>
@@ -5646,7 +5863,7 @@
           <p:cNvPr id="44" name="">
             <a:extLst xmlns:a="http://schemas.openxmlformats.org/drawingml/2006/main">
               <a:ext uri="{FF2B5EF4-FFF2-40B4-BE49-F238E27FC236}">
-                <a16:creationId xmlns:a16="http://schemas.microsoft.com/office/drawing/2014/main" id="{BDFA571A-23D0-4015-B3EB-5E5FD4A1AA27}"/>
+                <a16:creationId xmlns:a16="http://schemas.microsoft.com/office/drawing/2014/main" id="{8570DF67-E22F-40BE-A773-7AE08C349D0E}"/>
               </a:ext>
             </a:extLst>
           </p:cNvPr>
@@ -5704,7 +5921,7 @@
           <p:cNvPr id="45" name="">
             <a:extLst xmlns:a="http://schemas.openxmlformats.org/drawingml/2006/main">
               <a:ext uri="{FF2B5EF4-FFF2-40B4-BE49-F238E27FC236}">
-                <a16:creationId xmlns:a16="http://schemas.microsoft.com/office/drawing/2014/main" id="{F1CBF313-13DA-4EA1-B2B2-C117F8D8046A}"/>
+                <a16:creationId xmlns:a16="http://schemas.microsoft.com/office/drawing/2014/main" id="{7DADDE60-6B4E-4CAC-997B-F45E348D40E3}"/>
               </a:ext>
             </a:extLst>
           </p:cNvPr>
@@ -5760,7 +5977,7 @@
     </p:spTree>
     <p:extLst>
       <p:ext uri="{BB962C8B-B14F-4D97-AF65-F5344CB8AC3E}">
-        <p14:creationId xmlns:p14="http://schemas.microsoft.com/office/powerpoint/2010/main" val="873540808"/>
+        <p14:creationId xmlns:p14="http://schemas.microsoft.com/office/powerpoint/2010/main" val="1073042771"/>
       </p:ext>
     </p:extLst>
   </p:cSld>
@@ -5791,7 +6008,7 @@
           <p:cNvPr id="46" name="">
             <a:extLst xmlns:a="http://schemas.openxmlformats.org/drawingml/2006/main">
               <a:ext uri="{FF2B5EF4-FFF2-40B4-BE49-F238E27FC236}">
-                <a16:creationId xmlns:a16="http://schemas.microsoft.com/office/drawing/2014/main" id="{313FAC35-5D8F-4779-8123-52BB6124F238}"/>
+                <a16:creationId xmlns:a16="http://schemas.microsoft.com/office/drawing/2014/main" id="{A2F4F726-A791-41A3-AB2E-A002287AE6F6}"/>
               </a:ext>
             </a:extLst>
           </p:cNvPr>
@@ -5849,7 +6066,7 @@
           <p:cNvPr id="2" name="">
             <a:extLst xmlns:a="http://schemas.openxmlformats.org/drawingml/2006/main">
               <a:ext uri="{FF2B5EF4-FFF2-40B4-BE49-F238E27FC236}">
-                <a16:creationId xmlns:a16="http://schemas.microsoft.com/office/drawing/2014/main" id="{E3ED03CD-A47D-46C7-B689-D260D7023998}"/>
+                <a16:creationId xmlns:a16="http://schemas.microsoft.com/office/drawing/2014/main" id="{E464AB91-8927-4A41-B9A3-EB5C298349ED}"/>
               </a:ext>
             </a:extLst>
           </p:cNvPr>
@@ -5907,7 +6124,7 @@
           <p:cNvPr id="3" name="">
             <a:extLst xmlns:a="http://schemas.openxmlformats.org/drawingml/2006/main">
               <a:ext uri="{FF2B5EF4-FFF2-40B4-BE49-F238E27FC236}">
-                <a16:creationId xmlns:a16="http://schemas.microsoft.com/office/drawing/2014/main" id="{80DC1A91-4400-4C18-A715-9F8BC00D9750}"/>
+                <a16:creationId xmlns:a16="http://schemas.microsoft.com/office/drawing/2014/main" id="{10C79741-132A-40D4-BF98-C6542E64DFA7}"/>
               </a:ext>
             </a:extLst>
           </p:cNvPr>
@@ -5965,7 +6182,7 @@
           <p:cNvPr id="4" name="">
             <a:extLst xmlns:a="http://schemas.openxmlformats.org/drawingml/2006/main">
               <a:ext uri="{FF2B5EF4-FFF2-40B4-BE49-F238E27FC236}">
-                <a16:creationId xmlns:a16="http://schemas.microsoft.com/office/drawing/2014/main" id="{35204F46-042C-4E20-B0F5-3D1F08AAC253}"/>
+                <a16:creationId xmlns:a16="http://schemas.microsoft.com/office/drawing/2014/main" id="{BB3AE12E-B3FA-4BA3-BBBD-A2E42E147C7D}"/>
               </a:ext>
             </a:extLst>
           </p:cNvPr>
@@ -5996,7 +6213,7 @@
           <p:cNvPr id="5" name="">
             <a:extLst xmlns:a="http://schemas.openxmlformats.org/drawingml/2006/main">
               <a:ext uri="{FF2B5EF4-FFF2-40B4-BE49-F238E27FC236}">
-                <a16:creationId xmlns:a16="http://schemas.microsoft.com/office/drawing/2014/main" id="{34C7DCB1-E7CB-4D96-BDC4-0D189763CFCF}"/>
+                <a16:creationId xmlns:a16="http://schemas.microsoft.com/office/drawing/2014/main" id="{8AD1C972-29B5-4AF0-998D-8FB44DAE9564}"/>
               </a:ext>
             </a:extLst>
           </p:cNvPr>
@@ -6054,7 +6271,7 @@
           <p:cNvPr id="6" name="">
             <a:extLst xmlns:a="http://schemas.openxmlformats.org/drawingml/2006/main">
               <a:ext uri="{FF2B5EF4-FFF2-40B4-BE49-F238E27FC236}">
-                <a16:creationId xmlns:a16="http://schemas.microsoft.com/office/drawing/2014/main" id="{E42662F7-B7F4-44B8-8E78-7B96CA1F860E}"/>
+                <a16:creationId xmlns:a16="http://schemas.microsoft.com/office/drawing/2014/main" id="{1C09204B-4D31-41DD-A274-633C11863E89}"/>
               </a:ext>
             </a:extLst>
           </p:cNvPr>
@@ -6087,7 +6304,7 @@
           <p:cNvPr id="7" name="">
             <a:extLst xmlns:a="http://schemas.openxmlformats.org/drawingml/2006/main">
               <a:ext uri="{FF2B5EF4-FFF2-40B4-BE49-F238E27FC236}">
-                <a16:creationId xmlns:a16="http://schemas.microsoft.com/office/drawing/2014/main" id="{A4941D5F-8B1B-42EA-AD5A-754FDD3D86FF}"/>
+                <a16:creationId xmlns:a16="http://schemas.microsoft.com/office/drawing/2014/main" id="{6F1A8204-0417-4516-BC57-C7C11090EE10}"/>
               </a:ext>
             </a:extLst>
           </p:cNvPr>
@@ -6145,7 +6362,7 @@
           <p:cNvPr id="8" name="">
             <a:extLst xmlns:a="http://schemas.openxmlformats.org/drawingml/2006/main">
               <a:ext uri="{FF2B5EF4-FFF2-40B4-BE49-F238E27FC236}">
-                <a16:creationId xmlns:a16="http://schemas.microsoft.com/office/drawing/2014/main" id="{F0013C4F-DA8B-4FCC-9B8E-ABE25806D649}"/>
+                <a16:creationId xmlns:a16="http://schemas.microsoft.com/office/drawing/2014/main" id="{E92327E1-B18E-456B-B13D-71A97311E31F}"/>
               </a:ext>
             </a:extLst>
           </p:cNvPr>
@@ -6178,7 +6395,7 @@
           <p:cNvPr id="9" name="">
             <a:extLst xmlns:a="http://schemas.openxmlformats.org/drawingml/2006/main">
               <a:ext uri="{FF2B5EF4-FFF2-40B4-BE49-F238E27FC236}">
-                <a16:creationId xmlns:a16="http://schemas.microsoft.com/office/drawing/2014/main" id="{43064551-888F-492B-8CDB-886D5A270692}"/>
+                <a16:creationId xmlns:a16="http://schemas.microsoft.com/office/drawing/2014/main" id="{38126682-61B4-4A62-BFEC-6E983CEB1DBA}"/>
               </a:ext>
             </a:extLst>
           </p:cNvPr>
@@ -6236,7 +6453,7 @@
           <p:cNvPr id="10" name="">
             <a:extLst xmlns:a="http://schemas.openxmlformats.org/drawingml/2006/main">
               <a:ext uri="{FF2B5EF4-FFF2-40B4-BE49-F238E27FC236}">
-                <a16:creationId xmlns:a16="http://schemas.microsoft.com/office/drawing/2014/main" id="{AE712F8C-1770-4C6F-9985-256480BBA8FF}"/>
+                <a16:creationId xmlns:a16="http://schemas.microsoft.com/office/drawing/2014/main" id="{B463B62E-4FDE-48CB-B64E-79867F29E720}"/>
               </a:ext>
             </a:extLst>
           </p:cNvPr>
@@ -6269,7 +6486,7 @@
           <p:cNvPr id="11" name="">
             <a:extLst xmlns:a="http://schemas.openxmlformats.org/drawingml/2006/main">
               <a:ext uri="{FF2B5EF4-FFF2-40B4-BE49-F238E27FC236}">
-                <a16:creationId xmlns:a16="http://schemas.microsoft.com/office/drawing/2014/main" id="{247D8B4B-D4A5-49BD-ABAE-D578BC421A50}"/>
+                <a16:creationId xmlns:a16="http://schemas.microsoft.com/office/drawing/2014/main" id="{6184D5B0-5A01-482D-8B89-B121FE340735}"/>
               </a:ext>
             </a:extLst>
           </p:cNvPr>
@@ -6327,7 +6544,7 @@
           <p:cNvPr id="12" name="">
             <a:extLst xmlns:a="http://schemas.openxmlformats.org/drawingml/2006/main">
               <a:ext uri="{FF2B5EF4-FFF2-40B4-BE49-F238E27FC236}">
-                <a16:creationId xmlns:a16="http://schemas.microsoft.com/office/drawing/2014/main" id="{C88D2894-5BCB-4063-A46A-9747C1472DE6}"/>
+                <a16:creationId xmlns:a16="http://schemas.microsoft.com/office/drawing/2014/main" id="{8EB6695C-A93C-434B-8BB3-2EB20870E08F}"/>
               </a:ext>
             </a:extLst>
           </p:cNvPr>
@@ -6360,7 +6577,7 @@
           <p:cNvPr id="13" name="">
             <a:extLst xmlns:a="http://schemas.openxmlformats.org/drawingml/2006/main">
               <a:ext uri="{FF2B5EF4-FFF2-40B4-BE49-F238E27FC236}">
-                <a16:creationId xmlns:a16="http://schemas.microsoft.com/office/drawing/2014/main" id="{C5032191-2732-4089-A931-54D925AD0280}"/>
+                <a16:creationId xmlns:a16="http://schemas.microsoft.com/office/drawing/2014/main" id="{05AE7CF4-3CA3-4A4F-8A11-745C4C37E4E3}"/>
               </a:ext>
             </a:extLst>
           </p:cNvPr>
@@ -6418,7 +6635,7 @@
           <p:cNvPr id="14" name="">
             <a:extLst xmlns:a="http://schemas.openxmlformats.org/drawingml/2006/main">
               <a:ext uri="{FF2B5EF4-FFF2-40B4-BE49-F238E27FC236}">
-                <a16:creationId xmlns:a16="http://schemas.microsoft.com/office/drawing/2014/main" id="{17F220ED-A380-42DF-87FA-5280C39C0C8F}"/>
+                <a16:creationId xmlns:a16="http://schemas.microsoft.com/office/drawing/2014/main" id="{5E65CAFE-DEB4-4667-8E10-A5847B828E52}"/>
               </a:ext>
             </a:extLst>
           </p:cNvPr>
@@ -6451,7 +6668,7 @@
           <p:cNvPr id="15" name="">
             <a:extLst xmlns:a="http://schemas.openxmlformats.org/drawingml/2006/main">
               <a:ext uri="{FF2B5EF4-FFF2-40B4-BE49-F238E27FC236}">
-                <a16:creationId xmlns:a16="http://schemas.microsoft.com/office/drawing/2014/main" id="{EBF2F2F3-0985-4581-AB19-B6173BA5B67E}"/>
+                <a16:creationId xmlns:a16="http://schemas.microsoft.com/office/drawing/2014/main" id="{5FCD4637-25E9-4A64-BAFA-3D6FC1AF33BA}"/>
               </a:ext>
             </a:extLst>
           </p:cNvPr>
@@ -6509,7 +6726,7 @@
           <p:cNvPr id="16" name="">
             <a:extLst xmlns:a="http://schemas.openxmlformats.org/drawingml/2006/main">
               <a:ext uri="{FF2B5EF4-FFF2-40B4-BE49-F238E27FC236}">
-                <a16:creationId xmlns:a16="http://schemas.microsoft.com/office/drawing/2014/main" id="{DA3F2CC6-C842-48F3-B4C9-3157B8BB3542}"/>
+                <a16:creationId xmlns:a16="http://schemas.microsoft.com/office/drawing/2014/main" id="{41E31FCA-D86B-48B0-9AF8-0208901241CE}"/>
               </a:ext>
             </a:extLst>
           </p:cNvPr>
@@ -6567,7 +6784,7 @@
           <p:cNvPr id="17" name="">
             <a:extLst xmlns:a="http://schemas.openxmlformats.org/drawingml/2006/main">
               <a:ext uri="{FF2B5EF4-FFF2-40B4-BE49-F238E27FC236}">
-                <a16:creationId xmlns:a16="http://schemas.microsoft.com/office/drawing/2014/main" id="{39406EA0-99A6-4C66-BDC4-4B522FEDD12F}"/>
+                <a16:creationId xmlns:a16="http://schemas.microsoft.com/office/drawing/2014/main" id="{4E998B78-AD9D-4ADF-B0F3-B2C110C5A44A}"/>
               </a:ext>
             </a:extLst>
           </p:cNvPr>
@@ -6625,7 +6842,7 @@
           <p:cNvPr id="18" name="">
             <a:extLst xmlns:a="http://schemas.openxmlformats.org/drawingml/2006/main">
               <a:ext uri="{FF2B5EF4-FFF2-40B4-BE49-F238E27FC236}">
-                <a16:creationId xmlns:a16="http://schemas.microsoft.com/office/drawing/2014/main" id="{A70A3DBF-5262-4232-9C88-624A6AF6FE79}"/>
+                <a16:creationId xmlns:a16="http://schemas.microsoft.com/office/drawing/2014/main" id="{49815D47-5870-4FE1-92FA-B02FE57A9254}"/>
               </a:ext>
             </a:extLst>
           </p:cNvPr>
@@ -6683,7 +6900,7 @@
           <p:cNvPr id="19" name="">
             <a:extLst xmlns:a="http://schemas.openxmlformats.org/drawingml/2006/main">
               <a:ext uri="{FF2B5EF4-FFF2-40B4-BE49-F238E27FC236}">
-                <a16:creationId xmlns:a16="http://schemas.microsoft.com/office/drawing/2014/main" id="{B82FF7C3-83B2-4BF7-AF1E-81EE8AB3E8DF}"/>
+                <a16:creationId xmlns:a16="http://schemas.microsoft.com/office/drawing/2014/main" id="{683C1838-C6FE-4509-B36A-30F39E6DFC63}"/>
               </a:ext>
             </a:extLst>
           </p:cNvPr>
@@ -6716,7 +6933,7 @@
           <p:cNvPr id="20" name="">
             <a:extLst xmlns:a="http://schemas.openxmlformats.org/drawingml/2006/main">
               <a:ext uri="{FF2B5EF4-FFF2-40B4-BE49-F238E27FC236}">
-                <a16:creationId xmlns:a16="http://schemas.microsoft.com/office/drawing/2014/main" id="{88A07401-7DD0-4CA8-8066-1F3CFEBF43EB}"/>
+                <a16:creationId xmlns:a16="http://schemas.microsoft.com/office/drawing/2014/main" id="{7486C05A-E9AF-4121-9453-7C0CF8444570}"/>
               </a:ext>
             </a:extLst>
           </p:cNvPr>
@@ -6774,7 +6991,7 @@
           <p:cNvPr id="21" name="">
             <a:extLst xmlns:a="http://schemas.openxmlformats.org/drawingml/2006/main">
               <a:ext uri="{FF2B5EF4-FFF2-40B4-BE49-F238E27FC236}">
-                <a16:creationId xmlns:a16="http://schemas.microsoft.com/office/drawing/2014/main" id="{F91D0EB0-A843-4693-9D05-13302B70449A}"/>
+                <a16:creationId xmlns:a16="http://schemas.microsoft.com/office/drawing/2014/main" id="{AF7A5119-6477-41ED-B3B7-224324FA2C7E}"/>
               </a:ext>
             </a:extLst>
           </p:cNvPr>
@@ -6832,7 +7049,7 @@
           <p:cNvPr id="22" name="">
             <a:extLst xmlns:a="http://schemas.openxmlformats.org/drawingml/2006/main">
               <a:ext uri="{FF2B5EF4-FFF2-40B4-BE49-F238E27FC236}">
-                <a16:creationId xmlns:a16="http://schemas.microsoft.com/office/drawing/2014/main" id="{0FFEE098-45AC-45E9-B254-48607BBFD197}"/>
+                <a16:creationId xmlns:a16="http://schemas.microsoft.com/office/drawing/2014/main" id="{B3F3A7DC-0FCD-49D2-A897-C3754284B95E}"/>
               </a:ext>
             </a:extLst>
           </p:cNvPr>
@@ -6890,7 +7107,7 @@
           <p:cNvPr id="23" name="">
             <a:extLst xmlns:a="http://schemas.openxmlformats.org/drawingml/2006/main">
               <a:ext uri="{FF2B5EF4-FFF2-40B4-BE49-F238E27FC236}">
-                <a16:creationId xmlns:a16="http://schemas.microsoft.com/office/drawing/2014/main" id="{15D337AB-D23D-402A-A522-391644D477F8}"/>
+                <a16:creationId xmlns:a16="http://schemas.microsoft.com/office/drawing/2014/main" id="{8EF8396C-C38F-4302-AC1F-616852E2610F}"/>
               </a:ext>
             </a:extLst>
           </p:cNvPr>
@@ -6923,7 +7140,7 @@
           <p:cNvPr id="24" name="">
             <a:extLst xmlns:a="http://schemas.openxmlformats.org/drawingml/2006/main">
               <a:ext uri="{FF2B5EF4-FFF2-40B4-BE49-F238E27FC236}">
-                <a16:creationId xmlns:a16="http://schemas.microsoft.com/office/drawing/2014/main" id="{85CB24BA-33F7-426F-BB85-53C37D5AFE66}"/>
+                <a16:creationId xmlns:a16="http://schemas.microsoft.com/office/drawing/2014/main" id="{8362B5AA-D467-474C-B53E-0D2F1E9CFFC8}"/>
               </a:ext>
             </a:extLst>
           </p:cNvPr>
@@ -6981,7 +7198,7 @@
           <p:cNvPr id="25" name="">
             <a:extLst xmlns:a="http://schemas.openxmlformats.org/drawingml/2006/main">
               <a:ext uri="{FF2B5EF4-FFF2-40B4-BE49-F238E27FC236}">
-                <a16:creationId xmlns:a16="http://schemas.microsoft.com/office/drawing/2014/main" id="{16ED7A24-9D83-4BD4-B2E2-22A7540EE9B4}"/>
+                <a16:creationId xmlns:a16="http://schemas.microsoft.com/office/drawing/2014/main" id="{46C28CAB-3966-4A06-8BBC-D1B2F5AFC163}"/>
               </a:ext>
             </a:extLst>
           </p:cNvPr>
@@ -7039,7 +7256,7 @@
           <p:cNvPr id="26" name="">
             <a:extLst xmlns:a="http://schemas.openxmlformats.org/drawingml/2006/main">
               <a:ext uri="{FF2B5EF4-FFF2-40B4-BE49-F238E27FC236}">
-                <a16:creationId xmlns:a16="http://schemas.microsoft.com/office/drawing/2014/main" id="{617F0F91-6D85-4F90-AD2A-23EDCE16A111}"/>
+                <a16:creationId xmlns:a16="http://schemas.microsoft.com/office/drawing/2014/main" id="{734BAD74-72E9-4807-B1D2-E9E7C2AD2A5F}"/>
               </a:ext>
             </a:extLst>
           </p:cNvPr>
@@ -7097,7 +7314,7 @@
           <p:cNvPr id="27" name="">
             <a:extLst xmlns:a="http://schemas.openxmlformats.org/drawingml/2006/main">
               <a:ext uri="{FF2B5EF4-FFF2-40B4-BE49-F238E27FC236}">
-                <a16:creationId xmlns:a16="http://schemas.microsoft.com/office/drawing/2014/main" id="{EEAF03EE-5E8A-4EB4-ABEB-83B9CAC95AF0}"/>
+                <a16:creationId xmlns:a16="http://schemas.microsoft.com/office/drawing/2014/main" id="{1C0365DB-DB59-4BA1-9A87-C1E7D3D73DEC}"/>
               </a:ext>
             </a:extLst>
           </p:cNvPr>
@@ -7130,7 +7347,7 @@
           <p:cNvPr id="28" name="">
             <a:extLst xmlns:a="http://schemas.openxmlformats.org/drawingml/2006/main">
               <a:ext uri="{FF2B5EF4-FFF2-40B4-BE49-F238E27FC236}">
-                <a16:creationId xmlns:a16="http://schemas.microsoft.com/office/drawing/2014/main" id="{8E7765D8-E703-46DF-B4DF-ED048D302702}"/>
+                <a16:creationId xmlns:a16="http://schemas.microsoft.com/office/drawing/2014/main" id="{59F438A3-804C-4745-BB47-71E2ABFB1A4F}"/>
               </a:ext>
             </a:extLst>
           </p:cNvPr>
@@ -7188,7 +7405,7 @@
           <p:cNvPr id="29" name="">
             <a:extLst xmlns:a="http://schemas.openxmlformats.org/drawingml/2006/main">
               <a:ext uri="{FF2B5EF4-FFF2-40B4-BE49-F238E27FC236}">
-                <a16:creationId xmlns:a16="http://schemas.microsoft.com/office/drawing/2014/main" id="{9FF0D895-1DD1-439D-A336-75FB287CE776}"/>
+                <a16:creationId xmlns:a16="http://schemas.microsoft.com/office/drawing/2014/main" id="{FADBF203-67B8-4CF7-8DA6-8D3FE4A37845}"/>
               </a:ext>
             </a:extLst>
           </p:cNvPr>
@@ -7246,7 +7463,7 @@
           <p:cNvPr id="30" name="">
             <a:extLst xmlns:a="http://schemas.openxmlformats.org/drawingml/2006/main">
               <a:ext uri="{FF2B5EF4-FFF2-40B4-BE49-F238E27FC236}">
-                <a16:creationId xmlns:a16="http://schemas.microsoft.com/office/drawing/2014/main" id="{28099813-CABE-45DB-A3DC-082BDBFC3FEC}"/>
+                <a16:creationId xmlns:a16="http://schemas.microsoft.com/office/drawing/2014/main" id="{1F184F44-42A8-4D80-BCE8-917B4E22F91B}"/>
               </a:ext>
             </a:extLst>
           </p:cNvPr>
@@ -7304,7 +7521,7 @@
           <p:cNvPr id="31" name="">
             <a:extLst xmlns:a="http://schemas.openxmlformats.org/drawingml/2006/main">
               <a:ext uri="{FF2B5EF4-FFF2-40B4-BE49-F238E27FC236}">
-                <a16:creationId xmlns:a16="http://schemas.microsoft.com/office/drawing/2014/main" id="{43B9CF01-37D5-4661-BD9F-66C206346159}"/>
+                <a16:creationId xmlns:a16="http://schemas.microsoft.com/office/drawing/2014/main" id="{F6226B92-2F96-4F82-913D-3B0DCA9DE5B7}"/>
               </a:ext>
             </a:extLst>
           </p:cNvPr>
@@ -7337,7 +7554,7 @@
           <p:cNvPr id="32" name="">
             <a:extLst xmlns:a="http://schemas.openxmlformats.org/drawingml/2006/main">
               <a:ext uri="{FF2B5EF4-FFF2-40B4-BE49-F238E27FC236}">
-                <a16:creationId xmlns:a16="http://schemas.microsoft.com/office/drawing/2014/main" id="{25BE47F4-0EBA-4B73-BD88-6FD29301B967}"/>
+                <a16:creationId xmlns:a16="http://schemas.microsoft.com/office/drawing/2014/main" id="{545720C2-F397-4F6F-940B-9D09B0713601}"/>
               </a:ext>
             </a:extLst>
           </p:cNvPr>
@@ -7395,7 +7612,7 @@
           <p:cNvPr id="33" name="">
             <a:extLst xmlns:a="http://schemas.openxmlformats.org/drawingml/2006/main">
               <a:ext uri="{FF2B5EF4-FFF2-40B4-BE49-F238E27FC236}">
-                <a16:creationId xmlns:a16="http://schemas.microsoft.com/office/drawing/2014/main" id="{619CBC93-AADC-4BF8-B1AE-03C07430EE20}"/>
+                <a16:creationId xmlns:a16="http://schemas.microsoft.com/office/drawing/2014/main" id="{A2083FF2-2F29-4D63-9B0D-138C170EF4E8}"/>
               </a:ext>
             </a:extLst>
           </p:cNvPr>
@@ -7453,7 +7670,7 @@
           <p:cNvPr id="34" name="">
             <a:extLst xmlns:a="http://schemas.openxmlformats.org/drawingml/2006/main">
               <a:ext uri="{FF2B5EF4-FFF2-40B4-BE49-F238E27FC236}">
-                <a16:creationId xmlns:a16="http://schemas.microsoft.com/office/drawing/2014/main" id="{4C4E0D91-611A-40D5-89A0-8CC437CE3AA9}"/>
+                <a16:creationId xmlns:a16="http://schemas.microsoft.com/office/drawing/2014/main" id="{08317434-8B2C-4CCA-9B5B-85090EC6C992}"/>
               </a:ext>
             </a:extLst>
           </p:cNvPr>
@@ -7511,7 +7728,7 @@
           <p:cNvPr id="35" name="">
             <a:extLst xmlns:a="http://schemas.openxmlformats.org/drawingml/2006/main">
               <a:ext uri="{FF2B5EF4-FFF2-40B4-BE49-F238E27FC236}">
-                <a16:creationId xmlns:a16="http://schemas.microsoft.com/office/drawing/2014/main" id="{AB745E20-DB2A-4B40-9421-DD5A29B951F0}"/>
+                <a16:creationId xmlns:a16="http://schemas.microsoft.com/office/drawing/2014/main" id="{9B87CE4B-A47C-4E6C-9CE5-7FC7492AEEFE}"/>
               </a:ext>
             </a:extLst>
           </p:cNvPr>
@@ -7544,7 +7761,7 @@
           <p:cNvPr id="36" name="">
             <a:extLst xmlns:a="http://schemas.openxmlformats.org/drawingml/2006/main">
               <a:ext uri="{FF2B5EF4-FFF2-40B4-BE49-F238E27FC236}">
-                <a16:creationId xmlns:a16="http://schemas.microsoft.com/office/drawing/2014/main" id="{A0CA865E-67FD-4EF1-A34E-47B73BDB3309}"/>
+                <a16:creationId xmlns:a16="http://schemas.microsoft.com/office/drawing/2014/main" id="{3C4B4300-4AB3-4B20-8259-BFB69C589188}"/>
               </a:ext>
             </a:extLst>
           </p:cNvPr>
@@ -7602,7 +7819,7 @@
           <p:cNvPr id="37" name="">
             <a:extLst xmlns:a="http://schemas.openxmlformats.org/drawingml/2006/main">
               <a:ext uri="{FF2B5EF4-FFF2-40B4-BE49-F238E27FC236}">
-                <a16:creationId xmlns:a16="http://schemas.microsoft.com/office/drawing/2014/main" id="{326C9846-3B10-4A42-B561-8139422E83CE}"/>
+                <a16:creationId xmlns:a16="http://schemas.microsoft.com/office/drawing/2014/main" id="{7CF475DD-3C26-4262-85B8-9A699701DBF7}"/>
               </a:ext>
             </a:extLst>
           </p:cNvPr>
@@ -7660,7 +7877,7 @@
           <p:cNvPr id="38" name="">
             <a:extLst xmlns:a="http://schemas.openxmlformats.org/drawingml/2006/main">
               <a:ext uri="{FF2B5EF4-FFF2-40B4-BE49-F238E27FC236}">
-                <a16:creationId xmlns:a16="http://schemas.microsoft.com/office/drawing/2014/main" id="{CA829127-E71F-4275-A62B-05BF14C5F43A}"/>
+                <a16:creationId xmlns:a16="http://schemas.microsoft.com/office/drawing/2014/main" id="{7A064A3D-2003-4B5F-AB32-C8111520984A}"/>
               </a:ext>
             </a:extLst>
           </p:cNvPr>
@@ -7718,7 +7935,7 @@
           <p:cNvPr id="39" name="">
             <a:extLst xmlns:a="http://schemas.openxmlformats.org/drawingml/2006/main">
               <a:ext uri="{FF2B5EF4-FFF2-40B4-BE49-F238E27FC236}">
-                <a16:creationId xmlns:a16="http://schemas.microsoft.com/office/drawing/2014/main" id="{07BFEDCF-1161-4BB5-B348-F97237F13A7F}"/>
+                <a16:creationId xmlns:a16="http://schemas.microsoft.com/office/drawing/2014/main" id="{B5E2CD64-156C-4CFE-9350-E1230062FBBA}"/>
               </a:ext>
             </a:extLst>
           </p:cNvPr>
@@ -7751,7 +7968,7 @@
           <p:cNvPr id="40" name="">
             <a:extLst xmlns:a="http://schemas.openxmlformats.org/drawingml/2006/main">
               <a:ext uri="{FF2B5EF4-FFF2-40B4-BE49-F238E27FC236}">
-                <a16:creationId xmlns:a16="http://schemas.microsoft.com/office/drawing/2014/main" id="{DAA36133-752A-43A2-A2A5-0F01EBE0F65D}"/>
+                <a16:creationId xmlns:a16="http://schemas.microsoft.com/office/drawing/2014/main" id="{E660AF56-267C-4EA8-AEEC-4A72DE89E8C9}"/>
               </a:ext>
             </a:extLst>
           </p:cNvPr>
@@ -7809,7 +8026,7 @@
           <p:cNvPr id="41" name="">
             <a:extLst xmlns:a="http://schemas.openxmlformats.org/drawingml/2006/main">
               <a:ext uri="{FF2B5EF4-FFF2-40B4-BE49-F238E27FC236}">
-                <a16:creationId xmlns:a16="http://schemas.microsoft.com/office/drawing/2014/main" id="{F10A439E-9B9D-4B01-8D5B-BB1B137F3544}"/>
+                <a16:creationId xmlns:a16="http://schemas.microsoft.com/office/drawing/2014/main" id="{41A61A73-3719-496B-842B-03A7B7D1B612}"/>
               </a:ext>
             </a:extLst>
           </p:cNvPr>
@@ -7867,7 +8084,7 @@
           <p:cNvPr id="42" name="">
             <a:extLst xmlns:a="http://schemas.openxmlformats.org/drawingml/2006/main">
               <a:ext uri="{FF2B5EF4-FFF2-40B4-BE49-F238E27FC236}">
-                <a16:creationId xmlns:a16="http://schemas.microsoft.com/office/drawing/2014/main" id="{CFC0612A-AF1A-46D5-88B0-595A8D1BAE69}"/>
+                <a16:creationId xmlns:a16="http://schemas.microsoft.com/office/drawing/2014/main" id="{0E273248-1537-4495-808A-FD983B8B8D5E}"/>
               </a:ext>
             </a:extLst>
           </p:cNvPr>
@@ -7925,7 +8142,7 @@
           <p:cNvPr id="43" name="">
             <a:extLst xmlns:a="http://schemas.openxmlformats.org/drawingml/2006/main">
               <a:ext uri="{FF2B5EF4-FFF2-40B4-BE49-F238E27FC236}">
-                <a16:creationId xmlns:a16="http://schemas.microsoft.com/office/drawing/2014/main" id="{7C6FB5F8-DF48-412C-8E0D-D0036EA7B61C}"/>
+                <a16:creationId xmlns:a16="http://schemas.microsoft.com/office/drawing/2014/main" id="{6F0AAF2B-D5A5-4D11-939A-3F8CFE9F0950}"/>
               </a:ext>
             </a:extLst>
           </p:cNvPr>
@@ -7956,7 +8173,7 @@
           <p:cNvPr id="44" name="">
             <a:extLst xmlns:a="http://schemas.openxmlformats.org/drawingml/2006/main">
               <a:ext uri="{FF2B5EF4-FFF2-40B4-BE49-F238E27FC236}">
-                <a16:creationId xmlns:a16="http://schemas.microsoft.com/office/drawing/2014/main" id="{0ECC6128-4AF9-4C07-9920-3ACDE59DA282}"/>
+                <a16:creationId xmlns:a16="http://schemas.microsoft.com/office/drawing/2014/main" id="{DB3BB8A4-7D21-430F-A3D9-2234BC686149}"/>
               </a:ext>
             </a:extLst>
           </p:cNvPr>
@@ -8014,7 +8231,7 @@
           <p:cNvPr id="45" name="">
             <a:extLst xmlns:a="http://schemas.openxmlformats.org/drawingml/2006/main">
               <a:ext uri="{FF2B5EF4-FFF2-40B4-BE49-F238E27FC236}">
-                <a16:creationId xmlns:a16="http://schemas.microsoft.com/office/drawing/2014/main" id="{9BFAF7B5-8F68-43E1-9298-85C133623CF9}"/>
+                <a16:creationId xmlns:a16="http://schemas.microsoft.com/office/drawing/2014/main" id="{E6E1EB7C-B9A2-4EDD-AF90-604C3FAFB1CB}"/>
               </a:ext>
             </a:extLst>
           </p:cNvPr>
@@ -8070,7 +8287,7 @@
     </p:spTree>
     <p:extLst>
       <p:ext uri="{BB962C8B-B14F-4D97-AF65-F5344CB8AC3E}">
-        <p14:creationId xmlns:p14="http://schemas.microsoft.com/office/powerpoint/2010/main" val="798284948"/>
+        <p14:creationId xmlns:p14="http://schemas.microsoft.com/office/powerpoint/2010/main" val="637331286"/>
       </p:ext>
     </p:extLst>
   </p:cSld>

</xml_diff>